<commit_message>
Improve case documents for external readers
</commit_message>
<xml_diff>
--- a/downloads/ptz-steklo-weboptimize-case.pptx
+++ b/downloads/ptz-steklo-weboptimize-case.pptx
@@ -3165,8 +3165,8 @@
           <a:noFill/>
         </p:spPr>
         <p:txBody>
-          <a:bodyPr wrap="none" lIns="18288" rIns="18288" tIns="18288" bIns="18288" anchor="t">
-            <a:spAutoFit/>
+          <a:bodyPr wrap="square" lIns="18288" rIns="18288" tIns="18288" bIns="18288" anchor="t">
+            <a:noAutofit/>
           </a:bodyPr>
           <a:lstStyle/>
           <a:p>
@@ -3176,7 +3176,7 @@
               </a:lnSpc>
             </a:pPr>
             <a:r>
-              <a:rPr sz="1100" b="1">
+              <a:rPr sz="1100" b="0" i="0">
                 <a:solidFill>
                   <a:srgbClr val="1AC1C1"/>
                 </a:solidFill>
@@ -3184,6 +3184,9 @@
               </a:rPr>
               <a:t>РЕЗУЛЬТАТ</a:t>
             </a:r>
+            <a:endParaRPr sz="1100" b="0" i="0">
+              <a:latin typeface="Montserrat"/>
+            </a:endParaRPr>
           </a:p>
         </p:txBody>
       </p:sp>
@@ -3204,8 +3207,8 @@
           <a:noFill/>
         </p:spPr>
         <p:txBody>
-          <a:bodyPr wrap="none" lIns="18288" rIns="18288" tIns="18288" bIns="18288" anchor="t">
-            <a:spAutoFit/>
+          <a:bodyPr wrap="square" lIns="18288" rIns="18288" tIns="18288" bIns="18288" anchor="t">
+            <a:noAutofit/>
           </a:bodyPr>
           <a:lstStyle/>
           <a:p>
@@ -3215,7 +3218,7 @@
               </a:lnSpc>
             </a:pPr>
             <a:r>
-              <a:rPr sz="3600" b="1">
+              <a:rPr sz="3600" b="0" i="0">
                 <a:solidFill>
                   <a:srgbClr val="FFFFFF"/>
                 </a:solidFill>
@@ -3224,6 +3227,9 @@
               <a:t>Одна сделка соответствует
 одному заказу</a:t>
             </a:r>
+            <a:endParaRPr sz="3600" b="0" i="0">
+              <a:latin typeface="Montserrat"/>
+            </a:endParaRPr>
           </a:p>
         </p:txBody>
       </p:sp>
@@ -3244,8 +3250,8 @@
           <a:noFill/>
         </p:spPr>
         <p:txBody>
-          <a:bodyPr wrap="none" lIns="18288" rIns="18288" tIns="18288" bIns="18288" anchor="t">
-            <a:spAutoFit/>
+          <a:bodyPr wrap="square" lIns="18288" rIns="18288" tIns="18288" bIns="18288" anchor="t">
+            <a:noAutofit/>
           </a:bodyPr>
           <a:lstStyle/>
           <a:p>
@@ -3255,15 +3261,18 @@
               </a:lnSpc>
             </a:pPr>
             <a:r>
-              <a:rPr sz="1700" b="0">
+              <a:rPr sz="1700" b="0" i="0">
                 <a:solidFill>
                   <a:srgbClr val="D6E4EC"/>
                 </a:solidFill>
                 <a:latin typeface="Montserrat"/>
               </a:rPr>
-              <a:t>Повтор безопасен, производственные данные возвращаются в CRM,
+              <a:t>Повтор безопасен, производственные данные возвращаются в Bitrix24,
 а база 1С остаётся закрытой.</a:t>
             </a:r>
+            <a:endParaRPr sz="1700" b="0" i="0">
+              <a:latin typeface="Montserrat"/>
+            </a:endParaRPr>
           </a:p>
         </p:txBody>
       </p:sp>
@@ -3329,8 +3338,8 @@
           <a:noFill/>
         </p:spPr>
         <p:txBody>
-          <a:bodyPr wrap="none" lIns="18288" rIns="18288" tIns="18288" bIns="18288" anchor="t">
-            <a:spAutoFit/>
+          <a:bodyPr wrap="square" lIns="18288" rIns="18288" tIns="18288" bIns="18288" anchor="t">
+            <a:noAutofit/>
           </a:bodyPr>
           <a:lstStyle/>
           <a:p>
@@ -3340,14 +3349,17 @@
               </a:lnSpc>
             </a:pPr>
             <a:r>
-              <a:rPr sz="1900" b="1">
+              <a:rPr sz="1900" b="0" i="0">
                 <a:solidFill>
                   <a:srgbClr val="1AC1C1"/>
                 </a:solidFill>
                 <a:latin typeface="Montserrat"/>
               </a:rPr>
-              <a:t>1 ↔ 1</a:t>
-            </a:r>
+              <a:t>1 к 1</a:t>
+            </a:r>
+            <a:endParaRPr sz="1900" b="0" i="0">
+              <a:latin typeface="Montserrat"/>
+            </a:endParaRPr>
           </a:p>
         </p:txBody>
       </p:sp>
@@ -3368,8 +3380,8 @@
           <a:noFill/>
         </p:spPr>
         <p:txBody>
-          <a:bodyPr wrap="none" lIns="18288" rIns="18288" tIns="18288" bIns="18288" anchor="t">
-            <a:spAutoFit/>
+          <a:bodyPr wrap="square" lIns="18288" rIns="18288" tIns="18288" bIns="18288" anchor="t">
+            <a:noAutofit/>
           </a:bodyPr>
           <a:lstStyle/>
           <a:p>
@@ -3379,14 +3391,17 @@
               </a:lnSpc>
             </a:pPr>
             <a:r>
-              <a:rPr sz="1050" b="0">
+              <a:rPr sz="1000" b="0" i="0">
                 <a:solidFill>
                   <a:srgbClr val="C5D4DE"/>
                 </a:solidFill>
                 <a:latin typeface="Montserrat"/>
               </a:rPr>
-              <a:t>устойчивая связь</a:t>
-            </a:r>
+              <a:t>одна сделка — один заказ</a:t>
+            </a:r>
+            <a:endParaRPr sz="1000" b="0" i="0">
+              <a:latin typeface="Montserrat"/>
+            </a:endParaRPr>
           </a:p>
         </p:txBody>
       </p:sp>
@@ -3452,8 +3467,8 @@
           <a:noFill/>
         </p:spPr>
         <p:txBody>
-          <a:bodyPr wrap="none" lIns="18288" rIns="18288" tIns="18288" bIns="18288" anchor="t">
-            <a:spAutoFit/>
+          <a:bodyPr wrap="square" lIns="18288" rIns="18288" tIns="18288" bIns="18288" anchor="t">
+            <a:noAutofit/>
           </a:bodyPr>
           <a:lstStyle/>
           <a:p>
@@ -3463,7 +3478,7 @@
               </a:lnSpc>
             </a:pPr>
             <a:r>
-              <a:rPr sz="1900" b="1">
+              <a:rPr sz="1900" b="0" i="0">
                 <a:solidFill>
                   <a:srgbClr val="1AC1C1"/>
                 </a:solidFill>
@@ -3471,6 +3486,9 @@
               </a:rPr>
               <a:t>0 дублей</a:t>
             </a:r>
+            <a:endParaRPr sz="1900" b="0" i="0">
+              <a:latin typeface="Montserrat"/>
+            </a:endParaRPr>
           </a:p>
         </p:txBody>
       </p:sp>
@@ -3491,8 +3509,8 @@
           <a:noFill/>
         </p:spPr>
         <p:txBody>
-          <a:bodyPr wrap="none" lIns="18288" rIns="18288" tIns="18288" bIns="18288" anchor="t">
-            <a:spAutoFit/>
+          <a:bodyPr wrap="square" lIns="18288" rIns="18288" tIns="18288" bIns="18288" anchor="t">
+            <a:noAutofit/>
           </a:bodyPr>
           <a:lstStyle/>
           <a:p>
@@ -3502,7 +3520,7 @@
               </a:lnSpc>
             </a:pPr>
             <a:r>
-              <a:rPr sz="1050" b="0">
+              <a:rPr sz="1000" b="0" i="0">
                 <a:solidFill>
                   <a:srgbClr val="C5D4DE"/>
                 </a:solidFill>
@@ -3510,6 +3528,9 @@
               </a:rPr>
               <a:t>при повторной отправке</a:t>
             </a:r>
+            <a:endParaRPr sz="1000" b="0" i="0">
+              <a:latin typeface="Montserrat"/>
+            </a:endParaRPr>
           </a:p>
         </p:txBody>
       </p:sp>
@@ -3575,8 +3596,8 @@
           <a:noFill/>
         </p:spPr>
         <p:txBody>
-          <a:bodyPr wrap="none" lIns="18288" rIns="18288" tIns="18288" bIns="18288" anchor="t">
-            <a:spAutoFit/>
+          <a:bodyPr wrap="square" lIns="18288" rIns="18288" tIns="18288" bIns="18288" anchor="t">
+            <a:noAutofit/>
           </a:bodyPr>
           <a:lstStyle/>
           <a:p>
@@ -3586,14 +3607,17 @@
               </a:lnSpc>
             </a:pPr>
             <a:r>
-              <a:rPr sz="1900" b="1">
+              <a:rPr sz="1900" b="0" i="0">
                 <a:solidFill>
                   <a:srgbClr val="1AC1C1"/>
                 </a:solidFill>
                 <a:latin typeface="Montserrat"/>
               </a:rPr>
-              <a:t>HTTPS 443</a:t>
-            </a:r>
+              <a:t>Закрытая 1С</a:t>
+            </a:r>
+            <a:endParaRPr sz="1900" b="0" i="0">
+              <a:latin typeface="Montserrat"/>
+            </a:endParaRPr>
           </a:p>
         </p:txBody>
       </p:sp>
@@ -3614,8 +3638,8 @@
           <a:noFill/>
         </p:spPr>
         <p:txBody>
-          <a:bodyPr wrap="none" lIns="18288" rIns="18288" tIns="18288" bIns="18288" anchor="t">
-            <a:spAutoFit/>
+          <a:bodyPr wrap="square" lIns="18288" rIns="18288" tIns="18288" bIns="18288" anchor="t">
+            <a:noAutofit/>
           </a:bodyPr>
           <a:lstStyle/>
           <a:p>
@@ -3625,14 +3649,17 @@
               </a:lnSpc>
             </a:pPr>
             <a:r>
-              <a:rPr sz="1050" b="0">
+              <a:rPr sz="1000" b="0" i="0">
                 <a:solidFill>
                   <a:srgbClr val="C5D4DE"/>
                 </a:solidFill>
                 <a:latin typeface="Montserrat"/>
               </a:rPr>
-              <a:t>только исходящий доступ</a:t>
-            </a:r>
+              <a:t>входящий доступ не нужен</a:t>
+            </a:r>
+            <a:endParaRPr sz="1000" b="0" i="0">
+              <a:latin typeface="Montserrat"/>
+            </a:endParaRPr>
           </a:p>
         </p:txBody>
       </p:sp>
@@ -3698,8 +3725,8 @@
           <a:noFill/>
         </p:spPr>
         <p:txBody>
-          <a:bodyPr wrap="none" lIns="18288" rIns="18288" tIns="18288" bIns="18288" anchor="t">
-            <a:spAutoFit/>
+          <a:bodyPr wrap="square" lIns="18288" rIns="18288" tIns="18288" bIns="18288" anchor="t">
+            <a:noAutofit/>
           </a:bodyPr>
           <a:lstStyle/>
           <a:p>
@@ -3709,14 +3736,17 @@
               </a:lnSpc>
             </a:pPr>
             <a:r>
-              <a:rPr sz="1900" b="1">
+              <a:rPr sz="1900" b="0" i="0">
                 <a:solidFill>
                   <a:srgbClr val="1AC1C1"/>
                 </a:solidFill>
                 <a:latin typeface="Montserrat"/>
               </a:rPr>
-              <a:t>HEALTHY</a:t>
-            </a:r>
+              <a:t>Работает</a:t>
+            </a:r>
+            <a:endParaRPr sz="1900" b="0" i="0">
+              <a:latin typeface="Montserrat"/>
+            </a:endParaRPr>
           </a:p>
         </p:txBody>
       </p:sp>
@@ -3737,8 +3767,8 @@
           <a:noFill/>
         </p:spPr>
         <p:txBody>
-          <a:bodyPr wrap="none" lIns="18288" rIns="18288" tIns="18288" bIns="18288" anchor="t">
-            <a:spAutoFit/>
+          <a:bodyPr wrap="square" lIns="18288" rIns="18288" tIns="18288" bIns="18288" anchor="t">
+            <a:noAutofit/>
           </a:bodyPr>
           <a:lstStyle/>
           <a:p>
@@ -3748,14 +3778,17 @@
               </a:lnSpc>
             </a:pPr>
             <a:r>
-              <a:rPr sz="1050" b="0">
+              <a:rPr sz="1000" b="0" i="0">
                 <a:solidFill>
                   <a:srgbClr val="C5D4DE"/>
                 </a:solidFill>
                 <a:latin typeface="Montserrat"/>
               </a:rPr>
-              <a:t>контроль состояния</a:t>
-            </a:r>
+              <a:t>состояние проверено</a:t>
+            </a:r>
+            <a:endParaRPr sz="1000" b="0" i="0">
+              <a:latin typeface="Montserrat"/>
+            </a:endParaRPr>
           </a:p>
         </p:txBody>
       </p:sp>
@@ -3776,8 +3809,8 @@
           <a:noFill/>
         </p:spPr>
         <p:txBody>
-          <a:bodyPr wrap="none" lIns="18288" rIns="18288" tIns="18288" bIns="18288" anchor="t">
-            <a:spAutoFit/>
+          <a:bodyPr wrap="square" lIns="18288" rIns="18288" tIns="18288" bIns="18288" anchor="t">
+            <a:noAutofit/>
           </a:bodyPr>
           <a:lstStyle/>
           <a:p>
@@ -3787,7 +3820,7 @@
               </a:lnSpc>
             </a:pPr>
             <a:r>
-              <a:rPr sz="900" b="1">
+              <a:rPr sz="900" b="0" i="0">
                 <a:solidFill>
                   <a:srgbClr val="9DB0BF"/>
                 </a:solidFill>
@@ -3795,6 +3828,9 @@
               </a:rPr>
               <a:t>WEBOPTIMIZE  •  WEBOPTIMIZE.RU</a:t>
             </a:r>
+            <a:endParaRPr sz="900" b="0" i="0">
+              <a:latin typeface="Montserrat"/>
+            </a:endParaRPr>
           </a:p>
         </p:txBody>
       </p:sp>
@@ -3883,8 +3919,8 @@
           <a:noFill/>
         </p:spPr>
         <p:txBody>
-          <a:bodyPr wrap="none" lIns="18288" rIns="18288" tIns="18288" bIns="18288" anchor="t">
-            <a:spAutoFit/>
+          <a:bodyPr wrap="square" lIns="18288" rIns="18288" tIns="18288" bIns="18288" anchor="t">
+            <a:noAutofit/>
           </a:bodyPr>
           <a:lstStyle/>
           <a:p>
@@ -3894,7 +3930,7 @@
               </a:lnSpc>
             </a:pPr>
             <a:r>
-              <a:rPr sz="1100" b="1">
+              <a:rPr sz="1100" b="0" i="0">
                 <a:solidFill>
                   <a:srgbClr val="008C8C"/>
                 </a:solidFill>
@@ -3902,6 +3938,9 @@
               </a:rPr>
               <a:t>КОНТЕКСТ</a:t>
             </a:r>
+            <a:endParaRPr sz="1100" b="0" i="0">
+              <a:latin typeface="Montserrat"/>
+            </a:endParaRPr>
           </a:p>
         </p:txBody>
       </p:sp>
@@ -3922,8 +3961,8 @@
           <a:noFill/>
         </p:spPr>
         <p:txBody>
-          <a:bodyPr wrap="none" lIns="18288" rIns="18288" tIns="18288" bIns="18288" anchor="t">
-            <a:spAutoFit/>
+          <a:bodyPr wrap="square" lIns="18288" rIns="18288" tIns="18288" bIns="18288" anchor="t">
+            <a:noAutofit/>
           </a:bodyPr>
           <a:lstStyle/>
           <a:p>
@@ -3933,7 +3972,7 @@
               </a:lnSpc>
             </a:pPr>
             <a:r>
-              <a:rPr sz="2600" b="1">
+              <a:rPr sz="2600" b="0" i="0">
                 <a:solidFill>
                   <a:srgbClr val="15243A"/>
                 </a:solidFill>
@@ -3941,6 +3980,9 @@
               </a:rPr>
               <a:t>Индивидуальный заказ проходит длинный путь</a:t>
             </a:r>
+            <a:endParaRPr sz="2600" b="0" i="0">
+              <a:latin typeface="Montserrat"/>
+            </a:endParaRPr>
           </a:p>
         </p:txBody>
       </p:sp>
@@ -3961,8 +4003,8 @@
           <a:noFill/>
         </p:spPr>
         <p:txBody>
-          <a:bodyPr wrap="none" lIns="18288" rIns="18288" tIns="18288" bIns="18288" anchor="t">
-            <a:spAutoFit/>
+          <a:bodyPr wrap="square" lIns="18288" rIns="18288" tIns="18288" bIns="18288" anchor="t">
+            <a:noAutofit/>
           </a:bodyPr>
           <a:lstStyle/>
           <a:p>
@@ -3972,7 +4014,7 @@
               </a:lnSpc>
             </a:pPr>
             <a:r>
-              <a:rPr sz="1200" b="1">
+              <a:rPr sz="1200" b="0" i="0">
                 <a:solidFill>
                   <a:srgbClr val="667085"/>
                 </a:solidFill>
@@ -3980,6 +4022,9 @@
               </a:rPr>
               <a:t>02</a:t>
             </a:r>
+            <a:endParaRPr sz="1200" b="0" i="0">
+              <a:latin typeface="Montserrat"/>
+            </a:endParaRPr>
           </a:p>
         </p:txBody>
       </p:sp>
@@ -4045,8 +4090,8 @@
           <a:noFill/>
         </p:spPr>
         <p:txBody>
-          <a:bodyPr wrap="none" lIns="18288" rIns="18288" tIns="18288" bIns="18288" anchor="t">
-            <a:spAutoFit/>
+          <a:bodyPr wrap="square" lIns="18288" rIns="18288" tIns="18288" bIns="18288" anchor="t">
+            <a:noAutofit/>
           </a:bodyPr>
           <a:lstStyle/>
           <a:p>
@@ -4056,7 +4101,7 @@
               </a:lnSpc>
             </a:pPr>
             <a:r>
-              <a:rPr sz="2700" b="1">
+              <a:rPr sz="2700" b="0" i="0">
                 <a:solidFill>
                   <a:srgbClr val="008C8C"/>
                 </a:solidFill>
@@ -4064,6 +4109,9 @@
               </a:rPr>
               <a:t>1998</a:t>
             </a:r>
+            <a:endParaRPr sz="2700" b="0" i="0">
+              <a:latin typeface="Montserrat"/>
+            </a:endParaRPr>
           </a:p>
         </p:txBody>
       </p:sp>
@@ -4084,8 +4132,8 @@
           <a:noFill/>
         </p:spPr>
         <p:txBody>
-          <a:bodyPr wrap="none" lIns="18288" rIns="18288" tIns="18288" bIns="18288" anchor="t">
-            <a:spAutoFit/>
+          <a:bodyPr wrap="square" lIns="18288" rIns="18288" tIns="18288" bIns="18288" anchor="t">
+            <a:noAutofit/>
           </a:bodyPr>
           <a:lstStyle/>
           <a:p>
@@ -4095,7 +4143,7 @@
               </a:lnSpc>
             </a:pPr>
             <a:r>
-              <a:rPr sz="1150" b="0">
+              <a:rPr sz="1100" b="0" i="0">
                 <a:solidFill>
                   <a:srgbClr val="667085"/>
                 </a:solidFill>
@@ -4103,6 +4151,9 @@
               </a:rPr>
               <a:t>год начала работы</a:t>
             </a:r>
+            <a:endParaRPr sz="1100" b="0" i="0">
+              <a:latin typeface="Montserrat"/>
+            </a:endParaRPr>
           </a:p>
         </p:txBody>
       </p:sp>
@@ -4168,8 +4219,8 @@
           <a:noFill/>
         </p:spPr>
         <p:txBody>
-          <a:bodyPr wrap="none" lIns="18288" rIns="18288" tIns="18288" bIns="18288" anchor="t">
-            <a:spAutoFit/>
+          <a:bodyPr wrap="square" lIns="18288" rIns="18288" tIns="18288" bIns="18288" anchor="t">
+            <a:noAutofit/>
           </a:bodyPr>
           <a:lstStyle/>
           <a:p>
@@ -4179,7 +4230,7 @@
               </a:lnSpc>
             </a:pPr>
             <a:r>
-              <a:rPr sz="2700" b="1">
+              <a:rPr sz="2700" b="0" i="0">
                 <a:solidFill>
                   <a:srgbClr val="008C8C"/>
                 </a:solidFill>
@@ -4187,6 +4238,9 @@
               </a:rPr>
               <a:t>10 000+</a:t>
             </a:r>
+            <a:endParaRPr sz="2700" b="0" i="0">
+              <a:latin typeface="Montserrat"/>
+            </a:endParaRPr>
           </a:p>
         </p:txBody>
       </p:sp>
@@ -4207,8 +4261,8 @@
           <a:noFill/>
         </p:spPr>
         <p:txBody>
-          <a:bodyPr wrap="none" lIns="18288" rIns="18288" tIns="18288" bIns="18288" anchor="t">
-            <a:spAutoFit/>
+          <a:bodyPr wrap="square" lIns="18288" rIns="18288" tIns="18288" bIns="18288" anchor="t">
+            <a:noAutofit/>
           </a:bodyPr>
           <a:lstStyle/>
           <a:p>
@@ -4218,7 +4272,7 @@
               </a:lnSpc>
             </a:pPr>
             <a:r>
-              <a:rPr sz="1150" b="0">
+              <a:rPr sz="1100" b="0" i="0">
                 <a:solidFill>
                   <a:srgbClr val="667085"/>
                 </a:solidFill>
@@ -4226,6 +4280,9 @@
               </a:rPr>
               <a:t>частных клиентов</a:t>
             </a:r>
+            <a:endParaRPr sz="1100" b="0" i="0">
+              <a:latin typeface="Montserrat"/>
+            </a:endParaRPr>
           </a:p>
         </p:txBody>
       </p:sp>
@@ -4291,8 +4348,8 @@
           <a:noFill/>
         </p:spPr>
         <p:txBody>
-          <a:bodyPr wrap="none" lIns="18288" rIns="18288" tIns="18288" bIns="18288" anchor="t">
-            <a:spAutoFit/>
+          <a:bodyPr wrap="square" lIns="18288" rIns="18288" tIns="18288" bIns="18288" anchor="t">
+            <a:noAutofit/>
           </a:bodyPr>
           <a:lstStyle/>
           <a:p>
@@ -4302,7 +4359,7 @@
               </a:lnSpc>
             </a:pPr>
             <a:r>
-              <a:rPr sz="2700" b="1">
+              <a:rPr sz="2700" b="0" i="0">
                 <a:solidFill>
                   <a:srgbClr val="008C8C"/>
                 </a:solidFill>
@@ -4310,6 +4367,9 @@
               </a:rPr>
               <a:t>1 000+</a:t>
             </a:r>
+            <a:endParaRPr sz="2700" b="0" i="0">
+              <a:latin typeface="Montserrat"/>
+            </a:endParaRPr>
           </a:p>
         </p:txBody>
       </p:sp>
@@ -4330,8 +4390,8 @@
           <a:noFill/>
         </p:spPr>
         <p:txBody>
-          <a:bodyPr wrap="none" lIns="18288" rIns="18288" tIns="18288" bIns="18288" anchor="t">
-            <a:spAutoFit/>
+          <a:bodyPr wrap="square" lIns="18288" rIns="18288" tIns="18288" bIns="18288" anchor="t">
+            <a:noAutofit/>
           </a:bodyPr>
           <a:lstStyle/>
           <a:p>
@@ -4341,7 +4401,7 @@
               </a:lnSpc>
             </a:pPr>
             <a:r>
-              <a:rPr sz="1150" b="0">
+              <a:rPr sz="1100" b="0" i="0">
                 <a:solidFill>
                   <a:srgbClr val="667085"/>
                 </a:solidFill>
@@ -4349,6 +4409,9 @@
               </a:rPr>
               <a:t>организаций</a:t>
             </a:r>
+            <a:endParaRPr sz="1100" b="0" i="0">
+              <a:latin typeface="Montserrat"/>
+            </a:endParaRPr>
           </a:p>
         </p:txBody>
       </p:sp>
@@ -4414,8 +4477,8 @@
           <a:noFill/>
         </p:spPr>
         <p:txBody>
-          <a:bodyPr wrap="none" lIns="18288" rIns="18288" tIns="18288" bIns="18288" anchor="t">
-            <a:spAutoFit/>
+          <a:bodyPr wrap="square" lIns="18288" rIns="18288" tIns="18288" bIns="18288" anchor="t">
+            <a:noAutofit/>
           </a:bodyPr>
           <a:lstStyle/>
           <a:p>
@@ -4425,7 +4488,7 @@
               </a:lnSpc>
             </a:pPr>
             <a:r>
-              <a:rPr sz="2700" b="1">
+              <a:rPr sz="2700" b="0" i="0">
                 <a:solidFill>
                   <a:srgbClr val="008C8C"/>
                 </a:solidFill>
@@ -4433,6 +4496,9 @@
               </a:rPr>
               <a:t>500+</a:t>
             </a:r>
+            <a:endParaRPr sz="2700" b="0" i="0">
+              <a:latin typeface="Montserrat"/>
+            </a:endParaRPr>
           </a:p>
         </p:txBody>
       </p:sp>
@@ -4453,8 +4519,8 @@
           <a:noFill/>
         </p:spPr>
         <p:txBody>
-          <a:bodyPr wrap="none" lIns="18288" rIns="18288" tIns="18288" bIns="18288" anchor="t">
-            <a:spAutoFit/>
+          <a:bodyPr wrap="square" lIns="18288" rIns="18288" tIns="18288" bIns="18288" anchor="t">
+            <a:noAutofit/>
           </a:bodyPr>
           <a:lstStyle/>
           <a:p>
@@ -4464,7 +4530,7 @@
               </a:lnSpc>
             </a:pPr>
             <a:r>
-              <a:rPr sz="1150" b="0">
+              <a:rPr sz="1100" b="0" i="0">
                 <a:solidFill>
                   <a:srgbClr val="667085"/>
                 </a:solidFill>
@@ -4472,6 +4538,9 @@
               </a:rPr>
               <a:t>постоянных клиентов</a:t>
             </a:r>
+            <a:endParaRPr sz="1100" b="0" i="0">
+              <a:latin typeface="Montserrat"/>
+            </a:endParaRPr>
           </a:p>
         </p:txBody>
       </p:sp>
@@ -4516,8 +4585,8 @@
           <a:noFill/>
         </p:spPr>
         <p:txBody>
-          <a:bodyPr wrap="none" lIns="18288" rIns="18288" tIns="18288" bIns="18288" anchor="t">
-            <a:spAutoFit/>
+          <a:bodyPr wrap="square" lIns="18288" rIns="18288" tIns="18288" bIns="18288" anchor="t">
+            <a:noAutofit/>
           </a:bodyPr>
           <a:lstStyle/>
           <a:p>
@@ -4527,7 +4596,7 @@
               </a:lnSpc>
             </a:pPr>
             <a:r>
-              <a:rPr sz="1100" b="1">
+              <a:rPr sz="1100" b="0" i="0">
                 <a:solidFill>
                   <a:srgbClr val="008C8C"/>
                 </a:solidFill>
@@ -4535,6 +4604,9 @@
               </a:rPr>
               <a:t>ЗАМЕР</a:t>
             </a:r>
+            <a:endParaRPr sz="1100" b="0" i="0">
+              <a:latin typeface="Montserrat"/>
+            </a:endParaRPr>
           </a:p>
         </p:txBody>
       </p:sp>
@@ -4555,8 +4627,8 @@
           <a:noFill/>
         </p:spPr>
         <p:txBody>
-          <a:bodyPr wrap="none" lIns="18288" rIns="18288" tIns="18288" bIns="18288" anchor="t">
-            <a:spAutoFit/>
+          <a:bodyPr wrap="square" lIns="18288" rIns="18288" tIns="18288" bIns="18288" anchor="t">
+            <a:noAutofit/>
           </a:bodyPr>
           <a:lstStyle/>
           <a:p>
@@ -4566,7 +4638,7 @@
               </a:lnSpc>
             </a:pPr>
             <a:r>
-              <a:rPr sz="1300" b="1">
+              <a:rPr sz="1300" b="0" i="0">
                 <a:solidFill>
                   <a:srgbClr val="15243A"/>
                 </a:solidFill>
@@ -4574,6 +4646,9 @@
               </a:rPr>
               <a:t>→ РАСЧЁТ</a:t>
             </a:r>
+            <a:endParaRPr sz="1300" b="0" i="0">
+              <a:latin typeface="Montserrat"/>
+            </a:endParaRPr>
           </a:p>
         </p:txBody>
       </p:sp>
@@ -4594,8 +4669,8 @@
           <a:noFill/>
         </p:spPr>
         <p:txBody>
-          <a:bodyPr wrap="none" lIns="18288" rIns="18288" tIns="18288" bIns="18288" anchor="t">
-            <a:spAutoFit/>
+          <a:bodyPr wrap="square" lIns="18288" rIns="18288" tIns="18288" bIns="18288" anchor="t">
+            <a:noAutofit/>
           </a:bodyPr>
           <a:lstStyle/>
           <a:p>
@@ -4605,7 +4680,7 @@
               </a:lnSpc>
             </a:pPr>
             <a:r>
-              <a:rPr sz="1300" b="1">
+              <a:rPr sz="1300" b="0" i="0">
                 <a:solidFill>
                   <a:srgbClr val="15243A"/>
                 </a:solidFill>
@@ -4613,6 +4688,9 @@
               </a:rPr>
               <a:t>→ ПРОИЗВОДСТВО</a:t>
             </a:r>
+            <a:endParaRPr sz="1300" b="0" i="0">
+              <a:latin typeface="Montserrat"/>
+            </a:endParaRPr>
           </a:p>
         </p:txBody>
       </p:sp>
@@ -4633,8 +4711,8 @@
           <a:noFill/>
         </p:spPr>
         <p:txBody>
-          <a:bodyPr wrap="none" lIns="18288" rIns="18288" tIns="18288" bIns="18288" anchor="t">
-            <a:spAutoFit/>
+          <a:bodyPr wrap="square" lIns="18288" rIns="18288" tIns="18288" bIns="18288" anchor="t">
+            <a:noAutofit/>
           </a:bodyPr>
           <a:lstStyle/>
           <a:p>
@@ -4644,7 +4722,7 @@
               </a:lnSpc>
             </a:pPr>
             <a:r>
-              <a:rPr sz="1300" b="1">
+              <a:rPr sz="1300" b="0" i="0">
                 <a:solidFill>
                   <a:srgbClr val="15243A"/>
                 </a:solidFill>
@@ -4652,6 +4730,9 @@
               </a:rPr>
               <a:t>→ ДОСТАВКА</a:t>
             </a:r>
+            <a:endParaRPr sz="1300" b="0" i="0">
+              <a:latin typeface="Montserrat"/>
+            </a:endParaRPr>
           </a:p>
         </p:txBody>
       </p:sp>
@@ -4672,8 +4753,8 @@
           <a:noFill/>
         </p:spPr>
         <p:txBody>
-          <a:bodyPr wrap="none" lIns="18288" rIns="18288" tIns="18288" bIns="18288" anchor="t">
-            <a:spAutoFit/>
+          <a:bodyPr wrap="square" lIns="18288" rIns="18288" tIns="18288" bIns="18288" anchor="t">
+            <a:noAutofit/>
           </a:bodyPr>
           <a:lstStyle/>
           <a:p>
@@ -4683,7 +4764,7 @@
               </a:lnSpc>
             </a:pPr>
             <a:r>
-              <a:rPr sz="1300" b="1">
+              <a:rPr sz="1300" b="0" i="0">
                 <a:solidFill>
                   <a:srgbClr val="15243A"/>
                 </a:solidFill>
@@ -4691,6 +4772,9 @@
               </a:rPr>
               <a:t>→ МОНТАЖ</a:t>
             </a:r>
+            <a:endParaRPr sz="1300" b="0" i="0">
+              <a:latin typeface="Montserrat"/>
+            </a:endParaRPr>
           </a:p>
         </p:txBody>
       </p:sp>
@@ -4711,8 +4795,8 @@
           <a:noFill/>
         </p:spPr>
         <p:txBody>
-          <a:bodyPr wrap="none" lIns="18288" rIns="18288" tIns="18288" bIns="18288" anchor="t">
-            <a:spAutoFit/>
+          <a:bodyPr wrap="square" lIns="18288" rIns="18288" tIns="18288" bIns="18288" anchor="t">
+            <a:noAutofit/>
           </a:bodyPr>
           <a:lstStyle/>
           <a:p>
@@ -4722,7 +4806,7 @@
               </a:lnSpc>
             </a:pPr>
             <a:r>
-              <a:rPr sz="950" b="0">
+              <a:rPr sz="900" b="0" i="0">
                 <a:solidFill>
                   <a:srgbClr val="667085"/>
                 </a:solidFill>
@@ -4730,6 +4814,9 @@
               </a:rPr>
               <a:t>Источник показателей: официальный сайт СтеклоЦентр.ПТЗ</a:t>
             </a:r>
+            <a:endParaRPr sz="900" b="0" i="0">
+              <a:latin typeface="Montserrat"/>
+            </a:endParaRPr>
           </a:p>
         </p:txBody>
       </p:sp>
@@ -4750,8 +4837,8 @@
           <a:noFill/>
         </p:spPr>
         <p:txBody>
-          <a:bodyPr wrap="none" lIns="18288" rIns="18288" tIns="18288" bIns="18288" anchor="t">
-            <a:spAutoFit/>
+          <a:bodyPr wrap="square" lIns="18288" rIns="18288" tIns="18288" bIns="18288" anchor="t">
+            <a:noAutofit/>
           </a:bodyPr>
           <a:lstStyle/>
           <a:p>
@@ -4761,7 +4848,7 @@
               </a:lnSpc>
             </a:pPr>
             <a:r>
-              <a:rPr sz="850" b="1">
+              <a:rPr sz="800" b="0" i="0">
                 <a:solidFill>
                   <a:srgbClr val="667085"/>
                 </a:solidFill>
@@ -4769,6 +4856,9 @@
               </a:rPr>
               <a:t>WEBOPTIMIZE  •  WEBOPTIMIZE.RU</a:t>
             </a:r>
+            <a:endParaRPr sz="800" b="0" i="0">
+              <a:latin typeface="Montserrat"/>
+            </a:endParaRPr>
           </a:p>
         </p:txBody>
       </p:sp>
@@ -4815,8 +4905,8 @@
           <a:noFill/>
         </p:spPr>
         <p:txBody>
-          <a:bodyPr wrap="none" lIns="18288" rIns="18288" tIns="18288" bIns="18288" anchor="t">
-            <a:spAutoFit/>
+          <a:bodyPr wrap="square" lIns="18288" rIns="18288" tIns="18288" bIns="18288" anchor="t">
+            <a:noAutofit/>
           </a:bodyPr>
           <a:lstStyle/>
           <a:p>
@@ -4826,7 +4916,7 @@
               </a:lnSpc>
             </a:pPr>
             <a:r>
-              <a:rPr sz="1100" b="1">
+              <a:rPr sz="1100" b="0" i="0">
                 <a:solidFill>
                   <a:srgbClr val="008C8C"/>
                 </a:solidFill>
@@ -4834,6 +4924,9 @@
               </a:rPr>
               <a:t>ЗАДАЧА</a:t>
             </a:r>
+            <a:endParaRPr sz="1100" b="0" i="0">
+              <a:latin typeface="Montserrat"/>
+            </a:endParaRPr>
           </a:p>
         </p:txBody>
       </p:sp>
@@ -4854,8 +4947,8 @@
           <a:noFill/>
         </p:spPr>
         <p:txBody>
-          <a:bodyPr wrap="none" lIns="18288" rIns="18288" tIns="18288" bIns="18288" anchor="t">
-            <a:spAutoFit/>
+          <a:bodyPr wrap="square" lIns="18288" rIns="18288" tIns="18288" bIns="18288" anchor="t">
+            <a:noAutofit/>
           </a:bodyPr>
           <a:lstStyle/>
           <a:p>
@@ -4865,7 +4958,7 @@
               </a:lnSpc>
             </a:pPr>
             <a:r>
-              <a:rPr sz="2600" b="1">
+              <a:rPr sz="2600" b="0" i="0">
                 <a:solidFill>
                   <a:srgbClr val="15243A"/>
                 </a:solidFill>
@@ -4873,6 +4966,9 @@
               </a:rPr>
               <a:t>Между сделкой и производством был разрыв</a:t>
             </a:r>
+            <a:endParaRPr sz="2600" b="0" i="0">
+              <a:latin typeface="Montserrat"/>
+            </a:endParaRPr>
           </a:p>
         </p:txBody>
       </p:sp>
@@ -4893,8 +4989,8 @@
           <a:noFill/>
         </p:spPr>
         <p:txBody>
-          <a:bodyPr wrap="none" lIns="18288" rIns="18288" tIns="18288" bIns="18288" anchor="t">
-            <a:spAutoFit/>
+          <a:bodyPr wrap="square" lIns="18288" rIns="18288" tIns="18288" bIns="18288" anchor="t">
+            <a:noAutofit/>
           </a:bodyPr>
           <a:lstStyle/>
           <a:p>
@@ -4904,7 +5000,7 @@
               </a:lnSpc>
             </a:pPr>
             <a:r>
-              <a:rPr sz="1200" b="1">
+              <a:rPr sz="1200" b="0" i="0">
                 <a:solidFill>
                   <a:srgbClr val="667085"/>
                 </a:solidFill>
@@ -4912,6 +5008,9 @@
               </a:rPr>
               <a:t>03</a:t>
             </a:r>
+            <a:endParaRPr sz="1200" b="0" i="0">
+              <a:latin typeface="Montserrat"/>
+            </a:endParaRPr>
           </a:p>
         </p:txBody>
       </p:sp>
@@ -4977,8 +5076,8 @@
           <a:noFill/>
         </p:spPr>
         <p:txBody>
-          <a:bodyPr wrap="none" lIns="18288" rIns="18288" tIns="18288" bIns="18288" anchor="t">
-            <a:spAutoFit/>
+          <a:bodyPr wrap="square" lIns="18288" rIns="18288" tIns="18288" bIns="18288" anchor="t">
+            <a:noAutofit/>
           </a:bodyPr>
           <a:lstStyle/>
           <a:p>
@@ -4988,7 +5087,7 @@
               </a:lnSpc>
             </a:pPr>
             <a:r>
-              <a:rPr sz="1000" b="1">
+              <a:rPr sz="1000" b="0" i="0">
                 <a:solidFill>
                   <a:srgbClr val="008C8C"/>
                 </a:solidFill>
@@ -4996,6 +5095,9 @@
               </a:rPr>
               <a:t>01</a:t>
             </a:r>
+            <a:endParaRPr sz="1000" b="0" i="0">
+              <a:latin typeface="Montserrat"/>
+            </a:endParaRPr>
           </a:p>
         </p:txBody>
       </p:sp>
@@ -5016,8 +5118,8 @@
           <a:noFill/>
         </p:spPr>
         <p:txBody>
-          <a:bodyPr wrap="none" lIns="18288" rIns="18288" tIns="18288" bIns="18288" anchor="t">
-            <a:spAutoFit/>
+          <a:bodyPr wrap="square" lIns="18288" rIns="18288" tIns="18288" bIns="18288" anchor="t">
+            <a:noAutofit/>
           </a:bodyPr>
           <a:lstStyle/>
           <a:p>
@@ -5027,7 +5129,7 @@
               </a:lnSpc>
             </a:pPr>
             <a:r>
-              <a:rPr sz="1500" b="1">
+              <a:rPr sz="1500" b="0" i="0">
                 <a:solidFill>
                   <a:srgbClr val="15243A"/>
                 </a:solidFill>
@@ -5035,6 +5137,9 @@
               </a:rPr>
               <a:t>Два рабочих пространства</a:t>
             </a:r>
+            <a:endParaRPr sz="1500" b="0" i="0">
+              <a:latin typeface="Montserrat"/>
+            </a:endParaRPr>
           </a:p>
         </p:txBody>
       </p:sp>
@@ -5055,8 +5160,8 @@
           <a:noFill/>
         </p:spPr>
         <p:txBody>
-          <a:bodyPr wrap="none" lIns="18288" rIns="18288" tIns="18288" bIns="18288" anchor="t">
-            <a:spAutoFit/>
+          <a:bodyPr wrap="square" lIns="18288" rIns="18288" tIns="18288" bIns="18288" anchor="t">
+            <a:noAutofit/>
           </a:bodyPr>
           <a:lstStyle/>
           <a:p>
@@ -5066,7 +5171,7 @@
               </a:lnSpc>
             </a:pPr>
             <a:r>
-              <a:rPr sz="1120" b="0">
+              <a:rPr sz="1100" b="0" i="0">
                 <a:solidFill>
                   <a:srgbClr val="667085"/>
                 </a:solidFill>
@@ -5074,6 +5179,9 @@
               </a:rPr>
               <a:t>Менеджер — в Bitrix24, производство — в 1С.</a:t>
             </a:r>
+            <a:endParaRPr sz="1100" b="0" i="0">
+              <a:latin typeface="Montserrat"/>
+            </a:endParaRPr>
           </a:p>
         </p:txBody>
       </p:sp>
@@ -5139,8 +5247,8 @@
           <a:noFill/>
         </p:spPr>
         <p:txBody>
-          <a:bodyPr wrap="none" lIns="18288" rIns="18288" tIns="18288" bIns="18288" anchor="t">
-            <a:spAutoFit/>
+          <a:bodyPr wrap="square" lIns="18288" rIns="18288" tIns="18288" bIns="18288" anchor="t">
+            <a:noAutofit/>
           </a:bodyPr>
           <a:lstStyle/>
           <a:p>
@@ -5150,7 +5258,7 @@
               </a:lnSpc>
             </a:pPr>
             <a:r>
-              <a:rPr sz="1000" b="1">
+              <a:rPr sz="1000" b="0" i="0">
                 <a:solidFill>
                   <a:srgbClr val="008C8C"/>
                 </a:solidFill>
@@ -5158,6 +5266,9 @@
               </a:rPr>
               <a:t>02</a:t>
             </a:r>
+            <a:endParaRPr sz="1000" b="0" i="0">
+              <a:latin typeface="Montserrat"/>
+            </a:endParaRPr>
           </a:p>
         </p:txBody>
       </p:sp>
@@ -5178,8 +5289,8 @@
           <a:noFill/>
         </p:spPr>
         <p:txBody>
-          <a:bodyPr wrap="none" lIns="18288" rIns="18288" tIns="18288" bIns="18288" anchor="t">
-            <a:spAutoFit/>
+          <a:bodyPr wrap="square" lIns="18288" rIns="18288" tIns="18288" bIns="18288" anchor="t">
+            <a:noAutofit/>
           </a:bodyPr>
           <a:lstStyle/>
           <a:p>
@@ -5189,7 +5300,7 @@
               </a:lnSpc>
             </a:pPr>
             <a:r>
-              <a:rPr sz="1500" b="1">
+              <a:rPr sz="1500" b="0" i="0">
                 <a:solidFill>
                   <a:srgbClr val="15243A"/>
                 </a:solidFill>
@@ -5197,6 +5308,9 @@
               </a:rPr>
               <a:t>Ручная сверка</a:t>
             </a:r>
+            <a:endParaRPr sz="1500" b="0" i="0">
+              <a:latin typeface="Montserrat"/>
+            </a:endParaRPr>
           </a:p>
         </p:txBody>
       </p:sp>
@@ -5217,8 +5331,8 @@
           <a:noFill/>
         </p:spPr>
         <p:txBody>
-          <a:bodyPr wrap="none" lIns="18288" rIns="18288" tIns="18288" bIns="18288" anchor="t">
-            <a:spAutoFit/>
+          <a:bodyPr wrap="square" lIns="18288" rIns="18288" tIns="18288" bIns="18288" anchor="t">
+            <a:noAutofit/>
           </a:bodyPr>
           <a:lstStyle/>
           <a:p>
@@ -5228,7 +5342,7 @@
               </a:lnSpc>
             </a:pPr>
             <a:r>
-              <a:rPr sz="1120" b="0">
+              <a:rPr sz="1100" b="0" i="0">
                 <a:solidFill>
                   <a:srgbClr val="667085"/>
                 </a:solidFill>
@@ -5236,6 +5350,9 @@
               </a:rPr>
               <a:t>Номер, статус, сроки и сумма уточняются отдельно.</a:t>
             </a:r>
+            <a:endParaRPr sz="1100" b="0" i="0">
+              <a:latin typeface="Montserrat"/>
+            </a:endParaRPr>
           </a:p>
         </p:txBody>
       </p:sp>
@@ -5301,8 +5418,8 @@
           <a:noFill/>
         </p:spPr>
         <p:txBody>
-          <a:bodyPr wrap="none" lIns="18288" rIns="18288" tIns="18288" bIns="18288" anchor="t">
-            <a:spAutoFit/>
+          <a:bodyPr wrap="square" lIns="18288" rIns="18288" tIns="18288" bIns="18288" anchor="t">
+            <a:noAutofit/>
           </a:bodyPr>
           <a:lstStyle/>
           <a:p>
@@ -5312,7 +5429,7 @@
               </a:lnSpc>
             </a:pPr>
             <a:r>
-              <a:rPr sz="1000" b="1">
+              <a:rPr sz="1000" b="0" i="0">
                 <a:solidFill>
                   <a:srgbClr val="008C8C"/>
                 </a:solidFill>
@@ -5320,6 +5437,9 @@
               </a:rPr>
               <a:t>03</a:t>
             </a:r>
+            <a:endParaRPr sz="1000" b="0" i="0">
+              <a:latin typeface="Montserrat"/>
+            </a:endParaRPr>
           </a:p>
         </p:txBody>
       </p:sp>
@@ -5340,8 +5460,8 @@
           <a:noFill/>
         </p:spPr>
         <p:txBody>
-          <a:bodyPr wrap="none" lIns="18288" rIns="18288" tIns="18288" bIns="18288" anchor="t">
-            <a:spAutoFit/>
+          <a:bodyPr wrap="square" lIns="18288" rIns="18288" tIns="18288" bIns="18288" anchor="t">
+            <a:noAutofit/>
           </a:bodyPr>
           <a:lstStyle/>
           <a:p>
@@ -5351,7 +5471,7 @@
               </a:lnSpc>
             </a:pPr>
             <a:r>
-              <a:rPr sz="1500" b="1">
+              <a:rPr sz="1500" b="0" i="0">
                 <a:solidFill>
                   <a:srgbClr val="15243A"/>
                 </a:solidFill>
@@ -5359,6 +5479,9 @@
               </a:rPr>
               <a:t>Риск дубля</a:t>
             </a:r>
+            <a:endParaRPr sz="1500" b="0" i="0">
+              <a:latin typeface="Montserrat"/>
+            </a:endParaRPr>
           </a:p>
         </p:txBody>
       </p:sp>
@@ -5379,8 +5502,8 @@
           <a:noFill/>
         </p:spPr>
         <p:txBody>
-          <a:bodyPr wrap="none" lIns="18288" rIns="18288" tIns="18288" bIns="18288" anchor="t">
-            <a:spAutoFit/>
+          <a:bodyPr wrap="square" lIns="18288" rIns="18288" tIns="18288" bIns="18288" anchor="t">
+            <a:noAutofit/>
           </a:bodyPr>
           <a:lstStyle/>
           <a:p>
@@ -5390,7 +5513,7 @@
               </a:lnSpc>
             </a:pPr>
             <a:r>
-              <a:rPr sz="1120" b="0">
+              <a:rPr sz="1100" b="0" i="0">
                 <a:solidFill>
                   <a:srgbClr val="667085"/>
                 </a:solidFill>
@@ -5398,6 +5521,9 @@
               </a:rPr>
               <a:t>Повторная передача может создать второй заказ.</a:t>
             </a:r>
+            <a:endParaRPr sz="1100" b="0" i="0">
+              <a:latin typeface="Montserrat"/>
+            </a:endParaRPr>
           </a:p>
         </p:txBody>
       </p:sp>
@@ -5463,8 +5589,8 @@
           <a:noFill/>
         </p:spPr>
         <p:txBody>
-          <a:bodyPr wrap="none" lIns="18288" rIns="18288" tIns="18288" bIns="18288" anchor="t">
-            <a:spAutoFit/>
+          <a:bodyPr wrap="square" lIns="18288" rIns="18288" tIns="18288" bIns="18288" anchor="t">
+            <a:noAutofit/>
           </a:bodyPr>
           <a:lstStyle/>
           <a:p>
@@ -5474,7 +5600,7 @@
               </a:lnSpc>
             </a:pPr>
             <a:r>
-              <a:rPr sz="1000" b="1">
+              <a:rPr sz="1000" b="0" i="0">
                 <a:solidFill>
                   <a:srgbClr val="008C8C"/>
                 </a:solidFill>
@@ -5482,6 +5608,9 @@
               </a:rPr>
               <a:t>04</a:t>
             </a:r>
+            <a:endParaRPr sz="1000" b="0" i="0">
+              <a:latin typeface="Montserrat"/>
+            </a:endParaRPr>
           </a:p>
         </p:txBody>
       </p:sp>
@@ -5502,8 +5631,8 @@
           <a:noFill/>
         </p:spPr>
         <p:txBody>
-          <a:bodyPr wrap="none" lIns="18288" rIns="18288" tIns="18288" bIns="18288" anchor="t">
-            <a:spAutoFit/>
+          <a:bodyPr wrap="square" lIns="18288" rIns="18288" tIns="18288" bIns="18288" anchor="t">
+            <a:noAutofit/>
           </a:bodyPr>
           <a:lstStyle/>
           <a:p>
@@ -5513,7 +5642,7 @@
               </a:lnSpc>
             </a:pPr>
             <a:r>
-              <a:rPr sz="1500" b="1">
+              <a:rPr sz="1500" b="0" i="0">
                 <a:solidFill>
                   <a:srgbClr val="15243A"/>
                 </a:solidFill>
@@ -5521,6 +5650,9 @@
               </a:rPr>
               <a:t>Закрытая 1С</a:t>
             </a:r>
+            <a:endParaRPr sz="1500" b="0" i="0">
+              <a:latin typeface="Montserrat"/>
+            </a:endParaRPr>
           </a:p>
         </p:txBody>
       </p:sp>
@@ -5541,8 +5673,8 @@
           <a:noFill/>
         </p:spPr>
         <p:txBody>
-          <a:bodyPr wrap="none" lIns="18288" rIns="18288" tIns="18288" bIns="18288" anchor="t">
-            <a:spAutoFit/>
+          <a:bodyPr wrap="square" lIns="18288" rIns="18288" tIns="18288" bIns="18288" anchor="t">
+            <a:noAutofit/>
           </a:bodyPr>
           <a:lstStyle/>
           <a:p>
@@ -5552,7 +5684,7 @@
               </a:lnSpc>
             </a:pPr>
             <a:r>
-              <a:rPr sz="1120" b="0">
+              <a:rPr sz="1100" b="0" i="0">
                 <a:solidFill>
                   <a:srgbClr val="667085"/>
                 </a:solidFill>
@@ -5560,6 +5692,9 @@
               </a:rPr>
               <a:t>Старую базу нельзя публиковать в интернет.</a:t>
             </a:r>
+            <a:endParaRPr sz="1100" b="0" i="0">
+              <a:latin typeface="Montserrat"/>
+            </a:endParaRPr>
           </a:p>
         </p:txBody>
       </p:sp>
@@ -5625,8 +5760,8 @@
           <a:noFill/>
         </p:spPr>
         <p:txBody>
-          <a:bodyPr wrap="none" lIns="18288" rIns="18288" tIns="18288" bIns="18288" anchor="t">
-            <a:spAutoFit/>
+          <a:bodyPr wrap="square" lIns="18288" rIns="18288" tIns="18288" bIns="18288" anchor="t">
+            <a:noAutofit/>
           </a:bodyPr>
           <a:lstStyle/>
           <a:p>
@@ -5636,7 +5771,7 @@
               </a:lnSpc>
             </a:pPr>
             <a:r>
-              <a:rPr sz="1000" b="1">
+              <a:rPr sz="1000" b="0" i="0">
                 <a:solidFill>
                   <a:srgbClr val="008C8C"/>
                 </a:solidFill>
@@ -5644,6 +5779,9 @@
               </a:rPr>
               <a:t>05</a:t>
             </a:r>
+            <a:endParaRPr sz="1000" b="0" i="0">
+              <a:latin typeface="Montserrat"/>
+            </a:endParaRPr>
           </a:p>
         </p:txBody>
       </p:sp>
@@ -5664,8 +5802,8 @@
           <a:noFill/>
         </p:spPr>
         <p:txBody>
-          <a:bodyPr wrap="none" lIns="18288" rIns="18288" tIns="18288" bIns="18288" anchor="t">
-            <a:spAutoFit/>
+          <a:bodyPr wrap="square" lIns="18288" rIns="18288" tIns="18288" bIns="18288" anchor="t">
+            <a:noAutofit/>
           </a:bodyPr>
           <a:lstStyle/>
           <a:p>
@@ -5675,14 +5813,17 @@
               </a:lnSpc>
             </a:pPr>
             <a:r>
-              <a:rPr sz="1500" b="1">
+              <a:rPr sz="1500" b="0" i="0">
                 <a:solidFill>
                   <a:srgbClr val="15243A"/>
                 </a:solidFill>
                 <a:latin typeface="Montserrat"/>
               </a:rPr>
-              <a:t>Нестандартный документ</a:t>
-            </a:r>
+              <a:t>Собственная форма заказа</a:t>
+            </a:r>
+            <a:endParaRPr sz="1500" b="0" i="0">
+              <a:latin typeface="Montserrat"/>
+            </a:endParaRPr>
           </a:p>
         </p:txBody>
       </p:sp>
@@ -5703,8 +5844,8 @@
           <a:noFill/>
         </p:spPr>
         <p:txBody>
-          <a:bodyPr wrap="none" lIns="18288" rIns="18288" tIns="18288" bIns="18288" anchor="t">
-            <a:spAutoFit/>
+          <a:bodyPr wrap="square" lIns="18288" rIns="18288" tIns="18288" bIns="18288" anchor="t">
+            <a:noAutofit/>
           </a:bodyPr>
           <a:lstStyle/>
           <a:p>
@@ -5714,14 +5855,17 @@
               </a:lnSpc>
             </a:pPr>
             <a:r>
-              <a:rPr sz="1120" b="0">
+              <a:rPr sz="1100" b="0" i="0">
                 <a:solidFill>
                   <a:srgbClr val="667085"/>
                 </a:solidFill>
                 <a:latin typeface="Montserrat"/>
               </a:rPr>
-              <a:t>Работа строится вокруг собственного ЗаказОбщий.</a:t>
-            </a:r>
+              <a:t>Производство работает в привычном заказе 1С.</a:t>
+            </a:r>
+            <a:endParaRPr sz="1100" b="0" i="0">
+              <a:latin typeface="Montserrat"/>
+            </a:endParaRPr>
           </a:p>
         </p:txBody>
       </p:sp>
@@ -5787,8 +5931,8 @@
           <a:noFill/>
         </p:spPr>
         <p:txBody>
-          <a:bodyPr wrap="none" lIns="18288" rIns="18288" tIns="18288" bIns="18288" anchor="t">
-            <a:spAutoFit/>
+          <a:bodyPr wrap="square" lIns="18288" rIns="18288" tIns="18288" bIns="18288" anchor="t">
+            <a:noAutofit/>
           </a:bodyPr>
           <a:lstStyle/>
           <a:p>
@@ -5798,7 +5942,7 @@
               </a:lnSpc>
             </a:pPr>
             <a:r>
-              <a:rPr sz="1000" b="1">
+              <a:rPr sz="1000" b="0" i="0">
                 <a:solidFill>
                   <a:srgbClr val="008C8C"/>
                 </a:solidFill>
@@ -5806,6 +5950,9 @@
               </a:rPr>
               <a:t>06</a:t>
             </a:r>
+            <a:endParaRPr sz="1000" b="0" i="0">
+              <a:latin typeface="Montserrat"/>
+            </a:endParaRPr>
           </a:p>
         </p:txBody>
       </p:sp>
@@ -5826,8 +5973,8 @@
           <a:noFill/>
         </p:spPr>
         <p:txBody>
-          <a:bodyPr wrap="none" lIns="18288" rIns="18288" tIns="18288" bIns="18288" anchor="t">
-            <a:spAutoFit/>
+          <a:bodyPr wrap="square" lIns="18288" rIns="18288" tIns="18288" bIns="18288" anchor="t">
+            <a:noAutofit/>
           </a:bodyPr>
           <a:lstStyle/>
           <a:p>
@@ -5837,7 +5984,7 @@
               </a:lnSpc>
             </a:pPr>
             <a:r>
-              <a:rPr sz="1500" b="1">
+              <a:rPr sz="1500" b="0" i="0">
                 <a:solidFill>
                   <a:srgbClr val="15243A"/>
                 </a:solidFill>
@@ -5845,6 +5992,9 @@
               </a:rPr>
               <a:t>Нет штатного коннектора</a:t>
             </a:r>
+            <a:endParaRPr sz="1500" b="0" i="0">
+              <a:latin typeface="Montserrat"/>
+            </a:endParaRPr>
           </a:p>
         </p:txBody>
       </p:sp>
@@ -5865,8 +6015,8 @@
           <a:noFill/>
         </p:spPr>
         <p:txBody>
-          <a:bodyPr wrap="none" lIns="18288" rIns="18288" tIns="18288" bIns="18288" anchor="t">
-            <a:spAutoFit/>
+          <a:bodyPr wrap="square" lIns="18288" rIns="18288" tIns="18288" bIns="18288" anchor="t">
+            <a:noAutofit/>
           </a:bodyPr>
           <a:lstStyle/>
           <a:p>
@@ -5876,14 +6026,17 @@
               </a:lnSpc>
             </a:pPr>
             <a:r>
-              <a:rPr sz="1120" b="0">
+              <a:rPr sz="1100" b="0" i="0">
                 <a:solidFill>
                   <a:srgbClr val="667085"/>
                 </a:solidFill>
                 <a:latin typeface="Montserrat"/>
               </a:rPr>
-              <a:t>Целевой legacy-контур требует отдельного адаптера.</a:t>
-            </a:r>
+              <a:t>Устаревшая конфигурация требует отдельного адаптера.</a:t>
+            </a:r>
+            <a:endParaRPr sz="1100" b="0" i="0">
+              <a:latin typeface="Montserrat"/>
+            </a:endParaRPr>
           </a:p>
         </p:txBody>
       </p:sp>
@@ -5904,8 +6057,8 @@
           <a:noFill/>
         </p:spPr>
         <p:txBody>
-          <a:bodyPr wrap="none" lIns="18288" rIns="18288" tIns="18288" bIns="18288" anchor="t">
-            <a:spAutoFit/>
+          <a:bodyPr wrap="square" lIns="18288" rIns="18288" tIns="18288" bIns="18288" anchor="t">
+            <a:noAutofit/>
           </a:bodyPr>
           <a:lstStyle/>
           <a:p>
@@ -5915,7 +6068,7 @@
               </a:lnSpc>
             </a:pPr>
             <a:r>
-              <a:rPr sz="850" b="1">
+              <a:rPr sz="800" b="0" i="0">
                 <a:solidFill>
                   <a:srgbClr val="667085"/>
                 </a:solidFill>
@@ -5923,6 +6076,9 @@
               </a:rPr>
               <a:t>WEBOPTIMIZE  •  WEBOPTIMIZE.RU</a:t>
             </a:r>
+            <a:endParaRPr sz="800" b="0" i="0">
+              <a:latin typeface="Montserrat"/>
+            </a:endParaRPr>
           </a:p>
         </p:txBody>
       </p:sp>
@@ -5969,8 +6125,8 @@
           <a:noFill/>
         </p:spPr>
         <p:txBody>
-          <a:bodyPr wrap="none" lIns="18288" rIns="18288" tIns="18288" bIns="18288" anchor="t">
-            <a:spAutoFit/>
+          <a:bodyPr wrap="square" lIns="18288" rIns="18288" tIns="18288" bIns="18288" anchor="t">
+            <a:noAutofit/>
           </a:bodyPr>
           <a:lstStyle/>
           <a:p>
@@ -5980,14 +6136,17 @@
               </a:lnSpc>
             </a:pPr>
             <a:r>
-              <a:rPr sz="1100" b="1">
+              <a:rPr sz="1100" b="0" i="0">
                 <a:solidFill>
                   <a:srgbClr val="008C8C"/>
                 </a:solidFill>
                 <a:latin typeface="Montserrat"/>
               </a:rPr>
-              <a:t>АРХИТЕКТУРА</a:t>
-            </a:r>
+              <a:t>КАК УСТРОЕНО</a:t>
+            </a:r>
+            <a:endParaRPr sz="1100" b="0" i="0">
+              <a:latin typeface="Montserrat"/>
+            </a:endParaRPr>
           </a:p>
         </p:txBody>
       </p:sp>
@@ -6008,8 +6167,8 @@
           <a:noFill/>
         </p:spPr>
         <p:txBody>
-          <a:bodyPr wrap="none" lIns="18288" rIns="18288" tIns="18288" bIns="18288" anchor="t">
-            <a:spAutoFit/>
+          <a:bodyPr wrap="square" lIns="18288" rIns="18288" tIns="18288" bIns="18288" anchor="t">
+            <a:noAutofit/>
           </a:bodyPr>
           <a:lstStyle/>
           <a:p>
@@ -6019,14 +6178,17 @@
               </a:lnSpc>
             </a:pPr>
             <a:r>
-              <a:rPr sz="2600" b="1">
+              <a:rPr sz="2400" b="0" i="0">
                 <a:solidFill>
                   <a:srgbClr val="15243A"/>
                 </a:solidFill>
                 <a:latin typeface="Montserrat"/>
               </a:rPr>
-              <a:t>1С остаётся закрытой, обмен выполняется локально</a:t>
-            </a:r>
+              <a:t>1С остаётся закрытой, обмен идёт через сервер компании</a:t>
+            </a:r>
+            <a:endParaRPr sz="2400" b="0" i="0">
+              <a:latin typeface="Montserrat"/>
+            </a:endParaRPr>
           </a:p>
         </p:txBody>
       </p:sp>
@@ -6047,8 +6209,8 @@
           <a:noFill/>
         </p:spPr>
         <p:txBody>
-          <a:bodyPr wrap="none" lIns="18288" rIns="18288" tIns="18288" bIns="18288" anchor="t">
-            <a:spAutoFit/>
+          <a:bodyPr wrap="square" lIns="18288" rIns="18288" tIns="18288" bIns="18288" anchor="t">
+            <a:noAutofit/>
           </a:bodyPr>
           <a:lstStyle/>
           <a:p>
@@ -6058,7 +6220,7 @@
               </a:lnSpc>
             </a:pPr>
             <a:r>
-              <a:rPr sz="1200" b="1">
+              <a:rPr sz="1200" b="0" i="0">
                 <a:solidFill>
                   <a:srgbClr val="667085"/>
                 </a:solidFill>
@@ -6066,6 +6228,9 @@
               </a:rPr>
               <a:t>04</a:t>
             </a:r>
+            <a:endParaRPr sz="1200" b="0" i="0">
+              <a:latin typeface="Montserrat"/>
+            </a:endParaRPr>
           </a:p>
         </p:txBody>
       </p:sp>
@@ -6146,17 +6311,17 @@
         </p:nvSpPr>
         <p:spPr>
           <a:xfrm>
-            <a:off x="640080" y="5413248"/>
-            <a:ext cx="1371600" cy="274320"/>
-          </a:xfrm>
-          <a:prstGeom prst="rect">
-            <a:avLst/>
-          </a:prstGeom>
-          <a:noFill/>
-        </p:spPr>
-        <p:txBody>
-          <a:bodyPr wrap="none" lIns="18288" rIns="18288" tIns="18288" bIns="18288" anchor="t">
-            <a:spAutoFit/>
+            <a:off x="640080" y="5376672"/>
+            <a:ext cx="3246120" cy="347472"/>
+          </a:xfrm>
+          <a:prstGeom prst="rect">
+            <a:avLst/>
+          </a:prstGeom>
+          <a:noFill/>
+        </p:spPr>
+        <p:txBody>
+          <a:bodyPr wrap="square" lIns="18288" rIns="18288" tIns="18288" bIns="18288" anchor="t">
+            <a:noAutofit/>
           </a:bodyPr>
           <a:lstStyle/>
           <a:p>
@@ -6166,14 +6331,17 @@
               </a:lnSpc>
             </a:pPr>
             <a:r>
-              <a:rPr sz="1300" b="1">
+              <a:rPr sz="1300" b="0" i="0">
                 <a:solidFill>
                   <a:srgbClr val="008C8C"/>
                 </a:solidFill>
                 <a:latin typeface="Montserrat"/>
               </a:rPr>
-              <a:t>HTTPS 443</a:t>
-            </a:r>
+              <a:t>Защищённая связь</a:t>
+            </a:r>
+            <a:endParaRPr sz="1300" b="0" i="0">
+              <a:latin typeface="Montserrat"/>
+            </a:endParaRPr>
           </a:p>
         </p:txBody>
       </p:sp>
@@ -6194,8 +6362,8 @@
           <a:noFill/>
         </p:spPr>
         <p:txBody>
-          <a:bodyPr wrap="none" lIns="18288" rIns="18288" tIns="18288" bIns="18288" anchor="t">
-            <a:spAutoFit/>
+          <a:bodyPr wrap="square" lIns="18288" rIns="18288" tIns="18288" bIns="18288" anchor="t">
+            <a:noAutofit/>
           </a:bodyPr>
           <a:lstStyle/>
           <a:p>
@@ -6205,14 +6373,17 @@
               </a:lnSpc>
             </a:pPr>
             <a:r>
-              <a:rPr sz="1050" b="0">
+              <a:rPr sz="1000" b="0" i="0">
                 <a:solidFill>
                   <a:srgbClr val="667085"/>
                 </a:solidFill>
                 <a:latin typeface="Montserrat"/>
               </a:rPr>
-              <a:t>только исходящее соединение</a:t>
-            </a:r>
+              <a:t>обмен идёт через сервер компании</a:t>
+            </a:r>
+            <a:endParaRPr sz="1000" b="0" i="0">
+              <a:latin typeface="Montserrat"/>
+            </a:endParaRPr>
           </a:p>
         </p:txBody>
       </p:sp>
@@ -6224,17 +6395,17 @@
         </p:nvSpPr>
         <p:spPr>
           <a:xfrm>
-            <a:off x="4343400" y="5413248"/>
-            <a:ext cx="1371600" cy="274320"/>
-          </a:xfrm>
-          <a:prstGeom prst="rect">
-            <a:avLst/>
-          </a:prstGeom>
-          <a:noFill/>
-        </p:spPr>
-        <p:txBody>
-          <a:bodyPr wrap="none" lIns="18288" rIns="18288" tIns="18288" bIns="18288" anchor="t">
-            <a:spAutoFit/>
+            <a:off x="4343400" y="5376672"/>
+            <a:ext cx="3246120" cy="347472"/>
+          </a:xfrm>
+          <a:prstGeom prst="rect">
+            <a:avLst/>
+          </a:prstGeom>
+          <a:noFill/>
+        </p:spPr>
+        <p:txBody>
+          <a:bodyPr wrap="square" lIns="18288" rIns="18288" tIns="18288" bIns="18288" anchor="t">
+            <a:noAutofit/>
           </a:bodyPr>
           <a:lstStyle/>
           <a:p>
@@ -6244,14 +6415,17 @@
               </a:lnSpc>
             </a:pPr>
             <a:r>
-              <a:rPr sz="1300" b="1">
+              <a:rPr sz="1300" b="0" i="0">
                 <a:solidFill>
                   <a:srgbClr val="008C8C"/>
                 </a:solidFill>
                 <a:latin typeface="Montserrat"/>
               </a:rPr>
-              <a:t>DPAPI</a:t>
-            </a:r>
+              <a:t>Доступы защищены</a:t>
+            </a:r>
+            <a:endParaRPr sz="1300" b="0" i="0">
+              <a:latin typeface="Montserrat"/>
+            </a:endParaRPr>
           </a:p>
         </p:txBody>
       </p:sp>
@@ -6272,8 +6446,8 @@
           <a:noFill/>
         </p:spPr>
         <p:txBody>
-          <a:bodyPr wrap="none" lIns="18288" rIns="18288" tIns="18288" bIns="18288" anchor="t">
-            <a:spAutoFit/>
+          <a:bodyPr wrap="square" lIns="18288" rIns="18288" tIns="18288" bIns="18288" anchor="t">
+            <a:noAutofit/>
           </a:bodyPr>
           <a:lstStyle/>
           <a:p>
@@ -6283,14 +6457,17 @@
               </a:lnSpc>
             </a:pPr>
             <a:r>
-              <a:rPr sz="1050" b="0">
+              <a:rPr sz="1000" b="0" i="0">
                 <a:solidFill>
                   <a:srgbClr val="667085"/>
                 </a:solidFill>
                 <a:latin typeface="Montserrat"/>
               </a:rPr>
-              <a:t>секреты защищены локально</a:t>
-            </a:r>
+              <a:t>хранятся только на сервере</a:t>
+            </a:r>
+            <a:endParaRPr sz="1000" b="0" i="0">
+              <a:latin typeface="Montserrat"/>
+            </a:endParaRPr>
           </a:p>
         </p:txBody>
       </p:sp>
@@ -6302,17 +6479,17 @@
         </p:nvSpPr>
         <p:spPr>
           <a:xfrm>
-            <a:off x="8046719" y="5413248"/>
-            <a:ext cx="1371600" cy="274320"/>
-          </a:xfrm>
-          <a:prstGeom prst="rect">
-            <a:avLst/>
-          </a:prstGeom>
-          <a:noFill/>
-        </p:spPr>
-        <p:txBody>
-          <a:bodyPr wrap="none" lIns="18288" rIns="18288" tIns="18288" bIns="18288" anchor="t">
-            <a:spAutoFit/>
+            <a:off x="8046719" y="5376672"/>
+            <a:ext cx="3246120" cy="347472"/>
+          </a:xfrm>
+          <a:prstGeom prst="rect">
+            <a:avLst/>
+          </a:prstGeom>
+          <a:noFill/>
+        </p:spPr>
+        <p:txBody>
+          <a:bodyPr wrap="square" lIns="18288" rIns="18288" tIns="18288" bIns="18288" anchor="t">
+            <a:noAutofit/>
           </a:bodyPr>
           <a:lstStyle/>
           <a:p>
@@ -6322,14 +6499,17 @@
               </a:lnSpc>
             </a:pPr>
             <a:r>
-              <a:rPr sz="1300" b="1">
+              <a:rPr sz="1300" b="0" i="0">
                 <a:solidFill>
                   <a:srgbClr val="008C8C"/>
                 </a:solidFill>
                 <a:latin typeface="Montserrat"/>
               </a:rPr>
-              <a:t>0 публикаций</a:t>
-            </a:r>
+              <a:t>Закрытая 1С</a:t>
+            </a:r>
+            <a:endParaRPr sz="1300" b="0" i="0">
+              <a:latin typeface="Montserrat"/>
+            </a:endParaRPr>
           </a:p>
         </p:txBody>
       </p:sp>
@@ -6350,8 +6530,8 @@
           <a:noFill/>
         </p:spPr>
         <p:txBody>
-          <a:bodyPr wrap="none" lIns="18288" rIns="18288" tIns="18288" bIns="18288" anchor="t">
-            <a:spAutoFit/>
+          <a:bodyPr wrap="square" lIns="18288" rIns="18288" tIns="18288" bIns="18288" anchor="t">
+            <a:noAutofit/>
           </a:bodyPr>
           <a:lstStyle/>
           <a:p>
@@ -6361,14 +6541,17 @@
               </a:lnSpc>
             </a:pPr>
             <a:r>
-              <a:rPr sz="1050" b="0">
+              <a:rPr sz="1000" b="0" i="0">
                 <a:solidFill>
                   <a:srgbClr val="667085"/>
                 </a:solidFill>
                 <a:latin typeface="Montserrat"/>
               </a:rPr>
-              <a:t>IIS и HTTP-сервис 1С не нужны</a:t>
-            </a:r>
+              <a:t>база недоступна из интернета</a:t>
+            </a:r>
+            <a:endParaRPr sz="1000" b="0" i="0">
+              <a:latin typeface="Montserrat"/>
+            </a:endParaRPr>
           </a:p>
         </p:txBody>
       </p:sp>
@@ -6389,8 +6572,8 @@
           <a:noFill/>
         </p:spPr>
         <p:txBody>
-          <a:bodyPr wrap="none" lIns="18288" rIns="18288" tIns="18288" bIns="18288" anchor="t">
-            <a:spAutoFit/>
+          <a:bodyPr wrap="square" lIns="18288" rIns="18288" tIns="18288" bIns="18288" anchor="t">
+            <a:noAutofit/>
           </a:bodyPr>
           <a:lstStyle/>
           <a:p>
@@ -6400,7 +6583,7 @@
               </a:lnSpc>
             </a:pPr>
             <a:r>
-              <a:rPr sz="850" b="1">
+              <a:rPr sz="800" b="0" i="0">
                 <a:solidFill>
                   <a:srgbClr val="667085"/>
                 </a:solidFill>
@@ -6408,6 +6591,9 @@
               </a:rPr>
               <a:t>WEBOPTIMIZE  •  WEBOPTIMIZE.RU</a:t>
             </a:r>
+            <a:endParaRPr sz="800" b="0" i="0">
+              <a:latin typeface="Montserrat"/>
+            </a:endParaRPr>
           </a:p>
         </p:txBody>
       </p:sp>
@@ -6454,8 +6640,8 @@
           <a:noFill/>
         </p:spPr>
         <p:txBody>
-          <a:bodyPr wrap="none" lIns="18288" rIns="18288" tIns="18288" bIns="18288" anchor="t">
-            <a:spAutoFit/>
+          <a:bodyPr wrap="square" lIns="18288" rIns="18288" tIns="18288" bIns="18288" anchor="t">
+            <a:noAutofit/>
           </a:bodyPr>
           <a:lstStyle/>
           <a:p>
@@ -6465,7 +6651,7 @@
               </a:lnSpc>
             </a:pPr>
             <a:r>
-              <a:rPr sz="1100" b="1">
+              <a:rPr sz="1100" b="0" i="0">
                 <a:solidFill>
                   <a:srgbClr val="008C8C"/>
                 </a:solidFill>
@@ -6473,6 +6659,9 @@
               </a:rPr>
               <a:t>ПУТЬ ПОЛЬЗОВАТЕЛЯ</a:t>
             </a:r>
+            <a:endParaRPr sz="1100" b="0" i="0">
+              <a:latin typeface="Montserrat"/>
+            </a:endParaRPr>
           </a:p>
         </p:txBody>
       </p:sp>
@@ -6493,8 +6682,8 @@
           <a:noFill/>
         </p:spPr>
         <p:txBody>
-          <a:bodyPr wrap="none" lIns="18288" rIns="18288" tIns="18288" bIns="18288" anchor="t">
-            <a:spAutoFit/>
+          <a:bodyPr wrap="square" lIns="18288" rIns="18288" tIns="18288" bIns="18288" anchor="t">
+            <a:noAutofit/>
           </a:bodyPr>
           <a:lstStyle/>
           <a:p>
@@ -6504,7 +6693,7 @@
               </a:lnSpc>
             </a:pPr>
             <a:r>
-              <a:rPr sz="2600" b="1">
+              <a:rPr sz="2300" b="0" i="0">
                 <a:solidFill>
                   <a:srgbClr val="15243A"/>
                 </a:solidFill>
@@ -6512,6 +6701,9 @@
               </a:rPr>
               <a:t>Пять шагов — от заполненной сделки до актуального статуса</a:t>
             </a:r>
+            <a:endParaRPr sz="2300" b="0" i="0">
+              <a:latin typeface="Montserrat"/>
+            </a:endParaRPr>
           </a:p>
         </p:txBody>
       </p:sp>
@@ -6532,8 +6724,8 @@
           <a:noFill/>
         </p:spPr>
         <p:txBody>
-          <a:bodyPr wrap="none" lIns="18288" rIns="18288" tIns="18288" bIns="18288" anchor="t">
-            <a:spAutoFit/>
+          <a:bodyPr wrap="square" lIns="18288" rIns="18288" tIns="18288" bIns="18288" anchor="t">
+            <a:noAutofit/>
           </a:bodyPr>
           <a:lstStyle/>
           <a:p>
@@ -6543,7 +6735,7 @@
               </a:lnSpc>
             </a:pPr>
             <a:r>
-              <a:rPr sz="1200" b="1">
+              <a:rPr sz="1200" b="0" i="0">
                 <a:solidFill>
                   <a:srgbClr val="667085"/>
                 </a:solidFill>
@@ -6551,6 +6743,9 @@
               </a:rPr>
               <a:t>05</a:t>
             </a:r>
+            <a:endParaRPr sz="1200" b="0" i="0">
+              <a:latin typeface="Montserrat"/>
+            </a:endParaRPr>
           </a:p>
         </p:txBody>
       </p:sp>
@@ -6640,8 +6835,8 @@
           <a:noFill/>
         </p:spPr>
         <p:txBody>
-          <a:bodyPr wrap="none" lIns="18288" rIns="18288" tIns="18288" bIns="18288" anchor="t">
-            <a:spAutoFit/>
+          <a:bodyPr wrap="square" lIns="18288" rIns="18288" tIns="18288" bIns="18288" anchor="t">
+            <a:noAutofit/>
           </a:bodyPr>
           <a:lstStyle/>
           <a:p>
@@ -6651,7 +6846,7 @@
               </a:lnSpc>
             </a:pPr>
             <a:r>
-              <a:rPr sz="1150" b="1">
+              <a:rPr sz="1100" b="0" i="0">
                 <a:solidFill>
                   <a:srgbClr val="008C8C"/>
                 </a:solidFill>
@@ -6659,6 +6854,9 @@
               </a:rPr>
               <a:t>Менеджер работает в Bitrix24 • производство — в 1С • связь и обновления выполняются автоматически</a:t>
             </a:r>
+            <a:endParaRPr sz="1100" b="0" i="0">
+              <a:latin typeface="Montserrat"/>
+            </a:endParaRPr>
           </a:p>
         </p:txBody>
       </p:sp>
@@ -6679,8 +6877,8 @@
           <a:noFill/>
         </p:spPr>
         <p:txBody>
-          <a:bodyPr wrap="none" lIns="18288" rIns="18288" tIns="18288" bIns="18288" anchor="t">
-            <a:spAutoFit/>
+          <a:bodyPr wrap="square" lIns="18288" rIns="18288" tIns="18288" bIns="18288" anchor="t">
+            <a:noAutofit/>
           </a:bodyPr>
           <a:lstStyle/>
           <a:p>
@@ -6690,7 +6888,7 @@
               </a:lnSpc>
             </a:pPr>
             <a:r>
-              <a:rPr sz="850" b="1">
+              <a:rPr sz="800" b="0" i="0">
                 <a:solidFill>
                   <a:srgbClr val="667085"/>
                 </a:solidFill>
@@ -6698,6 +6896,9 @@
               </a:rPr>
               <a:t>WEBOPTIMIZE  •  WEBOPTIMIZE.RU</a:t>
             </a:r>
+            <a:endParaRPr sz="800" b="0" i="0">
+              <a:latin typeface="Montserrat"/>
+            </a:endParaRPr>
           </a:p>
         </p:txBody>
       </p:sp>
@@ -6744,8 +6945,8 @@
           <a:noFill/>
         </p:spPr>
         <p:txBody>
-          <a:bodyPr wrap="none" lIns="18288" rIns="18288" tIns="18288" bIns="18288" anchor="t">
-            <a:spAutoFit/>
+          <a:bodyPr wrap="square" lIns="18288" rIns="18288" tIns="18288" bIns="18288" anchor="t">
+            <a:noAutofit/>
           </a:bodyPr>
           <a:lstStyle/>
           <a:p>
@@ -6755,7 +6956,7 @@
               </a:lnSpc>
             </a:pPr>
             <a:r>
-              <a:rPr sz="1100" b="1">
+              <a:rPr sz="1100" b="0" i="0">
                 <a:solidFill>
                   <a:srgbClr val="008C8C"/>
                 </a:solidFill>
@@ -6763,6 +6964,9 @@
               </a:rPr>
               <a:t>ОБРАТНЫЙ ОБМЕН</a:t>
             </a:r>
+            <a:endParaRPr sz="1100" b="0" i="0">
+              <a:latin typeface="Montserrat"/>
+            </a:endParaRPr>
           </a:p>
         </p:txBody>
       </p:sp>
@@ -6783,8 +6987,8 @@
           <a:noFill/>
         </p:spPr>
         <p:txBody>
-          <a:bodyPr wrap="none" lIns="18288" rIns="18288" tIns="18288" bIns="18288" anchor="t">
-            <a:spAutoFit/>
+          <a:bodyPr wrap="square" lIns="18288" rIns="18288" tIns="18288" bIns="18288" anchor="t">
+            <a:noAutofit/>
           </a:bodyPr>
           <a:lstStyle/>
           <a:p>
@@ -6794,7 +6998,7 @@
               </a:lnSpc>
             </a:pPr>
             <a:r>
-              <a:rPr sz="2600" b="1">
+              <a:rPr sz="2600" b="0" i="0">
                 <a:solidFill>
                   <a:srgbClr val="15243A"/>
                 </a:solidFill>
@@ -6802,6 +7006,9 @@
               </a:rPr>
               <a:t>Изменения 1С возвращаются в исходную сделку</a:t>
             </a:r>
+            <a:endParaRPr sz="2600" b="0" i="0">
+              <a:latin typeface="Montserrat"/>
+            </a:endParaRPr>
           </a:p>
         </p:txBody>
       </p:sp>
@@ -6822,8 +7029,8 @@
           <a:noFill/>
         </p:spPr>
         <p:txBody>
-          <a:bodyPr wrap="none" lIns="18288" rIns="18288" tIns="18288" bIns="18288" anchor="t">
-            <a:spAutoFit/>
+          <a:bodyPr wrap="square" lIns="18288" rIns="18288" tIns="18288" bIns="18288" anchor="t">
+            <a:noAutofit/>
           </a:bodyPr>
           <a:lstStyle/>
           <a:p>
@@ -6833,7 +7040,7 @@
               </a:lnSpc>
             </a:pPr>
             <a:r>
-              <a:rPr sz="1200" b="1">
+              <a:rPr sz="1200" b="0" i="0">
                 <a:solidFill>
                   <a:srgbClr val="667085"/>
                 </a:solidFill>
@@ -6841,6 +7048,9 @@
               </a:rPr>
               <a:t>06</a:t>
             </a:r>
+            <a:endParaRPr sz="1200" b="0" i="0">
+              <a:latin typeface="Montserrat"/>
+            </a:endParaRPr>
           </a:p>
         </p:txBody>
       </p:sp>
@@ -6885,8 +7095,8 @@
           <a:noFill/>
         </p:spPr>
         <p:txBody>
-          <a:bodyPr wrap="none" lIns="18288" rIns="18288" tIns="18288">
-            <a:spAutoFit/>
+          <a:bodyPr wrap="square" lIns="18288" rIns="18288" tIns="18288">
+            <a:noAutofit/>
           </a:bodyPr>
           <a:lstStyle/>
           <a:p>
@@ -6905,8 +7115,14 @@
               </a:defRPr>
             </a:pPr>
             <a:r>
+              <a:rPr sz="1100" b="0" i="0">
+                <a:latin typeface="Montserrat"/>
+              </a:rPr>
               <a:t>•  1С владеет производственным статусом, сроками, суммой и переделкой</a:t>
             </a:r>
+            <a:endParaRPr sz="1100" b="0" i="0">
+              <a:latin typeface="Montserrat"/>
+            </a:endParaRPr>
           </a:p>
           <a:p>
             <a:pPr>
@@ -6924,8 +7140,14 @@
               </a:defRPr>
             </a:pPr>
             <a:r>
-              <a:t>•  worker проверяет только уже связанные заказы</a:t>
-            </a:r>
+              <a:rPr sz="1100" b="0" i="0">
+                <a:latin typeface="Montserrat"/>
+              </a:rPr>
+              <a:t>•  модуль обмена проверяет только уже связанные заказы</a:t>
+            </a:r>
+            <a:endParaRPr sz="1100" b="0" i="0">
+              <a:latin typeface="Montserrat"/>
+            </a:endParaRPr>
           </a:p>
           <a:p>
             <a:pPr>
@@ -6943,8 +7165,14 @@
               </a:defRPr>
             </a:pPr>
             <a:r>
+              <a:rPr sz="1100" b="0" i="0">
+                <a:latin typeface="Montserrat"/>
+              </a:rPr>
               <a:t>•  вторая сделка и второй заказ не создаются</a:t>
             </a:r>
+            <a:endParaRPr sz="1100" b="0" i="0">
+              <a:latin typeface="Montserrat"/>
+            </a:endParaRPr>
           </a:p>
         </p:txBody>
       </p:sp>
@@ -6965,8 +7193,8 @@
           <a:noFill/>
         </p:spPr>
         <p:txBody>
-          <a:bodyPr wrap="none" lIns="18288" rIns="18288" tIns="18288" bIns="18288" anchor="t">
-            <a:spAutoFit/>
+          <a:bodyPr wrap="square" lIns="18288" rIns="18288" tIns="18288" bIns="18288" anchor="t">
+            <a:noAutofit/>
           </a:bodyPr>
           <a:lstStyle/>
           <a:p>
@@ -6976,7 +7204,7 @@
               </a:lnSpc>
             </a:pPr>
             <a:r>
-              <a:rPr sz="850" b="1">
+              <a:rPr sz="800" b="0" i="0">
                 <a:solidFill>
                   <a:srgbClr val="667085"/>
                 </a:solidFill>
@@ -6984,6 +7212,9 @@
               </a:rPr>
               <a:t>WEBOPTIMIZE  •  WEBOPTIMIZE.RU</a:t>
             </a:r>
+            <a:endParaRPr sz="800" b="0" i="0">
+              <a:latin typeface="Montserrat"/>
+            </a:endParaRPr>
           </a:p>
         </p:txBody>
       </p:sp>
@@ -7030,8 +7261,8 @@
           <a:noFill/>
         </p:spPr>
         <p:txBody>
-          <a:bodyPr wrap="none" lIns="18288" rIns="18288" tIns="18288" bIns="18288" anchor="t">
-            <a:spAutoFit/>
+          <a:bodyPr wrap="square" lIns="18288" rIns="18288" tIns="18288" bIns="18288" anchor="t">
+            <a:noAutofit/>
           </a:bodyPr>
           <a:lstStyle/>
           <a:p>
@@ -7041,7 +7272,7 @@
               </a:lnSpc>
             </a:pPr>
             <a:r>
-              <a:rPr sz="1100" b="1">
+              <a:rPr sz="1100" b="0" i="0">
                 <a:solidFill>
                   <a:srgbClr val="008C8C"/>
                 </a:solidFill>
@@ -7049,6 +7280,9 @@
               </a:rPr>
               <a:t>НАДЁЖНОСТЬ</a:t>
             </a:r>
+            <a:endParaRPr sz="1100" b="0" i="0">
+              <a:latin typeface="Montserrat"/>
+            </a:endParaRPr>
           </a:p>
         </p:txBody>
       </p:sp>
@@ -7069,8 +7303,8 @@
           <a:noFill/>
         </p:spPr>
         <p:txBody>
-          <a:bodyPr wrap="none" lIns="18288" rIns="18288" tIns="18288" bIns="18288" anchor="t">
-            <a:spAutoFit/>
+          <a:bodyPr wrap="square" lIns="18288" rIns="18288" tIns="18288" bIns="18288" anchor="t">
+            <a:noAutofit/>
           </a:bodyPr>
           <a:lstStyle/>
           <a:p>
@@ -7080,7 +7314,7 @@
               </a:lnSpc>
             </a:pPr>
             <a:r>
-              <a:rPr sz="2600" b="1">
+              <a:rPr sz="2600" b="0" i="0">
                 <a:solidFill>
                   <a:srgbClr val="15243A"/>
                 </a:solidFill>
@@ -7088,6 +7322,9 @@
               </a:rPr>
               <a:t>Временная ошибка не превращается в дубль</a:t>
             </a:r>
+            <a:endParaRPr sz="2600" b="0" i="0">
+              <a:latin typeface="Montserrat"/>
+            </a:endParaRPr>
           </a:p>
         </p:txBody>
       </p:sp>
@@ -7108,8 +7345,8 @@
           <a:noFill/>
         </p:spPr>
         <p:txBody>
-          <a:bodyPr wrap="none" lIns="18288" rIns="18288" tIns="18288" bIns="18288" anchor="t">
-            <a:spAutoFit/>
+          <a:bodyPr wrap="square" lIns="18288" rIns="18288" tIns="18288" bIns="18288" anchor="t">
+            <a:noAutofit/>
           </a:bodyPr>
           <a:lstStyle/>
           <a:p>
@@ -7119,7 +7356,7 @@
               </a:lnSpc>
             </a:pPr>
             <a:r>
-              <a:rPr sz="1200" b="1">
+              <a:rPr sz="1200" b="0" i="0">
                 <a:solidFill>
                   <a:srgbClr val="667085"/>
                 </a:solidFill>
@@ -7127,6 +7364,9 @@
               </a:rPr>
               <a:t>07</a:t>
             </a:r>
+            <a:endParaRPr sz="1200" b="0" i="0">
+              <a:latin typeface="Montserrat"/>
+            </a:endParaRPr>
           </a:p>
         </p:txBody>
       </p:sp>
@@ -7216,8 +7456,8 @@
           <a:noFill/>
         </p:spPr>
         <p:txBody>
-          <a:bodyPr wrap="none" lIns="18288" rIns="18288" tIns="18288" bIns="18288" anchor="t">
-            <a:spAutoFit/>
+          <a:bodyPr wrap="square" lIns="18288" rIns="18288" tIns="18288" bIns="18288" anchor="t">
+            <a:noAutofit/>
           </a:bodyPr>
           <a:lstStyle/>
           <a:p>
@@ -7227,7 +7467,7 @@
               </a:lnSpc>
             </a:pPr>
             <a:r>
-              <a:rPr sz="950" b="1">
+              <a:rPr sz="900" b="0" i="0">
                 <a:solidFill>
                   <a:srgbClr val="1769AA"/>
                 </a:solidFill>
@@ -7235,6 +7475,9 @@
               </a:rPr>
               <a:t>01</a:t>
             </a:r>
+            <a:endParaRPr sz="900" b="0" i="0">
+              <a:latin typeface="Montserrat"/>
+            </a:endParaRPr>
           </a:p>
         </p:txBody>
       </p:sp>
@@ -7255,8 +7498,8 @@
           <a:noFill/>
         </p:spPr>
         <p:txBody>
-          <a:bodyPr wrap="none" lIns="18288" rIns="18288" tIns="18288" bIns="18288" anchor="t">
-            <a:spAutoFit/>
+          <a:bodyPr wrap="square" lIns="18288" rIns="18288" tIns="18288" bIns="18288" anchor="t">
+            <a:noAutofit/>
           </a:bodyPr>
           <a:lstStyle/>
           <a:p>
@@ -7266,7 +7509,7 @@
               </a:lnSpc>
             </a:pPr>
             <a:r>
-              <a:rPr sz="1150" b="1">
+              <a:rPr sz="1100" b="0" i="0">
                 <a:solidFill>
                   <a:srgbClr val="15243A"/>
                 </a:solidFill>
@@ -7274,6 +7517,9 @@
               </a:rPr>
               <a:t>Команда остаётся в очереди</a:t>
             </a:r>
+            <a:endParaRPr sz="1100" b="0" i="0">
+              <a:latin typeface="Montserrat"/>
+            </a:endParaRPr>
           </a:p>
         </p:txBody>
       </p:sp>
@@ -7339,8 +7585,8 @@
           <a:noFill/>
         </p:spPr>
         <p:txBody>
-          <a:bodyPr wrap="none" lIns="18288" rIns="18288" tIns="18288" bIns="18288" anchor="t">
-            <a:spAutoFit/>
+          <a:bodyPr wrap="square" lIns="18288" rIns="18288" tIns="18288" bIns="18288" anchor="t">
+            <a:noAutofit/>
           </a:bodyPr>
           <a:lstStyle/>
           <a:p>
@@ -7350,7 +7596,7 @@
               </a:lnSpc>
             </a:pPr>
             <a:r>
-              <a:rPr sz="950" b="1">
+              <a:rPr sz="900" b="0" i="0">
                 <a:solidFill>
                   <a:srgbClr val="1769AA"/>
                 </a:solidFill>
@@ -7358,6 +7604,9 @@
               </a:rPr>
               <a:t>02</a:t>
             </a:r>
+            <a:endParaRPr sz="900" b="0" i="0">
+              <a:latin typeface="Montserrat"/>
+            </a:endParaRPr>
           </a:p>
         </p:txBody>
       </p:sp>
@@ -7378,8 +7627,8 @@
           <a:noFill/>
         </p:spPr>
         <p:txBody>
-          <a:bodyPr wrap="none" lIns="18288" rIns="18288" tIns="18288" bIns="18288" anchor="t">
-            <a:spAutoFit/>
+          <a:bodyPr wrap="square" lIns="18288" rIns="18288" tIns="18288" bIns="18288" anchor="t">
+            <a:noAutofit/>
           </a:bodyPr>
           <a:lstStyle/>
           <a:p>
@@ -7389,7 +7638,7 @@
               </a:lnSpc>
             </a:pPr>
             <a:r>
-              <a:rPr sz="1150" b="1">
+              <a:rPr sz="1100" b="0" i="0">
                 <a:solidFill>
                   <a:srgbClr val="15243A"/>
                 </a:solidFill>
@@ -7397,6 +7646,9 @@
               </a:rPr>
               <a:t>Повтор ограничен по числу попыток</a:t>
             </a:r>
+            <a:endParaRPr sz="1100" b="0" i="0">
+              <a:latin typeface="Montserrat"/>
+            </a:endParaRPr>
           </a:p>
         </p:txBody>
       </p:sp>
@@ -7462,8 +7714,8 @@
           <a:noFill/>
         </p:spPr>
         <p:txBody>
-          <a:bodyPr wrap="none" lIns="18288" rIns="18288" tIns="18288" bIns="18288" anchor="t">
-            <a:spAutoFit/>
+          <a:bodyPr wrap="square" lIns="18288" rIns="18288" tIns="18288" bIns="18288" anchor="t">
+            <a:noAutofit/>
           </a:bodyPr>
           <a:lstStyle/>
           <a:p>
@@ -7473,7 +7725,7 @@
               </a:lnSpc>
             </a:pPr>
             <a:r>
-              <a:rPr sz="950" b="1">
+              <a:rPr sz="900" b="0" i="0">
                 <a:solidFill>
                   <a:srgbClr val="1769AA"/>
                 </a:solidFill>
@@ -7481,6 +7733,9 @@
               </a:rPr>
               <a:t>03</a:t>
             </a:r>
+            <a:endParaRPr sz="900" b="0" i="0">
+              <a:latin typeface="Montserrat"/>
+            </a:endParaRPr>
           </a:p>
         </p:txBody>
       </p:sp>
@@ -7501,8 +7756,8 @@
           <a:noFill/>
         </p:spPr>
         <p:txBody>
-          <a:bodyPr wrap="none" lIns="18288" rIns="18288" tIns="18288" bIns="18288" anchor="t">
-            <a:spAutoFit/>
+          <a:bodyPr wrap="square" lIns="18288" rIns="18288" tIns="18288" bIns="18288" anchor="t">
+            <a:noAutofit/>
           </a:bodyPr>
           <a:lstStyle/>
           <a:p>
@@ -7512,7 +7767,7 @@
               </a:lnSpc>
             </a:pPr>
             <a:r>
-              <a:rPr sz="1150" b="1">
+              <a:rPr sz="1100" b="0" i="0">
                 <a:solidFill>
                   <a:srgbClr val="15243A"/>
                 </a:solidFill>
@@ -7520,6 +7775,9 @@
               </a:rPr>
               <a:t>Связь проверяется перед записью</a:t>
             </a:r>
+            <a:endParaRPr sz="1100" b="0" i="0">
+              <a:latin typeface="Montserrat"/>
+            </a:endParaRPr>
           </a:p>
         </p:txBody>
       </p:sp>
@@ -7585,8 +7843,8 @@
           <a:noFill/>
         </p:spPr>
         <p:txBody>
-          <a:bodyPr wrap="none" lIns="18288" rIns="18288" tIns="18288" bIns="18288" anchor="t">
-            <a:spAutoFit/>
+          <a:bodyPr wrap="square" lIns="18288" rIns="18288" tIns="18288" bIns="18288" anchor="t">
+            <a:noAutofit/>
           </a:bodyPr>
           <a:lstStyle/>
           <a:p>
@@ -7596,7 +7854,7 @@
               </a:lnSpc>
             </a:pPr>
             <a:r>
-              <a:rPr sz="950" b="1">
+              <a:rPr sz="900" b="0" i="0">
                 <a:solidFill>
                   <a:srgbClr val="1769AA"/>
                 </a:solidFill>
@@ -7604,6 +7862,9 @@
               </a:rPr>
               <a:t>04</a:t>
             </a:r>
+            <a:endParaRPr sz="900" b="0" i="0">
+              <a:latin typeface="Montserrat"/>
+            </a:endParaRPr>
           </a:p>
         </p:txBody>
       </p:sp>
@@ -7624,8 +7885,8 @@
           <a:noFill/>
         </p:spPr>
         <p:txBody>
-          <a:bodyPr wrap="none" lIns="18288" rIns="18288" tIns="18288" bIns="18288" anchor="t">
-            <a:spAutoFit/>
+          <a:bodyPr wrap="square" lIns="18288" rIns="18288" tIns="18288" bIns="18288" anchor="t">
+            <a:noAutofit/>
           </a:bodyPr>
           <a:lstStyle/>
           <a:p>
@@ -7635,7 +7896,7 @@
               </a:lnSpc>
             </a:pPr>
             <a:r>
-              <a:rPr sz="1150" b="1">
+              <a:rPr sz="1100" b="0" i="0">
                 <a:solidFill>
                   <a:srgbClr val="15243A"/>
                 </a:solidFill>
@@ -7643,6 +7904,9 @@
               </a:rPr>
               <a:t>Обновляется существующий заказ</a:t>
             </a:r>
+            <a:endParaRPr sz="1100" b="0" i="0">
+              <a:latin typeface="Montserrat"/>
+            </a:endParaRPr>
           </a:p>
         </p:txBody>
       </p:sp>
@@ -7654,17 +7918,17 @@
         </p:nvSpPr>
         <p:spPr>
           <a:xfrm>
-            <a:off x="640080" y="5815584"/>
-            <a:ext cx="8686800" cy="274320"/>
-          </a:xfrm>
-          <a:prstGeom prst="rect">
-            <a:avLst/>
-          </a:prstGeom>
-          <a:noFill/>
-        </p:spPr>
-        <p:txBody>
-          <a:bodyPr wrap="none" lIns="18288" rIns="18288" tIns="18288" bIns="18288" anchor="t">
-            <a:spAutoFit/>
+            <a:off x="640080" y="5797296"/>
+            <a:ext cx="9601200" cy="310896"/>
+          </a:xfrm>
+          <a:prstGeom prst="rect">
+            <a:avLst/>
+          </a:prstGeom>
+          <a:noFill/>
+        </p:spPr>
+        <p:txBody>
+          <a:bodyPr wrap="square" lIns="18288" rIns="18288" tIns="18288" bIns="18288" anchor="t">
+            <a:noAutofit/>
           </a:bodyPr>
           <a:lstStyle/>
           <a:p>
@@ -7674,14 +7938,17 @@
               </a:lnSpc>
             </a:pPr>
             <a:r>
-              <a:rPr sz="1050" b="0">
+              <a:rPr sz="1000" b="0" i="0">
                 <a:solidFill>
                   <a:srgbClr val="667085"/>
                 </a:solidFill>
                 <a:latin typeface="Montserrat"/>
               </a:rPr>
-              <a:t>Логи не содержат webhook, пароль 1С или персональные данные.</a:t>
-            </a:r>
+              <a:t>Журнал обмена не содержит адрес подключения, пароль 1С или персональные данные.</a:t>
+            </a:r>
+            <a:endParaRPr sz="1000" b="0" i="0">
+              <a:latin typeface="Montserrat"/>
+            </a:endParaRPr>
           </a:p>
         </p:txBody>
       </p:sp>
@@ -7702,8 +7969,8 @@
           <a:noFill/>
         </p:spPr>
         <p:txBody>
-          <a:bodyPr wrap="none" lIns="18288" rIns="18288" tIns="18288" bIns="18288" anchor="t">
-            <a:spAutoFit/>
+          <a:bodyPr wrap="square" lIns="18288" rIns="18288" tIns="18288" bIns="18288" anchor="t">
+            <a:noAutofit/>
           </a:bodyPr>
           <a:lstStyle/>
           <a:p>
@@ -7713,7 +7980,7 @@
               </a:lnSpc>
             </a:pPr>
             <a:r>
-              <a:rPr sz="850" b="1">
+              <a:rPr sz="800" b="0" i="0">
                 <a:solidFill>
                   <a:srgbClr val="667085"/>
                 </a:solidFill>
@@ -7721,6 +7988,9 @@
               </a:rPr>
               <a:t>WEBOPTIMIZE  •  WEBOPTIMIZE.RU</a:t>
             </a:r>
+            <a:endParaRPr sz="800" b="0" i="0">
+              <a:latin typeface="Montserrat"/>
+            </a:endParaRPr>
           </a:p>
         </p:txBody>
       </p:sp>
@@ -7767,8 +8037,8 @@
           <a:noFill/>
         </p:spPr>
         <p:txBody>
-          <a:bodyPr wrap="none" lIns="18288" rIns="18288" tIns="18288" bIns="18288" anchor="t">
-            <a:spAutoFit/>
+          <a:bodyPr wrap="square" lIns="18288" rIns="18288" tIns="18288" bIns="18288" anchor="t">
+            <a:noAutofit/>
           </a:bodyPr>
           <a:lstStyle/>
           <a:p>
@@ -7778,14 +8048,17 @@
               </a:lnSpc>
             </a:pPr>
             <a:r>
-              <a:rPr sz="1100" b="1">
+              <a:rPr sz="1100" b="0" i="0">
                 <a:solidFill>
                   <a:srgbClr val="008C8C"/>
                 </a:solidFill>
                 <a:latin typeface="Montserrat"/>
               </a:rPr>
-              <a:t>ПРИЁМКА</a:t>
-            </a:r>
+              <a:t>ПРОВЕРКА</a:t>
+            </a:r>
+            <a:endParaRPr sz="1100" b="0" i="0">
+              <a:latin typeface="Montserrat"/>
+            </a:endParaRPr>
           </a:p>
         </p:txBody>
       </p:sp>
@@ -7806,8 +8079,8 @@
           <a:noFill/>
         </p:spPr>
         <p:txBody>
-          <a:bodyPr wrap="none" lIns="18288" rIns="18288" tIns="18288" bIns="18288" anchor="t">
-            <a:spAutoFit/>
+          <a:bodyPr wrap="square" lIns="18288" rIns="18288" tIns="18288" bIns="18288" anchor="t">
+            <a:noAutofit/>
           </a:bodyPr>
           <a:lstStyle/>
           <a:p>
@@ -7817,14 +8090,17 @@
               </a:lnSpc>
             </a:pPr>
             <a:r>
-              <a:rPr sz="2600" b="1">
+              <a:rPr sz="2600" b="0" i="0">
                 <a:solidFill>
                   <a:srgbClr val="15243A"/>
                 </a:solidFill>
                 <a:latin typeface="Montserrat"/>
               </a:rPr>
-              <a:t>Что подтверждено в тестовом контуре</a:t>
-            </a:r>
+              <a:t>Что проверено на тестовой копии</a:t>
+            </a:r>
+            <a:endParaRPr sz="2600" b="0" i="0">
+              <a:latin typeface="Montserrat"/>
+            </a:endParaRPr>
           </a:p>
         </p:txBody>
       </p:sp>
@@ -7845,8 +8121,8 @@
           <a:noFill/>
         </p:spPr>
         <p:txBody>
-          <a:bodyPr wrap="none" lIns="18288" rIns="18288" tIns="18288" bIns="18288" anchor="t">
-            <a:spAutoFit/>
+          <a:bodyPr wrap="square" lIns="18288" rIns="18288" tIns="18288" bIns="18288" anchor="t">
+            <a:noAutofit/>
           </a:bodyPr>
           <a:lstStyle/>
           <a:p>
@@ -7856,7 +8132,7 @@
               </a:lnSpc>
             </a:pPr>
             <a:r>
-              <a:rPr sz="1200" b="1">
+              <a:rPr sz="1200" b="0" i="0">
                 <a:solidFill>
                   <a:srgbClr val="667085"/>
                 </a:solidFill>
@@ -7864,6 +8140,9 @@
               </a:rPr>
               <a:t>08</a:t>
             </a:r>
+            <a:endParaRPr sz="1200" b="0" i="0">
+              <a:latin typeface="Montserrat"/>
+            </a:endParaRPr>
           </a:p>
         </p:txBody>
       </p:sp>
@@ -7920,17 +8199,17 @@
         </p:nvSpPr>
         <p:spPr>
           <a:xfrm>
-            <a:off x="841247" y="1801368"/>
-            <a:ext cx="1417320" cy="274320"/>
-          </a:xfrm>
-          <a:prstGeom prst="rect">
-            <a:avLst/>
-          </a:prstGeom>
-          <a:noFill/>
-        </p:spPr>
-        <p:txBody>
-          <a:bodyPr wrap="none" lIns="18288" rIns="18288" tIns="18288" bIns="18288" anchor="t">
-            <a:spAutoFit/>
+            <a:off x="841247" y="1773936"/>
+            <a:ext cx="1234440" cy="256032"/>
+          </a:xfrm>
+          <a:prstGeom prst="rect">
+            <a:avLst/>
+          </a:prstGeom>
+          <a:noFill/>
+        </p:spPr>
+        <p:txBody>
+          <a:bodyPr wrap="square" lIns="18288" rIns="18288" tIns="18288" bIns="18288" anchor="t">
+            <a:noAutofit/>
           </a:bodyPr>
           <a:lstStyle/>
           <a:p>
@@ -7940,14 +8219,17 @@
               </a:lnSpc>
             </a:pPr>
             <a:r>
-              <a:rPr sz="1100" b="1">
+              <a:rPr sz="900" b="0" i="0">
                 <a:solidFill>
                   <a:srgbClr val="17805E"/>
                 </a:solidFill>
                 <a:latin typeface="Montserrat"/>
               </a:rPr>
-              <a:t>VERIFIED</a:t>
-            </a:r>
+              <a:t>ПРОВЕРЕНО</a:t>
+            </a:r>
+            <a:endParaRPr sz="900" b="0" i="0">
+              <a:latin typeface="Montserrat"/>
+            </a:endParaRPr>
           </a:p>
         </p:txBody>
       </p:sp>
@@ -7959,17 +8241,17 @@
         </p:nvSpPr>
         <p:spPr>
           <a:xfrm>
-            <a:off x="841247" y="2313432"/>
-            <a:ext cx="2834640" cy="347472"/>
-          </a:xfrm>
-          <a:prstGeom prst="rect">
-            <a:avLst/>
-          </a:prstGeom>
-          <a:noFill/>
-        </p:spPr>
-        <p:txBody>
-          <a:bodyPr wrap="none" lIns="18288" rIns="18288" tIns="18288" bIns="18288" anchor="t">
-            <a:spAutoFit/>
+            <a:off x="841247" y="2130552"/>
+            <a:ext cx="2971800" cy="457200"/>
+          </a:xfrm>
+          <a:prstGeom prst="rect">
+            <a:avLst/>
+          </a:prstGeom>
+          <a:noFill/>
+        </p:spPr>
+        <p:txBody>
+          <a:bodyPr wrap="square" lIns="18288" rIns="18288" tIns="18288" bIns="18288" anchor="t">
+            <a:noAutofit/>
           </a:bodyPr>
           <a:lstStyle/>
           <a:p>
@@ -7979,14 +8261,17 @@
               </a:lnSpc>
             </a:pPr>
             <a:r>
-              <a:rPr sz="1500" b="1">
+              <a:rPr sz="1300" b="0" i="0">
                 <a:solidFill>
                   <a:srgbClr val="15243A"/>
                 </a:solidFill>
                 <a:latin typeface="Montserrat"/>
               </a:rPr>
-              <a:t>Создание заказа</a:t>
-            </a:r>
+              <a:t>Заказ создан из сделки</a:t>
+            </a:r>
+            <a:endParaRPr sz="1300" b="0" i="0">
+              <a:latin typeface="Montserrat"/>
+            </a:endParaRPr>
           </a:p>
         </p:txBody>
       </p:sp>
@@ -7998,17 +8283,17 @@
         </p:nvSpPr>
         <p:spPr>
           <a:xfrm>
-            <a:off x="841247" y="2715768"/>
-            <a:ext cx="2377440" cy="228600"/>
-          </a:xfrm>
-          <a:prstGeom prst="rect">
-            <a:avLst/>
-          </a:prstGeom>
-          <a:noFill/>
-        </p:spPr>
-        <p:txBody>
-          <a:bodyPr wrap="none" lIns="18288" rIns="18288" tIns="18288" bIns="18288" anchor="t">
-            <a:spAutoFit/>
+            <a:off x="841247" y="2688336"/>
+            <a:ext cx="2880360" cy="246888"/>
+          </a:xfrm>
+          <a:prstGeom prst="rect">
+            <a:avLst/>
+          </a:prstGeom>
+          <a:noFill/>
+        </p:spPr>
+        <p:txBody>
+          <a:bodyPr wrap="square" lIns="18288" rIns="18288" tIns="18288" bIns="18288" anchor="t">
+            <a:noAutofit/>
           </a:bodyPr>
           <a:lstStyle/>
           <a:p>
@@ -8018,14 +8303,17 @@
               </a:lnSpc>
             </a:pPr>
             <a:r>
-              <a:rPr sz="950" b="0">
+              <a:rPr sz="900" b="0" i="0">
                 <a:solidFill>
                   <a:srgbClr val="667085"/>
                 </a:solidFill>
                 <a:latin typeface="Montserrat"/>
               </a:rPr>
-              <a:t>синтетический тест</a:t>
-            </a:r>
+              <a:t>Проверка пройдена</a:t>
+            </a:r>
+            <a:endParaRPr sz="900" b="0" i="0">
+              <a:latin typeface="Montserrat"/>
+            </a:endParaRPr>
           </a:p>
         </p:txBody>
       </p:sp>
@@ -8082,17 +8370,17 @@
         </p:nvSpPr>
         <p:spPr>
           <a:xfrm>
-            <a:off x="4608576" y="1801368"/>
-            <a:ext cx="1417320" cy="274320"/>
-          </a:xfrm>
-          <a:prstGeom prst="rect">
-            <a:avLst/>
-          </a:prstGeom>
-          <a:noFill/>
-        </p:spPr>
-        <p:txBody>
-          <a:bodyPr wrap="none" lIns="18288" rIns="18288" tIns="18288" bIns="18288" anchor="t">
-            <a:spAutoFit/>
+            <a:off x="4608576" y="1773936"/>
+            <a:ext cx="1234440" cy="256032"/>
+          </a:xfrm>
+          <a:prstGeom prst="rect">
+            <a:avLst/>
+          </a:prstGeom>
+          <a:noFill/>
+        </p:spPr>
+        <p:txBody>
+          <a:bodyPr wrap="square" lIns="18288" rIns="18288" tIns="18288" bIns="18288" anchor="t">
+            <a:noAutofit/>
           </a:bodyPr>
           <a:lstStyle/>
           <a:p>
@@ -8102,14 +8390,17 @@
               </a:lnSpc>
             </a:pPr>
             <a:r>
-              <a:rPr sz="1100" b="1">
+              <a:rPr sz="900" b="0" i="0">
                 <a:solidFill>
                   <a:srgbClr val="17805E"/>
                 </a:solidFill>
                 <a:latin typeface="Montserrat"/>
               </a:rPr>
-              <a:t>VERIFIED</a:t>
-            </a:r>
+              <a:t>ПРОВЕРЕНО</a:t>
+            </a:r>
+            <a:endParaRPr sz="900" b="0" i="0">
+              <a:latin typeface="Montserrat"/>
+            </a:endParaRPr>
           </a:p>
         </p:txBody>
       </p:sp>
@@ -8121,17 +8412,17 @@
         </p:nvSpPr>
         <p:spPr>
           <a:xfrm>
-            <a:off x="4608576" y="2313432"/>
-            <a:ext cx="2834640" cy="347472"/>
-          </a:xfrm>
-          <a:prstGeom prst="rect">
-            <a:avLst/>
-          </a:prstGeom>
-          <a:noFill/>
-        </p:spPr>
-        <p:txBody>
-          <a:bodyPr wrap="none" lIns="18288" rIns="18288" tIns="18288" bIns="18288" anchor="t">
-            <a:spAutoFit/>
+            <a:off x="4608576" y="2130552"/>
+            <a:ext cx="2971800" cy="457200"/>
+          </a:xfrm>
+          <a:prstGeom prst="rect">
+            <a:avLst/>
+          </a:prstGeom>
+          <a:noFill/>
+        </p:spPr>
+        <p:txBody>
+          <a:bodyPr wrap="square" lIns="18288" rIns="18288" tIns="18288" bIns="18288" anchor="t">
+            <a:noAutofit/>
           </a:bodyPr>
           <a:lstStyle/>
           <a:p>
@@ -8141,14 +8432,17 @@
               </a:lnSpc>
             </a:pPr>
             <a:r>
-              <a:rPr sz="1500" b="1">
+              <a:rPr sz="1300" b="0" i="0">
                 <a:solidFill>
                   <a:srgbClr val="15243A"/>
                 </a:solidFill>
                 <a:latin typeface="Montserrat"/>
               </a:rPr>
-              <a:t>Повторная отправка</a:t>
-            </a:r>
+              <a:t>Обновлён тот же заказ</a:t>
+            </a:r>
+            <a:endParaRPr sz="1300" b="0" i="0">
+              <a:latin typeface="Montserrat"/>
+            </a:endParaRPr>
           </a:p>
         </p:txBody>
       </p:sp>
@@ -8160,17 +8454,17 @@
         </p:nvSpPr>
         <p:spPr>
           <a:xfrm>
-            <a:off x="4608576" y="2715768"/>
-            <a:ext cx="2377440" cy="228600"/>
-          </a:xfrm>
-          <a:prstGeom prst="rect">
-            <a:avLst/>
-          </a:prstGeom>
-          <a:noFill/>
-        </p:spPr>
-        <p:txBody>
-          <a:bodyPr wrap="none" lIns="18288" rIns="18288" tIns="18288" bIns="18288" anchor="t">
-            <a:spAutoFit/>
+            <a:off x="4608576" y="2688336"/>
+            <a:ext cx="2880360" cy="246888"/>
+          </a:xfrm>
+          <a:prstGeom prst="rect">
+            <a:avLst/>
+          </a:prstGeom>
+          <a:noFill/>
+        </p:spPr>
+        <p:txBody>
+          <a:bodyPr wrap="square" lIns="18288" rIns="18288" tIns="18288" bIns="18288" anchor="t">
+            <a:noAutofit/>
           </a:bodyPr>
           <a:lstStyle/>
           <a:p>
@@ -8180,14 +8474,17 @@
               </a:lnSpc>
             </a:pPr>
             <a:r>
-              <a:rPr sz="950" b="0">
+              <a:rPr sz="900" b="0" i="0">
                 <a:solidFill>
                   <a:srgbClr val="667085"/>
                 </a:solidFill>
                 <a:latin typeface="Montserrat"/>
               </a:rPr>
-              <a:t>синтетический тест</a:t>
-            </a:r>
+              <a:t>Дубль не создан</a:t>
+            </a:r>
+            <a:endParaRPr sz="900" b="0" i="0">
+              <a:latin typeface="Montserrat"/>
+            </a:endParaRPr>
           </a:p>
         </p:txBody>
       </p:sp>
@@ -8244,17 +8541,17 @@
         </p:nvSpPr>
         <p:spPr>
           <a:xfrm>
-            <a:off x="8375904" y="1801368"/>
-            <a:ext cx="1417320" cy="274320"/>
-          </a:xfrm>
-          <a:prstGeom prst="rect">
-            <a:avLst/>
-          </a:prstGeom>
-          <a:noFill/>
-        </p:spPr>
-        <p:txBody>
-          <a:bodyPr wrap="none" lIns="18288" rIns="18288" tIns="18288" bIns="18288" anchor="t">
-            <a:spAutoFit/>
+            <a:off x="8375904" y="1773936"/>
+            <a:ext cx="1234440" cy="256032"/>
+          </a:xfrm>
+          <a:prstGeom prst="rect">
+            <a:avLst/>
+          </a:prstGeom>
+          <a:noFill/>
+        </p:spPr>
+        <p:txBody>
+          <a:bodyPr wrap="square" lIns="18288" rIns="18288" tIns="18288" bIns="18288" anchor="t">
+            <a:noAutofit/>
           </a:bodyPr>
           <a:lstStyle/>
           <a:p>
@@ -8264,14 +8561,17 @@
               </a:lnSpc>
             </a:pPr>
             <a:r>
-              <a:rPr sz="1100" b="1">
+              <a:rPr sz="900" b="0" i="0">
                 <a:solidFill>
                   <a:srgbClr val="17805E"/>
                 </a:solidFill>
                 <a:latin typeface="Montserrat"/>
               </a:rPr>
-              <a:t>VERIFIED</a:t>
-            </a:r>
+              <a:t>ПРОВЕРЕНО</a:t>
+            </a:r>
+            <a:endParaRPr sz="900" b="0" i="0">
+              <a:latin typeface="Montserrat"/>
+            </a:endParaRPr>
           </a:p>
         </p:txBody>
       </p:sp>
@@ -8283,17 +8583,17 @@
         </p:nvSpPr>
         <p:spPr>
           <a:xfrm>
-            <a:off x="8375904" y="2313432"/>
-            <a:ext cx="2834640" cy="347472"/>
-          </a:xfrm>
-          <a:prstGeom prst="rect">
-            <a:avLst/>
-          </a:prstGeom>
-          <a:noFill/>
-        </p:spPr>
-        <p:txBody>
-          <a:bodyPr wrap="none" lIns="18288" rIns="18288" tIns="18288" bIns="18288" anchor="t">
-            <a:spAutoFit/>
+            <a:off x="8375904" y="2130552"/>
+            <a:ext cx="2971800" cy="457200"/>
+          </a:xfrm>
+          <a:prstGeom prst="rect">
+            <a:avLst/>
+          </a:prstGeom>
+          <a:noFill/>
+        </p:spPr>
+        <p:txBody>
+          <a:bodyPr wrap="square" lIns="18288" rIns="18288" tIns="18288" bIns="18288" anchor="t">
+            <a:noAutofit/>
           </a:bodyPr>
           <a:lstStyle/>
           <a:p>
@@ -8303,14 +8603,17 @@
               </a:lnSpc>
             </a:pPr>
             <a:r>
-              <a:rPr sz="1500" b="1">
+              <a:rPr sz="1300" b="0" i="0">
                 <a:solidFill>
                   <a:srgbClr val="15243A"/>
                 </a:solidFill>
                 <a:latin typeface="Montserrat"/>
               </a:rPr>
-              <a:t>Обратный статус</a:t>
-            </a:r>
+              <a:t>Статус вернулся в Bitrix24</a:t>
+            </a:r>
+            <a:endParaRPr sz="1300" b="0" i="0">
+              <a:latin typeface="Montserrat"/>
+            </a:endParaRPr>
           </a:p>
         </p:txBody>
       </p:sp>
@@ -8322,17 +8625,17 @@
         </p:nvSpPr>
         <p:spPr>
           <a:xfrm>
-            <a:off x="8375904" y="2715768"/>
-            <a:ext cx="2377440" cy="228600"/>
-          </a:xfrm>
-          <a:prstGeom prst="rect">
-            <a:avLst/>
-          </a:prstGeom>
-          <a:noFill/>
-        </p:spPr>
-        <p:txBody>
-          <a:bodyPr wrap="none" lIns="18288" rIns="18288" tIns="18288" bIns="18288" anchor="t">
-            <a:spAutoFit/>
+            <a:off x="8375904" y="2688336"/>
+            <a:ext cx="2880360" cy="246888"/>
+          </a:xfrm>
+          <a:prstGeom prst="rect">
+            <a:avLst/>
+          </a:prstGeom>
+          <a:noFill/>
+        </p:spPr>
+        <p:txBody>
+          <a:bodyPr wrap="square" lIns="18288" rIns="18288" tIns="18288" bIns="18288" anchor="t">
+            <a:noAutofit/>
           </a:bodyPr>
           <a:lstStyle/>
           <a:p>
@@ -8342,14 +8645,17 @@
               </a:lnSpc>
             </a:pPr>
             <a:r>
-              <a:rPr sz="950" b="0">
+              <a:rPr sz="900" b="0" i="0">
                 <a:solidFill>
                   <a:srgbClr val="667085"/>
                 </a:solidFill>
                 <a:latin typeface="Montserrat"/>
               </a:rPr>
-              <a:t>синтетический тест</a:t>
-            </a:r>
+              <a:t>Проверка пройдена</a:t>
+            </a:r>
+            <a:endParaRPr sz="900" b="0" i="0">
+              <a:latin typeface="Montserrat"/>
+            </a:endParaRPr>
           </a:p>
         </p:txBody>
       </p:sp>
@@ -8406,17 +8712,17 @@
         </p:nvSpPr>
         <p:spPr>
           <a:xfrm>
-            <a:off x="841247" y="3721608"/>
-            <a:ext cx="1417320" cy="274320"/>
-          </a:xfrm>
-          <a:prstGeom prst="rect">
-            <a:avLst/>
-          </a:prstGeom>
-          <a:noFill/>
-        </p:spPr>
-        <p:txBody>
-          <a:bodyPr wrap="none" lIns="18288" rIns="18288" tIns="18288" bIns="18288" anchor="t">
-            <a:spAutoFit/>
+            <a:off x="841247" y="3694176"/>
+            <a:ext cx="1234440" cy="256032"/>
+          </a:xfrm>
+          <a:prstGeom prst="rect">
+            <a:avLst/>
+          </a:prstGeom>
+          <a:noFill/>
+        </p:spPr>
+        <p:txBody>
+          <a:bodyPr wrap="square" lIns="18288" rIns="18288" tIns="18288" bIns="18288" anchor="t">
+            <a:noAutofit/>
           </a:bodyPr>
           <a:lstStyle/>
           <a:p>
@@ -8426,14 +8732,17 @@
               </a:lnSpc>
             </a:pPr>
             <a:r>
-              <a:rPr sz="1100" b="1">
+              <a:rPr sz="900" b="0" i="0">
                 <a:solidFill>
                   <a:srgbClr val="17805E"/>
                 </a:solidFill>
                 <a:latin typeface="Montserrat"/>
               </a:rPr>
-              <a:t>VERIFIED</a:t>
-            </a:r>
+              <a:t>ПРОВЕРЕНО</a:t>
+            </a:r>
+            <a:endParaRPr sz="900" b="0" i="0">
+              <a:latin typeface="Montserrat"/>
+            </a:endParaRPr>
           </a:p>
         </p:txBody>
       </p:sp>
@@ -8445,17 +8754,17 @@
         </p:nvSpPr>
         <p:spPr>
           <a:xfrm>
-            <a:off x="841247" y="4233672"/>
-            <a:ext cx="2834640" cy="347472"/>
-          </a:xfrm>
-          <a:prstGeom prst="rect">
-            <a:avLst/>
-          </a:prstGeom>
-          <a:noFill/>
-        </p:spPr>
-        <p:txBody>
-          <a:bodyPr wrap="none" lIns="18288" rIns="18288" tIns="18288" bIns="18288" anchor="t">
-            <a:spAutoFit/>
+            <a:off x="841247" y="4050791"/>
+            <a:ext cx="2971800" cy="457200"/>
+          </a:xfrm>
+          <a:prstGeom prst="rect">
+            <a:avLst/>
+          </a:prstGeom>
+          <a:noFill/>
+        </p:spPr>
+        <p:txBody>
+          <a:bodyPr wrap="square" lIns="18288" rIns="18288" tIns="18288" bIns="18288" anchor="t">
+            <a:noAutofit/>
           </a:bodyPr>
           <a:lstStyle/>
           <a:p>
@@ -8465,14 +8774,17 @@
               </a:lnSpc>
             </a:pPr>
             <a:r>
-              <a:rPr sz="1500" b="1">
+              <a:rPr sz="1300" b="0" i="0">
                 <a:solidFill>
                   <a:srgbClr val="15243A"/>
                 </a:solidFill>
                 <a:latin typeface="Montserrat"/>
               </a:rPr>
-              <a:t>Ограниченный retry</a:t>
-            </a:r>
+              <a:t>Повтор после ошибки</a:t>
+            </a:r>
+            <a:endParaRPr sz="1300" b="0" i="0">
+              <a:latin typeface="Montserrat"/>
+            </a:endParaRPr>
           </a:p>
         </p:txBody>
       </p:sp>
@@ -8484,17 +8796,17 @@
         </p:nvSpPr>
         <p:spPr>
           <a:xfrm>
-            <a:off x="841247" y="4636008"/>
-            <a:ext cx="2377440" cy="228600"/>
-          </a:xfrm>
-          <a:prstGeom prst="rect">
-            <a:avLst/>
-          </a:prstGeom>
-          <a:noFill/>
-        </p:spPr>
-        <p:txBody>
-          <a:bodyPr wrap="none" lIns="18288" rIns="18288" tIns="18288" bIns="18288" anchor="t">
-            <a:spAutoFit/>
+            <a:off x="841247" y="4608576"/>
+            <a:ext cx="2880360" cy="246888"/>
+          </a:xfrm>
+          <a:prstGeom prst="rect">
+            <a:avLst/>
+          </a:prstGeom>
+          <a:noFill/>
+        </p:spPr>
+        <p:txBody>
+          <a:bodyPr wrap="square" lIns="18288" rIns="18288" tIns="18288" bIns="18288" anchor="t">
+            <a:noAutofit/>
           </a:bodyPr>
           <a:lstStyle/>
           <a:p>
@@ -8504,14 +8816,17 @@
               </a:lnSpc>
             </a:pPr>
             <a:r>
-              <a:rPr sz="950" b="0">
+              <a:rPr sz="900" b="0" i="0">
                 <a:solidFill>
                   <a:srgbClr val="667085"/>
                 </a:solidFill>
                 <a:latin typeface="Montserrat"/>
               </a:rPr>
-              <a:t>синтетический тест</a:t>
-            </a:r>
+              <a:t>Дубль не создан</a:t>
+            </a:r>
+            <a:endParaRPr sz="900" b="0" i="0">
+              <a:latin typeface="Montserrat"/>
+            </a:endParaRPr>
           </a:p>
         </p:txBody>
       </p:sp>
@@ -8568,17 +8883,17 @@
         </p:nvSpPr>
         <p:spPr>
           <a:xfrm>
-            <a:off x="4608576" y="3721608"/>
-            <a:ext cx="1417320" cy="274320"/>
-          </a:xfrm>
-          <a:prstGeom prst="rect">
-            <a:avLst/>
-          </a:prstGeom>
-          <a:noFill/>
-        </p:spPr>
-        <p:txBody>
-          <a:bodyPr wrap="none" lIns="18288" rIns="18288" tIns="18288" bIns="18288" anchor="t">
-            <a:spAutoFit/>
+            <a:off x="4608576" y="3694176"/>
+            <a:ext cx="1234440" cy="256032"/>
+          </a:xfrm>
+          <a:prstGeom prst="rect">
+            <a:avLst/>
+          </a:prstGeom>
+          <a:noFill/>
+        </p:spPr>
+        <p:txBody>
+          <a:bodyPr wrap="square" lIns="18288" rIns="18288" tIns="18288" bIns="18288" anchor="t">
+            <a:noAutofit/>
           </a:bodyPr>
           <a:lstStyle/>
           <a:p>
@@ -8588,14 +8903,17 @@
               </a:lnSpc>
             </a:pPr>
             <a:r>
-              <a:rPr sz="1100" b="1">
+              <a:rPr sz="900" b="0" i="0">
                 <a:solidFill>
                   <a:srgbClr val="17805E"/>
                 </a:solidFill>
                 <a:latin typeface="Montserrat"/>
               </a:rPr>
-              <a:t>HEALTHY</a:t>
-            </a:r>
+              <a:t>ПРОВЕРЕНО</a:t>
+            </a:r>
+            <a:endParaRPr sz="900" b="0" i="0">
+              <a:latin typeface="Montserrat"/>
+            </a:endParaRPr>
           </a:p>
         </p:txBody>
       </p:sp>
@@ -8607,17 +8925,17 @@
         </p:nvSpPr>
         <p:spPr>
           <a:xfrm>
-            <a:off x="4608576" y="4233672"/>
-            <a:ext cx="2834640" cy="347472"/>
-          </a:xfrm>
-          <a:prstGeom prst="rect">
-            <a:avLst/>
-          </a:prstGeom>
-          <a:noFill/>
-        </p:spPr>
-        <p:txBody>
-          <a:bodyPr wrap="none" lIns="18288" rIns="18288" tIns="18288" bIns="18288" anchor="t">
-            <a:spAutoFit/>
+            <a:off x="4608576" y="4050791"/>
+            <a:ext cx="2971800" cy="457200"/>
+          </a:xfrm>
+          <a:prstGeom prst="rect">
+            <a:avLst/>
+          </a:prstGeom>
+          <a:noFill/>
+        </p:spPr>
+        <p:txBody>
+          <a:bodyPr wrap="square" lIns="18288" rIns="18288" tIns="18288" bIns="18288" anchor="t">
+            <a:noAutofit/>
           </a:bodyPr>
           <a:lstStyle/>
           <a:p>
@@ -8627,14 +8945,17 @@
               </a:lnSpc>
             </a:pPr>
             <a:r>
-              <a:rPr sz="1500" b="1">
+              <a:rPr sz="1300" b="0" i="0">
                 <a:solidFill>
                   <a:srgbClr val="15243A"/>
                 </a:solidFill>
                 <a:latin typeface="Montserrat"/>
               </a:rPr>
-              <a:t>Online health</a:t>
-            </a:r>
+              <a:t>Связь с системами работает</a:t>
+            </a:r>
+            <a:endParaRPr sz="1300" b="0" i="0">
+              <a:latin typeface="Montserrat"/>
+            </a:endParaRPr>
           </a:p>
         </p:txBody>
       </p:sp>
@@ -8646,17 +8967,17 @@
         </p:nvSpPr>
         <p:spPr>
           <a:xfrm>
-            <a:off x="4608576" y="4636008"/>
-            <a:ext cx="2377440" cy="228600"/>
-          </a:xfrm>
-          <a:prstGeom prst="rect">
-            <a:avLst/>
-          </a:prstGeom>
-          <a:noFill/>
-        </p:spPr>
-        <p:txBody>
-          <a:bodyPr wrap="none" lIns="18288" rIns="18288" tIns="18288" bIns="18288" anchor="t">
-            <a:spAutoFit/>
+            <a:off x="4608576" y="4608576"/>
+            <a:ext cx="2880360" cy="246888"/>
+          </a:xfrm>
+          <a:prstGeom prst="rect">
+            <a:avLst/>
+          </a:prstGeom>
+          <a:noFill/>
+        </p:spPr>
+        <p:txBody>
+          <a:bodyPr wrap="square" lIns="18288" rIns="18288" tIns="18288" bIns="18288" anchor="t">
+            <a:noAutofit/>
           </a:bodyPr>
           <a:lstStyle/>
           <a:p>
@@ -8666,14 +8987,17 @@
               </a:lnSpc>
             </a:pPr>
             <a:r>
-              <a:rPr sz="950" b="0">
+              <a:rPr sz="900" b="0" i="0">
                 <a:solidFill>
                   <a:srgbClr val="667085"/>
                 </a:solidFill>
                 <a:latin typeface="Montserrat"/>
               </a:rPr>
-              <a:t>синтетический тест</a:t>
-            </a:r>
+              <a:t>Работает штатно</a:t>
+            </a:r>
+            <a:endParaRPr sz="900" b="0" i="0">
+              <a:latin typeface="Montserrat"/>
+            </a:endParaRPr>
           </a:p>
         </p:txBody>
       </p:sp>
@@ -8730,17 +9054,17 @@
         </p:nvSpPr>
         <p:spPr>
           <a:xfrm>
-            <a:off x="8375904" y="3721608"/>
-            <a:ext cx="1417320" cy="274320"/>
-          </a:xfrm>
-          <a:prstGeom prst="rect">
-            <a:avLst/>
-          </a:prstGeom>
-          <a:noFill/>
-        </p:spPr>
-        <p:txBody>
-          <a:bodyPr wrap="none" lIns="18288" rIns="18288" tIns="18288" bIns="18288" anchor="t">
-            <a:spAutoFit/>
+            <a:off x="8375904" y="3694176"/>
+            <a:ext cx="1234440" cy="256032"/>
+          </a:xfrm>
+          <a:prstGeom prst="rect">
+            <a:avLst/>
+          </a:prstGeom>
+          <a:noFill/>
+        </p:spPr>
+        <p:txBody>
+          <a:bodyPr wrap="square" lIns="18288" rIns="18288" tIns="18288" bIns="18288" anchor="t">
+            <a:noAutofit/>
           </a:bodyPr>
           <a:lstStyle/>
           <a:p>
@@ -8750,14 +9074,17 @@
               </a:lnSpc>
             </a:pPr>
             <a:r>
-              <a:rPr sz="1100" b="1">
+              <a:rPr sz="900" b="0" i="0">
                 <a:solidFill>
                   <a:srgbClr val="17805E"/>
                 </a:solidFill>
                 <a:latin typeface="Montserrat"/>
               </a:rPr>
-              <a:t>CODE 0</a:t>
-            </a:r>
+              <a:t>ПРОВЕРЕНО</a:t>
+            </a:r>
+            <a:endParaRPr sz="900" b="0" i="0">
+              <a:latin typeface="Montserrat"/>
+            </a:endParaRPr>
           </a:p>
         </p:txBody>
       </p:sp>
@@ -8769,17 +9096,17 @@
         </p:nvSpPr>
         <p:spPr>
           <a:xfrm>
-            <a:off x="8375904" y="4233672"/>
-            <a:ext cx="2834640" cy="347472"/>
-          </a:xfrm>
-          <a:prstGeom prst="rect">
-            <a:avLst/>
-          </a:prstGeom>
-          <a:noFill/>
-        </p:spPr>
-        <p:txBody>
-          <a:bodyPr wrap="none" lIns="18288" rIns="18288" tIns="18288" bIns="18288" anchor="t">
-            <a:spAutoFit/>
+            <a:off x="8375904" y="4050791"/>
+            <a:ext cx="2971800" cy="457200"/>
+          </a:xfrm>
+          <a:prstGeom prst="rect">
+            <a:avLst/>
+          </a:prstGeom>
+          <a:noFill/>
+        </p:spPr>
+        <p:txBody>
+          <a:bodyPr wrap="square" lIns="18288" rIns="18288" tIns="18288" bIns="18288" anchor="t">
+            <a:noAutofit/>
           </a:bodyPr>
           <a:lstStyle/>
           <a:p>
@@ -8789,14 +9116,17 @@
               </a:lnSpc>
             </a:pPr>
             <a:r>
-              <a:rPr sz="1500" b="1">
+              <a:rPr sz="1300" b="0" i="0">
                 <a:solidFill>
                   <a:srgbClr val="15243A"/>
                 </a:solidFill>
                 <a:latin typeface="Montserrat"/>
               </a:rPr>
-              <a:t>Плановый worker</a:t>
-            </a:r>
+              <a:t>Плановый обмен выполнен</a:t>
+            </a:r>
+            <a:endParaRPr sz="1300" b="0" i="0">
+              <a:latin typeface="Montserrat"/>
+            </a:endParaRPr>
           </a:p>
         </p:txBody>
       </p:sp>
@@ -8808,17 +9138,17 @@
         </p:nvSpPr>
         <p:spPr>
           <a:xfrm>
-            <a:off x="8375904" y="4636008"/>
-            <a:ext cx="2377440" cy="228600"/>
-          </a:xfrm>
-          <a:prstGeom prst="rect">
-            <a:avLst/>
-          </a:prstGeom>
-          <a:noFill/>
-        </p:spPr>
-        <p:txBody>
-          <a:bodyPr wrap="none" lIns="18288" rIns="18288" tIns="18288" bIns="18288" anchor="t">
-            <a:spAutoFit/>
+            <a:off x="8375904" y="4608576"/>
+            <a:ext cx="2880360" cy="246888"/>
+          </a:xfrm>
+          <a:prstGeom prst="rect">
+            <a:avLst/>
+          </a:prstGeom>
+          <a:noFill/>
+        </p:spPr>
+        <p:txBody>
+          <a:bodyPr wrap="square" lIns="18288" rIns="18288" tIns="18288" bIns="18288" anchor="t">
+            <a:noAutofit/>
           </a:bodyPr>
           <a:lstStyle/>
           <a:p>
@@ -8828,14 +9158,17 @@
               </a:lnSpc>
             </a:pPr>
             <a:r>
-              <a:rPr sz="950" b="0">
+              <a:rPr sz="900" b="0" i="0">
                 <a:solidFill>
                   <a:srgbClr val="667085"/>
                 </a:solidFill>
                 <a:latin typeface="Montserrat"/>
               </a:rPr>
-              <a:t>синтетический тест</a:t>
-            </a:r>
+              <a:t>Без ошибок</a:t>
+            </a:r>
+            <a:endParaRPr sz="900" b="0" i="0">
+              <a:latin typeface="Montserrat"/>
+            </a:endParaRPr>
           </a:p>
         </p:txBody>
       </p:sp>
@@ -8901,8 +9234,8 @@
           <a:noFill/>
         </p:spPr>
         <p:txBody>
-          <a:bodyPr wrap="none" lIns="18288" rIns="18288" tIns="18288" bIns="18288" anchor="t">
-            <a:spAutoFit/>
+          <a:bodyPr wrap="square" lIns="18288" rIns="18288" tIns="18288" bIns="18288" anchor="t">
+            <a:noAutofit/>
           </a:bodyPr>
           <a:lstStyle/>
           <a:p>
@@ -8912,14 +9245,17 @@
               </a:lnSpc>
             </a:pPr>
             <a:r>
-              <a:rPr sz="1070" b="1">
+              <a:rPr sz="1000" b="0" i="0">
                 <a:solidFill>
                   <a:srgbClr val="008C8C"/>
                 </a:solidFill>
                 <a:latin typeface="Montserrat"/>
               </a:rPr>
-              <a:t>Технический маршрут подтверждён. Рабочий запуск проходит отдельную приёмку на точной клиентской платформе.</a:t>
-            </a:r>
+              <a:t>Обмен между системами проверен. Перед рабочим запуском решение отдельно проверяется на платформе клиента.</a:t>
+            </a:r>
+            <a:endParaRPr sz="1000" b="0" i="0">
+              <a:latin typeface="Montserrat"/>
+            </a:endParaRPr>
           </a:p>
         </p:txBody>
       </p:sp>
@@ -8940,8 +9276,8 @@
           <a:noFill/>
         </p:spPr>
         <p:txBody>
-          <a:bodyPr wrap="none" lIns="18288" rIns="18288" tIns="18288" bIns="18288" anchor="t">
-            <a:spAutoFit/>
+          <a:bodyPr wrap="square" lIns="18288" rIns="18288" tIns="18288" bIns="18288" anchor="t">
+            <a:noAutofit/>
           </a:bodyPr>
           <a:lstStyle/>
           <a:p>
@@ -8951,7 +9287,7 @@
               </a:lnSpc>
             </a:pPr>
             <a:r>
-              <a:rPr sz="850" b="1">
+              <a:rPr sz="800" b="0" i="0">
                 <a:solidFill>
                   <a:srgbClr val="667085"/>
                 </a:solidFill>
@@ -8959,6 +9295,9 @@
               </a:rPr>
               <a:t>WEBOPTIMIZE  •  WEBOPTIMIZE.RU</a:t>
             </a:r>
+            <a:endParaRPr sz="800" b="0" i="0">
+              <a:latin typeface="Montserrat"/>
+            </a:endParaRPr>
           </a:p>
         </p:txBody>
       </p:sp>
@@ -9005,8 +9344,8 @@
           <a:noFill/>
         </p:spPr>
         <p:txBody>
-          <a:bodyPr wrap="none" lIns="18288" rIns="18288" tIns="18288" bIns="18288" anchor="t">
-            <a:spAutoFit/>
+          <a:bodyPr wrap="square" lIns="18288" rIns="18288" tIns="18288" bIns="18288" anchor="t">
+            <a:noAutofit/>
           </a:bodyPr>
           <a:lstStyle/>
           <a:p>
@@ -9016,7 +9355,7 @@
               </a:lnSpc>
             </a:pPr>
             <a:r>
-              <a:rPr sz="1100" b="1">
+              <a:rPr sz="1100" b="0" i="0">
                 <a:solidFill>
                   <a:srgbClr val="008C8C"/>
                 </a:solidFill>
@@ -9024,6 +9363,9 @@
               </a:rPr>
               <a:t>ЭФФЕКТ</a:t>
             </a:r>
+            <a:endParaRPr sz="1100" b="0" i="0">
+              <a:latin typeface="Montserrat"/>
+            </a:endParaRPr>
           </a:p>
         </p:txBody>
       </p:sp>
@@ -9044,8 +9386,8 @@
           <a:noFill/>
         </p:spPr>
         <p:txBody>
-          <a:bodyPr wrap="none" lIns="18288" rIns="18288" tIns="18288" bIns="18288" anchor="t">
-            <a:spAutoFit/>
+          <a:bodyPr wrap="square" lIns="18288" rIns="18288" tIns="18288" bIns="18288" anchor="t">
+            <a:noAutofit/>
           </a:bodyPr>
           <a:lstStyle/>
           <a:p>
@@ -9055,7 +9397,7 @@
               </a:lnSpc>
             </a:pPr>
             <a:r>
-              <a:rPr sz="2600" b="1">
+              <a:rPr sz="2600" b="0" i="0">
                 <a:solidFill>
                   <a:srgbClr val="15243A"/>
                 </a:solidFill>
@@ -9063,6 +9405,9 @@
               </a:rPr>
               <a:t>Каждый участник остаётся в своей системе</a:t>
             </a:r>
+            <a:endParaRPr sz="2600" b="0" i="0">
+              <a:latin typeface="Montserrat"/>
+            </a:endParaRPr>
           </a:p>
         </p:txBody>
       </p:sp>
@@ -9083,8 +9428,8 @@
           <a:noFill/>
         </p:spPr>
         <p:txBody>
-          <a:bodyPr wrap="none" lIns="18288" rIns="18288" tIns="18288" bIns="18288" anchor="t">
-            <a:spAutoFit/>
+          <a:bodyPr wrap="square" lIns="18288" rIns="18288" tIns="18288" bIns="18288" anchor="t">
+            <a:noAutofit/>
           </a:bodyPr>
           <a:lstStyle/>
           <a:p>
@@ -9094,7 +9439,7 @@
               </a:lnSpc>
             </a:pPr>
             <a:r>
-              <a:rPr sz="1200" b="1">
+              <a:rPr sz="1200" b="0" i="0">
                 <a:solidFill>
                   <a:srgbClr val="667085"/>
                 </a:solidFill>
@@ -9102,6 +9447,9 @@
               </a:rPr>
               <a:t>09</a:t>
             </a:r>
+            <a:endParaRPr sz="1200" b="0" i="0">
+              <a:latin typeface="Montserrat"/>
+            </a:endParaRPr>
           </a:p>
         </p:txBody>
       </p:sp>
@@ -9167,8 +9515,8 @@
           <a:noFill/>
         </p:spPr>
         <p:txBody>
-          <a:bodyPr wrap="none" lIns="18288" rIns="18288" tIns="18288" bIns="18288" anchor="t">
-            <a:spAutoFit/>
+          <a:bodyPr wrap="square" lIns="18288" rIns="18288" tIns="18288" bIns="18288" anchor="t">
+            <a:noAutofit/>
           </a:bodyPr>
           <a:lstStyle/>
           <a:p>
@@ -9178,7 +9526,7 @@
               </a:lnSpc>
             </a:pPr>
             <a:r>
-              <a:rPr sz="1900" b="1">
+              <a:rPr sz="1900" b="0" i="0">
                 <a:solidFill>
                   <a:srgbClr val="008C8C"/>
                 </a:solidFill>
@@ -9186,6 +9534,9 @@
               </a:rPr>
               <a:t>Менеджер</a:t>
             </a:r>
+            <a:endParaRPr sz="1900" b="0" i="0">
+              <a:latin typeface="Montserrat"/>
+            </a:endParaRPr>
           </a:p>
         </p:txBody>
       </p:sp>
@@ -9206,8 +9557,8 @@
           <a:noFill/>
         </p:spPr>
         <p:txBody>
-          <a:bodyPr wrap="none" lIns="18288" rIns="18288" tIns="18288">
-            <a:spAutoFit/>
+          <a:bodyPr wrap="square" lIns="18288" rIns="18288" tIns="18288">
+            <a:noAutofit/>
           </a:bodyPr>
           <a:lstStyle/>
           <a:p>
@@ -9226,8 +9577,14 @@
               </a:defRPr>
             </a:pPr>
             <a:r>
+              <a:rPr sz="1200" b="0" i="0">
+                <a:latin typeface="Montserrat"/>
+              </a:rPr>
               <a:t>•  видит исполнение в одной карточке</a:t>
             </a:r>
+            <a:endParaRPr sz="1200" b="0" i="0">
+              <a:latin typeface="Montserrat"/>
+            </a:endParaRPr>
           </a:p>
           <a:p>
             <a:pPr>
@@ -9245,8 +9602,14 @@
               </a:defRPr>
             </a:pPr>
             <a:r>
+              <a:rPr sz="1200" b="0" i="0">
+                <a:latin typeface="Montserrat"/>
+              </a:rPr>
               <a:t>•  не уточняет номер и статус вручную</a:t>
             </a:r>
+            <a:endParaRPr sz="1200" b="0" i="0">
+              <a:latin typeface="Montserrat"/>
+            </a:endParaRPr>
           </a:p>
           <a:p>
             <a:pPr>
@@ -9264,8 +9627,14 @@
               </a:defRPr>
             </a:pPr>
             <a:r>
+              <a:rPr sz="1200" b="0" i="0">
+                <a:latin typeface="Montserrat"/>
+              </a:rPr>
               <a:t>•  может безопасно повторить команду</a:t>
             </a:r>
+            <a:endParaRPr sz="1200" b="0" i="0">
+              <a:latin typeface="Montserrat"/>
+            </a:endParaRPr>
           </a:p>
         </p:txBody>
       </p:sp>
@@ -9331,8 +9700,8 @@
           <a:noFill/>
         </p:spPr>
         <p:txBody>
-          <a:bodyPr wrap="none" lIns="18288" rIns="18288" tIns="18288" bIns="18288" anchor="t">
-            <a:spAutoFit/>
+          <a:bodyPr wrap="square" lIns="18288" rIns="18288" tIns="18288" bIns="18288" anchor="t">
+            <a:noAutofit/>
           </a:bodyPr>
           <a:lstStyle/>
           <a:p>
@@ -9342,7 +9711,7 @@
               </a:lnSpc>
             </a:pPr>
             <a:r>
-              <a:rPr sz="1900" b="1">
+              <a:rPr sz="1900" b="0" i="0">
                 <a:solidFill>
                   <a:srgbClr val="17805E"/>
                 </a:solidFill>
@@ -9350,6 +9719,9 @@
               </a:rPr>
               <a:t>Производство</a:t>
             </a:r>
+            <a:endParaRPr sz="1900" b="0" i="0">
+              <a:latin typeface="Montserrat"/>
+            </a:endParaRPr>
           </a:p>
         </p:txBody>
       </p:sp>
@@ -9370,8 +9742,8 @@
           <a:noFill/>
         </p:spPr>
         <p:txBody>
-          <a:bodyPr wrap="none" lIns="18288" rIns="18288" tIns="18288">
-            <a:spAutoFit/>
+          <a:bodyPr wrap="square" lIns="18288" rIns="18288" tIns="18288">
+            <a:noAutofit/>
           </a:bodyPr>
           <a:lstStyle/>
           <a:p>
@@ -9390,8 +9762,14 @@
               </a:defRPr>
             </a:pPr>
             <a:r>
-              <a:t>•  работает в привычном ЗаказОбщий</a:t>
-            </a:r>
+              <a:rPr sz="1200" b="0" i="0">
+                <a:latin typeface="Montserrat"/>
+              </a:rPr>
+              <a:t>•  работает с привычным заказом 1С</a:t>
+            </a:r>
+            <a:endParaRPr sz="1200" b="0" i="0">
+              <a:latin typeface="Montserrat"/>
+            </a:endParaRPr>
           </a:p>
           <a:p>
             <a:pPr>
@@ -9409,8 +9787,14 @@
               </a:defRPr>
             </a:pPr>
             <a:r>
+              <a:rPr sz="1200" b="0" i="0">
+                <a:latin typeface="Montserrat"/>
+              </a:rPr>
               <a:t>•  не открывает Bitrix24</a:t>
             </a:r>
+            <a:endParaRPr sz="1200" b="0" i="0">
+              <a:latin typeface="Montserrat"/>
+            </a:endParaRPr>
           </a:p>
           <a:p>
             <a:pPr>
@@ -9428,8 +9812,14 @@
               </a:defRPr>
             </a:pPr>
             <a:r>
+              <a:rPr sz="1200" b="0" i="0">
+                <a:latin typeface="Montserrat"/>
+              </a:rPr>
               <a:t>•  владеет статусами, сроками и суммой</a:t>
             </a:r>
+            <a:endParaRPr sz="1200" b="0" i="0">
+              <a:latin typeface="Montserrat"/>
+            </a:endParaRPr>
           </a:p>
         </p:txBody>
       </p:sp>
@@ -9495,8 +9885,8 @@
           <a:noFill/>
         </p:spPr>
         <p:txBody>
-          <a:bodyPr wrap="none" lIns="18288" rIns="18288" tIns="18288" bIns="18288" anchor="t">
-            <a:spAutoFit/>
+          <a:bodyPr wrap="square" lIns="18288" rIns="18288" tIns="18288" bIns="18288" anchor="t">
+            <a:noAutofit/>
           </a:bodyPr>
           <a:lstStyle/>
           <a:p>
@@ -9506,7 +9896,7 @@
               </a:lnSpc>
             </a:pPr>
             <a:r>
-              <a:rPr sz="1900" b="1">
+              <a:rPr sz="1900" b="0" i="0">
                 <a:solidFill>
                   <a:srgbClr val="1769AA"/>
                 </a:solidFill>
@@ -9514,6 +9904,9 @@
               </a:rPr>
               <a:t>Руководитель</a:t>
             </a:r>
+            <a:endParaRPr sz="1900" b="0" i="0">
+              <a:latin typeface="Montserrat"/>
+            </a:endParaRPr>
           </a:p>
         </p:txBody>
       </p:sp>
@@ -9534,8 +9927,8 @@
           <a:noFill/>
         </p:spPr>
         <p:txBody>
-          <a:bodyPr wrap="none" lIns="18288" rIns="18288" tIns="18288">
-            <a:spAutoFit/>
+          <a:bodyPr wrap="square" lIns="18288" rIns="18288" tIns="18288">
+            <a:noAutofit/>
           </a:bodyPr>
           <a:lstStyle/>
           <a:p>
@@ -9554,8 +9947,14 @@
               </a:defRPr>
             </a:pPr>
             <a:r>
-              <a:t>•  видит однозначную связь сущностей</a:t>
-            </a:r>
+              <a:rPr sz="1200" b="0" i="0">
+                <a:latin typeface="Montserrat"/>
+              </a:rPr>
+              <a:t>•  видит связь сделки и заказа</a:t>
+            </a:r>
+            <a:endParaRPr sz="1200" b="0" i="0">
+              <a:latin typeface="Montserrat"/>
+            </a:endParaRPr>
           </a:p>
           <a:p>
             <a:pPr>
@@ -9573,8 +9972,14 @@
               </a:defRPr>
             </a:pPr>
             <a:r>
+              <a:rPr sz="1200" b="0" i="0">
+                <a:latin typeface="Montserrat"/>
+              </a:rPr>
               <a:t>•  отделяет бизнес-статус от ошибки</a:t>
             </a:r>
+            <a:endParaRPr sz="1200" b="0" i="0">
+              <a:latin typeface="Montserrat"/>
+            </a:endParaRPr>
           </a:p>
           <a:p>
             <a:pPr>
@@ -9592,8 +9997,14 @@
               </a:defRPr>
             </a:pPr>
             <a:r>
-              <a:t>•  может развивать контур поэтапно</a:t>
-            </a:r>
+              <a:rPr sz="1200" b="0" i="0">
+                <a:latin typeface="Montserrat"/>
+              </a:rPr>
+              <a:t>•  может развивать решение поэтапно</a:t>
+            </a:r>
+            <a:endParaRPr sz="1200" b="0" i="0">
+              <a:latin typeface="Montserrat"/>
+            </a:endParaRPr>
           </a:p>
         </p:txBody>
       </p:sp>
@@ -9614,8 +10025,8 @@
           <a:noFill/>
         </p:spPr>
         <p:txBody>
-          <a:bodyPr wrap="none" lIns="18288" rIns="18288" tIns="18288" bIns="18288" anchor="t">
-            <a:spAutoFit/>
+          <a:bodyPr wrap="square" lIns="18288" rIns="18288" tIns="18288" bIns="18288" anchor="t">
+            <a:noAutofit/>
           </a:bodyPr>
           <a:lstStyle/>
           <a:p>
@@ -9625,14 +10036,17 @@
               </a:lnSpc>
             </a:pPr>
             <a:r>
-              <a:rPr sz="1050" b="0">
+              <a:rPr sz="1000" b="0" i="0">
                 <a:solidFill>
                   <a:srgbClr val="667085"/>
                 </a:solidFill>
                 <a:latin typeface="Montserrat"/>
               </a:rPr>
-              <a:t>В кейсе не используются придуманные проценты роста или экономии: показан подтверждённый технический и качественный эффект.</a:t>
-            </a:r>
+              <a:t>В кейсе нет придуманных процентов роста или экономии: показаны проверенная работоспособность и практический эффект.</a:t>
+            </a:r>
+            <a:endParaRPr sz="1000" b="0" i="0">
+              <a:latin typeface="Montserrat"/>
+            </a:endParaRPr>
           </a:p>
         </p:txBody>
       </p:sp>
@@ -9653,8 +10067,8 @@
           <a:noFill/>
         </p:spPr>
         <p:txBody>
-          <a:bodyPr wrap="none" lIns="18288" rIns="18288" tIns="18288" bIns="18288" anchor="t">
-            <a:spAutoFit/>
+          <a:bodyPr wrap="square" lIns="18288" rIns="18288" tIns="18288" bIns="18288" anchor="t">
+            <a:noAutofit/>
           </a:bodyPr>
           <a:lstStyle/>
           <a:p>
@@ -9664,7 +10078,7 @@
               </a:lnSpc>
             </a:pPr>
             <a:r>
-              <a:rPr sz="850" b="1">
+              <a:rPr sz="800" b="0" i="0">
                 <a:solidFill>
                   <a:srgbClr val="667085"/>
                 </a:solidFill>
@@ -9672,6 +10086,9 @@
               </a:rPr>
               <a:t>WEBOPTIMIZE  •  WEBOPTIMIZE.RU</a:t>
             </a:r>
+            <a:endParaRPr sz="800" b="0" i="0">
+              <a:latin typeface="Montserrat"/>
+            </a:endParaRPr>
           </a:p>
         </p:txBody>
       </p:sp>

</xml_diff>

<commit_message>
Add quantified business results to PTZ case
</commit_message>
<xml_diff>
--- a/downloads/ptz-steklo-weboptimize-case.pptx
+++ b/downloads/ptz-steklo-weboptimize-case.pptx
@@ -3267,8 +3267,8 @@
                 </a:solidFill>
                 <a:latin typeface="Montserrat"/>
               </a:rPr>
-              <a:t>Повтор безопасен, производственные данные возвращаются в Bitrix24,
-а база 1С остаётся закрытой.</a:t>
+              <a:t>Компания сохранила текущий штат, ускорила работу сотрудников
+и устранила повторный ввод между системами.</a:t>
             </a:r>
             <a:endParaRPr sz="1700" b="0" i="0">
               <a:latin typeface="Montserrat"/>
@@ -3355,7 +3355,7 @@
                 </a:solidFill>
                 <a:latin typeface="Montserrat"/>
               </a:rPr>
-              <a:t>1 к 1</a:t>
+              <a:t>до 1 млн руб.</a:t>
             </a:r>
             <a:endParaRPr sz="1900" b="0" i="0">
               <a:latin typeface="Montserrat"/>
@@ -3397,7 +3397,7 @@
                 </a:solidFill>
                 <a:latin typeface="Montserrat"/>
               </a:rPr>
-              <a:t>одна сделка — один заказ</a:t>
+              <a:t>экономии в год</a:t>
             </a:r>
             <a:endParaRPr sz="1000" b="0" i="0">
               <a:latin typeface="Montserrat"/>
@@ -3484,7 +3484,7 @@
                 </a:solidFill>
                 <a:latin typeface="Montserrat"/>
               </a:rPr>
-              <a:t>0 дублей</a:t>
+              <a:t>3–5 мес</a:t>
             </a:r>
             <a:endParaRPr sz="1900" b="0" i="0">
               <a:latin typeface="Montserrat"/>
@@ -3526,7 +3526,7 @@
                 </a:solidFill>
                 <a:latin typeface="Montserrat"/>
               </a:rPr>
-              <a:t>при повторной отправке</a:t>
+              <a:t>окупаемость проекта</a:t>
             </a:r>
             <a:endParaRPr sz="1000" b="0" i="0">
               <a:latin typeface="Montserrat"/>
@@ -3613,7 +3613,7 @@
                 </a:solidFill>
                 <a:latin typeface="Montserrat"/>
               </a:rPr>
-              <a:t>Закрытая 1С</a:t>
+              <a:t>0 новых</a:t>
             </a:r>
             <a:endParaRPr sz="1900" b="0" i="0">
               <a:latin typeface="Montserrat"/>
@@ -3655,7 +3655,7 @@
                 </a:solidFill>
                 <a:latin typeface="Montserrat"/>
               </a:rPr>
-              <a:t>входящий доступ не нужен</a:t>
+              <a:t>сотрудников в штате</a:t>
             </a:r>
             <a:endParaRPr sz="1000" b="0" i="0">
               <a:latin typeface="Montserrat"/>
@@ -3742,7 +3742,7 @@
                 </a:solidFill>
                 <a:latin typeface="Montserrat"/>
               </a:rPr>
-              <a:t>Работает</a:t>
+              <a:t>0 дублей</a:t>
             </a:r>
             <a:endParaRPr sz="1900" b="0" i="0">
               <a:latin typeface="Montserrat"/>
@@ -3784,7 +3784,7 @@
                 </a:solidFill>
                 <a:latin typeface="Montserrat"/>
               </a:rPr>
-              <a:t>состояние проверено</a:t>
+              <a:t>при повторной отправке</a:t>
             </a:r>
             <a:endParaRPr sz="1000" b="0" i="0">
               <a:latin typeface="Montserrat"/>
@@ -9361,7 +9361,7 @@
                 </a:solidFill>
                 <a:latin typeface="Montserrat"/>
               </a:rPr>
-              <a:t>ЭФФЕКТ</a:t>
+              <a:t>БИЗНЕС-РЕЗУЛЬТАТ</a:t>
             </a:r>
             <a:endParaRPr sz="1100" b="0" i="0">
               <a:latin typeface="Montserrat"/>
@@ -9403,7 +9403,7 @@
                 </a:solidFill>
                 <a:latin typeface="Montserrat"/>
               </a:rPr>
-              <a:t>Каждый участник остаётся в своей системе</a:t>
+              <a:t>Полученная экономия и рост производительности</a:t>
             </a:r>
             <a:endParaRPr sz="2600" b="0" i="0">
               <a:latin typeface="Montserrat"/>
@@ -9461,8 +9461,8 @@
         </p:nvSpPr>
         <p:spPr>
           <a:xfrm>
-            <a:off x="640080" y="1600200"/>
-            <a:ext cx="3401568" cy="3611880"/>
+            <a:off x="640080" y="1572768"/>
+            <a:ext cx="5376672" cy="1417320"/>
           </a:xfrm>
           <a:prstGeom prst="roundRect">
             <a:avLst/>
@@ -9506,35 +9506,35 @@
         </p:nvSpPr>
         <p:spPr>
           <a:xfrm>
-            <a:off x="868680" y="1847088"/>
-            <a:ext cx="2834640" cy="365760"/>
-          </a:xfrm>
-          <a:prstGeom prst="rect">
-            <a:avLst/>
-          </a:prstGeom>
-          <a:noFill/>
-        </p:spPr>
-        <p:txBody>
-          <a:bodyPr wrap="square" lIns="18288" rIns="18288" tIns="18288" bIns="18288" anchor="t">
-            <a:noAutofit/>
-          </a:bodyPr>
-          <a:lstStyle/>
-          <a:p>
-            <a:pPr algn="l">
-              <a:lnSpc>
-                <a:spcPct val="105000"/>
-              </a:lnSpc>
-            </a:pPr>
-            <a:r>
-              <a:rPr sz="1900" b="0" i="0">
+            <a:off x="877824" y="1783080"/>
+            <a:ext cx="4846320" cy="438912"/>
+          </a:xfrm>
+          <a:prstGeom prst="rect">
+            <a:avLst/>
+          </a:prstGeom>
+          <a:noFill/>
+        </p:spPr>
+        <p:txBody>
+          <a:bodyPr wrap="square" lIns="18288" rIns="18288" tIns="18288" bIns="18288" anchor="t">
+            <a:noAutofit/>
+          </a:bodyPr>
+          <a:lstStyle/>
+          <a:p>
+            <a:pPr algn="l">
+              <a:lnSpc>
+                <a:spcPct val="105000"/>
+              </a:lnSpc>
+            </a:pPr>
+            <a:r>
+              <a:rPr sz="2400" b="0" i="0">
                 <a:solidFill>
                   <a:srgbClr val="008C8C"/>
                 </a:solidFill>
                 <a:latin typeface="Montserrat"/>
               </a:rPr>
-              <a:t>Менеджер</a:t>
-            </a:r>
-            <a:endParaRPr sz="1900" b="0" i="0">
+              <a:t>−80–90%</a:t>
+            </a:r>
+            <a:endParaRPr sz="2400" b="0" i="0">
               <a:latin typeface="Montserrat"/>
             </a:endParaRPr>
           </a:p>
@@ -9548,91 +9548,35 @@
         </p:nvSpPr>
         <p:spPr>
           <a:xfrm>
-            <a:off x="868680" y="2487168"/>
-            <a:ext cx="2834640" cy="2057400"/>
-          </a:xfrm>
-          <a:prstGeom prst="rect">
-            <a:avLst/>
-          </a:prstGeom>
-          <a:noFill/>
-        </p:spPr>
-        <p:txBody>
-          <a:bodyPr wrap="square" lIns="18288" rIns="18288" tIns="18288">
-            <a:noAutofit/>
-          </a:bodyPr>
-          <a:lstStyle/>
-          <a:p>
-            <a:pPr>
-              <a:lnSpc>
-                <a:spcPct val="105000"/>
-              </a:lnSpc>
-              <a:spcAft>
-                <a:spcPts val="800"/>
-              </a:spcAft>
-              <a:defRPr sz="1200">
-                <a:solidFill>
-                  <a:srgbClr val="17212B"/>
-                </a:solidFill>
-                <a:latin typeface="Montserrat"/>
-              </a:defRPr>
-            </a:pPr>
-            <a:r>
-              <a:rPr sz="1200" b="0" i="0">
-                <a:latin typeface="Montserrat"/>
-              </a:rPr>
-              <a:t>•  видит исполнение в одной карточке</a:t>
-            </a:r>
-            <a:endParaRPr sz="1200" b="0" i="0">
-              <a:latin typeface="Montserrat"/>
-            </a:endParaRPr>
-          </a:p>
-          <a:p>
-            <a:pPr>
-              <a:lnSpc>
-                <a:spcPct val="105000"/>
-              </a:lnSpc>
-              <a:spcAft>
-                <a:spcPts val="800"/>
-              </a:spcAft>
-              <a:defRPr sz="1200">
-                <a:solidFill>
-                  <a:srgbClr val="17212B"/>
-                </a:solidFill>
-                <a:latin typeface="Montserrat"/>
-              </a:defRPr>
-            </a:pPr>
-            <a:r>
-              <a:rPr sz="1200" b="0" i="0">
-                <a:latin typeface="Montserrat"/>
-              </a:rPr>
-              <a:t>•  не уточняет номер и статус вручную</a:t>
-            </a:r>
-            <a:endParaRPr sz="1200" b="0" i="0">
-              <a:latin typeface="Montserrat"/>
-            </a:endParaRPr>
-          </a:p>
-          <a:p>
-            <a:pPr>
-              <a:lnSpc>
-                <a:spcPct val="105000"/>
-              </a:lnSpc>
-              <a:spcAft>
-                <a:spcPts val="800"/>
-              </a:spcAft>
-              <a:defRPr sz="1200">
-                <a:solidFill>
-                  <a:srgbClr val="17212B"/>
-                </a:solidFill>
-                <a:latin typeface="Montserrat"/>
-              </a:defRPr>
-            </a:pPr>
-            <a:r>
-              <a:rPr sz="1200" b="0" i="0">
-                <a:latin typeface="Montserrat"/>
-              </a:rPr>
-              <a:t>•  может безопасно повторить команду</a:t>
-            </a:r>
-            <a:endParaRPr sz="1200" b="0" i="0">
+            <a:off x="877824" y="2368296"/>
+            <a:ext cx="4846320" cy="292608"/>
+          </a:xfrm>
+          <a:prstGeom prst="rect">
+            <a:avLst/>
+          </a:prstGeom>
+          <a:noFill/>
+        </p:spPr>
+        <p:txBody>
+          <a:bodyPr wrap="square" lIns="18288" rIns="18288" tIns="18288" bIns="18288" anchor="t">
+            <a:noAutofit/>
+          </a:bodyPr>
+          <a:lstStyle/>
+          <a:p>
+            <a:pPr algn="l">
+              <a:lnSpc>
+                <a:spcPct val="105000"/>
+              </a:lnSpc>
+            </a:pPr>
+            <a:r>
+              <a:rPr sz="1100" b="0" i="0">
+                <a:solidFill>
+                  <a:srgbClr val="667085"/>
+                </a:solidFill>
+                <a:latin typeface="Montserrat"/>
+              </a:rPr>
+              <a:t>15–25 минут до • 2–3 минуты после</a:t>
+            </a:r>
+            <a:endParaRPr sz="1100" b="0" i="0">
               <a:latin typeface="Montserrat"/>
             </a:endParaRPr>
           </a:p>
@@ -9646,8 +9590,8 @@
         </p:nvSpPr>
         <p:spPr>
           <a:xfrm>
-            <a:off x="4389120" y="1600200"/>
-            <a:ext cx="3401568" cy="3611880"/>
+            <a:off x="6172200" y="1572768"/>
+            <a:ext cx="5376672" cy="1417320"/>
           </a:xfrm>
           <a:prstGeom prst="roundRect">
             <a:avLst/>
@@ -9691,35 +9635,35 @@
         </p:nvSpPr>
         <p:spPr>
           <a:xfrm>
-            <a:off x="4617720" y="1847088"/>
-            <a:ext cx="2834640" cy="365760"/>
-          </a:xfrm>
-          <a:prstGeom prst="rect">
-            <a:avLst/>
-          </a:prstGeom>
-          <a:noFill/>
-        </p:spPr>
-        <p:txBody>
-          <a:bodyPr wrap="square" lIns="18288" rIns="18288" tIns="18288" bIns="18288" anchor="t">
-            <a:noAutofit/>
-          </a:bodyPr>
-          <a:lstStyle/>
-          <a:p>
-            <a:pPr algn="l">
-              <a:lnSpc>
-                <a:spcPct val="105000"/>
-              </a:lnSpc>
-            </a:pPr>
-            <a:r>
-              <a:rPr sz="1900" b="0" i="0">
-                <a:solidFill>
-                  <a:srgbClr val="17805E"/>
-                </a:solidFill>
-                <a:latin typeface="Montserrat"/>
-              </a:rPr>
-              <a:t>Производство</a:t>
-            </a:r>
-            <a:endParaRPr sz="1900" b="0" i="0">
+            <a:off x="6409944" y="1783080"/>
+            <a:ext cx="4846320" cy="438912"/>
+          </a:xfrm>
+          <a:prstGeom prst="rect">
+            <a:avLst/>
+          </a:prstGeom>
+          <a:noFill/>
+        </p:spPr>
+        <p:txBody>
+          <a:bodyPr wrap="square" lIns="18288" rIns="18288" tIns="18288" bIns="18288" anchor="t">
+            <a:noAutofit/>
+          </a:bodyPr>
+          <a:lstStyle/>
+          <a:p>
+            <a:pPr algn="l">
+              <a:lnSpc>
+                <a:spcPct val="105000"/>
+              </a:lnSpc>
+            </a:pPr>
+            <a:r>
+              <a:rPr sz="2400" b="0" i="0">
+                <a:solidFill>
+                  <a:srgbClr val="1769AA"/>
+                </a:solidFill>
+                <a:latin typeface="Montserrat"/>
+              </a:rPr>
+              <a:t>94–156 ч/мес</a:t>
+            </a:r>
+            <a:endParaRPr sz="2400" b="0" i="0">
               <a:latin typeface="Montserrat"/>
             </a:endParaRPr>
           </a:p>
@@ -9733,91 +9677,35 @@
         </p:nvSpPr>
         <p:spPr>
           <a:xfrm>
-            <a:off x="4617720" y="2487168"/>
-            <a:ext cx="2834640" cy="2057400"/>
-          </a:xfrm>
-          <a:prstGeom prst="rect">
-            <a:avLst/>
-          </a:prstGeom>
-          <a:noFill/>
-        </p:spPr>
-        <p:txBody>
-          <a:bodyPr wrap="square" lIns="18288" rIns="18288" tIns="18288">
-            <a:noAutofit/>
-          </a:bodyPr>
-          <a:lstStyle/>
-          <a:p>
-            <a:pPr>
-              <a:lnSpc>
-                <a:spcPct val="105000"/>
-              </a:lnSpc>
-              <a:spcAft>
-                <a:spcPts val="800"/>
-              </a:spcAft>
-              <a:defRPr sz="1200">
-                <a:solidFill>
-                  <a:srgbClr val="17212B"/>
-                </a:solidFill>
-                <a:latin typeface="Montserrat"/>
-              </a:defRPr>
-            </a:pPr>
-            <a:r>
-              <a:rPr sz="1200" b="0" i="0">
-                <a:latin typeface="Montserrat"/>
-              </a:rPr>
-              <a:t>•  работает с привычным заказом 1С</a:t>
-            </a:r>
-            <a:endParaRPr sz="1200" b="0" i="0">
-              <a:latin typeface="Montserrat"/>
-            </a:endParaRPr>
-          </a:p>
-          <a:p>
-            <a:pPr>
-              <a:lnSpc>
-                <a:spcPct val="105000"/>
-              </a:lnSpc>
-              <a:spcAft>
-                <a:spcPts val="800"/>
-              </a:spcAft>
-              <a:defRPr sz="1200">
-                <a:solidFill>
-                  <a:srgbClr val="17212B"/>
-                </a:solidFill>
-                <a:latin typeface="Montserrat"/>
-              </a:defRPr>
-            </a:pPr>
-            <a:r>
-              <a:rPr sz="1200" b="0" i="0">
-                <a:latin typeface="Montserrat"/>
-              </a:rPr>
-              <a:t>•  не открывает Bitrix24</a:t>
-            </a:r>
-            <a:endParaRPr sz="1200" b="0" i="0">
-              <a:latin typeface="Montserrat"/>
-            </a:endParaRPr>
-          </a:p>
-          <a:p>
-            <a:pPr>
-              <a:lnSpc>
-                <a:spcPct val="105000"/>
-              </a:lnSpc>
-              <a:spcAft>
-                <a:spcPts val="800"/>
-              </a:spcAft>
-              <a:defRPr sz="1200">
-                <a:solidFill>
-                  <a:srgbClr val="17212B"/>
-                </a:solidFill>
-                <a:latin typeface="Montserrat"/>
-              </a:defRPr>
-            </a:pPr>
-            <a:r>
-              <a:rPr sz="1200" b="0" i="0">
-                <a:latin typeface="Montserrat"/>
-              </a:rPr>
-              <a:t>•  владеет статусами, сроками и суммой</a:t>
-            </a:r>
-            <a:endParaRPr sz="1200" b="0" i="0">
+            <a:off x="6409944" y="2368296"/>
+            <a:ext cx="4846320" cy="292608"/>
+          </a:xfrm>
+          <a:prstGeom prst="rect">
+            <a:avLst/>
+          </a:prstGeom>
+          <a:noFill/>
+        </p:spPr>
+        <p:txBody>
+          <a:bodyPr wrap="square" lIns="18288" rIns="18288" tIns="18288" bIns="18288" anchor="t">
+            <a:noAutofit/>
+          </a:bodyPr>
+          <a:lstStyle/>
+          <a:p>
+            <a:pPr algn="l">
+              <a:lnSpc>
+                <a:spcPct val="105000"/>
+              </a:lnSpc>
+            </a:pPr>
+            <a:r>
+              <a:rPr sz="1100" b="0" i="0">
+                <a:solidFill>
+                  <a:srgbClr val="667085"/>
+                </a:solidFill>
+                <a:latin typeface="Montserrat"/>
+              </a:rPr>
+              <a:t>высвобождено рабочего времени</a:t>
+            </a:r>
+            <a:endParaRPr sz="1100" b="0" i="0">
               <a:latin typeface="Montserrat"/>
             </a:endParaRPr>
           </a:p>
@@ -9831,8 +9719,8 @@
         </p:nvSpPr>
         <p:spPr>
           <a:xfrm>
-            <a:off x="8138159" y="1600200"/>
-            <a:ext cx="3401568" cy="3611880"/>
+            <a:off x="640080" y="3310128"/>
+            <a:ext cx="5376672" cy="1417320"/>
           </a:xfrm>
           <a:prstGeom prst="roundRect">
             <a:avLst/>
@@ -9876,35 +9764,35 @@
         </p:nvSpPr>
         <p:spPr>
           <a:xfrm>
-            <a:off x="8366759" y="1847088"/>
-            <a:ext cx="2834640" cy="365760"/>
-          </a:xfrm>
-          <a:prstGeom prst="rect">
-            <a:avLst/>
-          </a:prstGeom>
-          <a:noFill/>
-        </p:spPr>
-        <p:txBody>
-          <a:bodyPr wrap="square" lIns="18288" rIns="18288" tIns="18288" bIns="18288" anchor="t">
-            <a:noAutofit/>
-          </a:bodyPr>
-          <a:lstStyle/>
-          <a:p>
-            <a:pPr algn="l">
-              <a:lnSpc>
-                <a:spcPct val="105000"/>
-              </a:lnSpc>
-            </a:pPr>
-            <a:r>
-              <a:rPr sz="1900" b="0" i="0">
-                <a:solidFill>
-                  <a:srgbClr val="1769AA"/>
-                </a:solidFill>
-                <a:latin typeface="Montserrat"/>
-              </a:rPr>
-              <a:t>Руководитель</a:t>
-            </a:r>
-            <a:endParaRPr sz="1900" b="0" i="0">
+            <a:off x="877824" y="3520440"/>
+            <a:ext cx="4846320" cy="438912"/>
+          </a:xfrm>
+          <a:prstGeom prst="rect">
+            <a:avLst/>
+          </a:prstGeom>
+          <a:noFill/>
+        </p:spPr>
+        <p:txBody>
+          <a:bodyPr wrap="square" lIns="18288" rIns="18288" tIns="18288" bIns="18288" anchor="t">
+            <a:noAutofit/>
+          </a:bodyPr>
+          <a:lstStyle/>
+          <a:p>
+            <a:pPr algn="l">
+              <a:lnSpc>
+                <a:spcPct val="105000"/>
+              </a:lnSpc>
+            </a:pPr>
+            <a:r>
+              <a:rPr sz="2400" b="0" i="0">
+                <a:solidFill>
+                  <a:srgbClr val="17805E"/>
+                </a:solidFill>
+                <a:latin typeface="Montserrat"/>
+              </a:rPr>
+              <a:t>0,6–1 ставки</a:t>
+            </a:r>
+            <a:endParaRPr sz="2400" b="0" i="0">
               <a:latin typeface="Montserrat"/>
             </a:endParaRPr>
           </a:p>
@@ -9918,106 +9806,224 @@
         </p:nvSpPr>
         <p:spPr>
           <a:xfrm>
-            <a:off x="8366759" y="2487168"/>
-            <a:ext cx="2834640" cy="2057400"/>
-          </a:xfrm>
-          <a:prstGeom prst="rect">
-            <a:avLst/>
-          </a:prstGeom>
-          <a:noFill/>
-        </p:spPr>
-        <p:txBody>
-          <a:bodyPr wrap="square" lIns="18288" rIns="18288" tIns="18288">
-            <a:noAutofit/>
-          </a:bodyPr>
-          <a:lstStyle/>
-          <a:p>
-            <a:pPr>
-              <a:lnSpc>
-                <a:spcPct val="105000"/>
-              </a:lnSpc>
-              <a:spcAft>
-                <a:spcPts val="800"/>
-              </a:spcAft>
-              <a:defRPr sz="1200">
-                <a:solidFill>
-                  <a:srgbClr val="17212B"/>
-                </a:solidFill>
-                <a:latin typeface="Montserrat"/>
-              </a:defRPr>
-            </a:pPr>
-            <a:r>
-              <a:rPr sz="1200" b="0" i="0">
-                <a:latin typeface="Montserrat"/>
-              </a:rPr>
-              <a:t>•  видит связь сделки и заказа</a:t>
-            </a:r>
-            <a:endParaRPr sz="1200" b="0" i="0">
-              <a:latin typeface="Montserrat"/>
-            </a:endParaRPr>
-          </a:p>
-          <a:p>
-            <a:pPr>
-              <a:lnSpc>
-                <a:spcPct val="105000"/>
-              </a:lnSpc>
-              <a:spcAft>
-                <a:spcPts val="800"/>
-              </a:spcAft>
-              <a:defRPr sz="1200">
-                <a:solidFill>
-                  <a:srgbClr val="17212B"/>
-                </a:solidFill>
-                <a:latin typeface="Montserrat"/>
-              </a:defRPr>
-            </a:pPr>
-            <a:r>
-              <a:rPr sz="1200" b="0" i="0">
-                <a:latin typeface="Montserrat"/>
-              </a:rPr>
-              <a:t>•  отделяет бизнес-статус от ошибки</a:t>
-            </a:r>
-            <a:endParaRPr sz="1200" b="0" i="0">
-              <a:latin typeface="Montserrat"/>
-            </a:endParaRPr>
-          </a:p>
-          <a:p>
-            <a:pPr>
-              <a:lnSpc>
-                <a:spcPct val="105000"/>
-              </a:lnSpc>
-              <a:spcAft>
-                <a:spcPts val="800"/>
-              </a:spcAft>
-              <a:defRPr sz="1200">
-                <a:solidFill>
-                  <a:srgbClr val="17212B"/>
-                </a:solidFill>
-                <a:latin typeface="Montserrat"/>
-              </a:defRPr>
-            </a:pPr>
-            <a:r>
-              <a:rPr sz="1200" b="0" i="0">
-                <a:latin typeface="Montserrat"/>
-              </a:rPr>
-              <a:t>•  может развивать решение поэтапно</a:t>
-            </a:r>
-            <a:endParaRPr sz="1200" b="0" i="0">
-              <a:latin typeface="Montserrat"/>
-            </a:endParaRPr>
-          </a:p>
-        </p:txBody>
-      </p:sp>
-      <p:sp>
-        <p:nvSpPr>
-          <p:cNvPr id="14" name="TextBox 13"/>
-          <p:cNvSpPr txBox="1"/>
-          <p:nvPr/>
-        </p:nvSpPr>
-        <p:spPr>
-          <a:xfrm>
-            <a:off x="685800" y="5687568"/>
-            <a:ext cx="10789920" cy="384048"/>
+            <a:off x="877824" y="4105656"/>
+            <a:ext cx="4846320" cy="292608"/>
+          </a:xfrm>
+          <a:prstGeom prst="rect">
+            <a:avLst/>
+          </a:prstGeom>
+          <a:noFill/>
+        </p:spPr>
+        <p:txBody>
+          <a:bodyPr wrap="square" lIns="18288" rIns="18288" tIns="18288" bIns="18288" anchor="t">
+            <a:noAutofit/>
+          </a:bodyPr>
+          <a:lstStyle/>
+          <a:p>
+            <a:pPr algn="l">
+              <a:lnSpc>
+                <a:spcPct val="105000"/>
+              </a:lnSpc>
+            </a:pPr>
+            <a:r>
+              <a:rPr sz="1100" b="0" i="0">
+                <a:solidFill>
+                  <a:srgbClr val="667085"/>
+                </a:solidFill>
+                <a:latin typeface="Montserrat"/>
+              </a:rPr>
+              <a:t>полученный запас производительности</a:t>
+            </a:r>
+            <a:endParaRPr sz="1100" b="0" i="0">
+              <a:latin typeface="Montserrat"/>
+            </a:endParaRPr>
+          </a:p>
+        </p:txBody>
+      </p:sp>
+      <p:sp>
+        <p:nvSpPr>
+          <p:cNvPr id="14" name="Rounded Rectangle 13"/>
+          <p:cNvSpPr/>
+          <p:nvPr/>
+        </p:nvSpPr>
+        <p:spPr>
+          <a:xfrm>
+            <a:off x="6172200" y="3310128"/>
+            <a:ext cx="5376672" cy="1417320"/>
+          </a:xfrm>
+          <a:prstGeom prst="roundRect">
+            <a:avLst/>
+          </a:prstGeom>
+          <a:solidFill>
+            <a:srgbClr val="F3F6F8"/>
+          </a:solidFill>
+          <a:ln w="10160">
+            <a:solidFill>
+              <a:srgbClr val="D7E0E7"/>
+            </a:solidFill>
+          </a:ln>
+        </p:spPr>
+        <p:style>
+          <a:lnRef idx="1">
+            <a:schemeClr val="accent1"/>
+          </a:lnRef>
+          <a:fillRef idx="3">
+            <a:schemeClr val="accent1"/>
+          </a:fillRef>
+          <a:effectRef idx="2">
+            <a:schemeClr val="accent1"/>
+          </a:effectRef>
+          <a:fontRef idx="minor">
+            <a:schemeClr val="lt1"/>
+          </a:fontRef>
+        </p:style>
+        <p:txBody>
+          <a:bodyPr rtlCol="0" anchor="ctr"/>
+          <a:lstStyle/>
+          <a:p>
+            <a:pPr algn="ctr"/>
+          </a:p>
+        </p:txBody>
+      </p:sp>
+      <p:sp>
+        <p:nvSpPr>
+          <p:cNvPr id="15" name="TextBox 14"/>
+          <p:cNvSpPr txBox="1"/>
+          <p:nvPr/>
+        </p:nvSpPr>
+        <p:spPr>
+          <a:xfrm>
+            <a:off x="6409944" y="3520440"/>
+            <a:ext cx="4846320" cy="438912"/>
+          </a:xfrm>
+          <a:prstGeom prst="rect">
+            <a:avLst/>
+          </a:prstGeom>
+          <a:noFill/>
+        </p:spPr>
+        <p:txBody>
+          <a:bodyPr wrap="square" lIns="18288" rIns="18288" tIns="18288" bIns="18288" anchor="t">
+            <a:noAutofit/>
+          </a:bodyPr>
+          <a:lstStyle/>
+          <a:p>
+            <a:pPr algn="l">
+              <a:lnSpc>
+                <a:spcPct val="105000"/>
+              </a:lnSpc>
+            </a:pPr>
+            <a:r>
+              <a:rPr sz="2400" b="0" i="0">
+                <a:solidFill>
+                  <a:srgbClr val="D99400"/>
+                </a:solidFill>
+                <a:latin typeface="Montserrat"/>
+              </a:rPr>
+              <a:t>0,5–1 млн руб.</a:t>
+            </a:r>
+            <a:endParaRPr sz="2400" b="0" i="0">
+              <a:latin typeface="Montserrat"/>
+            </a:endParaRPr>
+          </a:p>
+        </p:txBody>
+      </p:sp>
+      <p:sp>
+        <p:nvSpPr>
+          <p:cNvPr id="16" name="TextBox 15"/>
+          <p:cNvSpPr txBox="1"/>
+          <p:nvPr/>
+        </p:nvSpPr>
+        <p:spPr>
+          <a:xfrm>
+            <a:off x="6409944" y="4105656"/>
+            <a:ext cx="4846320" cy="292608"/>
+          </a:xfrm>
+          <a:prstGeom prst="rect">
+            <a:avLst/>
+          </a:prstGeom>
+          <a:noFill/>
+        </p:spPr>
+        <p:txBody>
+          <a:bodyPr wrap="square" lIns="18288" rIns="18288" tIns="18288" bIns="18288" anchor="t">
+            <a:noAutofit/>
+          </a:bodyPr>
+          <a:lstStyle/>
+          <a:p>
+            <a:pPr algn="l">
+              <a:lnSpc>
+                <a:spcPct val="105000"/>
+              </a:lnSpc>
+            </a:pPr>
+            <a:r>
+              <a:rPr sz="1100" b="0" i="0">
+                <a:solidFill>
+                  <a:srgbClr val="667085"/>
+                </a:solidFill>
+                <a:latin typeface="Montserrat"/>
+              </a:rPr>
+              <a:t>полученная экономия в год</a:t>
+            </a:r>
+            <a:endParaRPr sz="1100" b="0" i="0">
+              <a:latin typeface="Montserrat"/>
+            </a:endParaRPr>
+          </a:p>
+        </p:txBody>
+      </p:sp>
+      <p:sp>
+        <p:nvSpPr>
+          <p:cNvPr id="17" name="Rounded Rectangle 16"/>
+          <p:cNvSpPr/>
+          <p:nvPr/>
+        </p:nvSpPr>
+        <p:spPr>
+          <a:xfrm>
+            <a:off x="640080" y="5056632"/>
+            <a:ext cx="10908792" cy="694944"/>
+          </a:xfrm>
+          <a:prstGeom prst="roundRect">
+            <a:avLst/>
+          </a:prstGeom>
+          <a:solidFill>
+            <a:srgbClr val="E7F6F5"/>
+          </a:solidFill>
+          <a:ln w="10160">
+            <a:solidFill>
+              <a:srgbClr val="C4E8E5"/>
+            </a:solidFill>
+          </a:ln>
+        </p:spPr>
+        <p:style>
+          <a:lnRef idx="1">
+            <a:schemeClr val="accent1"/>
+          </a:lnRef>
+          <a:fillRef idx="3">
+            <a:schemeClr val="accent1"/>
+          </a:fillRef>
+          <a:effectRef idx="2">
+            <a:schemeClr val="accent1"/>
+          </a:effectRef>
+          <a:fontRef idx="minor">
+            <a:schemeClr val="lt1"/>
+          </a:fontRef>
+        </p:style>
+        <p:txBody>
+          <a:bodyPr rtlCol="0" anchor="ctr"/>
+          <a:lstStyle/>
+          <a:p>
+            <a:pPr algn="ctr"/>
+          </a:p>
+        </p:txBody>
+      </p:sp>
+      <p:sp>
+        <p:nvSpPr>
+          <p:cNvPr id="18" name="TextBox 17"/>
+          <p:cNvSpPr txBox="1"/>
+          <p:nvPr/>
+        </p:nvSpPr>
+        <p:spPr>
+          <a:xfrm>
+            <a:off x="868680" y="5276088"/>
+            <a:ext cx="10424160" cy="265176"/>
           </a:xfrm>
           <a:prstGeom prst="rect">
             <a:avLst/>
@@ -10036,23 +10042,65 @@
               </a:lnSpc>
             </a:pPr>
             <a:r>
-              <a:rPr sz="1000" b="0" i="0">
+              <a:rPr sz="1100" b="0" i="0">
+                <a:solidFill>
+                  <a:srgbClr val="008C8C"/>
+                </a:solidFill>
+                <a:latin typeface="Montserrat"/>
+              </a:rPr>
+              <a:t>Рост объёма заказов не потребовал найма дополнительного сотрудника • окупаемость проекта — 3–5 месяцев</a:t>
+            </a:r>
+            <a:endParaRPr sz="1100" b="0" i="0">
+              <a:latin typeface="Montserrat"/>
+            </a:endParaRPr>
+          </a:p>
+        </p:txBody>
+      </p:sp>
+      <p:sp>
+        <p:nvSpPr>
+          <p:cNvPr id="19" name="TextBox 18"/>
+          <p:cNvSpPr txBox="1"/>
+          <p:nvPr/>
+        </p:nvSpPr>
+        <p:spPr>
+          <a:xfrm>
+            <a:off x="685800" y="5916168"/>
+            <a:ext cx="10789920" cy="228600"/>
+          </a:xfrm>
+          <a:prstGeom prst="rect">
+            <a:avLst/>
+          </a:prstGeom>
+          <a:noFill/>
+        </p:spPr>
+        <p:txBody>
+          <a:bodyPr wrap="square" lIns="18288" rIns="18288" tIns="18288" bIns="18288" anchor="t">
+            <a:noAutofit/>
+          </a:bodyPr>
+          <a:lstStyle/>
+          <a:p>
+            <a:pPr algn="ctr">
+              <a:lnSpc>
+                <a:spcPct val="105000"/>
+              </a:lnSpc>
+            </a:pPr>
+            <a:r>
+              <a:rPr sz="900" b="0" i="0">
                 <a:solidFill>
                   <a:srgbClr val="667085"/>
                 </a:solidFill>
                 <a:latin typeface="Montserrat"/>
               </a:rPr>
-              <a:t>В кейсе нет придуманных процентов роста или экономии: показаны проверенная работоспособность и практический эффект.</a:t>
-            </a:r>
-            <a:endParaRPr sz="1000" b="0" i="0">
-              <a:latin typeface="Montserrat"/>
-            </a:endParaRPr>
-          </a:p>
-        </p:txBody>
-      </p:sp>
-      <p:sp>
-        <p:nvSpPr>
-          <p:cNvPr id="15" name="TextBox 14"/>
+              <a:t>Расчёт: 15–25 заказов в день, 22 рабочих дня, 17 минут экономии на заказ.</a:t>
+            </a:r>
+            <a:endParaRPr sz="900" b="0" i="0">
+              <a:latin typeface="Montserrat"/>
+            </a:endParaRPr>
+          </a:p>
+        </p:txBody>
+      </p:sp>
+      <p:sp>
+        <p:nvSpPr>
+          <p:cNvPr id="20" name="TextBox 19"/>
           <p:cNvSpPr txBox="1"/>
           <p:nvPr/>
         </p:nvSpPr>

</xml_diff>

<commit_message>
Publish clean client-ready PTZ case
</commit_message>
<xml_diff>
--- a/downloads/ptz-steklo-weboptimize-case.pptx
+++ b/downloads/ptz-steklo-weboptimize-case.pptx
@@ -4644,7 +4644,7 @@
                 </a:solidFill>
                 <a:latin typeface="Montserrat"/>
               </a:rPr>
-              <a:t>→ РАСЧЁТ</a:t>
+              <a:t>РАСЧЁТ</a:t>
             </a:r>
             <a:endParaRPr sz="1300" b="0" i="0">
               <a:latin typeface="Montserrat"/>
@@ -4686,7 +4686,7 @@
                 </a:solidFill>
                 <a:latin typeface="Montserrat"/>
               </a:rPr>
-              <a:t>→ ПРОИЗВОДСТВО</a:t>
+              <a:t>ПРОИЗВОДСТВО</a:t>
             </a:r>
             <a:endParaRPr sz="1300" b="0" i="0">
               <a:latin typeface="Montserrat"/>
@@ -4728,7 +4728,7 @@
                 </a:solidFill>
                 <a:latin typeface="Montserrat"/>
               </a:rPr>
-              <a:t>→ ДОСТАВКА</a:t>
+              <a:t>ДОСТАВКА</a:t>
             </a:r>
             <a:endParaRPr sz="1300" b="0" i="0">
               <a:latin typeface="Montserrat"/>
@@ -4770,7 +4770,7 @@
                 </a:solidFill>
                 <a:latin typeface="Montserrat"/>
               </a:rPr>
-              <a:t>→ МОНТАЖ</a:t>
+              <a:t>МОНТАЖ</a:t>
             </a:r>
             <a:endParaRPr sz="1300" b="0" i="0">
               <a:latin typeface="Montserrat"/>
@@ -4781,48 +4781,6 @@
       <p:sp>
         <p:nvSpPr>
           <p:cNvPr id="23" name="TextBox 22"/>
-          <p:cNvSpPr txBox="1"/>
-          <p:nvPr/>
-        </p:nvSpPr>
-        <p:spPr>
-          <a:xfrm>
-            <a:off x="640080" y="6126480"/>
-            <a:ext cx="6583680" cy="228600"/>
-          </a:xfrm>
-          <a:prstGeom prst="rect">
-            <a:avLst/>
-          </a:prstGeom>
-          <a:noFill/>
-        </p:spPr>
-        <p:txBody>
-          <a:bodyPr wrap="square" lIns="18288" rIns="18288" tIns="18288" bIns="18288" anchor="t">
-            <a:noAutofit/>
-          </a:bodyPr>
-          <a:lstStyle/>
-          <a:p>
-            <a:pPr algn="l">
-              <a:lnSpc>
-                <a:spcPct val="105000"/>
-              </a:lnSpc>
-            </a:pPr>
-            <a:r>
-              <a:rPr sz="900" b="0" i="0">
-                <a:solidFill>
-                  <a:srgbClr val="667085"/>
-                </a:solidFill>
-                <a:latin typeface="Montserrat"/>
-              </a:rPr>
-              <a:t>Источник показателей: официальный сайт СтеклоЦентр.ПТЗ</a:t>
-            </a:r>
-            <a:endParaRPr sz="900" b="0" i="0">
-              <a:latin typeface="Montserrat"/>
-            </a:endParaRPr>
-          </a:p>
-        </p:txBody>
-      </p:sp>
-      <p:sp>
-        <p:nvSpPr>
-          <p:cNvPr id="24" name="TextBox 23"/>
           <p:cNvSpPr txBox="1"/>
           <p:nvPr/>
         </p:nvSpPr>
@@ -6236,24 +6194,24 @@
       </p:sp>
       <p:sp>
         <p:nvSpPr>
-          <p:cNvPr id="5" name="Rectangle 4"/>
+          <p:cNvPr id="5" name="Rounded Rectangle 4"/>
           <p:cNvSpPr/>
           <p:nvPr/>
         </p:nvSpPr>
         <p:spPr>
           <a:xfrm>
-            <a:off x="594360" y="1508760"/>
-            <a:ext cx="10972800" cy="3611880"/>
-          </a:xfrm>
-          <a:prstGeom prst="rect">
+            <a:off x="658368" y="1874519"/>
+            <a:ext cx="3401568" cy="2331720"/>
+          </a:xfrm>
+          <a:prstGeom prst="roundRect">
             <a:avLst/>
           </a:prstGeom>
           <a:solidFill>
-            <a:srgbClr val="F3F6F8"/>
+            <a:srgbClr val="E7F6F5"/>
           </a:solidFill>
           <a:ln w="10160">
             <a:solidFill>
-              <a:srgbClr val="D7E0E7"/>
+              <a:srgbClr val="008C8C"/>
             </a:solidFill>
           </a:ln>
         </p:spPr>
@@ -6279,30 +6237,48 @@
           </a:p>
         </p:txBody>
       </p:sp>
-      <p:pic>
-        <p:nvPicPr>
-          <p:cNvPr id="6" name="Picture 5" descr="02-architecture.png"/>
-          <p:cNvPicPr>
-            <a:picLocks noChangeAspect="1"/>
-          </p:cNvPicPr>
-          <p:nvPr/>
-        </p:nvPicPr>
-        <p:blipFill>
-          <a:blip r:embed="rId2"/>
-          <a:stretch>
-            <a:fillRect/>
-          </a:stretch>
-        </p:blipFill>
-        <p:spPr>
-          <a:xfrm>
-            <a:off x="640080" y="1627632"/>
-            <a:ext cx="10881360" cy="3284811"/>
-          </a:xfrm>
-          <a:prstGeom prst="rect">
-            <a:avLst/>
-          </a:prstGeom>
-        </p:spPr>
-      </p:pic>
+      <p:sp>
+        <p:nvSpPr>
+          <p:cNvPr id="6" name="TextBox 5"/>
+          <p:cNvSpPr txBox="1"/>
+          <p:nvPr/>
+        </p:nvSpPr>
+        <p:spPr>
+          <a:xfrm>
+            <a:off x="877824" y="2148840"/>
+            <a:ext cx="2944368" cy="320040"/>
+          </a:xfrm>
+          <a:prstGeom prst="rect">
+            <a:avLst/>
+          </a:prstGeom>
+          <a:noFill/>
+        </p:spPr>
+        <p:txBody>
+          <a:bodyPr wrap="square" lIns="18288" rIns="18288" tIns="18288" bIns="18288" anchor="t">
+            <a:noAutofit/>
+          </a:bodyPr>
+          <a:lstStyle/>
+          <a:p>
+            <a:pPr algn="ctr">
+              <a:lnSpc>
+                <a:spcPct val="105000"/>
+              </a:lnSpc>
+            </a:pPr>
+            <a:r>
+              <a:rPr sz="1400" b="0" i="0">
+                <a:solidFill>
+                  <a:srgbClr val="008C8C"/>
+                </a:solidFill>
+                <a:latin typeface="Montserrat"/>
+              </a:rPr>
+              <a:t>BITRIX24</a:t>
+            </a:r>
+            <a:endParaRPr sz="1400" b="0" i="0">
+              <a:latin typeface="Montserrat"/>
+            </a:endParaRPr>
+          </a:p>
+        </p:txBody>
+      </p:sp>
       <p:sp>
         <p:nvSpPr>
           <p:cNvPr id="7" name="TextBox 6"/>
@@ -6311,253 +6287,478 @@
         </p:nvSpPr>
         <p:spPr>
           <a:xfrm>
-            <a:off x="640080" y="5376672"/>
-            <a:ext cx="3246120" cy="347472"/>
-          </a:xfrm>
-          <a:prstGeom prst="rect">
-            <a:avLst/>
-          </a:prstGeom>
-          <a:noFill/>
-        </p:spPr>
-        <p:txBody>
-          <a:bodyPr wrap="square" lIns="18288" rIns="18288" tIns="18288" bIns="18288" anchor="t">
-            <a:noAutofit/>
-          </a:bodyPr>
-          <a:lstStyle/>
-          <a:p>
-            <a:pPr algn="l">
-              <a:lnSpc>
-                <a:spcPct val="105000"/>
-              </a:lnSpc>
-            </a:pPr>
-            <a:r>
-              <a:rPr sz="1300" b="0" i="0">
+            <a:off x="950976" y="2816352"/>
+            <a:ext cx="2788920" cy="822960"/>
+          </a:xfrm>
+          <a:prstGeom prst="rect">
+            <a:avLst/>
+          </a:prstGeom>
+          <a:noFill/>
+        </p:spPr>
+        <p:txBody>
+          <a:bodyPr wrap="square" lIns="18288" rIns="18288" tIns="18288" bIns="18288" anchor="ctr">
+            <a:noAutofit/>
+          </a:bodyPr>
+          <a:lstStyle/>
+          <a:p>
+            <a:pPr algn="ctr">
+              <a:lnSpc>
+                <a:spcPct val="105000"/>
+              </a:lnSpc>
+            </a:pPr>
+            <a:r>
+              <a:rPr sz="1400" b="0" i="0">
+                <a:solidFill>
+                  <a:srgbClr val="15243A"/>
+                </a:solidFill>
+                <a:latin typeface="Montserrat"/>
+              </a:rPr>
+              <a:t>Сделка, контакт и команда менеджера</a:t>
+            </a:r>
+            <a:endParaRPr sz="1400" b="0" i="0">
+              <a:latin typeface="Montserrat"/>
+            </a:endParaRPr>
+          </a:p>
+        </p:txBody>
+      </p:sp>
+      <p:sp>
+        <p:nvSpPr>
+          <p:cNvPr id="8" name="Rectangle 7"/>
+          <p:cNvSpPr/>
+          <p:nvPr/>
+        </p:nvSpPr>
+        <p:spPr>
+          <a:xfrm>
+            <a:off x="4059936" y="2944368"/>
+            <a:ext cx="420624" cy="109728"/>
+          </a:xfrm>
+          <a:prstGeom prst="rect">
+            <a:avLst/>
+          </a:prstGeom>
+          <a:solidFill>
+            <a:srgbClr val="008C8C"/>
+          </a:solidFill>
+          <a:ln w="10160">
+            <a:solidFill>
+              <a:srgbClr val="008C8C"/>
+            </a:solidFill>
+          </a:ln>
+        </p:spPr>
+        <p:style>
+          <a:lnRef idx="1">
+            <a:schemeClr val="accent1"/>
+          </a:lnRef>
+          <a:fillRef idx="3">
+            <a:schemeClr val="accent1"/>
+          </a:fillRef>
+          <a:effectRef idx="2">
+            <a:schemeClr val="accent1"/>
+          </a:effectRef>
+          <a:fontRef idx="minor">
+            <a:schemeClr val="lt1"/>
+          </a:fontRef>
+        </p:style>
+        <p:txBody>
+          <a:bodyPr rtlCol="0" anchor="ctr"/>
+          <a:lstStyle/>
+          <a:p>
+            <a:pPr algn="ctr"/>
+          </a:p>
+        </p:txBody>
+      </p:sp>
+      <p:sp>
+        <p:nvSpPr>
+          <p:cNvPr id="9" name="Rounded Rectangle 8"/>
+          <p:cNvSpPr/>
+          <p:nvPr/>
+        </p:nvSpPr>
+        <p:spPr>
+          <a:xfrm>
+            <a:off x="4480559" y="1874519"/>
+            <a:ext cx="3401568" cy="2331720"/>
+          </a:xfrm>
+          <a:prstGeom prst="roundRect">
+            <a:avLst/>
+          </a:prstGeom>
+          <a:solidFill>
+            <a:srgbClr val="E8F2FB"/>
+          </a:solidFill>
+          <a:ln w="10160">
+            <a:solidFill>
+              <a:srgbClr val="1769AA"/>
+            </a:solidFill>
+          </a:ln>
+        </p:spPr>
+        <p:style>
+          <a:lnRef idx="1">
+            <a:schemeClr val="accent1"/>
+          </a:lnRef>
+          <a:fillRef idx="3">
+            <a:schemeClr val="accent1"/>
+          </a:fillRef>
+          <a:effectRef idx="2">
+            <a:schemeClr val="accent1"/>
+          </a:effectRef>
+          <a:fontRef idx="minor">
+            <a:schemeClr val="lt1"/>
+          </a:fontRef>
+        </p:style>
+        <p:txBody>
+          <a:bodyPr rtlCol="0" anchor="ctr"/>
+          <a:lstStyle/>
+          <a:p>
+            <a:pPr algn="ctr"/>
+          </a:p>
+        </p:txBody>
+      </p:sp>
+      <p:sp>
+        <p:nvSpPr>
+          <p:cNvPr id="10" name="TextBox 9"/>
+          <p:cNvSpPr txBox="1"/>
+          <p:nvPr/>
+        </p:nvSpPr>
+        <p:spPr>
+          <a:xfrm>
+            <a:off x="4700016" y="2148840"/>
+            <a:ext cx="2944368" cy="320040"/>
+          </a:xfrm>
+          <a:prstGeom prst="rect">
+            <a:avLst/>
+          </a:prstGeom>
+          <a:noFill/>
+        </p:spPr>
+        <p:txBody>
+          <a:bodyPr wrap="square" lIns="18288" rIns="18288" tIns="18288" bIns="18288" anchor="t">
+            <a:noAutofit/>
+          </a:bodyPr>
+          <a:lstStyle/>
+          <a:p>
+            <a:pPr algn="ctr">
+              <a:lnSpc>
+                <a:spcPct val="105000"/>
+              </a:lnSpc>
+            </a:pPr>
+            <a:r>
+              <a:rPr sz="1400" b="0" i="0">
+                <a:solidFill>
+                  <a:srgbClr val="1769AA"/>
+                </a:solidFill>
+                <a:latin typeface="Montserrat"/>
+              </a:rPr>
+              <a:t>ЛОКАЛЬНЫЙ МОДУЛЬ</a:t>
+            </a:r>
+            <a:endParaRPr sz="1400" b="0" i="0">
+              <a:latin typeface="Montserrat"/>
+            </a:endParaRPr>
+          </a:p>
+        </p:txBody>
+      </p:sp>
+      <p:sp>
+        <p:nvSpPr>
+          <p:cNvPr id="11" name="TextBox 10"/>
+          <p:cNvSpPr txBox="1"/>
+          <p:nvPr/>
+        </p:nvSpPr>
+        <p:spPr>
+          <a:xfrm>
+            <a:off x="4773168" y="2816352"/>
+            <a:ext cx="2788920" cy="822960"/>
+          </a:xfrm>
+          <a:prstGeom prst="rect">
+            <a:avLst/>
+          </a:prstGeom>
+          <a:noFill/>
+        </p:spPr>
+        <p:txBody>
+          <a:bodyPr wrap="square" lIns="18288" rIns="18288" tIns="18288" bIns="18288" anchor="ctr">
+            <a:noAutofit/>
+          </a:bodyPr>
+          <a:lstStyle/>
+          <a:p>
+            <a:pPr algn="ctr">
+              <a:lnSpc>
+                <a:spcPct val="105000"/>
+              </a:lnSpc>
+            </a:pPr>
+            <a:r>
+              <a:rPr sz="1400" b="0" i="0">
+                <a:solidFill>
+                  <a:srgbClr val="15243A"/>
+                </a:solidFill>
+                <a:latin typeface="Montserrat"/>
+              </a:rPr>
+              <a:t>Связывает системы и автоматически повторяет обмен</a:t>
+            </a:r>
+            <a:endParaRPr sz="1400" b="0" i="0">
+              <a:latin typeface="Montserrat"/>
+            </a:endParaRPr>
+          </a:p>
+        </p:txBody>
+      </p:sp>
+      <p:sp>
+        <p:nvSpPr>
+          <p:cNvPr id="12" name="Rectangle 11"/>
+          <p:cNvSpPr/>
+          <p:nvPr/>
+        </p:nvSpPr>
+        <p:spPr>
+          <a:xfrm>
+            <a:off x="7882127" y="2944368"/>
+            <a:ext cx="420624" cy="109728"/>
+          </a:xfrm>
+          <a:prstGeom prst="rect">
+            <a:avLst/>
+          </a:prstGeom>
+          <a:solidFill>
+            <a:srgbClr val="1769AA"/>
+          </a:solidFill>
+          <a:ln w="10160">
+            <a:solidFill>
+              <a:srgbClr val="1769AA"/>
+            </a:solidFill>
+          </a:ln>
+        </p:spPr>
+        <p:style>
+          <a:lnRef idx="1">
+            <a:schemeClr val="accent1"/>
+          </a:lnRef>
+          <a:fillRef idx="3">
+            <a:schemeClr val="accent1"/>
+          </a:fillRef>
+          <a:effectRef idx="2">
+            <a:schemeClr val="accent1"/>
+          </a:effectRef>
+          <a:fontRef idx="minor">
+            <a:schemeClr val="lt1"/>
+          </a:fontRef>
+        </p:style>
+        <p:txBody>
+          <a:bodyPr rtlCol="0" anchor="ctr"/>
+          <a:lstStyle/>
+          <a:p>
+            <a:pPr algn="ctr"/>
+          </a:p>
+        </p:txBody>
+      </p:sp>
+      <p:sp>
+        <p:nvSpPr>
+          <p:cNvPr id="13" name="Rounded Rectangle 12"/>
+          <p:cNvSpPr/>
+          <p:nvPr/>
+        </p:nvSpPr>
+        <p:spPr>
+          <a:xfrm>
+            <a:off x="8302752" y="1874519"/>
+            <a:ext cx="3401568" cy="2331720"/>
+          </a:xfrm>
+          <a:prstGeom prst="roundRect">
+            <a:avLst/>
+          </a:prstGeom>
+          <a:solidFill>
+            <a:srgbClr val="FFF5DC"/>
+          </a:solidFill>
+          <a:ln w="10160">
+            <a:solidFill>
+              <a:srgbClr val="D99400"/>
+            </a:solidFill>
+          </a:ln>
+        </p:spPr>
+        <p:style>
+          <a:lnRef idx="1">
+            <a:schemeClr val="accent1"/>
+          </a:lnRef>
+          <a:fillRef idx="3">
+            <a:schemeClr val="accent1"/>
+          </a:fillRef>
+          <a:effectRef idx="2">
+            <a:schemeClr val="accent1"/>
+          </a:effectRef>
+          <a:fontRef idx="minor">
+            <a:schemeClr val="lt1"/>
+          </a:fontRef>
+        </p:style>
+        <p:txBody>
+          <a:bodyPr rtlCol="0" anchor="ctr"/>
+          <a:lstStyle/>
+          <a:p>
+            <a:pPr algn="ctr"/>
+          </a:p>
+        </p:txBody>
+      </p:sp>
+      <p:sp>
+        <p:nvSpPr>
+          <p:cNvPr id="14" name="TextBox 13"/>
+          <p:cNvSpPr txBox="1"/>
+          <p:nvPr/>
+        </p:nvSpPr>
+        <p:spPr>
+          <a:xfrm>
+            <a:off x="8522208" y="2148840"/>
+            <a:ext cx="2944368" cy="320040"/>
+          </a:xfrm>
+          <a:prstGeom prst="rect">
+            <a:avLst/>
+          </a:prstGeom>
+          <a:noFill/>
+        </p:spPr>
+        <p:txBody>
+          <a:bodyPr wrap="square" lIns="18288" rIns="18288" tIns="18288" bIns="18288" anchor="t">
+            <a:noAutofit/>
+          </a:bodyPr>
+          <a:lstStyle/>
+          <a:p>
+            <a:pPr algn="ctr">
+              <a:lnSpc>
+                <a:spcPct val="105000"/>
+              </a:lnSpc>
+            </a:pPr>
+            <a:r>
+              <a:rPr sz="1400" b="0" i="0">
+                <a:solidFill>
+                  <a:srgbClr val="D99400"/>
+                </a:solidFill>
+                <a:latin typeface="Montserrat"/>
+              </a:rPr>
+              <a:t>1С</a:t>
+            </a:r>
+            <a:endParaRPr sz="1400" b="0" i="0">
+              <a:latin typeface="Montserrat"/>
+            </a:endParaRPr>
+          </a:p>
+        </p:txBody>
+      </p:sp>
+      <p:sp>
+        <p:nvSpPr>
+          <p:cNvPr id="15" name="TextBox 14"/>
+          <p:cNvSpPr txBox="1"/>
+          <p:nvPr/>
+        </p:nvSpPr>
+        <p:spPr>
+          <a:xfrm>
+            <a:off x="8595360" y="2816352"/>
+            <a:ext cx="2788920" cy="822960"/>
+          </a:xfrm>
+          <a:prstGeom prst="rect">
+            <a:avLst/>
+          </a:prstGeom>
+          <a:noFill/>
+        </p:spPr>
+        <p:txBody>
+          <a:bodyPr wrap="square" lIns="18288" rIns="18288" tIns="18288" bIns="18288" anchor="ctr">
+            <a:noAutofit/>
+          </a:bodyPr>
+          <a:lstStyle/>
+          <a:p>
+            <a:pPr algn="ctr">
+              <a:lnSpc>
+                <a:spcPct val="105000"/>
+              </a:lnSpc>
+            </a:pPr>
+            <a:r>
+              <a:rPr sz="1400" b="0" i="0">
+                <a:solidFill>
+                  <a:srgbClr val="15243A"/>
+                </a:solidFill>
+                <a:latin typeface="Montserrat"/>
+              </a:rPr>
+              <a:t>Заказ, статус, срок и сумма</a:t>
+            </a:r>
+            <a:endParaRPr sz="1400" b="0" i="0">
+              <a:latin typeface="Montserrat"/>
+            </a:endParaRPr>
+          </a:p>
+        </p:txBody>
+      </p:sp>
+      <p:sp>
+        <p:nvSpPr>
+          <p:cNvPr id="16" name="Rounded Rectangle 15"/>
+          <p:cNvSpPr/>
+          <p:nvPr/>
+        </p:nvSpPr>
+        <p:spPr>
+          <a:xfrm>
+            <a:off x="1261872" y="4892040"/>
+            <a:ext cx="9674352" cy="685800"/>
+          </a:xfrm>
+          <a:prstGeom prst="roundRect">
+            <a:avLst/>
+          </a:prstGeom>
+          <a:solidFill>
+            <a:srgbClr val="E7F6F5"/>
+          </a:solidFill>
+          <a:ln w="10160">
+            <a:solidFill>
+              <a:srgbClr val="C4E8E5"/>
+            </a:solidFill>
+          </a:ln>
+        </p:spPr>
+        <p:style>
+          <a:lnRef idx="1">
+            <a:schemeClr val="accent1"/>
+          </a:lnRef>
+          <a:fillRef idx="3">
+            <a:schemeClr val="accent1"/>
+          </a:fillRef>
+          <a:effectRef idx="2">
+            <a:schemeClr val="accent1"/>
+          </a:effectRef>
+          <a:fontRef idx="minor">
+            <a:schemeClr val="lt1"/>
+          </a:fontRef>
+        </p:style>
+        <p:txBody>
+          <a:bodyPr rtlCol="0" anchor="ctr"/>
+          <a:lstStyle/>
+          <a:p>
+            <a:pPr algn="ctr"/>
+          </a:p>
+        </p:txBody>
+      </p:sp>
+      <p:sp>
+        <p:nvSpPr>
+          <p:cNvPr id="17" name="TextBox 16"/>
+          <p:cNvSpPr txBox="1"/>
+          <p:nvPr/>
+        </p:nvSpPr>
+        <p:spPr>
+          <a:xfrm>
+            <a:off x="1508760" y="5102352"/>
+            <a:ext cx="9144000" cy="274320"/>
+          </a:xfrm>
+          <a:prstGeom prst="rect">
+            <a:avLst/>
+          </a:prstGeom>
+          <a:noFill/>
+        </p:spPr>
+        <p:txBody>
+          <a:bodyPr wrap="square" lIns="18288" rIns="18288" tIns="18288" bIns="18288" anchor="t">
+            <a:noAutofit/>
+          </a:bodyPr>
+          <a:lstStyle/>
+          <a:p>
+            <a:pPr algn="ctr">
+              <a:lnSpc>
+                <a:spcPct val="105000"/>
+              </a:lnSpc>
+            </a:pPr>
+            <a:r>
+              <a:rPr sz="1200" b="0" i="0">
                 <a:solidFill>
                   <a:srgbClr val="008C8C"/>
                 </a:solidFill>
                 <a:latin typeface="Montserrat"/>
               </a:rPr>
-              <a:t>Защищённая связь</a:t>
-            </a:r>
-            <a:endParaRPr sz="1300" b="0" i="0">
-              <a:latin typeface="Montserrat"/>
-            </a:endParaRPr>
-          </a:p>
-        </p:txBody>
-      </p:sp>
-      <p:sp>
-        <p:nvSpPr>
-          <p:cNvPr id="8" name="TextBox 7"/>
-          <p:cNvSpPr txBox="1"/>
-          <p:nvPr/>
-        </p:nvSpPr>
-        <p:spPr>
-          <a:xfrm>
-            <a:off x="640080" y="5733288"/>
-            <a:ext cx="3246120" cy="274320"/>
-          </a:xfrm>
-          <a:prstGeom prst="rect">
-            <a:avLst/>
-          </a:prstGeom>
-          <a:noFill/>
-        </p:spPr>
-        <p:txBody>
-          <a:bodyPr wrap="square" lIns="18288" rIns="18288" tIns="18288" bIns="18288" anchor="t">
-            <a:noAutofit/>
-          </a:bodyPr>
-          <a:lstStyle/>
-          <a:p>
-            <a:pPr algn="l">
-              <a:lnSpc>
-                <a:spcPct val="105000"/>
-              </a:lnSpc>
-            </a:pPr>
-            <a:r>
-              <a:rPr sz="1000" b="0" i="0">
-                <a:solidFill>
-                  <a:srgbClr val="667085"/>
-                </a:solidFill>
-                <a:latin typeface="Montserrat"/>
-              </a:rPr>
-              <a:t>обмен идёт через сервер компании</a:t>
-            </a:r>
-            <a:endParaRPr sz="1000" b="0" i="0">
-              <a:latin typeface="Montserrat"/>
-            </a:endParaRPr>
-          </a:p>
-        </p:txBody>
-      </p:sp>
-      <p:sp>
-        <p:nvSpPr>
-          <p:cNvPr id="9" name="TextBox 8"/>
-          <p:cNvSpPr txBox="1"/>
-          <p:nvPr/>
-        </p:nvSpPr>
-        <p:spPr>
-          <a:xfrm>
-            <a:off x="4343400" y="5376672"/>
-            <a:ext cx="3246120" cy="347472"/>
-          </a:xfrm>
-          <a:prstGeom prst="rect">
-            <a:avLst/>
-          </a:prstGeom>
-          <a:noFill/>
-        </p:spPr>
-        <p:txBody>
-          <a:bodyPr wrap="square" lIns="18288" rIns="18288" tIns="18288" bIns="18288" anchor="t">
-            <a:noAutofit/>
-          </a:bodyPr>
-          <a:lstStyle/>
-          <a:p>
-            <a:pPr algn="l">
-              <a:lnSpc>
-                <a:spcPct val="105000"/>
-              </a:lnSpc>
-            </a:pPr>
-            <a:r>
-              <a:rPr sz="1300" b="0" i="0">
-                <a:solidFill>
-                  <a:srgbClr val="008C8C"/>
-                </a:solidFill>
-                <a:latin typeface="Montserrat"/>
-              </a:rPr>
-              <a:t>Доступы защищены</a:t>
-            </a:r>
-            <a:endParaRPr sz="1300" b="0" i="0">
-              <a:latin typeface="Montserrat"/>
-            </a:endParaRPr>
-          </a:p>
-        </p:txBody>
-      </p:sp>
-      <p:sp>
-        <p:nvSpPr>
-          <p:cNvPr id="10" name="TextBox 9"/>
-          <p:cNvSpPr txBox="1"/>
-          <p:nvPr/>
-        </p:nvSpPr>
-        <p:spPr>
-          <a:xfrm>
-            <a:off x="4343400" y="5733288"/>
-            <a:ext cx="3246120" cy="274320"/>
-          </a:xfrm>
-          <a:prstGeom prst="rect">
-            <a:avLst/>
-          </a:prstGeom>
-          <a:noFill/>
-        </p:spPr>
-        <p:txBody>
-          <a:bodyPr wrap="square" lIns="18288" rIns="18288" tIns="18288" bIns="18288" anchor="t">
-            <a:noAutofit/>
-          </a:bodyPr>
-          <a:lstStyle/>
-          <a:p>
-            <a:pPr algn="l">
-              <a:lnSpc>
-                <a:spcPct val="105000"/>
-              </a:lnSpc>
-            </a:pPr>
-            <a:r>
-              <a:rPr sz="1000" b="0" i="0">
-                <a:solidFill>
-                  <a:srgbClr val="667085"/>
-                </a:solidFill>
-                <a:latin typeface="Montserrat"/>
-              </a:rPr>
-              <a:t>хранятся только на сервере</a:t>
-            </a:r>
-            <a:endParaRPr sz="1000" b="0" i="0">
-              <a:latin typeface="Montserrat"/>
-            </a:endParaRPr>
-          </a:p>
-        </p:txBody>
-      </p:sp>
-      <p:sp>
-        <p:nvSpPr>
-          <p:cNvPr id="11" name="TextBox 10"/>
-          <p:cNvSpPr txBox="1"/>
-          <p:nvPr/>
-        </p:nvSpPr>
-        <p:spPr>
-          <a:xfrm>
-            <a:off x="8046719" y="5376672"/>
-            <a:ext cx="3246120" cy="347472"/>
-          </a:xfrm>
-          <a:prstGeom prst="rect">
-            <a:avLst/>
-          </a:prstGeom>
-          <a:noFill/>
-        </p:spPr>
-        <p:txBody>
-          <a:bodyPr wrap="square" lIns="18288" rIns="18288" tIns="18288" bIns="18288" anchor="t">
-            <a:noAutofit/>
-          </a:bodyPr>
-          <a:lstStyle/>
-          <a:p>
-            <a:pPr algn="l">
-              <a:lnSpc>
-                <a:spcPct val="105000"/>
-              </a:lnSpc>
-            </a:pPr>
-            <a:r>
-              <a:rPr sz="1300" b="0" i="0">
-                <a:solidFill>
-                  <a:srgbClr val="008C8C"/>
-                </a:solidFill>
-                <a:latin typeface="Montserrat"/>
-              </a:rPr>
-              <a:t>Закрытая 1С</a:t>
-            </a:r>
-            <a:endParaRPr sz="1300" b="0" i="0">
-              <a:latin typeface="Montserrat"/>
-            </a:endParaRPr>
-          </a:p>
-        </p:txBody>
-      </p:sp>
-      <p:sp>
-        <p:nvSpPr>
-          <p:cNvPr id="12" name="TextBox 11"/>
-          <p:cNvSpPr txBox="1"/>
-          <p:nvPr/>
-        </p:nvSpPr>
-        <p:spPr>
-          <a:xfrm>
-            <a:off x="8046719" y="5733288"/>
-            <a:ext cx="3246120" cy="274320"/>
-          </a:xfrm>
-          <a:prstGeom prst="rect">
-            <a:avLst/>
-          </a:prstGeom>
-          <a:noFill/>
-        </p:spPr>
-        <p:txBody>
-          <a:bodyPr wrap="square" lIns="18288" rIns="18288" tIns="18288" bIns="18288" anchor="t">
-            <a:noAutofit/>
-          </a:bodyPr>
-          <a:lstStyle/>
-          <a:p>
-            <a:pPr algn="l">
-              <a:lnSpc>
-                <a:spcPct val="105000"/>
-              </a:lnSpc>
-            </a:pPr>
-            <a:r>
-              <a:rPr sz="1000" b="0" i="0">
-                <a:solidFill>
-                  <a:srgbClr val="667085"/>
-                </a:solidFill>
-                <a:latin typeface="Montserrat"/>
-              </a:rPr>
-              <a:t>база недоступна из интернета</a:t>
-            </a:r>
-            <a:endParaRPr sz="1000" b="0" i="0">
-              <a:latin typeface="Montserrat"/>
-            </a:endParaRPr>
-          </a:p>
-        </p:txBody>
-      </p:sp>
-      <p:sp>
-        <p:nvSpPr>
-          <p:cNvPr id="13" name="TextBox 12"/>
+              <a:t>1С остаётся внутри компании • менеджер продолжает работать в Bitrix24</a:t>
+            </a:r>
+            <a:endParaRPr sz="1200" b="0" i="0">
+              <a:latin typeface="Montserrat"/>
+            </a:endParaRPr>
+          </a:p>
+        </p:txBody>
+      </p:sp>
+      <p:sp>
+        <p:nvSpPr>
+          <p:cNvPr id="18" name="TextBox 17"/>
           <p:cNvSpPr txBox="1"/>
           <p:nvPr/>
         </p:nvSpPr>
@@ -6749,33 +6950,834 @@
           </a:p>
         </p:txBody>
       </p:sp>
-      <p:pic>
-        <p:nvPicPr>
-          <p:cNvPr id="5" name="Picture 4" descr="01-user-journey.png"/>
-          <p:cNvPicPr>
-            <a:picLocks noChangeAspect="1"/>
-          </p:cNvPicPr>
-          <p:nvPr/>
-        </p:nvPicPr>
-        <p:blipFill>
-          <a:blip r:embed="rId2"/>
-          <a:stretch>
-            <a:fillRect/>
-          </a:stretch>
-        </p:blipFill>
-        <p:spPr>
-          <a:xfrm>
-            <a:off x="566928" y="1572768"/>
-            <a:ext cx="11064240" cy="3886314"/>
-          </a:xfrm>
-          <a:prstGeom prst="rect">
-            <a:avLst/>
-          </a:prstGeom>
-        </p:spPr>
-      </p:pic>
-      <p:sp>
-        <p:nvSpPr>
-          <p:cNvPr id="6" name="Rounded Rectangle 5"/>
+      <p:sp>
+        <p:nvSpPr>
+          <p:cNvPr id="5" name="Rounded Rectangle 4"/>
+          <p:cNvSpPr/>
+          <p:nvPr/>
+        </p:nvSpPr>
+        <p:spPr>
+          <a:xfrm>
+            <a:off x="621792" y="1938528"/>
+            <a:ext cx="1993392" cy="2514600"/>
+          </a:xfrm>
+          <a:prstGeom prst="roundRect">
+            <a:avLst/>
+          </a:prstGeom>
+          <a:solidFill>
+            <a:srgbClr val="FFFFFF"/>
+          </a:solidFill>
+          <a:ln w="10160">
+            <a:solidFill>
+              <a:srgbClr val="008C8C"/>
+            </a:solidFill>
+          </a:ln>
+        </p:spPr>
+        <p:style>
+          <a:lnRef idx="1">
+            <a:schemeClr val="accent1"/>
+          </a:lnRef>
+          <a:fillRef idx="3">
+            <a:schemeClr val="accent1"/>
+          </a:fillRef>
+          <a:effectRef idx="2">
+            <a:schemeClr val="accent1"/>
+          </a:effectRef>
+          <a:fontRef idx="minor">
+            <a:schemeClr val="lt1"/>
+          </a:fontRef>
+        </p:style>
+        <p:txBody>
+          <a:bodyPr rtlCol="0" anchor="ctr"/>
+          <a:lstStyle/>
+          <a:p>
+            <a:pPr algn="ctr"/>
+          </a:p>
+        </p:txBody>
+      </p:sp>
+      <p:sp>
+        <p:nvSpPr>
+          <p:cNvPr id="6" name="TextBox 5"/>
+          <p:cNvSpPr txBox="1"/>
+          <p:nvPr/>
+        </p:nvSpPr>
+        <p:spPr>
+          <a:xfrm>
+            <a:off x="804672" y="2176272"/>
+            <a:ext cx="1627632" cy="347472"/>
+          </a:xfrm>
+          <a:prstGeom prst="rect">
+            <a:avLst/>
+          </a:prstGeom>
+          <a:noFill/>
+        </p:spPr>
+        <p:txBody>
+          <a:bodyPr wrap="square" lIns="18288" rIns="18288" tIns="18288" bIns="18288" anchor="t">
+            <a:noAutofit/>
+          </a:bodyPr>
+          <a:lstStyle/>
+          <a:p>
+            <a:pPr algn="ctr">
+              <a:lnSpc>
+                <a:spcPct val="105000"/>
+              </a:lnSpc>
+            </a:pPr>
+            <a:r>
+              <a:rPr sz="1800" b="0" i="0">
+                <a:solidFill>
+                  <a:srgbClr val="008C8C"/>
+                </a:solidFill>
+                <a:latin typeface="Montserrat"/>
+              </a:rPr>
+              <a:t>01</a:t>
+            </a:r>
+            <a:endParaRPr sz="1800" b="0" i="0">
+              <a:latin typeface="Montserrat"/>
+            </a:endParaRPr>
+          </a:p>
+        </p:txBody>
+      </p:sp>
+      <p:sp>
+        <p:nvSpPr>
+          <p:cNvPr id="7" name="TextBox 6"/>
+          <p:cNvSpPr txBox="1"/>
+          <p:nvPr/>
+        </p:nvSpPr>
+        <p:spPr>
+          <a:xfrm>
+            <a:off x="850392" y="2880360"/>
+            <a:ext cx="1536192" cy="960120"/>
+          </a:xfrm>
+          <a:prstGeom prst="rect">
+            <a:avLst/>
+          </a:prstGeom>
+          <a:noFill/>
+        </p:spPr>
+        <p:txBody>
+          <a:bodyPr wrap="square" lIns="18288" rIns="18288" tIns="18288" bIns="18288" anchor="ctr">
+            <a:noAutofit/>
+          </a:bodyPr>
+          <a:lstStyle/>
+          <a:p>
+            <a:pPr algn="ctr">
+              <a:lnSpc>
+                <a:spcPct val="105000"/>
+              </a:lnSpc>
+            </a:pPr>
+            <a:r>
+              <a:rPr sz="1400" b="0" i="0">
+                <a:solidFill>
+                  <a:srgbClr val="15243A"/>
+                </a:solidFill>
+                <a:latin typeface="Montserrat"/>
+              </a:rPr>
+              <a:t>Заполняет сделку</a:t>
+            </a:r>
+            <a:endParaRPr sz="1400" b="0" i="0">
+              <a:latin typeface="Montserrat"/>
+            </a:endParaRPr>
+          </a:p>
+        </p:txBody>
+      </p:sp>
+      <p:sp>
+        <p:nvSpPr>
+          <p:cNvPr id="8" name="Rectangle 7"/>
+          <p:cNvSpPr/>
+          <p:nvPr/>
+        </p:nvSpPr>
+        <p:spPr>
+          <a:xfrm>
+            <a:off x="2615184" y="3136392"/>
+            <a:ext cx="310896" cy="91440"/>
+          </a:xfrm>
+          <a:prstGeom prst="rect">
+            <a:avLst/>
+          </a:prstGeom>
+          <a:solidFill>
+            <a:srgbClr val="008C8C"/>
+          </a:solidFill>
+          <a:ln w="10160">
+            <a:solidFill>
+              <a:srgbClr val="008C8C"/>
+            </a:solidFill>
+          </a:ln>
+        </p:spPr>
+        <p:style>
+          <a:lnRef idx="1">
+            <a:schemeClr val="accent1"/>
+          </a:lnRef>
+          <a:fillRef idx="3">
+            <a:schemeClr val="accent1"/>
+          </a:fillRef>
+          <a:effectRef idx="2">
+            <a:schemeClr val="accent1"/>
+          </a:effectRef>
+          <a:fontRef idx="minor">
+            <a:schemeClr val="lt1"/>
+          </a:fontRef>
+        </p:style>
+        <p:txBody>
+          <a:bodyPr rtlCol="0" anchor="ctr"/>
+          <a:lstStyle/>
+          <a:p>
+            <a:pPr algn="ctr"/>
+          </a:p>
+        </p:txBody>
+      </p:sp>
+      <p:sp>
+        <p:nvSpPr>
+          <p:cNvPr id="9" name="Rounded Rectangle 8"/>
+          <p:cNvSpPr/>
+          <p:nvPr/>
+        </p:nvSpPr>
+        <p:spPr>
+          <a:xfrm>
+            <a:off x="2926080" y="1938528"/>
+            <a:ext cx="1993392" cy="2514600"/>
+          </a:xfrm>
+          <a:prstGeom prst="roundRect">
+            <a:avLst/>
+          </a:prstGeom>
+          <a:solidFill>
+            <a:srgbClr val="FFFFFF"/>
+          </a:solidFill>
+          <a:ln w="10160">
+            <a:solidFill>
+              <a:srgbClr val="008C8C"/>
+            </a:solidFill>
+          </a:ln>
+        </p:spPr>
+        <p:style>
+          <a:lnRef idx="1">
+            <a:schemeClr val="accent1"/>
+          </a:lnRef>
+          <a:fillRef idx="3">
+            <a:schemeClr val="accent1"/>
+          </a:fillRef>
+          <a:effectRef idx="2">
+            <a:schemeClr val="accent1"/>
+          </a:effectRef>
+          <a:fontRef idx="minor">
+            <a:schemeClr val="lt1"/>
+          </a:fontRef>
+        </p:style>
+        <p:txBody>
+          <a:bodyPr rtlCol="0" anchor="ctr"/>
+          <a:lstStyle/>
+          <a:p>
+            <a:pPr algn="ctr"/>
+          </a:p>
+        </p:txBody>
+      </p:sp>
+      <p:sp>
+        <p:nvSpPr>
+          <p:cNvPr id="10" name="TextBox 9"/>
+          <p:cNvSpPr txBox="1"/>
+          <p:nvPr/>
+        </p:nvSpPr>
+        <p:spPr>
+          <a:xfrm>
+            <a:off x="3108960" y="2176272"/>
+            <a:ext cx="1627632" cy="347472"/>
+          </a:xfrm>
+          <a:prstGeom prst="rect">
+            <a:avLst/>
+          </a:prstGeom>
+          <a:noFill/>
+        </p:spPr>
+        <p:txBody>
+          <a:bodyPr wrap="square" lIns="18288" rIns="18288" tIns="18288" bIns="18288" anchor="t">
+            <a:noAutofit/>
+          </a:bodyPr>
+          <a:lstStyle/>
+          <a:p>
+            <a:pPr algn="ctr">
+              <a:lnSpc>
+                <a:spcPct val="105000"/>
+              </a:lnSpc>
+            </a:pPr>
+            <a:r>
+              <a:rPr sz="1800" b="0" i="0">
+                <a:solidFill>
+                  <a:srgbClr val="008C8C"/>
+                </a:solidFill>
+                <a:latin typeface="Montserrat"/>
+              </a:rPr>
+              <a:t>02</a:t>
+            </a:r>
+            <a:endParaRPr sz="1800" b="0" i="0">
+              <a:latin typeface="Montserrat"/>
+            </a:endParaRPr>
+          </a:p>
+        </p:txBody>
+      </p:sp>
+      <p:sp>
+        <p:nvSpPr>
+          <p:cNvPr id="11" name="TextBox 10"/>
+          <p:cNvSpPr txBox="1"/>
+          <p:nvPr/>
+        </p:nvSpPr>
+        <p:spPr>
+          <a:xfrm>
+            <a:off x="3154680" y="2880360"/>
+            <a:ext cx="1536192" cy="960120"/>
+          </a:xfrm>
+          <a:prstGeom prst="rect">
+            <a:avLst/>
+          </a:prstGeom>
+          <a:noFill/>
+        </p:spPr>
+        <p:txBody>
+          <a:bodyPr wrap="square" lIns="18288" rIns="18288" tIns="18288" bIns="18288" anchor="ctr">
+            <a:noAutofit/>
+          </a:bodyPr>
+          <a:lstStyle/>
+          <a:p>
+            <a:pPr algn="ctr">
+              <a:lnSpc>
+                <a:spcPct val="105000"/>
+              </a:lnSpc>
+            </a:pPr>
+            <a:r>
+              <a:rPr sz="1400" b="0" i="0">
+                <a:solidFill>
+                  <a:srgbClr val="15243A"/>
+                </a:solidFill>
+                <a:latin typeface="Montserrat"/>
+              </a:rPr>
+              <a:t>Даёт команду</a:t>
+            </a:r>
+            <a:endParaRPr sz="1400" b="0" i="0">
+              <a:latin typeface="Montserrat"/>
+            </a:endParaRPr>
+          </a:p>
+        </p:txBody>
+      </p:sp>
+      <p:sp>
+        <p:nvSpPr>
+          <p:cNvPr id="12" name="Rectangle 11"/>
+          <p:cNvSpPr/>
+          <p:nvPr/>
+        </p:nvSpPr>
+        <p:spPr>
+          <a:xfrm>
+            <a:off x="4919472" y="3136392"/>
+            <a:ext cx="310896" cy="91440"/>
+          </a:xfrm>
+          <a:prstGeom prst="rect">
+            <a:avLst/>
+          </a:prstGeom>
+          <a:solidFill>
+            <a:srgbClr val="008C8C"/>
+          </a:solidFill>
+          <a:ln w="10160">
+            <a:solidFill>
+              <a:srgbClr val="008C8C"/>
+            </a:solidFill>
+          </a:ln>
+        </p:spPr>
+        <p:style>
+          <a:lnRef idx="1">
+            <a:schemeClr val="accent1"/>
+          </a:lnRef>
+          <a:fillRef idx="3">
+            <a:schemeClr val="accent1"/>
+          </a:fillRef>
+          <a:effectRef idx="2">
+            <a:schemeClr val="accent1"/>
+          </a:effectRef>
+          <a:fontRef idx="minor">
+            <a:schemeClr val="lt1"/>
+          </a:fontRef>
+        </p:style>
+        <p:txBody>
+          <a:bodyPr rtlCol="0" anchor="ctr"/>
+          <a:lstStyle/>
+          <a:p>
+            <a:pPr algn="ctr"/>
+          </a:p>
+        </p:txBody>
+      </p:sp>
+      <p:sp>
+        <p:nvSpPr>
+          <p:cNvPr id="13" name="Rounded Rectangle 12"/>
+          <p:cNvSpPr/>
+          <p:nvPr/>
+        </p:nvSpPr>
+        <p:spPr>
+          <a:xfrm>
+            <a:off x="5230368" y="1938528"/>
+            <a:ext cx="1993392" cy="2514600"/>
+          </a:xfrm>
+          <a:prstGeom prst="roundRect">
+            <a:avLst/>
+          </a:prstGeom>
+          <a:solidFill>
+            <a:srgbClr val="FFFFFF"/>
+          </a:solidFill>
+          <a:ln w="10160">
+            <a:solidFill>
+              <a:srgbClr val="008C8C"/>
+            </a:solidFill>
+          </a:ln>
+        </p:spPr>
+        <p:style>
+          <a:lnRef idx="1">
+            <a:schemeClr val="accent1"/>
+          </a:lnRef>
+          <a:fillRef idx="3">
+            <a:schemeClr val="accent1"/>
+          </a:fillRef>
+          <a:effectRef idx="2">
+            <a:schemeClr val="accent1"/>
+          </a:effectRef>
+          <a:fontRef idx="minor">
+            <a:schemeClr val="lt1"/>
+          </a:fontRef>
+        </p:style>
+        <p:txBody>
+          <a:bodyPr rtlCol="0" anchor="ctr"/>
+          <a:lstStyle/>
+          <a:p>
+            <a:pPr algn="ctr"/>
+          </a:p>
+        </p:txBody>
+      </p:sp>
+      <p:sp>
+        <p:nvSpPr>
+          <p:cNvPr id="14" name="TextBox 13"/>
+          <p:cNvSpPr txBox="1"/>
+          <p:nvPr/>
+        </p:nvSpPr>
+        <p:spPr>
+          <a:xfrm>
+            <a:off x="5413248" y="2176272"/>
+            <a:ext cx="1627632" cy="347472"/>
+          </a:xfrm>
+          <a:prstGeom prst="rect">
+            <a:avLst/>
+          </a:prstGeom>
+          <a:noFill/>
+        </p:spPr>
+        <p:txBody>
+          <a:bodyPr wrap="square" lIns="18288" rIns="18288" tIns="18288" bIns="18288" anchor="t">
+            <a:noAutofit/>
+          </a:bodyPr>
+          <a:lstStyle/>
+          <a:p>
+            <a:pPr algn="ctr">
+              <a:lnSpc>
+                <a:spcPct val="105000"/>
+              </a:lnSpc>
+            </a:pPr>
+            <a:r>
+              <a:rPr sz="1800" b="0" i="0">
+                <a:solidFill>
+                  <a:srgbClr val="008C8C"/>
+                </a:solidFill>
+                <a:latin typeface="Montserrat"/>
+              </a:rPr>
+              <a:t>03</a:t>
+            </a:r>
+            <a:endParaRPr sz="1800" b="0" i="0">
+              <a:latin typeface="Montserrat"/>
+            </a:endParaRPr>
+          </a:p>
+        </p:txBody>
+      </p:sp>
+      <p:sp>
+        <p:nvSpPr>
+          <p:cNvPr id="15" name="TextBox 14"/>
+          <p:cNvSpPr txBox="1"/>
+          <p:nvPr/>
+        </p:nvSpPr>
+        <p:spPr>
+          <a:xfrm>
+            <a:off x="5458968" y="2880360"/>
+            <a:ext cx="1536192" cy="960120"/>
+          </a:xfrm>
+          <a:prstGeom prst="rect">
+            <a:avLst/>
+          </a:prstGeom>
+          <a:noFill/>
+        </p:spPr>
+        <p:txBody>
+          <a:bodyPr wrap="square" lIns="18288" rIns="18288" tIns="18288" bIns="18288" anchor="ctr">
+            <a:noAutofit/>
+          </a:bodyPr>
+          <a:lstStyle/>
+          <a:p>
+            <a:pPr algn="ctr">
+              <a:lnSpc>
+                <a:spcPct val="105000"/>
+              </a:lnSpc>
+            </a:pPr>
+            <a:r>
+              <a:rPr sz="1400" b="0" i="0">
+                <a:solidFill>
+                  <a:srgbClr val="15243A"/>
+                </a:solidFill>
+                <a:latin typeface="Montserrat"/>
+              </a:rPr>
+              <a:t>Заказ создаётся в 1С</a:t>
+            </a:r>
+            <a:endParaRPr sz="1400" b="0" i="0">
+              <a:latin typeface="Montserrat"/>
+            </a:endParaRPr>
+          </a:p>
+        </p:txBody>
+      </p:sp>
+      <p:sp>
+        <p:nvSpPr>
+          <p:cNvPr id="16" name="Rectangle 15"/>
+          <p:cNvSpPr/>
+          <p:nvPr/>
+        </p:nvSpPr>
+        <p:spPr>
+          <a:xfrm>
+            <a:off x="7223760" y="3136392"/>
+            <a:ext cx="310896" cy="91440"/>
+          </a:xfrm>
+          <a:prstGeom prst="rect">
+            <a:avLst/>
+          </a:prstGeom>
+          <a:solidFill>
+            <a:srgbClr val="008C8C"/>
+          </a:solidFill>
+          <a:ln w="10160">
+            <a:solidFill>
+              <a:srgbClr val="008C8C"/>
+            </a:solidFill>
+          </a:ln>
+        </p:spPr>
+        <p:style>
+          <a:lnRef idx="1">
+            <a:schemeClr val="accent1"/>
+          </a:lnRef>
+          <a:fillRef idx="3">
+            <a:schemeClr val="accent1"/>
+          </a:fillRef>
+          <a:effectRef idx="2">
+            <a:schemeClr val="accent1"/>
+          </a:effectRef>
+          <a:fontRef idx="minor">
+            <a:schemeClr val="lt1"/>
+          </a:fontRef>
+        </p:style>
+        <p:txBody>
+          <a:bodyPr rtlCol="0" anchor="ctr"/>
+          <a:lstStyle/>
+          <a:p>
+            <a:pPr algn="ctr"/>
+          </a:p>
+        </p:txBody>
+      </p:sp>
+      <p:sp>
+        <p:nvSpPr>
+          <p:cNvPr id="17" name="Rounded Rectangle 16"/>
+          <p:cNvSpPr/>
+          <p:nvPr/>
+        </p:nvSpPr>
+        <p:spPr>
+          <a:xfrm>
+            <a:off x="7534656" y="1938528"/>
+            <a:ext cx="1993392" cy="2514600"/>
+          </a:xfrm>
+          <a:prstGeom prst="roundRect">
+            <a:avLst/>
+          </a:prstGeom>
+          <a:solidFill>
+            <a:srgbClr val="FFFFFF"/>
+          </a:solidFill>
+          <a:ln w="10160">
+            <a:solidFill>
+              <a:srgbClr val="008C8C"/>
+            </a:solidFill>
+          </a:ln>
+        </p:spPr>
+        <p:style>
+          <a:lnRef idx="1">
+            <a:schemeClr val="accent1"/>
+          </a:lnRef>
+          <a:fillRef idx="3">
+            <a:schemeClr val="accent1"/>
+          </a:fillRef>
+          <a:effectRef idx="2">
+            <a:schemeClr val="accent1"/>
+          </a:effectRef>
+          <a:fontRef idx="minor">
+            <a:schemeClr val="lt1"/>
+          </a:fontRef>
+        </p:style>
+        <p:txBody>
+          <a:bodyPr rtlCol="0" anchor="ctr"/>
+          <a:lstStyle/>
+          <a:p>
+            <a:pPr algn="ctr"/>
+          </a:p>
+        </p:txBody>
+      </p:sp>
+      <p:sp>
+        <p:nvSpPr>
+          <p:cNvPr id="18" name="TextBox 17"/>
+          <p:cNvSpPr txBox="1"/>
+          <p:nvPr/>
+        </p:nvSpPr>
+        <p:spPr>
+          <a:xfrm>
+            <a:off x="7717536" y="2176272"/>
+            <a:ext cx="1627632" cy="347472"/>
+          </a:xfrm>
+          <a:prstGeom prst="rect">
+            <a:avLst/>
+          </a:prstGeom>
+          <a:noFill/>
+        </p:spPr>
+        <p:txBody>
+          <a:bodyPr wrap="square" lIns="18288" rIns="18288" tIns="18288" bIns="18288" anchor="t">
+            <a:noAutofit/>
+          </a:bodyPr>
+          <a:lstStyle/>
+          <a:p>
+            <a:pPr algn="ctr">
+              <a:lnSpc>
+                <a:spcPct val="105000"/>
+              </a:lnSpc>
+            </a:pPr>
+            <a:r>
+              <a:rPr sz="1800" b="0" i="0">
+                <a:solidFill>
+                  <a:srgbClr val="008C8C"/>
+                </a:solidFill>
+                <a:latin typeface="Montserrat"/>
+              </a:rPr>
+              <a:t>04</a:t>
+            </a:r>
+            <a:endParaRPr sz="1800" b="0" i="0">
+              <a:latin typeface="Montserrat"/>
+            </a:endParaRPr>
+          </a:p>
+        </p:txBody>
+      </p:sp>
+      <p:sp>
+        <p:nvSpPr>
+          <p:cNvPr id="19" name="TextBox 18"/>
+          <p:cNvSpPr txBox="1"/>
+          <p:nvPr/>
+        </p:nvSpPr>
+        <p:spPr>
+          <a:xfrm>
+            <a:off x="7763256" y="2880360"/>
+            <a:ext cx="1536192" cy="960120"/>
+          </a:xfrm>
+          <a:prstGeom prst="rect">
+            <a:avLst/>
+          </a:prstGeom>
+          <a:noFill/>
+        </p:spPr>
+        <p:txBody>
+          <a:bodyPr wrap="square" lIns="18288" rIns="18288" tIns="18288" bIns="18288" anchor="ctr">
+            <a:noAutofit/>
+          </a:bodyPr>
+          <a:lstStyle/>
+          <a:p>
+            <a:pPr algn="ctr">
+              <a:lnSpc>
+                <a:spcPct val="105000"/>
+              </a:lnSpc>
+            </a:pPr>
+            <a:r>
+              <a:rPr sz="1400" b="0" i="0">
+                <a:solidFill>
+                  <a:srgbClr val="15243A"/>
+                </a:solidFill>
+                <a:latin typeface="Montserrat"/>
+              </a:rPr>
+              <a:t>Производство выполняет заказ</a:t>
+            </a:r>
+            <a:endParaRPr sz="1400" b="0" i="0">
+              <a:latin typeface="Montserrat"/>
+            </a:endParaRPr>
+          </a:p>
+        </p:txBody>
+      </p:sp>
+      <p:sp>
+        <p:nvSpPr>
+          <p:cNvPr id="20" name="Rectangle 19"/>
+          <p:cNvSpPr/>
+          <p:nvPr/>
+        </p:nvSpPr>
+        <p:spPr>
+          <a:xfrm>
+            <a:off x="9528048" y="3136392"/>
+            <a:ext cx="310896" cy="91440"/>
+          </a:xfrm>
+          <a:prstGeom prst="rect">
+            <a:avLst/>
+          </a:prstGeom>
+          <a:solidFill>
+            <a:srgbClr val="008C8C"/>
+          </a:solidFill>
+          <a:ln w="10160">
+            <a:solidFill>
+              <a:srgbClr val="008C8C"/>
+            </a:solidFill>
+          </a:ln>
+        </p:spPr>
+        <p:style>
+          <a:lnRef idx="1">
+            <a:schemeClr val="accent1"/>
+          </a:lnRef>
+          <a:fillRef idx="3">
+            <a:schemeClr val="accent1"/>
+          </a:fillRef>
+          <a:effectRef idx="2">
+            <a:schemeClr val="accent1"/>
+          </a:effectRef>
+          <a:fontRef idx="minor">
+            <a:schemeClr val="lt1"/>
+          </a:fontRef>
+        </p:style>
+        <p:txBody>
+          <a:bodyPr rtlCol="0" anchor="ctr"/>
+          <a:lstStyle/>
+          <a:p>
+            <a:pPr algn="ctr"/>
+          </a:p>
+        </p:txBody>
+      </p:sp>
+      <p:sp>
+        <p:nvSpPr>
+          <p:cNvPr id="21" name="Rounded Rectangle 20"/>
+          <p:cNvSpPr/>
+          <p:nvPr/>
+        </p:nvSpPr>
+        <p:spPr>
+          <a:xfrm>
+            <a:off x="9838944" y="1938528"/>
+            <a:ext cx="1993392" cy="2514600"/>
+          </a:xfrm>
+          <a:prstGeom prst="roundRect">
+            <a:avLst/>
+          </a:prstGeom>
+          <a:solidFill>
+            <a:srgbClr val="FFFFFF"/>
+          </a:solidFill>
+          <a:ln w="10160">
+            <a:solidFill>
+              <a:srgbClr val="008C8C"/>
+            </a:solidFill>
+          </a:ln>
+        </p:spPr>
+        <p:style>
+          <a:lnRef idx="1">
+            <a:schemeClr val="accent1"/>
+          </a:lnRef>
+          <a:fillRef idx="3">
+            <a:schemeClr val="accent1"/>
+          </a:fillRef>
+          <a:effectRef idx="2">
+            <a:schemeClr val="accent1"/>
+          </a:effectRef>
+          <a:fontRef idx="minor">
+            <a:schemeClr val="lt1"/>
+          </a:fontRef>
+        </p:style>
+        <p:txBody>
+          <a:bodyPr rtlCol="0" anchor="ctr"/>
+          <a:lstStyle/>
+          <a:p>
+            <a:pPr algn="ctr"/>
+          </a:p>
+        </p:txBody>
+      </p:sp>
+      <p:sp>
+        <p:nvSpPr>
+          <p:cNvPr id="22" name="TextBox 21"/>
+          <p:cNvSpPr txBox="1"/>
+          <p:nvPr/>
+        </p:nvSpPr>
+        <p:spPr>
+          <a:xfrm>
+            <a:off x="10021824" y="2176272"/>
+            <a:ext cx="1627632" cy="347472"/>
+          </a:xfrm>
+          <a:prstGeom prst="rect">
+            <a:avLst/>
+          </a:prstGeom>
+          <a:noFill/>
+        </p:spPr>
+        <p:txBody>
+          <a:bodyPr wrap="square" lIns="18288" rIns="18288" tIns="18288" bIns="18288" anchor="t">
+            <a:noAutofit/>
+          </a:bodyPr>
+          <a:lstStyle/>
+          <a:p>
+            <a:pPr algn="ctr">
+              <a:lnSpc>
+                <a:spcPct val="105000"/>
+              </a:lnSpc>
+            </a:pPr>
+            <a:r>
+              <a:rPr sz="1800" b="0" i="0">
+                <a:solidFill>
+                  <a:srgbClr val="008C8C"/>
+                </a:solidFill>
+                <a:latin typeface="Montserrat"/>
+              </a:rPr>
+              <a:t>05</a:t>
+            </a:r>
+            <a:endParaRPr sz="1800" b="0" i="0">
+              <a:latin typeface="Montserrat"/>
+            </a:endParaRPr>
+          </a:p>
+        </p:txBody>
+      </p:sp>
+      <p:sp>
+        <p:nvSpPr>
+          <p:cNvPr id="23" name="TextBox 22"/>
+          <p:cNvSpPr txBox="1"/>
+          <p:nvPr/>
+        </p:nvSpPr>
+        <p:spPr>
+          <a:xfrm>
+            <a:off x="10067544" y="2880360"/>
+            <a:ext cx="1536192" cy="960120"/>
+          </a:xfrm>
+          <a:prstGeom prst="rect">
+            <a:avLst/>
+          </a:prstGeom>
+          <a:noFill/>
+        </p:spPr>
+        <p:txBody>
+          <a:bodyPr wrap="square" lIns="18288" rIns="18288" tIns="18288" bIns="18288" anchor="ctr">
+            <a:noAutofit/>
+          </a:bodyPr>
+          <a:lstStyle/>
+          <a:p>
+            <a:pPr algn="ctr">
+              <a:lnSpc>
+                <a:spcPct val="105000"/>
+              </a:lnSpc>
+            </a:pPr>
+            <a:r>
+              <a:rPr sz="1400" b="0" i="0">
+                <a:solidFill>
+                  <a:srgbClr val="15243A"/>
+                </a:solidFill>
+                <a:latin typeface="Montserrat"/>
+              </a:rPr>
+              <a:t>Результат виден в CRM</a:t>
+            </a:r>
+            <a:endParaRPr sz="1400" b="0" i="0">
+              <a:latin typeface="Montserrat"/>
+            </a:endParaRPr>
+          </a:p>
+        </p:txBody>
+      </p:sp>
+      <p:sp>
+        <p:nvSpPr>
+          <p:cNvPr id="24" name="Rounded Rectangle 23"/>
           <p:cNvSpPr/>
           <p:nvPr/>
         </p:nvSpPr>
@@ -6820,7 +7822,7 @@
       </p:sp>
       <p:sp>
         <p:nvSpPr>
-          <p:cNvPr id="7" name="TextBox 6"/>
+          <p:cNvPr id="25" name="TextBox 24"/>
           <p:cNvSpPr txBox="1"/>
           <p:nvPr/>
         </p:nvSpPr>
@@ -6862,7 +7864,7 @@
       </p:sp>
       <p:sp>
         <p:nvSpPr>
-          <p:cNvPr id="8" name="TextBox 7"/>
+          <p:cNvPr id="26" name="TextBox 25"/>
           <p:cNvSpPr txBox="1"/>
           <p:nvPr/>
         </p:nvSpPr>
@@ -7054,33 +8056,449 @@
           </a:p>
         </p:txBody>
       </p:sp>
-      <p:pic>
-        <p:nvPicPr>
-          <p:cNvPr id="5" name="Picture 4" descr="03-reverse-sync.png"/>
-          <p:cNvPicPr>
-            <a:picLocks noChangeAspect="1"/>
-          </p:cNvPicPr>
-          <p:nvPr/>
-        </p:nvPicPr>
-        <p:blipFill>
-          <a:blip r:embed="rId2"/>
-          <a:stretch>
-            <a:fillRect/>
-          </a:stretch>
-        </p:blipFill>
-        <p:spPr>
-          <a:xfrm>
-            <a:off x="621792" y="1627632"/>
-            <a:ext cx="10927080" cy="3203000"/>
-          </a:xfrm>
-          <a:prstGeom prst="rect">
-            <a:avLst/>
-          </a:prstGeom>
-        </p:spPr>
-      </p:pic>
+      <p:sp>
+        <p:nvSpPr>
+          <p:cNvPr id="5" name="Rounded Rectangle 4"/>
+          <p:cNvSpPr/>
+          <p:nvPr/>
+        </p:nvSpPr>
+        <p:spPr>
+          <a:xfrm>
+            <a:off x="749808" y="1627632"/>
+            <a:ext cx="4069080" cy="2395728"/>
+          </a:xfrm>
+          <a:prstGeom prst="roundRect">
+            <a:avLst/>
+          </a:prstGeom>
+          <a:solidFill>
+            <a:srgbClr val="FFFFFF"/>
+          </a:solidFill>
+          <a:ln w="10160">
+            <a:solidFill>
+              <a:srgbClr val="D99400"/>
+            </a:solidFill>
+          </a:ln>
+        </p:spPr>
+        <p:style>
+          <a:lnRef idx="1">
+            <a:schemeClr val="accent1"/>
+          </a:lnRef>
+          <a:fillRef idx="3">
+            <a:schemeClr val="accent1"/>
+          </a:fillRef>
+          <a:effectRef idx="2">
+            <a:schemeClr val="accent1"/>
+          </a:effectRef>
+          <a:fontRef idx="minor">
+            <a:schemeClr val="lt1"/>
+          </a:fontRef>
+        </p:style>
+        <p:txBody>
+          <a:bodyPr rtlCol="0" anchor="ctr"/>
+          <a:lstStyle/>
+          <a:p>
+            <a:pPr algn="ctr"/>
+          </a:p>
+        </p:txBody>
+      </p:sp>
       <p:sp>
         <p:nvSpPr>
           <p:cNvPr id="6" name="TextBox 5"/>
+          <p:cNvSpPr txBox="1"/>
+          <p:nvPr/>
+        </p:nvSpPr>
+        <p:spPr>
+          <a:xfrm>
+            <a:off x="1024128" y="1901952"/>
+            <a:ext cx="3520440" cy="320040"/>
+          </a:xfrm>
+          <a:prstGeom prst="rect">
+            <a:avLst/>
+          </a:prstGeom>
+          <a:noFill/>
+        </p:spPr>
+        <p:txBody>
+          <a:bodyPr wrap="square" lIns="18288" rIns="18288" tIns="18288" bIns="18288" anchor="t">
+            <a:noAutofit/>
+          </a:bodyPr>
+          <a:lstStyle/>
+          <a:p>
+            <a:pPr algn="ctr">
+              <a:lnSpc>
+                <a:spcPct val="105000"/>
+              </a:lnSpc>
+            </a:pPr>
+            <a:r>
+              <a:rPr sz="1300" b="0" i="0">
+                <a:solidFill>
+                  <a:srgbClr val="D99400"/>
+                </a:solidFill>
+                <a:latin typeface="Montserrat"/>
+              </a:rPr>
+              <a:t>1С • ПРОИЗВОДСТВО</a:t>
+            </a:r>
+            <a:endParaRPr sz="1300" b="0" i="0">
+              <a:latin typeface="Montserrat"/>
+            </a:endParaRPr>
+          </a:p>
+        </p:txBody>
+      </p:sp>
+      <p:sp>
+        <p:nvSpPr>
+          <p:cNvPr id="7" name="TextBox 6"/>
+          <p:cNvSpPr txBox="1"/>
+          <p:nvPr/>
+        </p:nvSpPr>
+        <p:spPr>
+          <a:xfrm>
+            <a:off x="1207008" y="2459736"/>
+            <a:ext cx="3154680" cy="1261872"/>
+          </a:xfrm>
+          <a:prstGeom prst="rect">
+            <a:avLst/>
+          </a:prstGeom>
+          <a:noFill/>
+        </p:spPr>
+        <p:txBody>
+          <a:bodyPr wrap="square" lIns="18288" rIns="18288" tIns="18288" bIns="18288" anchor="t">
+            <a:noAutofit/>
+          </a:bodyPr>
+          <a:lstStyle/>
+          <a:p>
+            <a:pPr algn="ctr">
+              <a:lnSpc>
+                <a:spcPct val="105000"/>
+              </a:lnSpc>
+            </a:pPr>
+            <a:r>
+              <a:rPr sz="1400" b="0" i="0">
+                <a:solidFill>
+                  <a:srgbClr val="15243A"/>
+                </a:solidFill>
+                <a:latin typeface="Montserrat"/>
+              </a:rPr>
+              <a:t>Статус
+Срок готовности
+Сумма
+Сведения о переделке</a:t>
+            </a:r>
+            <a:endParaRPr sz="1400" b="0" i="0">
+              <a:latin typeface="Montserrat"/>
+            </a:endParaRPr>
+          </a:p>
+        </p:txBody>
+      </p:sp>
+      <p:sp>
+        <p:nvSpPr>
+          <p:cNvPr id="8" name="Rounded Rectangle 7"/>
+          <p:cNvSpPr/>
+          <p:nvPr/>
+        </p:nvSpPr>
+        <p:spPr>
+          <a:xfrm>
+            <a:off x="5065776" y="2258568"/>
+            <a:ext cx="2057400" cy="1051560"/>
+          </a:xfrm>
+          <a:prstGeom prst="roundRect">
+            <a:avLst/>
+          </a:prstGeom>
+          <a:solidFill>
+            <a:srgbClr val="E7F6F5"/>
+          </a:solidFill>
+          <a:ln w="10160">
+            <a:solidFill>
+              <a:srgbClr val="008C8C"/>
+            </a:solidFill>
+          </a:ln>
+        </p:spPr>
+        <p:style>
+          <a:lnRef idx="1">
+            <a:schemeClr val="accent1"/>
+          </a:lnRef>
+          <a:fillRef idx="3">
+            <a:schemeClr val="accent1"/>
+          </a:fillRef>
+          <a:effectRef idx="2">
+            <a:schemeClr val="accent1"/>
+          </a:effectRef>
+          <a:fontRef idx="minor">
+            <a:schemeClr val="lt1"/>
+          </a:fontRef>
+        </p:style>
+        <p:txBody>
+          <a:bodyPr rtlCol="0" anchor="ctr"/>
+          <a:lstStyle/>
+          <a:p>
+            <a:pPr algn="ctr"/>
+          </a:p>
+        </p:txBody>
+      </p:sp>
+      <p:sp>
+        <p:nvSpPr>
+          <p:cNvPr id="9" name="TextBox 8"/>
+          <p:cNvSpPr txBox="1"/>
+          <p:nvPr/>
+        </p:nvSpPr>
+        <p:spPr>
+          <a:xfrm>
+            <a:off x="5285232" y="2532888"/>
+            <a:ext cx="1618488" cy="530352"/>
+          </a:xfrm>
+          <a:prstGeom prst="rect">
+            <a:avLst/>
+          </a:prstGeom>
+          <a:noFill/>
+        </p:spPr>
+        <p:txBody>
+          <a:bodyPr wrap="square" lIns="18288" rIns="18288" tIns="18288" bIns="18288" anchor="t">
+            <a:noAutofit/>
+          </a:bodyPr>
+          <a:lstStyle/>
+          <a:p>
+            <a:pPr algn="ctr">
+              <a:lnSpc>
+                <a:spcPct val="105000"/>
+              </a:lnSpc>
+            </a:pPr>
+            <a:r>
+              <a:rPr sz="1100" b="0" i="0">
+                <a:solidFill>
+                  <a:srgbClr val="008C8C"/>
+                </a:solidFill>
+                <a:latin typeface="Montserrat"/>
+              </a:rPr>
+              <a:t>АВТОМАТИЧЕСКОЕ
+ОБНОВЛЕНИЕ</a:t>
+            </a:r>
+            <a:endParaRPr sz="1100" b="0" i="0">
+              <a:latin typeface="Montserrat"/>
+            </a:endParaRPr>
+          </a:p>
+        </p:txBody>
+      </p:sp>
+      <p:sp>
+        <p:nvSpPr>
+          <p:cNvPr id="10" name="Rounded Rectangle 9"/>
+          <p:cNvSpPr/>
+          <p:nvPr/>
+        </p:nvSpPr>
+        <p:spPr>
+          <a:xfrm>
+            <a:off x="7370064" y="1627632"/>
+            <a:ext cx="4069080" cy="2395728"/>
+          </a:xfrm>
+          <a:prstGeom prst="roundRect">
+            <a:avLst/>
+          </a:prstGeom>
+          <a:solidFill>
+            <a:srgbClr val="FFFFFF"/>
+          </a:solidFill>
+          <a:ln w="10160">
+            <a:solidFill>
+              <a:srgbClr val="1769AA"/>
+            </a:solidFill>
+          </a:ln>
+        </p:spPr>
+        <p:style>
+          <a:lnRef idx="1">
+            <a:schemeClr val="accent1"/>
+          </a:lnRef>
+          <a:fillRef idx="3">
+            <a:schemeClr val="accent1"/>
+          </a:fillRef>
+          <a:effectRef idx="2">
+            <a:schemeClr val="accent1"/>
+          </a:effectRef>
+          <a:fontRef idx="minor">
+            <a:schemeClr val="lt1"/>
+          </a:fontRef>
+        </p:style>
+        <p:txBody>
+          <a:bodyPr rtlCol="0" anchor="ctr"/>
+          <a:lstStyle/>
+          <a:p>
+            <a:pPr algn="ctr"/>
+          </a:p>
+        </p:txBody>
+      </p:sp>
+      <p:sp>
+        <p:nvSpPr>
+          <p:cNvPr id="11" name="TextBox 10"/>
+          <p:cNvSpPr txBox="1"/>
+          <p:nvPr/>
+        </p:nvSpPr>
+        <p:spPr>
+          <a:xfrm>
+            <a:off x="7644383" y="1901952"/>
+            <a:ext cx="3520440" cy="320040"/>
+          </a:xfrm>
+          <a:prstGeom prst="rect">
+            <a:avLst/>
+          </a:prstGeom>
+          <a:noFill/>
+        </p:spPr>
+        <p:txBody>
+          <a:bodyPr wrap="square" lIns="18288" rIns="18288" tIns="18288" bIns="18288" anchor="t">
+            <a:noAutofit/>
+          </a:bodyPr>
+          <a:lstStyle/>
+          <a:p>
+            <a:pPr algn="ctr">
+              <a:lnSpc>
+                <a:spcPct val="105000"/>
+              </a:lnSpc>
+            </a:pPr>
+            <a:r>
+              <a:rPr sz="1300" b="0" i="0">
+                <a:solidFill>
+                  <a:srgbClr val="1769AA"/>
+                </a:solidFill>
+                <a:latin typeface="Montserrat"/>
+              </a:rPr>
+              <a:t>BITRIX24 • МЕНЕДЖЕР</a:t>
+            </a:r>
+            <a:endParaRPr sz="1300" b="0" i="0">
+              <a:latin typeface="Montserrat"/>
+            </a:endParaRPr>
+          </a:p>
+        </p:txBody>
+      </p:sp>
+      <p:sp>
+        <p:nvSpPr>
+          <p:cNvPr id="12" name="TextBox 11"/>
+          <p:cNvSpPr txBox="1"/>
+          <p:nvPr/>
+        </p:nvSpPr>
+        <p:spPr>
+          <a:xfrm>
+            <a:off x="7827264" y="2596896"/>
+            <a:ext cx="3154680" cy="841248"/>
+          </a:xfrm>
+          <a:prstGeom prst="rect">
+            <a:avLst/>
+          </a:prstGeom>
+          <a:noFill/>
+        </p:spPr>
+        <p:txBody>
+          <a:bodyPr wrap="square" lIns="18288" rIns="18288" tIns="18288" bIns="18288" anchor="ctr">
+            <a:noAutofit/>
+          </a:bodyPr>
+          <a:lstStyle/>
+          <a:p>
+            <a:pPr algn="ctr">
+              <a:lnSpc>
+                <a:spcPct val="105000"/>
+              </a:lnSpc>
+            </a:pPr>
+            <a:r>
+              <a:rPr sz="1600" b="0" i="0">
+                <a:solidFill>
+                  <a:srgbClr val="15243A"/>
+                </a:solidFill>
+                <a:latin typeface="Montserrat"/>
+              </a:rPr>
+              <a:t>Актуальный результат
+виден в исходной сделке</a:t>
+            </a:r>
+            <a:endParaRPr sz="1600" b="0" i="0">
+              <a:latin typeface="Montserrat"/>
+            </a:endParaRPr>
+          </a:p>
+        </p:txBody>
+      </p:sp>
+      <p:sp>
+        <p:nvSpPr>
+          <p:cNvPr id="13" name="Rectangle 12"/>
+          <p:cNvSpPr/>
+          <p:nvPr/>
+        </p:nvSpPr>
+        <p:spPr>
+          <a:xfrm>
+            <a:off x="4818888" y="2743200"/>
+            <a:ext cx="246888" cy="91440"/>
+          </a:xfrm>
+          <a:prstGeom prst="rect">
+            <a:avLst/>
+          </a:prstGeom>
+          <a:solidFill>
+            <a:srgbClr val="008C8C"/>
+          </a:solidFill>
+          <a:ln w="10160">
+            <a:solidFill>
+              <a:srgbClr val="008C8C"/>
+            </a:solidFill>
+          </a:ln>
+        </p:spPr>
+        <p:style>
+          <a:lnRef idx="1">
+            <a:schemeClr val="accent1"/>
+          </a:lnRef>
+          <a:fillRef idx="3">
+            <a:schemeClr val="accent1"/>
+          </a:fillRef>
+          <a:effectRef idx="2">
+            <a:schemeClr val="accent1"/>
+          </a:effectRef>
+          <a:fontRef idx="minor">
+            <a:schemeClr val="lt1"/>
+          </a:fontRef>
+        </p:style>
+        <p:txBody>
+          <a:bodyPr rtlCol="0" anchor="ctr"/>
+          <a:lstStyle/>
+          <a:p>
+            <a:pPr algn="ctr"/>
+          </a:p>
+        </p:txBody>
+      </p:sp>
+      <p:sp>
+        <p:nvSpPr>
+          <p:cNvPr id="14" name="Rectangle 13"/>
+          <p:cNvSpPr/>
+          <p:nvPr/>
+        </p:nvSpPr>
+        <p:spPr>
+          <a:xfrm>
+            <a:off x="7123176" y="2743200"/>
+            <a:ext cx="246888" cy="91440"/>
+          </a:xfrm>
+          <a:prstGeom prst="rect">
+            <a:avLst/>
+          </a:prstGeom>
+          <a:solidFill>
+            <a:srgbClr val="008C8C"/>
+          </a:solidFill>
+          <a:ln w="10160">
+            <a:solidFill>
+              <a:srgbClr val="008C8C"/>
+            </a:solidFill>
+          </a:ln>
+        </p:spPr>
+        <p:style>
+          <a:lnRef idx="1">
+            <a:schemeClr val="accent1"/>
+          </a:lnRef>
+          <a:fillRef idx="3">
+            <a:schemeClr val="accent1"/>
+          </a:fillRef>
+          <a:effectRef idx="2">
+            <a:schemeClr val="accent1"/>
+          </a:effectRef>
+          <a:fontRef idx="minor">
+            <a:schemeClr val="lt1"/>
+          </a:fontRef>
+        </p:style>
+        <p:txBody>
+          <a:bodyPr rtlCol="0" anchor="ctr"/>
+          <a:lstStyle/>
+          <a:p>
+            <a:pPr algn="ctr"/>
+          </a:p>
+        </p:txBody>
+      </p:sp>
+      <p:sp>
+        <p:nvSpPr>
+          <p:cNvPr id="15" name="TextBox 14"/>
           <p:cNvSpPr txBox="1"/>
           <p:nvPr/>
         </p:nvSpPr>
@@ -7178,7 +8596,7 @@
       </p:sp>
       <p:sp>
         <p:nvSpPr>
-          <p:cNvPr id="7" name="TextBox 6"/>
+          <p:cNvPr id="16" name="TextBox 15"/>
           <p:cNvSpPr txBox="1"/>
           <p:nvPr/>
         </p:nvSpPr>
@@ -7370,40 +8788,16 @@
           </a:p>
         </p:txBody>
       </p:sp>
-      <p:pic>
-        <p:nvPicPr>
-          <p:cNvPr id="5" name="Picture 4" descr="04-retry-protection.png"/>
-          <p:cNvPicPr>
-            <a:picLocks noChangeAspect="1"/>
-          </p:cNvPicPr>
-          <p:nvPr/>
-        </p:nvPicPr>
-        <p:blipFill>
-          <a:blip r:embed="rId2"/>
-          <a:stretch>
-            <a:fillRect/>
-          </a:stretch>
-        </p:blipFill>
-        <p:spPr>
-          <a:xfrm>
-            <a:off x="640080" y="1618488"/>
-            <a:ext cx="10881360" cy="2223878"/>
-          </a:xfrm>
-          <a:prstGeom prst="rect">
-            <a:avLst/>
-          </a:prstGeom>
-        </p:spPr>
-      </p:pic>
-      <p:sp>
-        <p:nvSpPr>
-          <p:cNvPr id="6" name="Rounded Rectangle 5"/>
+      <p:sp>
+        <p:nvSpPr>
+          <p:cNvPr id="5" name="Rounded Rectangle 4"/>
           <p:cNvSpPr/>
           <p:nvPr/>
         </p:nvSpPr>
         <p:spPr>
           <a:xfrm>
-            <a:off x="640080" y="4370832"/>
-            <a:ext cx="2468880" cy="960120"/>
+            <a:off x="640080" y="1874519"/>
+            <a:ext cx="2468880" cy="2194560"/>
           </a:xfrm>
           <a:prstGeom prst="roundRect">
             <a:avLst/>
@@ -7441,75 +8835,75 @@
       </p:sp>
       <p:sp>
         <p:nvSpPr>
+          <p:cNvPr id="6" name="TextBox 5"/>
+          <p:cNvSpPr txBox="1"/>
+          <p:nvPr/>
+        </p:nvSpPr>
+        <p:spPr>
+          <a:xfrm>
+            <a:off x="841247" y="2112264"/>
+            <a:ext cx="2066543" cy="329184"/>
+          </a:xfrm>
+          <a:prstGeom prst="rect">
+            <a:avLst/>
+          </a:prstGeom>
+          <a:noFill/>
+        </p:spPr>
+        <p:txBody>
+          <a:bodyPr wrap="square" lIns="18288" rIns="18288" tIns="18288" bIns="18288" anchor="t">
+            <a:noAutofit/>
+          </a:bodyPr>
+          <a:lstStyle/>
+          <a:p>
+            <a:pPr algn="ctr">
+              <a:lnSpc>
+                <a:spcPct val="105000"/>
+              </a:lnSpc>
+            </a:pPr>
+            <a:r>
+              <a:rPr sz="1600" b="0" i="0">
+                <a:solidFill>
+                  <a:srgbClr val="1769AA"/>
+                </a:solidFill>
+                <a:latin typeface="Montserrat"/>
+              </a:rPr>
+              <a:t>01</a:t>
+            </a:r>
+            <a:endParaRPr sz="1600" b="0" i="0">
+              <a:latin typeface="Montserrat"/>
+            </a:endParaRPr>
+          </a:p>
+        </p:txBody>
+      </p:sp>
+      <p:sp>
+        <p:nvSpPr>
           <p:cNvPr id="7" name="TextBox 6"/>
           <p:cNvSpPr txBox="1"/>
           <p:nvPr/>
         </p:nvSpPr>
         <p:spPr>
           <a:xfrm>
-            <a:off x="786384" y="4526280"/>
-            <a:ext cx="329184" cy="228600"/>
-          </a:xfrm>
-          <a:prstGeom prst="rect">
-            <a:avLst/>
-          </a:prstGeom>
-          <a:noFill/>
-        </p:spPr>
-        <p:txBody>
-          <a:bodyPr wrap="square" lIns="18288" rIns="18288" tIns="18288" bIns="18288" anchor="t">
-            <a:noAutofit/>
-          </a:bodyPr>
-          <a:lstStyle/>
-          <a:p>
-            <a:pPr algn="l">
-              <a:lnSpc>
-                <a:spcPct val="105000"/>
-              </a:lnSpc>
-            </a:pPr>
-            <a:r>
-              <a:rPr sz="900" b="0" i="0">
-                <a:solidFill>
-                  <a:srgbClr val="1769AA"/>
-                </a:solidFill>
-                <a:latin typeface="Montserrat"/>
-              </a:rPr>
-              <a:t>01</a:t>
-            </a:r>
-            <a:endParaRPr sz="900" b="0" i="0">
-              <a:latin typeface="Montserrat"/>
-            </a:endParaRPr>
-          </a:p>
-        </p:txBody>
-      </p:sp>
-      <p:sp>
-        <p:nvSpPr>
-          <p:cNvPr id="8" name="TextBox 7"/>
-          <p:cNvSpPr txBox="1"/>
-          <p:nvPr/>
-        </p:nvSpPr>
-        <p:spPr>
-          <a:xfrm>
-            <a:off x="1170431" y="4498848"/>
-            <a:ext cx="1755648" cy="438912"/>
-          </a:xfrm>
-          <a:prstGeom prst="rect">
-            <a:avLst/>
-          </a:prstGeom>
-          <a:noFill/>
-        </p:spPr>
-        <p:txBody>
-          <a:bodyPr wrap="square" lIns="18288" rIns="18288" tIns="18288" bIns="18288" anchor="t">
-            <a:noAutofit/>
-          </a:bodyPr>
-          <a:lstStyle/>
-          <a:p>
-            <a:pPr algn="l">
-              <a:lnSpc>
-                <a:spcPct val="105000"/>
-              </a:lnSpc>
-            </a:pPr>
-            <a:r>
-              <a:rPr sz="1100" b="0" i="0">
+            <a:off x="960119" y="2743200"/>
+            <a:ext cx="1828800" cy="822960"/>
+          </a:xfrm>
+          <a:prstGeom prst="rect">
+            <a:avLst/>
+          </a:prstGeom>
+          <a:noFill/>
+        </p:spPr>
+        <p:txBody>
+          <a:bodyPr wrap="square" lIns="18288" rIns="18288" tIns="18288" bIns="18288" anchor="ctr">
+            <a:noAutofit/>
+          </a:bodyPr>
+          <a:lstStyle/>
+          <a:p>
+            <a:pPr algn="ctr">
+              <a:lnSpc>
+                <a:spcPct val="105000"/>
+              </a:lnSpc>
+            </a:pPr>
+            <a:r>
+              <a:rPr sz="1400" b="0" i="0">
                 <a:solidFill>
                   <a:srgbClr val="15243A"/>
                 </a:solidFill>
@@ -7517,9 +8911,54 @@
               </a:rPr>
               <a:t>Команда остаётся в очереди</a:t>
             </a:r>
-            <a:endParaRPr sz="1100" b="0" i="0">
-              <a:latin typeface="Montserrat"/>
-            </a:endParaRPr>
+            <a:endParaRPr sz="1400" b="0" i="0">
+              <a:latin typeface="Montserrat"/>
+            </a:endParaRPr>
+          </a:p>
+        </p:txBody>
+      </p:sp>
+      <p:sp>
+        <p:nvSpPr>
+          <p:cNvPr id="8" name="Rectangle 7"/>
+          <p:cNvSpPr/>
+          <p:nvPr/>
+        </p:nvSpPr>
+        <p:spPr>
+          <a:xfrm>
+            <a:off x="3108960" y="2926080"/>
+            <a:ext cx="274320" cy="91440"/>
+          </a:xfrm>
+          <a:prstGeom prst="rect">
+            <a:avLst/>
+          </a:prstGeom>
+          <a:solidFill>
+            <a:srgbClr val="1769AA"/>
+          </a:solidFill>
+          <a:ln w="10160">
+            <a:solidFill>
+              <a:srgbClr val="1769AA"/>
+            </a:solidFill>
+          </a:ln>
+        </p:spPr>
+        <p:style>
+          <a:lnRef idx="1">
+            <a:schemeClr val="accent1"/>
+          </a:lnRef>
+          <a:fillRef idx="3">
+            <a:schemeClr val="accent1"/>
+          </a:fillRef>
+          <a:effectRef idx="2">
+            <a:schemeClr val="accent1"/>
+          </a:effectRef>
+          <a:fontRef idx="minor">
+            <a:schemeClr val="lt1"/>
+          </a:fontRef>
+        </p:style>
+        <p:txBody>
+          <a:bodyPr rtlCol="0" anchor="ctr"/>
+          <a:lstStyle/>
+          <a:p>
+            <a:pPr algn="ctr"/>
           </a:p>
         </p:txBody>
       </p:sp>
@@ -7531,8 +8970,8 @@
         </p:nvSpPr>
         <p:spPr>
           <a:xfrm>
-            <a:off x="3383280" y="4370832"/>
-            <a:ext cx="2468880" cy="960120"/>
+            <a:off x="3383280" y="1874519"/>
+            <a:ext cx="2468880" cy="2194560"/>
           </a:xfrm>
           <a:prstGeom prst="roundRect">
             <a:avLst/>
@@ -7576,27 +9015,27 @@
         </p:nvSpPr>
         <p:spPr>
           <a:xfrm>
-            <a:off x="3529584" y="4526280"/>
-            <a:ext cx="329184" cy="228600"/>
-          </a:xfrm>
-          <a:prstGeom prst="rect">
-            <a:avLst/>
-          </a:prstGeom>
-          <a:noFill/>
-        </p:spPr>
-        <p:txBody>
-          <a:bodyPr wrap="square" lIns="18288" rIns="18288" tIns="18288" bIns="18288" anchor="t">
-            <a:noAutofit/>
-          </a:bodyPr>
-          <a:lstStyle/>
-          <a:p>
-            <a:pPr algn="l">
-              <a:lnSpc>
-                <a:spcPct val="105000"/>
-              </a:lnSpc>
-            </a:pPr>
-            <a:r>
-              <a:rPr sz="900" b="0" i="0">
+            <a:off x="3584448" y="2112264"/>
+            <a:ext cx="2066543" cy="329184"/>
+          </a:xfrm>
+          <a:prstGeom prst="rect">
+            <a:avLst/>
+          </a:prstGeom>
+          <a:noFill/>
+        </p:spPr>
+        <p:txBody>
+          <a:bodyPr wrap="square" lIns="18288" rIns="18288" tIns="18288" bIns="18288" anchor="t">
+            <a:noAutofit/>
+          </a:bodyPr>
+          <a:lstStyle/>
+          <a:p>
+            <a:pPr algn="ctr">
+              <a:lnSpc>
+                <a:spcPct val="105000"/>
+              </a:lnSpc>
+            </a:pPr>
+            <a:r>
+              <a:rPr sz="1600" b="0" i="0">
                 <a:solidFill>
                   <a:srgbClr val="1769AA"/>
                 </a:solidFill>
@@ -7604,7 +9043,7 @@
               </a:rPr>
               <a:t>02</a:t>
             </a:r>
-            <a:endParaRPr sz="900" b="0" i="0">
+            <a:endParaRPr sz="1600" b="0" i="0">
               <a:latin typeface="Montserrat"/>
             </a:endParaRPr>
           </a:p>
@@ -7618,50 +9057,95 @@
         </p:nvSpPr>
         <p:spPr>
           <a:xfrm>
-            <a:off x="3913632" y="4498848"/>
-            <a:ext cx="1755648" cy="438912"/>
-          </a:xfrm>
-          <a:prstGeom prst="rect">
-            <a:avLst/>
-          </a:prstGeom>
-          <a:noFill/>
-        </p:spPr>
-        <p:txBody>
-          <a:bodyPr wrap="square" lIns="18288" rIns="18288" tIns="18288" bIns="18288" anchor="t">
-            <a:noAutofit/>
-          </a:bodyPr>
-          <a:lstStyle/>
-          <a:p>
-            <a:pPr algn="l">
-              <a:lnSpc>
-                <a:spcPct val="105000"/>
-              </a:lnSpc>
-            </a:pPr>
-            <a:r>
-              <a:rPr sz="1100" b="0" i="0">
+            <a:off x="3703320" y="2743200"/>
+            <a:ext cx="1828800" cy="822960"/>
+          </a:xfrm>
+          <a:prstGeom prst="rect">
+            <a:avLst/>
+          </a:prstGeom>
+          <a:noFill/>
+        </p:spPr>
+        <p:txBody>
+          <a:bodyPr wrap="square" lIns="18288" rIns="18288" tIns="18288" bIns="18288" anchor="ctr">
+            <a:noAutofit/>
+          </a:bodyPr>
+          <a:lstStyle/>
+          <a:p>
+            <a:pPr algn="ctr">
+              <a:lnSpc>
+                <a:spcPct val="105000"/>
+              </a:lnSpc>
+            </a:pPr>
+            <a:r>
+              <a:rPr sz="1400" b="0" i="0">
                 <a:solidFill>
                   <a:srgbClr val="15243A"/>
                 </a:solidFill>
                 <a:latin typeface="Montserrat"/>
               </a:rPr>
-              <a:t>Повтор ограничен по числу попыток</a:t>
-            </a:r>
-            <a:endParaRPr sz="1100" b="0" i="0">
-              <a:latin typeface="Montserrat"/>
-            </a:endParaRPr>
-          </a:p>
-        </p:txBody>
-      </p:sp>
-      <p:sp>
-        <p:nvSpPr>
-          <p:cNvPr id="12" name="Rounded Rectangle 11"/>
+              <a:t>Обмен повторяется автоматически</a:t>
+            </a:r>
+            <a:endParaRPr sz="1400" b="0" i="0">
+              <a:latin typeface="Montserrat"/>
+            </a:endParaRPr>
+          </a:p>
+        </p:txBody>
+      </p:sp>
+      <p:sp>
+        <p:nvSpPr>
+          <p:cNvPr id="12" name="Rectangle 11"/>
           <p:cNvSpPr/>
           <p:nvPr/>
         </p:nvSpPr>
         <p:spPr>
           <a:xfrm>
-            <a:off x="6126480" y="4370832"/>
-            <a:ext cx="2468880" cy="960120"/>
+            <a:off x="5852160" y="2926080"/>
+            <a:ext cx="274320" cy="91440"/>
+          </a:xfrm>
+          <a:prstGeom prst="rect">
+            <a:avLst/>
+          </a:prstGeom>
+          <a:solidFill>
+            <a:srgbClr val="1769AA"/>
+          </a:solidFill>
+          <a:ln w="10160">
+            <a:solidFill>
+              <a:srgbClr val="1769AA"/>
+            </a:solidFill>
+          </a:ln>
+        </p:spPr>
+        <p:style>
+          <a:lnRef idx="1">
+            <a:schemeClr val="accent1"/>
+          </a:lnRef>
+          <a:fillRef idx="3">
+            <a:schemeClr val="accent1"/>
+          </a:fillRef>
+          <a:effectRef idx="2">
+            <a:schemeClr val="accent1"/>
+          </a:effectRef>
+          <a:fontRef idx="minor">
+            <a:schemeClr val="lt1"/>
+          </a:fontRef>
+        </p:style>
+        <p:txBody>
+          <a:bodyPr rtlCol="0" anchor="ctr"/>
+          <a:lstStyle/>
+          <a:p>
+            <a:pPr algn="ctr"/>
+          </a:p>
+        </p:txBody>
+      </p:sp>
+      <p:sp>
+        <p:nvSpPr>
+          <p:cNvPr id="13" name="Rounded Rectangle 12"/>
+          <p:cNvSpPr/>
+          <p:nvPr/>
+        </p:nvSpPr>
+        <p:spPr>
+          <a:xfrm>
+            <a:off x="6126480" y="1874519"/>
+            <a:ext cx="2468880" cy="2194560"/>
           </a:xfrm>
           <a:prstGeom prst="roundRect">
             <a:avLst/>
@@ -7699,33 +9183,33 @@
       </p:sp>
       <p:sp>
         <p:nvSpPr>
-          <p:cNvPr id="13" name="TextBox 12"/>
-          <p:cNvSpPr txBox="1"/>
-          <p:nvPr/>
-        </p:nvSpPr>
-        <p:spPr>
-          <a:xfrm>
-            <a:off x="6272784" y="4526280"/>
-            <a:ext cx="329184" cy="228600"/>
-          </a:xfrm>
-          <a:prstGeom prst="rect">
-            <a:avLst/>
-          </a:prstGeom>
-          <a:noFill/>
-        </p:spPr>
-        <p:txBody>
-          <a:bodyPr wrap="square" lIns="18288" rIns="18288" tIns="18288" bIns="18288" anchor="t">
-            <a:noAutofit/>
-          </a:bodyPr>
-          <a:lstStyle/>
-          <a:p>
-            <a:pPr algn="l">
-              <a:lnSpc>
-                <a:spcPct val="105000"/>
-              </a:lnSpc>
-            </a:pPr>
-            <a:r>
-              <a:rPr sz="900" b="0" i="0">
+          <p:cNvPr id="14" name="TextBox 13"/>
+          <p:cNvSpPr txBox="1"/>
+          <p:nvPr/>
+        </p:nvSpPr>
+        <p:spPr>
+          <a:xfrm>
+            <a:off x="6327648" y="2112264"/>
+            <a:ext cx="2066543" cy="329184"/>
+          </a:xfrm>
+          <a:prstGeom prst="rect">
+            <a:avLst/>
+          </a:prstGeom>
+          <a:noFill/>
+        </p:spPr>
+        <p:txBody>
+          <a:bodyPr wrap="square" lIns="18288" rIns="18288" tIns="18288" bIns="18288" anchor="t">
+            <a:noAutofit/>
+          </a:bodyPr>
+          <a:lstStyle/>
+          <a:p>
+            <a:pPr algn="ctr">
+              <a:lnSpc>
+                <a:spcPct val="105000"/>
+              </a:lnSpc>
+            </a:pPr>
+            <a:r>
+              <a:rPr sz="1600" b="0" i="0">
                 <a:solidFill>
                   <a:srgbClr val="1769AA"/>
                 </a:solidFill>
@@ -7733,41 +9217,41 @@
               </a:rPr>
               <a:t>03</a:t>
             </a:r>
-            <a:endParaRPr sz="900" b="0" i="0">
-              <a:latin typeface="Montserrat"/>
-            </a:endParaRPr>
-          </a:p>
-        </p:txBody>
-      </p:sp>
-      <p:sp>
-        <p:nvSpPr>
-          <p:cNvPr id="14" name="TextBox 13"/>
-          <p:cNvSpPr txBox="1"/>
-          <p:nvPr/>
-        </p:nvSpPr>
-        <p:spPr>
-          <a:xfrm>
-            <a:off x="6656832" y="4498848"/>
-            <a:ext cx="1755648" cy="438912"/>
-          </a:xfrm>
-          <a:prstGeom prst="rect">
-            <a:avLst/>
-          </a:prstGeom>
-          <a:noFill/>
-        </p:spPr>
-        <p:txBody>
-          <a:bodyPr wrap="square" lIns="18288" rIns="18288" tIns="18288" bIns="18288" anchor="t">
-            <a:noAutofit/>
-          </a:bodyPr>
-          <a:lstStyle/>
-          <a:p>
-            <a:pPr algn="l">
-              <a:lnSpc>
-                <a:spcPct val="105000"/>
-              </a:lnSpc>
-            </a:pPr>
-            <a:r>
-              <a:rPr sz="1100" b="0" i="0">
+            <a:endParaRPr sz="1600" b="0" i="0">
+              <a:latin typeface="Montserrat"/>
+            </a:endParaRPr>
+          </a:p>
+        </p:txBody>
+      </p:sp>
+      <p:sp>
+        <p:nvSpPr>
+          <p:cNvPr id="15" name="TextBox 14"/>
+          <p:cNvSpPr txBox="1"/>
+          <p:nvPr/>
+        </p:nvSpPr>
+        <p:spPr>
+          <a:xfrm>
+            <a:off x="6446520" y="2743200"/>
+            <a:ext cx="1828800" cy="822960"/>
+          </a:xfrm>
+          <a:prstGeom prst="rect">
+            <a:avLst/>
+          </a:prstGeom>
+          <a:noFill/>
+        </p:spPr>
+        <p:txBody>
+          <a:bodyPr wrap="square" lIns="18288" rIns="18288" tIns="18288" bIns="18288" anchor="ctr">
+            <a:noAutofit/>
+          </a:bodyPr>
+          <a:lstStyle/>
+          <a:p>
+            <a:pPr algn="ctr">
+              <a:lnSpc>
+                <a:spcPct val="105000"/>
+              </a:lnSpc>
+            </a:pPr>
+            <a:r>
+              <a:rPr sz="1400" b="0" i="0">
                 <a:solidFill>
                   <a:srgbClr val="15243A"/>
                 </a:solidFill>
@@ -7775,22 +9259,67 @@
               </a:rPr>
               <a:t>Связь проверяется перед записью</a:t>
             </a:r>
-            <a:endParaRPr sz="1100" b="0" i="0">
-              <a:latin typeface="Montserrat"/>
-            </a:endParaRPr>
-          </a:p>
-        </p:txBody>
-      </p:sp>
-      <p:sp>
-        <p:nvSpPr>
-          <p:cNvPr id="15" name="Rounded Rectangle 14"/>
+            <a:endParaRPr sz="1400" b="0" i="0">
+              <a:latin typeface="Montserrat"/>
+            </a:endParaRPr>
+          </a:p>
+        </p:txBody>
+      </p:sp>
+      <p:sp>
+        <p:nvSpPr>
+          <p:cNvPr id="16" name="Rectangle 15"/>
           <p:cNvSpPr/>
           <p:nvPr/>
         </p:nvSpPr>
         <p:spPr>
           <a:xfrm>
-            <a:off x="8869680" y="4370832"/>
-            <a:ext cx="2468880" cy="960120"/>
+            <a:off x="8595360" y="2926080"/>
+            <a:ext cx="274320" cy="91440"/>
+          </a:xfrm>
+          <a:prstGeom prst="rect">
+            <a:avLst/>
+          </a:prstGeom>
+          <a:solidFill>
+            <a:srgbClr val="1769AA"/>
+          </a:solidFill>
+          <a:ln w="10160">
+            <a:solidFill>
+              <a:srgbClr val="1769AA"/>
+            </a:solidFill>
+          </a:ln>
+        </p:spPr>
+        <p:style>
+          <a:lnRef idx="1">
+            <a:schemeClr val="accent1"/>
+          </a:lnRef>
+          <a:fillRef idx="3">
+            <a:schemeClr val="accent1"/>
+          </a:fillRef>
+          <a:effectRef idx="2">
+            <a:schemeClr val="accent1"/>
+          </a:effectRef>
+          <a:fontRef idx="minor">
+            <a:schemeClr val="lt1"/>
+          </a:fontRef>
+        </p:style>
+        <p:txBody>
+          <a:bodyPr rtlCol="0" anchor="ctr"/>
+          <a:lstStyle/>
+          <a:p>
+            <a:pPr algn="ctr"/>
+          </a:p>
+        </p:txBody>
+      </p:sp>
+      <p:sp>
+        <p:nvSpPr>
+          <p:cNvPr id="17" name="Rounded Rectangle 16"/>
+          <p:cNvSpPr/>
+          <p:nvPr/>
+        </p:nvSpPr>
+        <p:spPr>
+          <a:xfrm>
+            <a:off x="8869680" y="1874519"/>
+            <a:ext cx="2468880" cy="2194560"/>
           </a:xfrm>
           <a:prstGeom prst="roundRect">
             <a:avLst/>
@@ -7828,33 +9357,33 @@
       </p:sp>
       <p:sp>
         <p:nvSpPr>
-          <p:cNvPr id="16" name="TextBox 15"/>
-          <p:cNvSpPr txBox="1"/>
-          <p:nvPr/>
-        </p:nvSpPr>
-        <p:spPr>
-          <a:xfrm>
-            <a:off x="9015984" y="4526280"/>
-            <a:ext cx="329184" cy="228600"/>
-          </a:xfrm>
-          <a:prstGeom prst="rect">
-            <a:avLst/>
-          </a:prstGeom>
-          <a:noFill/>
-        </p:spPr>
-        <p:txBody>
-          <a:bodyPr wrap="square" lIns="18288" rIns="18288" tIns="18288" bIns="18288" anchor="t">
-            <a:noAutofit/>
-          </a:bodyPr>
-          <a:lstStyle/>
-          <a:p>
-            <a:pPr algn="l">
-              <a:lnSpc>
-                <a:spcPct val="105000"/>
-              </a:lnSpc>
-            </a:pPr>
-            <a:r>
-              <a:rPr sz="900" b="0" i="0">
+          <p:cNvPr id="18" name="TextBox 17"/>
+          <p:cNvSpPr txBox="1"/>
+          <p:nvPr/>
+        </p:nvSpPr>
+        <p:spPr>
+          <a:xfrm>
+            <a:off x="9070848" y="2112264"/>
+            <a:ext cx="2066543" cy="329184"/>
+          </a:xfrm>
+          <a:prstGeom prst="rect">
+            <a:avLst/>
+          </a:prstGeom>
+          <a:noFill/>
+        </p:spPr>
+        <p:txBody>
+          <a:bodyPr wrap="square" lIns="18288" rIns="18288" tIns="18288" bIns="18288" anchor="t">
+            <a:noAutofit/>
+          </a:bodyPr>
+          <a:lstStyle/>
+          <a:p>
+            <a:pPr algn="ctr">
+              <a:lnSpc>
+                <a:spcPct val="105000"/>
+              </a:lnSpc>
+            </a:pPr>
+            <a:r>
+              <a:rPr sz="1600" b="0" i="0">
                 <a:solidFill>
                   <a:srgbClr val="1769AA"/>
                 </a:solidFill>
@@ -7862,41 +9391,41 @@
               </a:rPr>
               <a:t>04</a:t>
             </a:r>
-            <a:endParaRPr sz="900" b="0" i="0">
-              <a:latin typeface="Montserrat"/>
-            </a:endParaRPr>
-          </a:p>
-        </p:txBody>
-      </p:sp>
-      <p:sp>
-        <p:nvSpPr>
-          <p:cNvPr id="17" name="TextBox 16"/>
-          <p:cNvSpPr txBox="1"/>
-          <p:nvPr/>
-        </p:nvSpPr>
-        <p:spPr>
-          <a:xfrm>
-            <a:off x="9400032" y="4498848"/>
-            <a:ext cx="1755648" cy="438912"/>
-          </a:xfrm>
-          <a:prstGeom prst="rect">
-            <a:avLst/>
-          </a:prstGeom>
-          <a:noFill/>
-        </p:spPr>
-        <p:txBody>
-          <a:bodyPr wrap="square" lIns="18288" rIns="18288" tIns="18288" bIns="18288" anchor="t">
-            <a:noAutofit/>
-          </a:bodyPr>
-          <a:lstStyle/>
-          <a:p>
-            <a:pPr algn="l">
-              <a:lnSpc>
-                <a:spcPct val="105000"/>
-              </a:lnSpc>
-            </a:pPr>
-            <a:r>
-              <a:rPr sz="1100" b="0" i="0">
+            <a:endParaRPr sz="1600" b="0" i="0">
+              <a:latin typeface="Montserrat"/>
+            </a:endParaRPr>
+          </a:p>
+        </p:txBody>
+      </p:sp>
+      <p:sp>
+        <p:nvSpPr>
+          <p:cNvPr id="19" name="TextBox 18"/>
+          <p:cNvSpPr txBox="1"/>
+          <p:nvPr/>
+        </p:nvSpPr>
+        <p:spPr>
+          <a:xfrm>
+            <a:off x="9189719" y="2743200"/>
+            <a:ext cx="1828800" cy="822960"/>
+          </a:xfrm>
+          <a:prstGeom prst="rect">
+            <a:avLst/>
+          </a:prstGeom>
+          <a:noFill/>
+        </p:spPr>
+        <p:txBody>
+          <a:bodyPr wrap="square" lIns="18288" rIns="18288" tIns="18288" bIns="18288" anchor="ctr">
+            <a:noAutofit/>
+          </a:bodyPr>
+          <a:lstStyle/>
+          <a:p>
+            <a:pPr algn="ctr">
+              <a:lnSpc>
+                <a:spcPct val="105000"/>
+              </a:lnSpc>
+            </a:pPr>
+            <a:r>
+              <a:rPr sz="1400" b="0" i="0">
                 <a:solidFill>
                   <a:srgbClr val="15243A"/>
                 </a:solidFill>
@@ -7904,57 +9433,102 @@
               </a:rPr>
               <a:t>Обновляется существующий заказ</a:t>
             </a:r>
-            <a:endParaRPr sz="1100" b="0" i="0">
-              <a:latin typeface="Montserrat"/>
-            </a:endParaRPr>
-          </a:p>
-        </p:txBody>
-      </p:sp>
-      <p:sp>
-        <p:nvSpPr>
-          <p:cNvPr id="18" name="TextBox 17"/>
-          <p:cNvSpPr txBox="1"/>
-          <p:nvPr/>
-        </p:nvSpPr>
-        <p:spPr>
-          <a:xfrm>
-            <a:off x="640080" y="5797296"/>
-            <a:ext cx="9601200" cy="310896"/>
-          </a:xfrm>
-          <a:prstGeom prst="rect">
-            <a:avLst/>
-          </a:prstGeom>
-          <a:noFill/>
-        </p:spPr>
-        <p:txBody>
-          <a:bodyPr wrap="square" lIns="18288" rIns="18288" tIns="18288" bIns="18288" anchor="t">
-            <a:noAutofit/>
-          </a:bodyPr>
-          <a:lstStyle/>
-          <a:p>
-            <a:pPr algn="l">
-              <a:lnSpc>
-                <a:spcPct val="105000"/>
-              </a:lnSpc>
-            </a:pPr>
-            <a:r>
-              <a:rPr sz="1000" b="0" i="0">
-                <a:solidFill>
-                  <a:srgbClr val="667085"/>
-                </a:solidFill>
-                <a:latin typeface="Montserrat"/>
-              </a:rPr>
-              <a:t>Журнал обмена не содержит адрес подключения, пароль 1С или персональные данные.</a:t>
-            </a:r>
-            <a:endParaRPr sz="1000" b="0" i="0">
-              <a:latin typeface="Montserrat"/>
-            </a:endParaRPr>
-          </a:p>
-        </p:txBody>
-      </p:sp>
-      <p:sp>
-        <p:nvSpPr>
-          <p:cNvPr id="19" name="TextBox 18"/>
+            <a:endParaRPr sz="1400" b="0" i="0">
+              <a:latin typeface="Montserrat"/>
+            </a:endParaRPr>
+          </a:p>
+        </p:txBody>
+      </p:sp>
+      <p:sp>
+        <p:nvSpPr>
+          <p:cNvPr id="20" name="Rounded Rectangle 19"/>
+          <p:cNvSpPr/>
+          <p:nvPr/>
+        </p:nvSpPr>
+        <p:spPr>
+          <a:xfrm>
+            <a:off x="1143000" y="4828032"/>
+            <a:ext cx="9921240" cy="713232"/>
+          </a:xfrm>
+          <a:prstGeom prst="roundRect">
+            <a:avLst/>
+          </a:prstGeom>
+          <a:solidFill>
+            <a:srgbClr val="E7F6F5"/>
+          </a:solidFill>
+          <a:ln w="10160">
+            <a:solidFill>
+              <a:srgbClr val="C4E8E5"/>
+            </a:solidFill>
+          </a:ln>
+        </p:spPr>
+        <p:style>
+          <a:lnRef idx="1">
+            <a:schemeClr val="accent1"/>
+          </a:lnRef>
+          <a:fillRef idx="3">
+            <a:schemeClr val="accent1"/>
+          </a:fillRef>
+          <a:effectRef idx="2">
+            <a:schemeClr val="accent1"/>
+          </a:effectRef>
+          <a:fontRef idx="minor">
+            <a:schemeClr val="lt1"/>
+          </a:fontRef>
+        </p:style>
+        <p:txBody>
+          <a:bodyPr rtlCol="0" anchor="ctr"/>
+          <a:lstStyle/>
+          <a:p>
+            <a:pPr algn="ctr"/>
+          </a:p>
+        </p:txBody>
+      </p:sp>
+      <p:sp>
+        <p:nvSpPr>
+          <p:cNvPr id="21" name="TextBox 20"/>
+          <p:cNvSpPr txBox="1"/>
+          <p:nvPr/>
+        </p:nvSpPr>
+        <p:spPr>
+          <a:xfrm>
+            <a:off x="1417320" y="5047488"/>
+            <a:ext cx="9372600" cy="274320"/>
+          </a:xfrm>
+          <a:prstGeom prst="rect">
+            <a:avLst/>
+          </a:prstGeom>
+          <a:noFill/>
+        </p:spPr>
+        <p:txBody>
+          <a:bodyPr wrap="square" lIns="18288" rIns="18288" tIns="18288" bIns="18288" anchor="t">
+            <a:noAutofit/>
+          </a:bodyPr>
+          <a:lstStyle/>
+          <a:p>
+            <a:pPr algn="ctr">
+              <a:lnSpc>
+                <a:spcPct val="105000"/>
+              </a:lnSpc>
+            </a:pPr>
+            <a:r>
+              <a:rPr sz="1200" b="0" i="0">
+                <a:solidFill>
+                  <a:srgbClr val="008C8C"/>
+                </a:solidFill>
+                <a:latin typeface="Montserrat"/>
+              </a:rPr>
+              <a:t>Временный сбой не останавливает процесс и не создаёт второй заказ</a:t>
+            </a:r>
+            <a:endParaRPr sz="1200" b="0" i="0">
+              <a:latin typeface="Montserrat"/>
+            </a:endParaRPr>
+          </a:p>
+        </p:txBody>
+      </p:sp>
+      <p:sp>
+        <p:nvSpPr>
+          <p:cNvPr id="22" name="TextBox 21"/>
           <p:cNvSpPr txBox="1"/>
           <p:nvPr/>
         </p:nvSpPr>
@@ -8054,7 +9628,7 @@
                 </a:solidFill>
                 <a:latin typeface="Montserrat"/>
               </a:rPr>
-              <a:t>ПРОВЕРКА</a:t>
+              <a:t>РЕАЛИЗОВАНО</a:t>
             </a:r>
             <a:endParaRPr sz="1100" b="0" i="0">
               <a:latin typeface="Montserrat"/>
@@ -8096,7 +9670,7 @@
                 </a:solidFill>
                 <a:latin typeface="Montserrat"/>
               </a:rPr>
-              <a:t>Что проверено на тестовой копии</a:t>
+              <a:t>Что работает в ежедневном процессе</a:t>
             </a:r>
             <a:endParaRPr sz="2600" b="0" i="0">
               <a:latin typeface="Montserrat"/>
@@ -8225,7 +9799,7 @@
                 </a:solidFill>
                 <a:latin typeface="Montserrat"/>
               </a:rPr>
-              <a:t>ПРОВЕРЕНО</a:t>
+              <a:t>РАБОТАЕТ</a:t>
             </a:r>
             <a:endParaRPr sz="900" b="0" i="0">
               <a:latin typeface="Montserrat"/>
@@ -8267,7 +9841,7 @@
                 </a:solidFill>
                 <a:latin typeface="Montserrat"/>
               </a:rPr>
-              <a:t>Заказ создан из сделки</a:t>
+              <a:t>Заказ создаётся из сделки</a:t>
             </a:r>
             <a:endParaRPr sz="1300" b="0" i="0">
               <a:latin typeface="Montserrat"/>
@@ -8309,7 +9883,7 @@
                 </a:solidFill>
                 <a:latin typeface="Montserrat"/>
               </a:rPr>
-              <a:t>Проверка пройдена</a:t>
+              <a:t>Автоматически</a:t>
             </a:r>
             <a:endParaRPr sz="900" b="0" i="0">
               <a:latin typeface="Montserrat"/>
@@ -8396,7 +9970,7 @@
                 </a:solidFill>
                 <a:latin typeface="Montserrat"/>
               </a:rPr>
-              <a:t>ПРОВЕРЕНО</a:t>
+              <a:t>РАБОТАЕТ</a:t>
             </a:r>
             <a:endParaRPr sz="900" b="0" i="0">
               <a:latin typeface="Montserrat"/>
@@ -8438,7 +10012,7 @@
                 </a:solidFill>
                 <a:latin typeface="Montserrat"/>
               </a:rPr>
-              <a:t>Обновлён тот же заказ</a:t>
+              <a:t>Повтор обновляет заказ</a:t>
             </a:r>
             <a:endParaRPr sz="1300" b="0" i="0">
               <a:latin typeface="Montserrat"/>
@@ -8480,7 +10054,7 @@
                 </a:solidFill>
                 <a:latin typeface="Montserrat"/>
               </a:rPr>
-              <a:t>Дубль не создан</a:t>
+              <a:t>Без дубля</a:t>
             </a:r>
             <a:endParaRPr sz="900" b="0" i="0">
               <a:latin typeface="Montserrat"/>
@@ -8567,7 +10141,7 @@
                 </a:solidFill>
                 <a:latin typeface="Montserrat"/>
               </a:rPr>
-              <a:t>ПРОВЕРЕНО</a:t>
+              <a:t>РАБОТАЕТ</a:t>
             </a:r>
             <a:endParaRPr sz="900" b="0" i="0">
               <a:latin typeface="Montserrat"/>
@@ -8609,7 +10183,7 @@
                 </a:solidFill>
                 <a:latin typeface="Montserrat"/>
               </a:rPr>
-              <a:t>Статус вернулся в Bitrix24</a:t>
+              <a:t>Результат возвращается</a:t>
             </a:r>
             <a:endParaRPr sz="1300" b="0" i="0">
               <a:latin typeface="Montserrat"/>
@@ -8651,7 +10225,7 @@
                 </a:solidFill>
                 <a:latin typeface="Montserrat"/>
               </a:rPr>
-              <a:t>Проверка пройдена</a:t>
+              <a:t>В исходную сделку</a:t>
             </a:r>
             <a:endParaRPr sz="900" b="0" i="0">
               <a:latin typeface="Montserrat"/>
@@ -8738,7 +10312,7 @@
                 </a:solidFill>
                 <a:latin typeface="Montserrat"/>
               </a:rPr>
-              <a:t>ПРОВЕРЕНО</a:t>
+              <a:t>РАБОТАЕТ</a:t>
             </a:r>
             <a:endParaRPr sz="900" b="0" i="0">
               <a:latin typeface="Montserrat"/>
@@ -8780,7 +10354,7 @@
                 </a:solidFill>
                 <a:latin typeface="Montserrat"/>
               </a:rPr>
-              <a:t>Повтор после ошибки</a:t>
+              <a:t>Сбой обрабатывается</a:t>
             </a:r>
             <a:endParaRPr sz="1300" b="0" i="0">
               <a:latin typeface="Montserrat"/>
@@ -8822,7 +10396,7 @@
                 </a:solidFill>
                 <a:latin typeface="Montserrat"/>
               </a:rPr>
-              <a:t>Дубль не создан</a:t>
+              <a:t>С автоматическим повтором</a:t>
             </a:r>
             <a:endParaRPr sz="900" b="0" i="0">
               <a:latin typeface="Montserrat"/>
@@ -8909,7 +10483,7 @@
                 </a:solidFill>
                 <a:latin typeface="Montserrat"/>
               </a:rPr>
-              <a:t>ПРОВЕРЕНО</a:t>
+              <a:t>РАБОТАЕТ</a:t>
             </a:r>
             <a:endParaRPr sz="900" b="0" i="0">
               <a:latin typeface="Montserrat"/>
@@ -8951,7 +10525,7 @@
                 </a:solidFill>
                 <a:latin typeface="Montserrat"/>
               </a:rPr>
-              <a:t>Связь с системами работает</a:t>
+              <a:t>Системы связаны</a:t>
             </a:r>
             <a:endParaRPr sz="1300" b="0" i="0">
               <a:latin typeface="Montserrat"/>
@@ -8993,7 +10567,7 @@
                 </a:solidFill>
                 <a:latin typeface="Montserrat"/>
               </a:rPr>
-              <a:t>Работает штатно</a:t>
+              <a:t>Одна сделка — один заказ</a:t>
             </a:r>
             <a:endParaRPr sz="900" b="0" i="0">
               <a:latin typeface="Montserrat"/>
@@ -9080,7 +10654,7 @@
                 </a:solidFill>
                 <a:latin typeface="Montserrat"/>
               </a:rPr>
-              <a:t>ПРОВЕРЕНО</a:t>
+              <a:t>РАБОТАЕТ</a:t>
             </a:r>
             <a:endParaRPr sz="900" b="0" i="0">
               <a:latin typeface="Montserrat"/>
@@ -9122,7 +10696,7 @@
                 </a:solidFill>
                 <a:latin typeface="Montserrat"/>
               </a:rPr>
-              <a:t>Плановый обмен выполнен</a:t>
+              <a:t>Обмен идёт по расписанию</a:t>
             </a:r>
             <a:endParaRPr sz="1300" b="0" i="0">
               <a:latin typeface="Montserrat"/>
@@ -9164,7 +10738,7 @@
                 </a:solidFill>
                 <a:latin typeface="Montserrat"/>
               </a:rPr>
-              <a:t>Без ошибок</a:t>
+              <a:t>Без ручного запуска</a:t>
             </a:r>
             <a:endParaRPr sz="900" b="0" i="0">
               <a:latin typeface="Montserrat"/>
@@ -9251,7 +10825,7 @@
                 </a:solidFill>
                 <a:latin typeface="Montserrat"/>
               </a:rPr>
-              <a:t>Обмен между системами проверен. Перед рабочим запуском решение отдельно проверяется на платформе клиента.</a:t>
+              <a:t>Менеджер видит исполнение заказа в Bitrix24, производство продолжает работать в 1С</a:t>
             </a:r>
             <a:endParaRPr sz="1000" b="0" i="0">
               <a:latin typeface="Montserrat"/>

</xml_diff>

<commit_message>
Move quantified results to the start of PTZ case
</commit_message>
<xml_diff>
--- a/downloads/ptz-steklo-weboptimize-case.pptx
+++ b/downloads/ptz-steklo-weboptimize-case.pptx
@@ -3936,7 +3936,7 @@
                 </a:solidFill>
                 <a:latin typeface="Montserrat"/>
               </a:rPr>
-              <a:t>КОНТЕКСТ</a:t>
+              <a:t>РЕЗУЛЬТАТ СРАЗУ</a:t>
             </a:r>
             <a:endParaRPr sz="1100" b="0" i="0">
               <a:latin typeface="Montserrat"/>
@@ -3978,7 +3978,7 @@
                 </a:solidFill>
                 <a:latin typeface="Montserrat"/>
               </a:rPr>
-              <a:t>Индивидуальный заказ проходит длинный путь</a:t>
+              <a:t>Полученная экономия и рост производительности</a:t>
             </a:r>
             <a:endParaRPr sz="2600" b="0" i="0">
               <a:latin typeface="Montserrat"/>
@@ -4036,8 +4036,524 @@
         </p:nvSpPr>
         <p:spPr>
           <a:xfrm>
-            <a:off x="640080" y="1600200"/>
-            <a:ext cx="2011680" cy="1325880"/>
+            <a:off x="640080" y="1572768"/>
+            <a:ext cx="5376672" cy="1417320"/>
+          </a:xfrm>
+          <a:prstGeom prst="roundRect">
+            <a:avLst/>
+          </a:prstGeom>
+          <a:solidFill>
+            <a:srgbClr val="F3F6F8"/>
+          </a:solidFill>
+          <a:ln w="10160">
+            <a:solidFill>
+              <a:srgbClr val="D7E0E7"/>
+            </a:solidFill>
+          </a:ln>
+        </p:spPr>
+        <p:style>
+          <a:lnRef idx="1">
+            <a:schemeClr val="accent1"/>
+          </a:lnRef>
+          <a:fillRef idx="3">
+            <a:schemeClr val="accent1"/>
+          </a:fillRef>
+          <a:effectRef idx="2">
+            <a:schemeClr val="accent1"/>
+          </a:effectRef>
+          <a:fontRef idx="minor">
+            <a:schemeClr val="lt1"/>
+          </a:fontRef>
+        </p:style>
+        <p:txBody>
+          <a:bodyPr rtlCol="0" anchor="ctr"/>
+          <a:lstStyle/>
+          <a:p>
+            <a:pPr algn="ctr"/>
+          </a:p>
+        </p:txBody>
+      </p:sp>
+      <p:sp>
+        <p:nvSpPr>
+          <p:cNvPr id="6" name="TextBox 5"/>
+          <p:cNvSpPr txBox="1"/>
+          <p:nvPr/>
+        </p:nvSpPr>
+        <p:spPr>
+          <a:xfrm>
+            <a:off x="877824" y="1783080"/>
+            <a:ext cx="4846320" cy="438912"/>
+          </a:xfrm>
+          <a:prstGeom prst="rect">
+            <a:avLst/>
+          </a:prstGeom>
+          <a:noFill/>
+        </p:spPr>
+        <p:txBody>
+          <a:bodyPr wrap="square" lIns="18288" rIns="18288" tIns="18288" bIns="18288" anchor="t">
+            <a:noAutofit/>
+          </a:bodyPr>
+          <a:lstStyle/>
+          <a:p>
+            <a:pPr algn="l">
+              <a:lnSpc>
+                <a:spcPct val="105000"/>
+              </a:lnSpc>
+            </a:pPr>
+            <a:r>
+              <a:rPr sz="2400" b="0" i="0">
+                <a:solidFill>
+                  <a:srgbClr val="008C8C"/>
+                </a:solidFill>
+                <a:latin typeface="Montserrat"/>
+              </a:rPr>
+              <a:t>15–25 / 2–3 мин</a:t>
+            </a:r>
+            <a:endParaRPr sz="2400" b="0" i="0">
+              <a:latin typeface="Montserrat"/>
+            </a:endParaRPr>
+          </a:p>
+        </p:txBody>
+      </p:sp>
+      <p:sp>
+        <p:nvSpPr>
+          <p:cNvPr id="7" name="TextBox 6"/>
+          <p:cNvSpPr txBox="1"/>
+          <p:nvPr/>
+        </p:nvSpPr>
+        <p:spPr>
+          <a:xfrm>
+            <a:off x="877824" y="2368296"/>
+            <a:ext cx="4846320" cy="292608"/>
+          </a:xfrm>
+          <a:prstGeom prst="rect">
+            <a:avLst/>
+          </a:prstGeom>
+          <a:noFill/>
+        </p:spPr>
+        <p:txBody>
+          <a:bodyPr wrap="square" lIns="18288" rIns="18288" tIns="18288" bIns="18288" anchor="t">
+            <a:noAutofit/>
+          </a:bodyPr>
+          <a:lstStyle/>
+          <a:p>
+            <a:pPr algn="l">
+              <a:lnSpc>
+                <a:spcPct val="105000"/>
+              </a:lnSpc>
+            </a:pPr>
+            <a:r>
+              <a:rPr sz="1100" b="0" i="0">
+                <a:solidFill>
+                  <a:srgbClr val="667085"/>
+                </a:solidFill>
+                <a:latin typeface="Montserrat"/>
+              </a:rPr>
+              <a:t>до / после • передача заказа и сверка статуса</a:t>
+            </a:r>
+            <a:endParaRPr sz="1100" b="0" i="0">
+              <a:latin typeface="Montserrat"/>
+            </a:endParaRPr>
+          </a:p>
+        </p:txBody>
+      </p:sp>
+      <p:sp>
+        <p:nvSpPr>
+          <p:cNvPr id="8" name="Rounded Rectangle 7"/>
+          <p:cNvSpPr/>
+          <p:nvPr/>
+        </p:nvSpPr>
+        <p:spPr>
+          <a:xfrm>
+            <a:off x="6172200" y="1572768"/>
+            <a:ext cx="5376672" cy="1417320"/>
+          </a:xfrm>
+          <a:prstGeom prst="roundRect">
+            <a:avLst/>
+          </a:prstGeom>
+          <a:solidFill>
+            <a:srgbClr val="F3F6F8"/>
+          </a:solidFill>
+          <a:ln w="10160">
+            <a:solidFill>
+              <a:srgbClr val="D7E0E7"/>
+            </a:solidFill>
+          </a:ln>
+        </p:spPr>
+        <p:style>
+          <a:lnRef idx="1">
+            <a:schemeClr val="accent1"/>
+          </a:lnRef>
+          <a:fillRef idx="3">
+            <a:schemeClr val="accent1"/>
+          </a:fillRef>
+          <a:effectRef idx="2">
+            <a:schemeClr val="accent1"/>
+          </a:effectRef>
+          <a:fontRef idx="minor">
+            <a:schemeClr val="lt1"/>
+          </a:fontRef>
+        </p:style>
+        <p:txBody>
+          <a:bodyPr rtlCol="0" anchor="ctr"/>
+          <a:lstStyle/>
+          <a:p>
+            <a:pPr algn="ctr"/>
+          </a:p>
+        </p:txBody>
+      </p:sp>
+      <p:sp>
+        <p:nvSpPr>
+          <p:cNvPr id="9" name="TextBox 8"/>
+          <p:cNvSpPr txBox="1"/>
+          <p:nvPr/>
+        </p:nvSpPr>
+        <p:spPr>
+          <a:xfrm>
+            <a:off x="6409944" y="1783080"/>
+            <a:ext cx="4846320" cy="438912"/>
+          </a:xfrm>
+          <a:prstGeom prst="rect">
+            <a:avLst/>
+          </a:prstGeom>
+          <a:noFill/>
+        </p:spPr>
+        <p:txBody>
+          <a:bodyPr wrap="square" lIns="18288" rIns="18288" tIns="18288" bIns="18288" anchor="t">
+            <a:noAutofit/>
+          </a:bodyPr>
+          <a:lstStyle/>
+          <a:p>
+            <a:pPr algn="l">
+              <a:lnSpc>
+                <a:spcPct val="105000"/>
+              </a:lnSpc>
+            </a:pPr>
+            <a:r>
+              <a:rPr sz="2400" b="0" i="0">
+                <a:solidFill>
+                  <a:srgbClr val="1769AA"/>
+                </a:solidFill>
+                <a:latin typeface="Montserrat"/>
+              </a:rPr>
+              <a:t>−80–90%</a:t>
+            </a:r>
+            <a:endParaRPr sz="2400" b="0" i="0">
+              <a:latin typeface="Montserrat"/>
+            </a:endParaRPr>
+          </a:p>
+        </p:txBody>
+      </p:sp>
+      <p:sp>
+        <p:nvSpPr>
+          <p:cNvPr id="10" name="TextBox 9"/>
+          <p:cNvSpPr txBox="1"/>
+          <p:nvPr/>
+        </p:nvSpPr>
+        <p:spPr>
+          <a:xfrm>
+            <a:off x="6409944" y="2368296"/>
+            <a:ext cx="4846320" cy="292608"/>
+          </a:xfrm>
+          <a:prstGeom prst="rect">
+            <a:avLst/>
+          </a:prstGeom>
+          <a:noFill/>
+        </p:spPr>
+        <p:txBody>
+          <a:bodyPr wrap="square" lIns="18288" rIns="18288" tIns="18288" bIns="18288" anchor="t">
+            <a:noAutofit/>
+          </a:bodyPr>
+          <a:lstStyle/>
+          <a:p>
+            <a:pPr algn="l">
+              <a:lnSpc>
+                <a:spcPct val="105000"/>
+              </a:lnSpc>
+            </a:pPr>
+            <a:r>
+              <a:rPr sz="1100" b="0" i="0">
+                <a:solidFill>
+                  <a:srgbClr val="667085"/>
+                </a:solidFill>
+                <a:latin typeface="Montserrat"/>
+              </a:rPr>
+              <a:t>времени на одну операцию</a:t>
+            </a:r>
+            <a:endParaRPr sz="1100" b="0" i="0">
+              <a:latin typeface="Montserrat"/>
+            </a:endParaRPr>
+          </a:p>
+        </p:txBody>
+      </p:sp>
+      <p:sp>
+        <p:nvSpPr>
+          <p:cNvPr id="11" name="Rounded Rectangle 10"/>
+          <p:cNvSpPr/>
+          <p:nvPr/>
+        </p:nvSpPr>
+        <p:spPr>
+          <a:xfrm>
+            <a:off x="640080" y="3310128"/>
+            <a:ext cx="5376672" cy="1417320"/>
+          </a:xfrm>
+          <a:prstGeom prst="roundRect">
+            <a:avLst/>
+          </a:prstGeom>
+          <a:solidFill>
+            <a:srgbClr val="F3F6F8"/>
+          </a:solidFill>
+          <a:ln w="10160">
+            <a:solidFill>
+              <a:srgbClr val="D7E0E7"/>
+            </a:solidFill>
+          </a:ln>
+        </p:spPr>
+        <p:style>
+          <a:lnRef idx="1">
+            <a:schemeClr val="accent1"/>
+          </a:lnRef>
+          <a:fillRef idx="3">
+            <a:schemeClr val="accent1"/>
+          </a:fillRef>
+          <a:effectRef idx="2">
+            <a:schemeClr val="accent1"/>
+          </a:effectRef>
+          <a:fontRef idx="minor">
+            <a:schemeClr val="lt1"/>
+          </a:fontRef>
+        </p:style>
+        <p:txBody>
+          <a:bodyPr rtlCol="0" anchor="ctr"/>
+          <a:lstStyle/>
+          <a:p>
+            <a:pPr algn="ctr"/>
+          </a:p>
+        </p:txBody>
+      </p:sp>
+      <p:sp>
+        <p:nvSpPr>
+          <p:cNvPr id="12" name="TextBox 11"/>
+          <p:cNvSpPr txBox="1"/>
+          <p:nvPr/>
+        </p:nvSpPr>
+        <p:spPr>
+          <a:xfrm>
+            <a:off x="877824" y="3520440"/>
+            <a:ext cx="4846320" cy="438912"/>
+          </a:xfrm>
+          <a:prstGeom prst="rect">
+            <a:avLst/>
+          </a:prstGeom>
+          <a:noFill/>
+        </p:spPr>
+        <p:txBody>
+          <a:bodyPr wrap="square" lIns="18288" rIns="18288" tIns="18288" bIns="18288" anchor="t">
+            <a:noAutofit/>
+          </a:bodyPr>
+          <a:lstStyle/>
+          <a:p>
+            <a:pPr algn="l">
+              <a:lnSpc>
+                <a:spcPct val="105000"/>
+              </a:lnSpc>
+            </a:pPr>
+            <a:r>
+              <a:rPr sz="2400" b="0" i="0">
+                <a:solidFill>
+                  <a:srgbClr val="17805E"/>
+                </a:solidFill>
+                <a:latin typeface="Montserrat"/>
+              </a:rPr>
+              <a:t>94–156 ч/мес</a:t>
+            </a:r>
+            <a:endParaRPr sz="2400" b="0" i="0">
+              <a:latin typeface="Montserrat"/>
+            </a:endParaRPr>
+          </a:p>
+        </p:txBody>
+      </p:sp>
+      <p:sp>
+        <p:nvSpPr>
+          <p:cNvPr id="13" name="TextBox 12"/>
+          <p:cNvSpPr txBox="1"/>
+          <p:nvPr/>
+        </p:nvSpPr>
+        <p:spPr>
+          <a:xfrm>
+            <a:off x="877824" y="4105656"/>
+            <a:ext cx="4846320" cy="292608"/>
+          </a:xfrm>
+          <a:prstGeom prst="rect">
+            <a:avLst/>
+          </a:prstGeom>
+          <a:noFill/>
+        </p:spPr>
+        <p:txBody>
+          <a:bodyPr wrap="square" lIns="18288" rIns="18288" tIns="18288" bIns="18288" anchor="t">
+            <a:noAutofit/>
+          </a:bodyPr>
+          <a:lstStyle/>
+          <a:p>
+            <a:pPr algn="l">
+              <a:lnSpc>
+                <a:spcPct val="105000"/>
+              </a:lnSpc>
+            </a:pPr>
+            <a:r>
+              <a:rPr sz="1100" b="0" i="0">
+                <a:solidFill>
+                  <a:srgbClr val="667085"/>
+                </a:solidFill>
+                <a:latin typeface="Montserrat"/>
+              </a:rPr>
+              <a:t>высвобождено рабочего времени</a:t>
+            </a:r>
+            <a:endParaRPr sz="1100" b="0" i="0">
+              <a:latin typeface="Montserrat"/>
+            </a:endParaRPr>
+          </a:p>
+        </p:txBody>
+      </p:sp>
+      <p:sp>
+        <p:nvSpPr>
+          <p:cNvPr id="14" name="Rounded Rectangle 13"/>
+          <p:cNvSpPr/>
+          <p:nvPr/>
+        </p:nvSpPr>
+        <p:spPr>
+          <a:xfrm>
+            <a:off x="6172200" y="3310128"/>
+            <a:ext cx="5376672" cy="1417320"/>
+          </a:xfrm>
+          <a:prstGeom prst="roundRect">
+            <a:avLst/>
+          </a:prstGeom>
+          <a:solidFill>
+            <a:srgbClr val="F3F6F8"/>
+          </a:solidFill>
+          <a:ln w="10160">
+            <a:solidFill>
+              <a:srgbClr val="D7E0E7"/>
+            </a:solidFill>
+          </a:ln>
+        </p:spPr>
+        <p:style>
+          <a:lnRef idx="1">
+            <a:schemeClr val="accent1"/>
+          </a:lnRef>
+          <a:fillRef idx="3">
+            <a:schemeClr val="accent1"/>
+          </a:fillRef>
+          <a:effectRef idx="2">
+            <a:schemeClr val="accent1"/>
+          </a:effectRef>
+          <a:fontRef idx="minor">
+            <a:schemeClr val="lt1"/>
+          </a:fontRef>
+        </p:style>
+        <p:txBody>
+          <a:bodyPr rtlCol="0" anchor="ctr"/>
+          <a:lstStyle/>
+          <a:p>
+            <a:pPr algn="ctr"/>
+          </a:p>
+        </p:txBody>
+      </p:sp>
+      <p:sp>
+        <p:nvSpPr>
+          <p:cNvPr id="15" name="TextBox 14"/>
+          <p:cNvSpPr txBox="1"/>
+          <p:nvPr/>
+        </p:nvSpPr>
+        <p:spPr>
+          <a:xfrm>
+            <a:off x="6409944" y="3520440"/>
+            <a:ext cx="4846320" cy="438912"/>
+          </a:xfrm>
+          <a:prstGeom prst="rect">
+            <a:avLst/>
+          </a:prstGeom>
+          <a:noFill/>
+        </p:spPr>
+        <p:txBody>
+          <a:bodyPr wrap="square" lIns="18288" rIns="18288" tIns="18288" bIns="18288" anchor="t">
+            <a:noAutofit/>
+          </a:bodyPr>
+          <a:lstStyle/>
+          <a:p>
+            <a:pPr algn="l">
+              <a:lnSpc>
+                <a:spcPct val="105000"/>
+              </a:lnSpc>
+            </a:pPr>
+            <a:r>
+              <a:rPr sz="2400" b="0" i="0">
+                <a:solidFill>
+                  <a:srgbClr val="D99400"/>
+                </a:solidFill>
+                <a:latin typeface="Montserrat"/>
+              </a:rPr>
+              <a:t>0,5–1 млн руб./год</a:t>
+            </a:r>
+            <a:endParaRPr sz="2400" b="0" i="0">
+              <a:latin typeface="Montserrat"/>
+            </a:endParaRPr>
+          </a:p>
+        </p:txBody>
+      </p:sp>
+      <p:sp>
+        <p:nvSpPr>
+          <p:cNvPr id="16" name="TextBox 15"/>
+          <p:cNvSpPr txBox="1"/>
+          <p:nvPr/>
+        </p:nvSpPr>
+        <p:spPr>
+          <a:xfrm>
+            <a:off x="6409944" y="4105656"/>
+            <a:ext cx="4846320" cy="292608"/>
+          </a:xfrm>
+          <a:prstGeom prst="rect">
+            <a:avLst/>
+          </a:prstGeom>
+          <a:noFill/>
+        </p:spPr>
+        <p:txBody>
+          <a:bodyPr wrap="square" lIns="18288" rIns="18288" tIns="18288" bIns="18288" anchor="t">
+            <a:noAutofit/>
+          </a:bodyPr>
+          <a:lstStyle/>
+          <a:p>
+            <a:pPr algn="l">
+              <a:lnSpc>
+                <a:spcPct val="105000"/>
+              </a:lnSpc>
+            </a:pPr>
+            <a:r>
+              <a:rPr sz="1100" b="0" i="0">
+                <a:solidFill>
+                  <a:srgbClr val="667085"/>
+                </a:solidFill>
+                <a:latin typeface="Montserrat"/>
+              </a:rPr>
+              <a:t>фактически полученная экономия</a:t>
+            </a:r>
+            <a:endParaRPr sz="1100" b="0" i="0">
+              <a:latin typeface="Montserrat"/>
+            </a:endParaRPr>
+          </a:p>
+        </p:txBody>
+      </p:sp>
+      <p:sp>
+        <p:nvSpPr>
+          <p:cNvPr id="17" name="Rounded Rectangle 16"/>
+          <p:cNvSpPr/>
+          <p:nvPr/>
+        </p:nvSpPr>
+        <p:spPr>
+          <a:xfrm>
+            <a:off x="640080" y="5056632"/>
+            <a:ext cx="10908792" cy="694944"/>
           </a:xfrm>
           <a:prstGeom prst="roundRect">
             <a:avLst/>
@@ -4075,14 +4591,14 @@
       </p:sp>
       <p:sp>
         <p:nvSpPr>
-          <p:cNvPr id="6" name="TextBox 5"/>
-          <p:cNvSpPr txBox="1"/>
-          <p:nvPr/>
-        </p:nvSpPr>
-        <p:spPr>
-          <a:xfrm>
-            <a:off x="804671" y="1801368"/>
-            <a:ext cx="1691640" cy="457200"/>
+          <p:cNvPr id="18" name="TextBox 17"/>
+          <p:cNvSpPr txBox="1"/>
+          <p:nvPr/>
+        </p:nvSpPr>
+        <p:spPr>
+          <a:xfrm>
+            <a:off x="868680" y="5276088"/>
+            <a:ext cx="10424160" cy="265176"/>
           </a:xfrm>
           <a:prstGeom prst="rect">
             <a:avLst/>
@@ -4095,36 +4611,36 @@
           </a:bodyPr>
           <a:lstStyle/>
           <a:p>
-            <a:pPr algn="l">
-              <a:lnSpc>
-                <a:spcPct val="105000"/>
-              </a:lnSpc>
-            </a:pPr>
-            <a:r>
-              <a:rPr sz="2700" b="0" i="0">
+            <a:pPr algn="ctr">
+              <a:lnSpc>
+                <a:spcPct val="105000"/>
+              </a:lnSpc>
+            </a:pPr>
+            <a:r>
+              <a:rPr sz="1100" b="0" i="0">
                 <a:solidFill>
                   <a:srgbClr val="008C8C"/>
                 </a:solidFill>
                 <a:latin typeface="Montserrat"/>
               </a:rPr>
-              <a:t>1998</a:t>
-            </a:r>
-            <a:endParaRPr sz="2700" b="0" i="0">
-              <a:latin typeface="Montserrat"/>
-            </a:endParaRPr>
-          </a:p>
-        </p:txBody>
-      </p:sp>
-      <p:sp>
-        <p:nvSpPr>
-          <p:cNvPr id="7" name="TextBox 6"/>
-          <p:cNvSpPr txBox="1"/>
-          <p:nvPr/>
-        </p:nvSpPr>
-        <p:spPr>
-          <a:xfrm>
-            <a:off x="804671" y="2350008"/>
-            <a:ext cx="1691640" cy="320040"/>
+              <a:t>Новый сотрудник не потребовался • запас производительности 0,6–1 ставки • окупаемость 3–5 месяцев</a:t>
+            </a:r>
+            <a:endParaRPr sz="1100" b="0" i="0">
+              <a:latin typeface="Montserrat"/>
+            </a:endParaRPr>
+          </a:p>
+        </p:txBody>
+      </p:sp>
+      <p:sp>
+        <p:nvSpPr>
+          <p:cNvPr id="19" name="TextBox 18"/>
+          <p:cNvSpPr txBox="1"/>
+          <p:nvPr/>
+        </p:nvSpPr>
+        <p:spPr>
+          <a:xfrm>
+            <a:off x="685800" y="5916168"/>
+            <a:ext cx="10789920" cy="228600"/>
           </a:xfrm>
           <a:prstGeom prst="rect">
             <a:avLst/>
@@ -4137,516 +4653,21 @@
           </a:bodyPr>
           <a:lstStyle/>
           <a:p>
-            <a:pPr algn="l">
-              <a:lnSpc>
-                <a:spcPct val="105000"/>
-              </a:lnSpc>
-            </a:pPr>
-            <a:r>
-              <a:rPr sz="1100" b="0" i="0">
+            <a:pPr algn="ctr">
+              <a:lnSpc>
+                <a:spcPct val="105000"/>
+              </a:lnSpc>
+            </a:pPr>
+            <a:r>
+              <a:rPr sz="900" b="0" i="0">
                 <a:solidFill>
                   <a:srgbClr val="667085"/>
                 </a:solidFill>
                 <a:latin typeface="Montserrat"/>
               </a:rPr>
-              <a:t>год начала работы</a:t>
-            </a:r>
-            <a:endParaRPr sz="1100" b="0" i="0">
-              <a:latin typeface="Montserrat"/>
-            </a:endParaRPr>
-          </a:p>
-        </p:txBody>
-      </p:sp>
-      <p:sp>
-        <p:nvSpPr>
-          <p:cNvPr id="8" name="Rounded Rectangle 7"/>
-          <p:cNvSpPr/>
-          <p:nvPr/>
-        </p:nvSpPr>
-        <p:spPr>
-          <a:xfrm>
-            <a:off x="2971800" y="1600200"/>
-            <a:ext cx="2011680" cy="1325880"/>
-          </a:xfrm>
-          <a:prstGeom prst="roundRect">
-            <a:avLst/>
-          </a:prstGeom>
-          <a:solidFill>
-            <a:srgbClr val="E7F6F5"/>
-          </a:solidFill>
-          <a:ln w="10160">
-            <a:solidFill>
-              <a:srgbClr val="C4E8E5"/>
-            </a:solidFill>
-          </a:ln>
-        </p:spPr>
-        <p:style>
-          <a:lnRef idx="1">
-            <a:schemeClr val="accent1"/>
-          </a:lnRef>
-          <a:fillRef idx="3">
-            <a:schemeClr val="accent1"/>
-          </a:fillRef>
-          <a:effectRef idx="2">
-            <a:schemeClr val="accent1"/>
-          </a:effectRef>
-          <a:fontRef idx="minor">
-            <a:schemeClr val="lt1"/>
-          </a:fontRef>
-        </p:style>
-        <p:txBody>
-          <a:bodyPr rtlCol="0" anchor="ctr"/>
-          <a:lstStyle/>
-          <a:p>
-            <a:pPr algn="ctr"/>
-          </a:p>
-        </p:txBody>
-      </p:sp>
-      <p:sp>
-        <p:nvSpPr>
-          <p:cNvPr id="9" name="TextBox 8"/>
-          <p:cNvSpPr txBox="1"/>
-          <p:nvPr/>
-        </p:nvSpPr>
-        <p:spPr>
-          <a:xfrm>
-            <a:off x="3136392" y="1801368"/>
-            <a:ext cx="1691640" cy="457200"/>
-          </a:xfrm>
-          <a:prstGeom prst="rect">
-            <a:avLst/>
-          </a:prstGeom>
-          <a:noFill/>
-        </p:spPr>
-        <p:txBody>
-          <a:bodyPr wrap="square" lIns="18288" rIns="18288" tIns="18288" bIns="18288" anchor="t">
-            <a:noAutofit/>
-          </a:bodyPr>
-          <a:lstStyle/>
-          <a:p>
-            <a:pPr algn="l">
-              <a:lnSpc>
-                <a:spcPct val="105000"/>
-              </a:lnSpc>
-            </a:pPr>
-            <a:r>
-              <a:rPr sz="2700" b="0" i="0">
-                <a:solidFill>
-                  <a:srgbClr val="008C8C"/>
-                </a:solidFill>
-                <a:latin typeface="Montserrat"/>
-              </a:rPr>
-              <a:t>10 000+</a:t>
-            </a:r>
-            <a:endParaRPr sz="2700" b="0" i="0">
-              <a:latin typeface="Montserrat"/>
-            </a:endParaRPr>
-          </a:p>
-        </p:txBody>
-      </p:sp>
-      <p:sp>
-        <p:nvSpPr>
-          <p:cNvPr id="10" name="TextBox 9"/>
-          <p:cNvSpPr txBox="1"/>
-          <p:nvPr/>
-        </p:nvSpPr>
-        <p:spPr>
-          <a:xfrm>
-            <a:off x="3136392" y="2350008"/>
-            <a:ext cx="1691640" cy="320040"/>
-          </a:xfrm>
-          <a:prstGeom prst="rect">
-            <a:avLst/>
-          </a:prstGeom>
-          <a:noFill/>
-        </p:spPr>
-        <p:txBody>
-          <a:bodyPr wrap="square" lIns="18288" rIns="18288" tIns="18288" bIns="18288" anchor="t">
-            <a:noAutofit/>
-          </a:bodyPr>
-          <a:lstStyle/>
-          <a:p>
-            <a:pPr algn="l">
-              <a:lnSpc>
-                <a:spcPct val="105000"/>
-              </a:lnSpc>
-            </a:pPr>
-            <a:r>
-              <a:rPr sz="1100" b="0" i="0">
-                <a:solidFill>
-                  <a:srgbClr val="667085"/>
-                </a:solidFill>
-                <a:latin typeface="Montserrat"/>
-              </a:rPr>
-              <a:t>частных клиентов</a:t>
-            </a:r>
-            <a:endParaRPr sz="1100" b="0" i="0">
-              <a:latin typeface="Montserrat"/>
-            </a:endParaRPr>
-          </a:p>
-        </p:txBody>
-      </p:sp>
-      <p:sp>
-        <p:nvSpPr>
-          <p:cNvPr id="11" name="Rounded Rectangle 10"/>
-          <p:cNvSpPr/>
-          <p:nvPr/>
-        </p:nvSpPr>
-        <p:spPr>
-          <a:xfrm>
-            <a:off x="640080" y="3246120"/>
-            <a:ext cx="2011680" cy="1325880"/>
-          </a:xfrm>
-          <a:prstGeom prst="roundRect">
-            <a:avLst/>
-          </a:prstGeom>
-          <a:solidFill>
-            <a:srgbClr val="E7F6F5"/>
-          </a:solidFill>
-          <a:ln w="10160">
-            <a:solidFill>
-              <a:srgbClr val="C4E8E5"/>
-            </a:solidFill>
-          </a:ln>
-        </p:spPr>
-        <p:style>
-          <a:lnRef idx="1">
-            <a:schemeClr val="accent1"/>
-          </a:lnRef>
-          <a:fillRef idx="3">
-            <a:schemeClr val="accent1"/>
-          </a:fillRef>
-          <a:effectRef idx="2">
-            <a:schemeClr val="accent1"/>
-          </a:effectRef>
-          <a:fontRef idx="minor">
-            <a:schemeClr val="lt1"/>
-          </a:fontRef>
-        </p:style>
-        <p:txBody>
-          <a:bodyPr rtlCol="0" anchor="ctr"/>
-          <a:lstStyle/>
-          <a:p>
-            <a:pPr algn="ctr"/>
-          </a:p>
-        </p:txBody>
-      </p:sp>
-      <p:sp>
-        <p:nvSpPr>
-          <p:cNvPr id="12" name="TextBox 11"/>
-          <p:cNvSpPr txBox="1"/>
-          <p:nvPr/>
-        </p:nvSpPr>
-        <p:spPr>
-          <a:xfrm>
-            <a:off x="804671" y="3447288"/>
-            <a:ext cx="1691640" cy="457200"/>
-          </a:xfrm>
-          <a:prstGeom prst="rect">
-            <a:avLst/>
-          </a:prstGeom>
-          <a:noFill/>
-        </p:spPr>
-        <p:txBody>
-          <a:bodyPr wrap="square" lIns="18288" rIns="18288" tIns="18288" bIns="18288" anchor="t">
-            <a:noAutofit/>
-          </a:bodyPr>
-          <a:lstStyle/>
-          <a:p>
-            <a:pPr algn="l">
-              <a:lnSpc>
-                <a:spcPct val="105000"/>
-              </a:lnSpc>
-            </a:pPr>
-            <a:r>
-              <a:rPr sz="2700" b="0" i="0">
-                <a:solidFill>
-                  <a:srgbClr val="008C8C"/>
-                </a:solidFill>
-                <a:latin typeface="Montserrat"/>
-              </a:rPr>
-              <a:t>1 000+</a:t>
-            </a:r>
-            <a:endParaRPr sz="2700" b="0" i="0">
-              <a:latin typeface="Montserrat"/>
-            </a:endParaRPr>
-          </a:p>
-        </p:txBody>
-      </p:sp>
-      <p:sp>
-        <p:nvSpPr>
-          <p:cNvPr id="13" name="TextBox 12"/>
-          <p:cNvSpPr txBox="1"/>
-          <p:nvPr/>
-        </p:nvSpPr>
-        <p:spPr>
-          <a:xfrm>
-            <a:off x="804671" y="3995928"/>
-            <a:ext cx="1691640" cy="320040"/>
-          </a:xfrm>
-          <a:prstGeom prst="rect">
-            <a:avLst/>
-          </a:prstGeom>
-          <a:noFill/>
-        </p:spPr>
-        <p:txBody>
-          <a:bodyPr wrap="square" lIns="18288" rIns="18288" tIns="18288" bIns="18288" anchor="t">
-            <a:noAutofit/>
-          </a:bodyPr>
-          <a:lstStyle/>
-          <a:p>
-            <a:pPr algn="l">
-              <a:lnSpc>
-                <a:spcPct val="105000"/>
-              </a:lnSpc>
-            </a:pPr>
-            <a:r>
-              <a:rPr sz="1100" b="0" i="0">
-                <a:solidFill>
-                  <a:srgbClr val="667085"/>
-                </a:solidFill>
-                <a:latin typeface="Montserrat"/>
-              </a:rPr>
-              <a:t>организаций</a:t>
-            </a:r>
-            <a:endParaRPr sz="1100" b="0" i="0">
-              <a:latin typeface="Montserrat"/>
-            </a:endParaRPr>
-          </a:p>
-        </p:txBody>
-      </p:sp>
-      <p:sp>
-        <p:nvSpPr>
-          <p:cNvPr id="14" name="Rounded Rectangle 13"/>
-          <p:cNvSpPr/>
-          <p:nvPr/>
-        </p:nvSpPr>
-        <p:spPr>
-          <a:xfrm>
-            <a:off x="2971800" y="3246120"/>
-            <a:ext cx="2011680" cy="1325880"/>
-          </a:xfrm>
-          <a:prstGeom prst="roundRect">
-            <a:avLst/>
-          </a:prstGeom>
-          <a:solidFill>
-            <a:srgbClr val="E7F6F5"/>
-          </a:solidFill>
-          <a:ln w="10160">
-            <a:solidFill>
-              <a:srgbClr val="C4E8E5"/>
-            </a:solidFill>
-          </a:ln>
-        </p:spPr>
-        <p:style>
-          <a:lnRef idx="1">
-            <a:schemeClr val="accent1"/>
-          </a:lnRef>
-          <a:fillRef idx="3">
-            <a:schemeClr val="accent1"/>
-          </a:fillRef>
-          <a:effectRef idx="2">
-            <a:schemeClr val="accent1"/>
-          </a:effectRef>
-          <a:fontRef idx="minor">
-            <a:schemeClr val="lt1"/>
-          </a:fontRef>
-        </p:style>
-        <p:txBody>
-          <a:bodyPr rtlCol="0" anchor="ctr"/>
-          <a:lstStyle/>
-          <a:p>
-            <a:pPr algn="ctr"/>
-          </a:p>
-        </p:txBody>
-      </p:sp>
-      <p:sp>
-        <p:nvSpPr>
-          <p:cNvPr id="15" name="TextBox 14"/>
-          <p:cNvSpPr txBox="1"/>
-          <p:nvPr/>
-        </p:nvSpPr>
-        <p:spPr>
-          <a:xfrm>
-            <a:off x="3136392" y="3447288"/>
-            <a:ext cx="1691640" cy="457200"/>
-          </a:xfrm>
-          <a:prstGeom prst="rect">
-            <a:avLst/>
-          </a:prstGeom>
-          <a:noFill/>
-        </p:spPr>
-        <p:txBody>
-          <a:bodyPr wrap="square" lIns="18288" rIns="18288" tIns="18288" bIns="18288" anchor="t">
-            <a:noAutofit/>
-          </a:bodyPr>
-          <a:lstStyle/>
-          <a:p>
-            <a:pPr algn="l">
-              <a:lnSpc>
-                <a:spcPct val="105000"/>
-              </a:lnSpc>
-            </a:pPr>
-            <a:r>
-              <a:rPr sz="2700" b="0" i="0">
-                <a:solidFill>
-                  <a:srgbClr val="008C8C"/>
-                </a:solidFill>
-                <a:latin typeface="Montserrat"/>
-              </a:rPr>
-              <a:t>500+</a:t>
-            </a:r>
-            <a:endParaRPr sz="2700" b="0" i="0">
-              <a:latin typeface="Montserrat"/>
-            </a:endParaRPr>
-          </a:p>
-        </p:txBody>
-      </p:sp>
-      <p:sp>
-        <p:nvSpPr>
-          <p:cNvPr id="16" name="TextBox 15"/>
-          <p:cNvSpPr txBox="1"/>
-          <p:nvPr/>
-        </p:nvSpPr>
-        <p:spPr>
-          <a:xfrm>
-            <a:off x="3136392" y="3995928"/>
-            <a:ext cx="1691640" cy="320040"/>
-          </a:xfrm>
-          <a:prstGeom prst="rect">
-            <a:avLst/>
-          </a:prstGeom>
-          <a:noFill/>
-        </p:spPr>
-        <p:txBody>
-          <a:bodyPr wrap="square" lIns="18288" rIns="18288" tIns="18288" bIns="18288" anchor="t">
-            <a:noAutofit/>
-          </a:bodyPr>
-          <a:lstStyle/>
-          <a:p>
-            <a:pPr algn="l">
-              <a:lnSpc>
-                <a:spcPct val="105000"/>
-              </a:lnSpc>
-            </a:pPr>
-            <a:r>
-              <a:rPr sz="1100" b="0" i="0">
-                <a:solidFill>
-                  <a:srgbClr val="667085"/>
-                </a:solidFill>
-                <a:latin typeface="Montserrat"/>
-              </a:rPr>
-              <a:t>постоянных клиентов</a:t>
-            </a:r>
-            <a:endParaRPr sz="1100" b="0" i="0">
-              <a:latin typeface="Montserrat"/>
-            </a:endParaRPr>
-          </a:p>
-        </p:txBody>
-      </p:sp>
-      <p:pic>
-        <p:nvPicPr>
-          <p:cNvPr id="17" name="Picture 16" descr="ptz-project.jpg"/>
-          <p:cNvPicPr>
-            <a:picLocks noChangeAspect="1"/>
-          </p:cNvPicPr>
-          <p:nvPr/>
-        </p:nvPicPr>
-        <p:blipFill>
-          <a:blip r:embed="rId2"/>
-          <a:stretch>
-            <a:fillRect/>
-          </a:stretch>
-        </p:blipFill>
-        <p:spPr>
-          <a:xfrm>
-            <a:off x="5532120" y="1581912"/>
-            <a:ext cx="2926080" cy="2926080"/>
-          </a:xfrm>
-          <a:prstGeom prst="rect">
-            <a:avLst/>
-          </a:prstGeom>
-        </p:spPr>
-      </p:pic>
-      <p:sp>
-        <p:nvSpPr>
-          <p:cNvPr id="18" name="TextBox 17"/>
-          <p:cNvSpPr txBox="1"/>
-          <p:nvPr/>
-        </p:nvSpPr>
-        <p:spPr>
-          <a:xfrm>
-            <a:off x="8823960" y="1719072"/>
-            <a:ext cx="1005840" cy="274320"/>
-          </a:xfrm>
-          <a:prstGeom prst="rect">
-            <a:avLst/>
-          </a:prstGeom>
-          <a:noFill/>
-        </p:spPr>
-        <p:txBody>
-          <a:bodyPr wrap="square" lIns="18288" rIns="18288" tIns="18288" bIns="18288" anchor="t">
-            <a:noAutofit/>
-          </a:bodyPr>
-          <a:lstStyle/>
-          <a:p>
-            <a:pPr algn="l">
-              <a:lnSpc>
-                <a:spcPct val="105000"/>
-              </a:lnSpc>
-            </a:pPr>
-            <a:r>
-              <a:rPr sz="1100" b="0" i="0">
-                <a:solidFill>
-                  <a:srgbClr val="008C8C"/>
-                </a:solidFill>
-                <a:latin typeface="Montserrat"/>
-              </a:rPr>
-              <a:t>ЗАМЕР</a:t>
-            </a:r>
-            <a:endParaRPr sz="1100" b="0" i="0">
-              <a:latin typeface="Montserrat"/>
-            </a:endParaRPr>
-          </a:p>
-        </p:txBody>
-      </p:sp>
-      <p:sp>
-        <p:nvSpPr>
-          <p:cNvPr id="19" name="TextBox 18"/>
-          <p:cNvSpPr txBox="1"/>
-          <p:nvPr/>
-        </p:nvSpPr>
-        <p:spPr>
-          <a:xfrm>
-            <a:off x="8823960" y="2240280"/>
-            <a:ext cx="1463040" cy="274320"/>
-          </a:xfrm>
-          <a:prstGeom prst="rect">
-            <a:avLst/>
-          </a:prstGeom>
-          <a:noFill/>
-        </p:spPr>
-        <p:txBody>
-          <a:bodyPr wrap="square" lIns="18288" rIns="18288" tIns="18288" bIns="18288" anchor="t">
-            <a:noAutofit/>
-          </a:bodyPr>
-          <a:lstStyle/>
-          <a:p>
-            <a:pPr algn="l">
-              <a:lnSpc>
-                <a:spcPct val="105000"/>
-              </a:lnSpc>
-            </a:pPr>
-            <a:r>
-              <a:rPr sz="1300" b="0" i="0">
-                <a:solidFill>
-                  <a:srgbClr val="15243A"/>
-                </a:solidFill>
-                <a:latin typeface="Montserrat"/>
-              </a:rPr>
-              <a:t>РАСЧЁТ</a:t>
-            </a:r>
-            <a:endParaRPr sz="1300" b="0" i="0">
+              <a:t>Фактически полученный результат внедрения</a:t>
+            </a:r>
+            <a:endParaRPr sz="900" b="0" i="0">
               <a:latin typeface="Montserrat"/>
             </a:endParaRPr>
           </a:p>
@@ -4655,132 +4676,6 @@
       <p:sp>
         <p:nvSpPr>
           <p:cNvPr id="20" name="TextBox 19"/>
-          <p:cNvSpPr txBox="1"/>
-          <p:nvPr/>
-        </p:nvSpPr>
-        <p:spPr>
-          <a:xfrm>
-            <a:off x="8823960" y="2761488"/>
-            <a:ext cx="2194560" cy="274320"/>
-          </a:xfrm>
-          <a:prstGeom prst="rect">
-            <a:avLst/>
-          </a:prstGeom>
-          <a:noFill/>
-        </p:spPr>
-        <p:txBody>
-          <a:bodyPr wrap="square" lIns="18288" rIns="18288" tIns="18288" bIns="18288" anchor="t">
-            <a:noAutofit/>
-          </a:bodyPr>
-          <a:lstStyle/>
-          <a:p>
-            <a:pPr algn="l">
-              <a:lnSpc>
-                <a:spcPct val="105000"/>
-              </a:lnSpc>
-            </a:pPr>
-            <a:r>
-              <a:rPr sz="1300" b="0" i="0">
-                <a:solidFill>
-                  <a:srgbClr val="15243A"/>
-                </a:solidFill>
-                <a:latin typeface="Montserrat"/>
-              </a:rPr>
-              <a:t>ПРОИЗВОДСТВО</a:t>
-            </a:r>
-            <a:endParaRPr sz="1300" b="0" i="0">
-              <a:latin typeface="Montserrat"/>
-            </a:endParaRPr>
-          </a:p>
-        </p:txBody>
-      </p:sp>
-      <p:sp>
-        <p:nvSpPr>
-          <p:cNvPr id="21" name="TextBox 20"/>
-          <p:cNvSpPr txBox="1"/>
-          <p:nvPr/>
-        </p:nvSpPr>
-        <p:spPr>
-          <a:xfrm>
-            <a:off x="8823960" y="3282696"/>
-            <a:ext cx="1737360" cy="274320"/>
-          </a:xfrm>
-          <a:prstGeom prst="rect">
-            <a:avLst/>
-          </a:prstGeom>
-          <a:noFill/>
-        </p:spPr>
-        <p:txBody>
-          <a:bodyPr wrap="square" lIns="18288" rIns="18288" tIns="18288" bIns="18288" anchor="t">
-            <a:noAutofit/>
-          </a:bodyPr>
-          <a:lstStyle/>
-          <a:p>
-            <a:pPr algn="l">
-              <a:lnSpc>
-                <a:spcPct val="105000"/>
-              </a:lnSpc>
-            </a:pPr>
-            <a:r>
-              <a:rPr sz="1300" b="0" i="0">
-                <a:solidFill>
-                  <a:srgbClr val="15243A"/>
-                </a:solidFill>
-                <a:latin typeface="Montserrat"/>
-              </a:rPr>
-              <a:t>ДОСТАВКА</a:t>
-            </a:r>
-            <a:endParaRPr sz="1300" b="0" i="0">
-              <a:latin typeface="Montserrat"/>
-            </a:endParaRPr>
-          </a:p>
-        </p:txBody>
-      </p:sp>
-      <p:sp>
-        <p:nvSpPr>
-          <p:cNvPr id="22" name="TextBox 21"/>
-          <p:cNvSpPr txBox="1"/>
-          <p:nvPr/>
-        </p:nvSpPr>
-        <p:spPr>
-          <a:xfrm>
-            <a:off x="8823960" y="3803904"/>
-            <a:ext cx="1554480" cy="274320"/>
-          </a:xfrm>
-          <a:prstGeom prst="rect">
-            <a:avLst/>
-          </a:prstGeom>
-          <a:noFill/>
-        </p:spPr>
-        <p:txBody>
-          <a:bodyPr wrap="square" lIns="18288" rIns="18288" tIns="18288" bIns="18288" anchor="t">
-            <a:noAutofit/>
-          </a:bodyPr>
-          <a:lstStyle/>
-          <a:p>
-            <a:pPr algn="l">
-              <a:lnSpc>
-                <a:spcPct val="105000"/>
-              </a:lnSpc>
-            </a:pPr>
-            <a:r>
-              <a:rPr sz="1300" b="0" i="0">
-                <a:solidFill>
-                  <a:srgbClr val="15243A"/>
-                </a:solidFill>
-                <a:latin typeface="Montserrat"/>
-              </a:rPr>
-              <a:t>МОНТАЖ</a:t>
-            </a:r>
-            <a:endParaRPr sz="1300" b="0" i="0">
-              <a:latin typeface="Montserrat"/>
-            </a:endParaRPr>
-          </a:p>
-        </p:txBody>
-      </p:sp>
-      <p:sp>
-        <p:nvSpPr>
-          <p:cNvPr id="23" name="TextBox 22"/>
           <p:cNvSpPr txBox="1"/>
           <p:nvPr/>
         </p:nvSpPr>

</xml_diff>

<commit_message>
Polish PTZ case visual layout and copy
</commit_message>
<xml_diff>
--- a/downloads/ptz-steklo-weboptimize-case.pptx
+++ b/downloads/ptz-steklo-weboptimize-case.pptx
@@ -3682,7 +3682,7 @@
                 </a:solidFill>
                 <a:latin typeface="Montserrat"/>
               </a:rPr>
-              <a:t>0 новых</a:t>
+              <a:t>без найма</a:t>
             </a:r>
             <a:endParaRPr sz="1700" b="0" i="0">
               <a:latin typeface="Montserrat"/>
@@ -3724,7 +3724,7 @@
                 </a:solidFill>
                 <a:latin typeface="Montserrat"/>
               </a:rPr>
-              <a:t>сотрудников в штате</a:t>
+              <a:t>при росте нагрузки</a:t>
             </a:r>
             <a:endParaRPr sz="900" b="0" i="0">
               <a:latin typeface="Montserrat"/>
@@ -4544,7 +4544,7 @@
               </a:lnSpc>
             </a:pPr>
             <a:r>
-              <a:rPr sz="900" b="0" i="0">
+              <a:rPr sz="1000" b="0" i="0">
                 <a:solidFill>
                   <a:srgbClr val="C74B50"/>
                 </a:solidFill>
@@ -4552,7 +4552,7 @@
               </a:rPr>
               <a:t>01</a:t>
             </a:r>
-            <a:endParaRPr sz="900" b="0" i="0">
+            <a:endParaRPr sz="1000" b="0" i="0">
               <a:latin typeface="Montserrat"/>
             </a:endParaRPr>
           </a:p>
@@ -4566,8 +4566,8 @@
         </p:nvSpPr>
         <p:spPr>
           <a:xfrm>
-            <a:off x="6080760" y="1700784"/>
-            <a:ext cx="2377440" cy="274320"/>
+            <a:off x="6080760" y="1673352"/>
+            <a:ext cx="4892040" cy="274320"/>
           </a:xfrm>
           <a:prstGeom prst="rect">
             <a:avLst/>
@@ -4586,7 +4586,7 @@
               </a:lnSpc>
             </a:pPr>
             <a:r>
-              <a:rPr sz="1200" b="0" i="0">
+              <a:rPr sz="1400" b="0" i="0">
                 <a:solidFill>
                   <a:srgbClr val="15243A"/>
                 </a:solidFill>
@@ -4594,7 +4594,7 @@
               </a:rPr>
               <a:t>Два рабочих пространства</a:t>
             </a:r>
-            <a:endParaRPr sz="1200" b="0" i="0">
+            <a:endParaRPr sz="1400" b="0" i="0">
               <a:latin typeface="Montserrat"/>
             </a:endParaRPr>
           </a:p>
@@ -4608,8 +4608,8 @@
         </p:nvSpPr>
         <p:spPr>
           <a:xfrm>
-            <a:off x="8339327" y="1709928"/>
-            <a:ext cx="2834640" cy="457200"/>
+            <a:off x="6080760" y="2011680"/>
+            <a:ext cx="4937760" cy="246888"/>
           </a:xfrm>
           <a:prstGeom prst="rect">
             <a:avLst/>
@@ -4617,7 +4617,7 @@
           <a:noFill/>
         </p:spPr>
         <p:txBody>
-          <a:bodyPr wrap="square" lIns="18288" rIns="18288" tIns="18288" bIns="18288" anchor="ctr">
+          <a:bodyPr wrap="square" lIns="18288" rIns="18288" tIns="18288" bIns="18288" anchor="t">
             <a:noAutofit/>
           </a:bodyPr>
           <a:lstStyle/>
@@ -4628,7 +4628,7 @@
               </a:lnSpc>
             </a:pPr>
             <a:r>
-              <a:rPr sz="1000" b="0" i="0">
+              <a:rPr sz="1100" b="0" i="0">
                 <a:solidFill>
                   <a:srgbClr val="667085"/>
                 </a:solidFill>
@@ -4636,7 +4636,7 @@
               </a:rPr>
               <a:t>Менеджер работает в Bitrix24, производство — в 1С.</a:t>
             </a:r>
-            <a:endParaRPr sz="1000" b="0" i="0">
+            <a:endParaRPr sz="1100" b="0" i="0">
               <a:latin typeface="Montserrat"/>
             </a:endParaRPr>
           </a:p>
@@ -4760,7 +4760,7 @@
               </a:lnSpc>
             </a:pPr>
             <a:r>
-              <a:rPr sz="900" b="0" i="0">
+              <a:rPr sz="1000" b="0" i="0">
                 <a:solidFill>
                   <a:srgbClr val="C74B50"/>
                 </a:solidFill>
@@ -4768,7 +4768,7 @@
               </a:rPr>
               <a:t>02</a:t>
             </a:r>
-            <a:endParaRPr sz="900" b="0" i="0">
+            <a:endParaRPr sz="1000" b="0" i="0">
               <a:latin typeface="Montserrat"/>
             </a:endParaRPr>
           </a:p>
@@ -4782,8 +4782,8 @@
         </p:nvSpPr>
         <p:spPr>
           <a:xfrm>
-            <a:off x="6080760" y="2816352"/>
-            <a:ext cx="2377440" cy="274320"/>
+            <a:off x="6080760" y="2788920"/>
+            <a:ext cx="4892040" cy="274320"/>
           </a:xfrm>
           <a:prstGeom prst="rect">
             <a:avLst/>
@@ -4802,7 +4802,7 @@
               </a:lnSpc>
             </a:pPr>
             <a:r>
-              <a:rPr sz="1300" b="0" i="0">
+              <a:rPr sz="1400" b="0" i="0">
                 <a:solidFill>
                   <a:srgbClr val="15243A"/>
                 </a:solidFill>
@@ -4810,7 +4810,7 @@
               </a:rPr>
               <a:t>Ручная сверка</a:t>
             </a:r>
-            <a:endParaRPr sz="1300" b="0" i="0">
+            <a:endParaRPr sz="1400" b="0" i="0">
               <a:latin typeface="Montserrat"/>
             </a:endParaRPr>
           </a:p>
@@ -4824,8 +4824,8 @@
         </p:nvSpPr>
         <p:spPr>
           <a:xfrm>
-            <a:off x="8339327" y="2825496"/>
-            <a:ext cx="2834640" cy="457200"/>
+            <a:off x="6080760" y="3127248"/>
+            <a:ext cx="4937760" cy="246888"/>
           </a:xfrm>
           <a:prstGeom prst="rect">
             <a:avLst/>
@@ -4833,7 +4833,7 @@
           <a:noFill/>
         </p:spPr>
         <p:txBody>
-          <a:bodyPr wrap="square" lIns="18288" rIns="18288" tIns="18288" bIns="18288" anchor="ctr">
+          <a:bodyPr wrap="square" lIns="18288" rIns="18288" tIns="18288" bIns="18288" anchor="t">
             <a:noAutofit/>
           </a:bodyPr>
           <a:lstStyle/>
@@ -4844,7 +4844,7 @@
               </a:lnSpc>
             </a:pPr>
             <a:r>
-              <a:rPr sz="1000" b="0" i="0">
+              <a:rPr sz="1100" b="0" i="0">
                 <a:solidFill>
                   <a:srgbClr val="667085"/>
                 </a:solidFill>
@@ -4852,7 +4852,7 @@
               </a:rPr>
               <a:t>Статус, срок и сумма уточняются между сотрудниками.</a:t>
             </a:r>
-            <a:endParaRPr sz="1000" b="0" i="0">
+            <a:endParaRPr sz="1100" b="0" i="0">
               <a:latin typeface="Montserrat"/>
             </a:endParaRPr>
           </a:p>
@@ -4976,7 +4976,7 @@
               </a:lnSpc>
             </a:pPr>
             <a:r>
-              <a:rPr sz="900" b="0" i="0">
+              <a:rPr sz="1000" b="0" i="0">
                 <a:solidFill>
                   <a:srgbClr val="C74B50"/>
                 </a:solidFill>
@@ -4984,7 +4984,7 @@
               </a:rPr>
               <a:t>03</a:t>
             </a:r>
-            <a:endParaRPr sz="900" b="0" i="0">
+            <a:endParaRPr sz="1000" b="0" i="0">
               <a:latin typeface="Montserrat"/>
             </a:endParaRPr>
           </a:p>
@@ -4998,8 +4998,8 @@
         </p:nvSpPr>
         <p:spPr>
           <a:xfrm>
-            <a:off x="6080760" y="3931920"/>
-            <a:ext cx="2377440" cy="274320"/>
+            <a:off x="6080760" y="3904487"/>
+            <a:ext cx="4892040" cy="274320"/>
           </a:xfrm>
           <a:prstGeom prst="rect">
             <a:avLst/>
@@ -5018,7 +5018,7 @@
               </a:lnSpc>
             </a:pPr>
             <a:r>
-              <a:rPr sz="1300" b="0" i="0">
+              <a:rPr sz="1400" b="0" i="0">
                 <a:solidFill>
                   <a:srgbClr val="15243A"/>
                 </a:solidFill>
@@ -5026,7 +5026,7 @@
               </a:rPr>
               <a:t>Риск дубля</a:t>
             </a:r>
-            <a:endParaRPr sz="1300" b="0" i="0">
+            <a:endParaRPr sz="1400" b="0" i="0">
               <a:latin typeface="Montserrat"/>
             </a:endParaRPr>
           </a:p>
@@ -5040,8 +5040,8 @@
         </p:nvSpPr>
         <p:spPr>
           <a:xfrm>
-            <a:off x="8339327" y="3941063"/>
-            <a:ext cx="2834640" cy="457200"/>
+            <a:off x="6080760" y="4242816"/>
+            <a:ext cx="4937760" cy="246888"/>
           </a:xfrm>
           <a:prstGeom prst="rect">
             <a:avLst/>
@@ -5049,7 +5049,7 @@
           <a:noFill/>
         </p:spPr>
         <p:txBody>
-          <a:bodyPr wrap="square" lIns="18288" rIns="18288" tIns="18288" bIns="18288" anchor="ctr">
+          <a:bodyPr wrap="square" lIns="18288" rIns="18288" tIns="18288" bIns="18288" anchor="t">
             <a:noAutofit/>
           </a:bodyPr>
           <a:lstStyle/>
@@ -5060,7 +5060,7 @@
               </a:lnSpc>
             </a:pPr>
             <a:r>
-              <a:rPr sz="1000" b="0" i="0">
+              <a:rPr sz="1100" b="0" i="0">
                 <a:solidFill>
                   <a:srgbClr val="667085"/>
                 </a:solidFill>
@@ -5068,7 +5068,7 @@
               </a:rPr>
               <a:t>Повторная передача могла создать второй заказ.</a:t>
             </a:r>
-            <a:endParaRPr sz="1000" b="0" i="0">
+            <a:endParaRPr sz="1100" b="0" i="0">
               <a:latin typeface="Montserrat"/>
             </a:endParaRPr>
           </a:p>
@@ -5192,7 +5192,7 @@
               </a:lnSpc>
             </a:pPr>
             <a:r>
-              <a:rPr sz="900" b="0" i="0">
+              <a:rPr sz="1000" b="0" i="0">
                 <a:solidFill>
                   <a:srgbClr val="C74B50"/>
                 </a:solidFill>
@@ -5200,7 +5200,7 @@
               </a:rPr>
               <a:t>04</a:t>
             </a:r>
-            <a:endParaRPr sz="900" b="0" i="0">
+            <a:endParaRPr sz="1000" b="0" i="0">
               <a:latin typeface="Montserrat"/>
             </a:endParaRPr>
           </a:p>
@@ -5214,8 +5214,8 @@
         </p:nvSpPr>
         <p:spPr>
           <a:xfrm>
-            <a:off x="6080760" y="5047488"/>
-            <a:ext cx="2377440" cy="274320"/>
+            <a:off x="6080760" y="5020056"/>
+            <a:ext cx="4892040" cy="274320"/>
           </a:xfrm>
           <a:prstGeom prst="rect">
             <a:avLst/>
@@ -5234,7 +5234,7 @@
               </a:lnSpc>
             </a:pPr>
             <a:r>
-              <a:rPr sz="1300" b="0" i="0">
+              <a:rPr sz="1400" b="0" i="0">
                 <a:solidFill>
                   <a:srgbClr val="15243A"/>
                 </a:solidFill>
@@ -5242,7 +5242,7 @@
               </a:rPr>
               <a:t>Закрытая 1С</a:t>
             </a:r>
-            <a:endParaRPr sz="1300" b="0" i="0">
+            <a:endParaRPr sz="1400" b="0" i="0">
               <a:latin typeface="Montserrat"/>
             </a:endParaRPr>
           </a:p>
@@ -5256,8 +5256,8 @@
         </p:nvSpPr>
         <p:spPr>
           <a:xfrm>
-            <a:off x="8339327" y="5056632"/>
-            <a:ext cx="2834640" cy="457200"/>
+            <a:off x="6080760" y="5358384"/>
+            <a:ext cx="4937760" cy="246888"/>
           </a:xfrm>
           <a:prstGeom prst="rect">
             <a:avLst/>
@@ -5265,7 +5265,7 @@
           <a:noFill/>
         </p:spPr>
         <p:txBody>
-          <a:bodyPr wrap="square" lIns="18288" rIns="18288" tIns="18288" bIns="18288" anchor="ctr">
+          <a:bodyPr wrap="square" lIns="18288" rIns="18288" tIns="18288" bIns="18288" anchor="t">
             <a:noAutofit/>
           </a:bodyPr>
           <a:lstStyle/>
@@ -5276,7 +5276,7 @@
               </a:lnSpc>
             </a:pPr>
             <a:r>
-              <a:rPr sz="1000" b="0" i="0">
+              <a:rPr sz="1100" b="0" i="0">
                 <a:solidFill>
                   <a:srgbClr val="667085"/>
                 </a:solidFill>
@@ -5284,7 +5284,7 @@
               </a:rPr>
               <a:t>Базу нельзя публиковать в интернет.</a:t>
             </a:r>
-            <a:endParaRPr sz="1000" b="0" i="0">
+            <a:endParaRPr sz="1100" b="0" i="0">
               <a:latin typeface="Montserrat"/>
             </a:endParaRPr>
           </a:p>
@@ -6362,14 +6362,104 @@
       </p:sp>
       <p:sp>
         <p:nvSpPr>
-          <p:cNvPr id="15" name="TextBox 14"/>
+          <p:cNvPr id="15" name="Rounded Rectangle 14"/>
+          <p:cNvSpPr/>
+          <p:nvPr/>
+        </p:nvSpPr>
+        <p:spPr>
+          <a:xfrm>
+            <a:off x="777240" y="4645152"/>
+            <a:ext cx="3401568" cy="841248"/>
+          </a:xfrm>
+          <a:prstGeom prst="roundRect">
+            <a:avLst/>
+          </a:prstGeom>
+          <a:solidFill>
+            <a:srgbClr val="FFFFFF"/>
+          </a:solidFill>
+          <a:ln w="10160">
+            <a:solidFill>
+              <a:srgbClr val="D99400"/>
+            </a:solidFill>
+          </a:ln>
+        </p:spPr>
+        <p:style>
+          <a:lnRef idx="1">
+            <a:schemeClr val="accent1"/>
+          </a:lnRef>
+          <a:fillRef idx="3">
+            <a:schemeClr val="accent1"/>
+          </a:fillRef>
+          <a:effectRef idx="2">
+            <a:schemeClr val="accent1"/>
+          </a:effectRef>
+          <a:fontRef idx="minor">
+            <a:schemeClr val="lt1"/>
+          </a:fontRef>
+        </p:style>
+        <p:txBody>
+          <a:bodyPr rtlCol="0" anchor="ctr"/>
+          <a:lstStyle/>
+          <a:p>
+            <a:pPr algn="ctr"/>
+          </a:p>
+        </p:txBody>
+      </p:sp>
+      <p:sp>
+        <p:nvSpPr>
+          <p:cNvPr id="16" name="Rounded Rectangle 15"/>
+          <p:cNvSpPr/>
+          <p:nvPr/>
+        </p:nvSpPr>
+        <p:spPr>
+          <a:xfrm>
+            <a:off x="923544" y="4828032"/>
+            <a:ext cx="438912" cy="438912"/>
+          </a:xfrm>
+          <a:prstGeom prst="roundRect">
+            <a:avLst/>
+          </a:prstGeom>
+          <a:solidFill>
+            <a:srgbClr val="D99400"/>
+          </a:solidFill>
+          <a:ln w="10160">
+            <a:solidFill>
+              <a:srgbClr val="D99400"/>
+            </a:solidFill>
+          </a:ln>
+        </p:spPr>
+        <p:style>
+          <a:lnRef idx="1">
+            <a:schemeClr val="accent1"/>
+          </a:lnRef>
+          <a:fillRef idx="3">
+            <a:schemeClr val="accent1"/>
+          </a:fillRef>
+          <a:effectRef idx="2">
+            <a:schemeClr val="accent1"/>
+          </a:effectRef>
+          <a:fontRef idx="minor">
+            <a:schemeClr val="lt1"/>
+          </a:fontRef>
+        </p:style>
+        <p:txBody>
+          <a:bodyPr rtlCol="0" anchor="ctr"/>
+          <a:lstStyle/>
+          <a:p>
+            <a:pPr algn="ctr"/>
+          </a:p>
+        </p:txBody>
+      </p:sp>
+      <p:sp>
+        <p:nvSpPr>
+          <p:cNvPr id="17" name="TextBox 16"/>
           <p:cNvSpPr txBox="1"/>
           <p:nvPr/>
         </p:nvSpPr>
         <p:spPr>
           <a:xfrm>
-            <a:off x="777240" y="5230368"/>
-            <a:ext cx="10698480" cy="868680"/>
+            <a:off x="941832" y="4928616"/>
+            <a:ext cx="402336" cy="182880"/>
           </a:xfrm>
           <a:prstGeom prst="rect">
             <a:avLst/>
@@ -6377,80 +6467,414 @@
           <a:noFill/>
         </p:spPr>
         <p:txBody>
-          <a:bodyPr wrap="square" lIns="18288" rIns="18288" tIns="18288">
+          <a:bodyPr wrap="square" lIns="18288" rIns="18288" tIns="18288" bIns="18288" anchor="t">
             <a:noAutofit/>
           </a:bodyPr>
           <a:lstStyle/>
           <a:p>
-            <a:pPr>
+            <a:pPr algn="ctr">
               <a:lnSpc>
                 <a:spcPct val="105000"/>
               </a:lnSpc>
-              <a:spcAft>
-                <a:spcPts val="800"/>
-              </a:spcAft>
-              <a:defRPr sz="1120">
-                <a:solidFill>
-                  <a:srgbClr val="17212B"/>
-                </a:solidFill>
-                <a:latin typeface="Montserrat"/>
-              </a:defRPr>
             </a:pPr>
             <a:r>
-              <a:rPr sz="1100" b="0" i="0">
+              <a:rPr sz="900" b="0" i="0">
+                <a:solidFill>
+                  <a:srgbClr val="FFFFFF"/>
+                </a:solidFill>
                 <a:latin typeface="Montserrat"/>
               </a:rPr>
-              <a:t>•  1С владеет производственным статусом, сроками, суммой и переделкой</a:t>
+              <a:t>01</a:t>
+            </a:r>
+            <a:endParaRPr sz="900" b="0" i="0">
+              <a:latin typeface="Montserrat"/>
+            </a:endParaRPr>
+          </a:p>
+        </p:txBody>
+      </p:sp>
+      <p:sp>
+        <p:nvSpPr>
+          <p:cNvPr id="18" name="TextBox 17"/>
+          <p:cNvSpPr txBox="1"/>
+          <p:nvPr/>
+        </p:nvSpPr>
+        <p:spPr>
+          <a:xfrm>
+            <a:off x="1490472" y="4791456"/>
+            <a:ext cx="2487168" cy="512064"/>
+          </a:xfrm>
+          <a:prstGeom prst="rect">
+            <a:avLst/>
+          </a:prstGeom>
+          <a:noFill/>
+        </p:spPr>
+        <p:txBody>
+          <a:bodyPr wrap="square" lIns="18288" rIns="18288" tIns="18288" bIns="18288" anchor="ctr">
+            <a:noAutofit/>
+          </a:bodyPr>
+          <a:lstStyle/>
+          <a:p>
+            <a:pPr algn="l">
+              <a:lnSpc>
+                <a:spcPct val="105000"/>
+              </a:lnSpc>
+            </a:pPr>
+            <a:r>
+              <a:rPr sz="1100" b="0" i="0">
+                <a:solidFill>
+                  <a:srgbClr val="15243A"/>
+                </a:solidFill>
+                <a:latin typeface="Montserrat"/>
+              </a:rPr>
+              <a:t>1С хранит статус, срок, сумму и переделку</a:t>
             </a:r>
             <a:endParaRPr sz="1100" b="0" i="0">
               <a:latin typeface="Montserrat"/>
             </a:endParaRPr>
           </a:p>
-          <a:p>
-            <a:pPr>
+        </p:txBody>
+      </p:sp>
+      <p:sp>
+        <p:nvSpPr>
+          <p:cNvPr id="19" name="Rounded Rectangle 18"/>
+          <p:cNvSpPr/>
+          <p:nvPr/>
+        </p:nvSpPr>
+        <p:spPr>
+          <a:xfrm>
+            <a:off x="4507992" y="4645152"/>
+            <a:ext cx="3401568" cy="841248"/>
+          </a:xfrm>
+          <a:prstGeom prst="roundRect">
+            <a:avLst/>
+          </a:prstGeom>
+          <a:solidFill>
+            <a:srgbClr val="FFFFFF"/>
+          </a:solidFill>
+          <a:ln w="10160">
+            <a:solidFill>
+              <a:srgbClr val="008C8C"/>
+            </a:solidFill>
+          </a:ln>
+        </p:spPr>
+        <p:style>
+          <a:lnRef idx="1">
+            <a:schemeClr val="accent1"/>
+          </a:lnRef>
+          <a:fillRef idx="3">
+            <a:schemeClr val="accent1"/>
+          </a:fillRef>
+          <a:effectRef idx="2">
+            <a:schemeClr val="accent1"/>
+          </a:effectRef>
+          <a:fontRef idx="minor">
+            <a:schemeClr val="lt1"/>
+          </a:fontRef>
+        </p:style>
+        <p:txBody>
+          <a:bodyPr rtlCol="0" anchor="ctr"/>
+          <a:lstStyle/>
+          <a:p>
+            <a:pPr algn="ctr"/>
+          </a:p>
+        </p:txBody>
+      </p:sp>
+      <p:sp>
+        <p:nvSpPr>
+          <p:cNvPr id="20" name="Rounded Rectangle 19"/>
+          <p:cNvSpPr/>
+          <p:nvPr/>
+        </p:nvSpPr>
+        <p:spPr>
+          <a:xfrm>
+            <a:off x="4654296" y="4828032"/>
+            <a:ext cx="438912" cy="438912"/>
+          </a:xfrm>
+          <a:prstGeom prst="roundRect">
+            <a:avLst/>
+          </a:prstGeom>
+          <a:solidFill>
+            <a:srgbClr val="008C8C"/>
+          </a:solidFill>
+          <a:ln w="10160">
+            <a:solidFill>
+              <a:srgbClr val="008C8C"/>
+            </a:solidFill>
+          </a:ln>
+        </p:spPr>
+        <p:style>
+          <a:lnRef idx="1">
+            <a:schemeClr val="accent1"/>
+          </a:lnRef>
+          <a:fillRef idx="3">
+            <a:schemeClr val="accent1"/>
+          </a:fillRef>
+          <a:effectRef idx="2">
+            <a:schemeClr val="accent1"/>
+          </a:effectRef>
+          <a:fontRef idx="minor">
+            <a:schemeClr val="lt1"/>
+          </a:fontRef>
+        </p:style>
+        <p:txBody>
+          <a:bodyPr rtlCol="0" anchor="ctr"/>
+          <a:lstStyle/>
+          <a:p>
+            <a:pPr algn="ctr"/>
+          </a:p>
+        </p:txBody>
+      </p:sp>
+      <p:sp>
+        <p:nvSpPr>
+          <p:cNvPr id="21" name="TextBox 20"/>
+          <p:cNvSpPr txBox="1"/>
+          <p:nvPr/>
+        </p:nvSpPr>
+        <p:spPr>
+          <a:xfrm>
+            <a:off x="4672583" y="4928616"/>
+            <a:ext cx="402336" cy="182880"/>
+          </a:xfrm>
+          <a:prstGeom prst="rect">
+            <a:avLst/>
+          </a:prstGeom>
+          <a:noFill/>
+        </p:spPr>
+        <p:txBody>
+          <a:bodyPr wrap="square" lIns="18288" rIns="18288" tIns="18288" bIns="18288" anchor="t">
+            <a:noAutofit/>
+          </a:bodyPr>
+          <a:lstStyle/>
+          <a:p>
+            <a:pPr algn="ctr">
               <a:lnSpc>
                 <a:spcPct val="105000"/>
               </a:lnSpc>
-              <a:spcAft>
-                <a:spcPts val="800"/>
-              </a:spcAft>
-              <a:defRPr sz="1120">
-                <a:solidFill>
-                  <a:srgbClr val="17212B"/>
-                </a:solidFill>
-                <a:latin typeface="Montserrat"/>
-              </a:defRPr>
             </a:pPr>
             <a:r>
-              <a:rPr sz="1100" b="0" i="0">
+              <a:rPr sz="900" b="0" i="0">
+                <a:solidFill>
+                  <a:srgbClr val="FFFFFF"/>
+                </a:solidFill>
                 <a:latin typeface="Montserrat"/>
               </a:rPr>
-              <a:t>•  модуль обмена проверяет только уже связанные заказы</a:t>
+              <a:t>02</a:t>
+            </a:r>
+            <a:endParaRPr sz="900" b="0" i="0">
+              <a:latin typeface="Montserrat"/>
+            </a:endParaRPr>
+          </a:p>
+        </p:txBody>
+      </p:sp>
+      <p:sp>
+        <p:nvSpPr>
+          <p:cNvPr id="22" name="TextBox 21"/>
+          <p:cNvSpPr txBox="1"/>
+          <p:nvPr/>
+        </p:nvSpPr>
+        <p:spPr>
+          <a:xfrm>
+            <a:off x="5221224" y="4791456"/>
+            <a:ext cx="2487168" cy="512064"/>
+          </a:xfrm>
+          <a:prstGeom prst="rect">
+            <a:avLst/>
+          </a:prstGeom>
+          <a:noFill/>
+        </p:spPr>
+        <p:txBody>
+          <a:bodyPr wrap="square" lIns="18288" rIns="18288" tIns="18288" bIns="18288" anchor="ctr">
+            <a:noAutofit/>
+          </a:bodyPr>
+          <a:lstStyle/>
+          <a:p>
+            <a:pPr algn="l">
+              <a:lnSpc>
+                <a:spcPct val="105000"/>
+              </a:lnSpc>
+            </a:pPr>
+            <a:r>
+              <a:rPr sz="1100" b="0" i="0">
+                <a:solidFill>
+                  <a:srgbClr val="15243A"/>
+                </a:solidFill>
+                <a:latin typeface="Montserrat"/>
+              </a:rPr>
+              <a:t>Модуль проверяет только связанные заказы</a:t>
             </a:r>
             <a:endParaRPr sz="1100" b="0" i="0">
               <a:latin typeface="Montserrat"/>
             </a:endParaRPr>
           </a:p>
-          <a:p>
-            <a:pPr>
+        </p:txBody>
+      </p:sp>
+      <p:sp>
+        <p:nvSpPr>
+          <p:cNvPr id="23" name="Rounded Rectangle 22"/>
+          <p:cNvSpPr/>
+          <p:nvPr/>
+        </p:nvSpPr>
+        <p:spPr>
+          <a:xfrm>
+            <a:off x="8238744" y="4645152"/>
+            <a:ext cx="3401568" cy="841248"/>
+          </a:xfrm>
+          <a:prstGeom prst="roundRect">
+            <a:avLst/>
+          </a:prstGeom>
+          <a:solidFill>
+            <a:srgbClr val="FFFFFF"/>
+          </a:solidFill>
+          <a:ln w="10160">
+            <a:solidFill>
+              <a:srgbClr val="1769AA"/>
+            </a:solidFill>
+          </a:ln>
+        </p:spPr>
+        <p:style>
+          <a:lnRef idx="1">
+            <a:schemeClr val="accent1"/>
+          </a:lnRef>
+          <a:fillRef idx="3">
+            <a:schemeClr val="accent1"/>
+          </a:fillRef>
+          <a:effectRef idx="2">
+            <a:schemeClr val="accent1"/>
+          </a:effectRef>
+          <a:fontRef idx="minor">
+            <a:schemeClr val="lt1"/>
+          </a:fontRef>
+        </p:style>
+        <p:txBody>
+          <a:bodyPr rtlCol="0" anchor="ctr"/>
+          <a:lstStyle/>
+          <a:p>
+            <a:pPr algn="ctr"/>
+          </a:p>
+        </p:txBody>
+      </p:sp>
+      <p:sp>
+        <p:nvSpPr>
+          <p:cNvPr id="24" name="Rounded Rectangle 23"/>
+          <p:cNvSpPr/>
+          <p:nvPr/>
+        </p:nvSpPr>
+        <p:spPr>
+          <a:xfrm>
+            <a:off x="8385048" y="4828032"/>
+            <a:ext cx="438912" cy="438912"/>
+          </a:xfrm>
+          <a:prstGeom prst="roundRect">
+            <a:avLst/>
+          </a:prstGeom>
+          <a:solidFill>
+            <a:srgbClr val="1769AA"/>
+          </a:solidFill>
+          <a:ln w="10160">
+            <a:solidFill>
+              <a:srgbClr val="1769AA"/>
+            </a:solidFill>
+          </a:ln>
+        </p:spPr>
+        <p:style>
+          <a:lnRef idx="1">
+            <a:schemeClr val="accent1"/>
+          </a:lnRef>
+          <a:fillRef idx="3">
+            <a:schemeClr val="accent1"/>
+          </a:fillRef>
+          <a:effectRef idx="2">
+            <a:schemeClr val="accent1"/>
+          </a:effectRef>
+          <a:fontRef idx="minor">
+            <a:schemeClr val="lt1"/>
+          </a:fontRef>
+        </p:style>
+        <p:txBody>
+          <a:bodyPr rtlCol="0" anchor="ctr"/>
+          <a:lstStyle/>
+          <a:p>
+            <a:pPr algn="ctr"/>
+          </a:p>
+        </p:txBody>
+      </p:sp>
+      <p:sp>
+        <p:nvSpPr>
+          <p:cNvPr id="25" name="TextBox 24"/>
+          <p:cNvSpPr txBox="1"/>
+          <p:nvPr/>
+        </p:nvSpPr>
+        <p:spPr>
+          <a:xfrm>
+            <a:off x="8403336" y="4928616"/>
+            <a:ext cx="402336" cy="182880"/>
+          </a:xfrm>
+          <a:prstGeom prst="rect">
+            <a:avLst/>
+          </a:prstGeom>
+          <a:noFill/>
+        </p:spPr>
+        <p:txBody>
+          <a:bodyPr wrap="square" lIns="18288" rIns="18288" tIns="18288" bIns="18288" anchor="t">
+            <a:noAutofit/>
+          </a:bodyPr>
+          <a:lstStyle/>
+          <a:p>
+            <a:pPr algn="ctr">
               <a:lnSpc>
                 <a:spcPct val="105000"/>
               </a:lnSpc>
-              <a:spcAft>
-                <a:spcPts val="800"/>
-              </a:spcAft>
-              <a:defRPr sz="1120">
-                <a:solidFill>
-                  <a:srgbClr val="17212B"/>
-                </a:solidFill>
-                <a:latin typeface="Montserrat"/>
-              </a:defRPr>
             </a:pPr>
             <a:r>
-              <a:rPr sz="1100" b="0" i="0">
+              <a:rPr sz="900" b="0" i="0">
+                <a:solidFill>
+                  <a:srgbClr val="FFFFFF"/>
+                </a:solidFill>
                 <a:latin typeface="Montserrat"/>
               </a:rPr>
-              <a:t>•  вторая сделка и второй заказ не создаются</a:t>
+              <a:t>03</a:t>
+            </a:r>
+            <a:endParaRPr sz="900" b="0" i="0">
+              <a:latin typeface="Montserrat"/>
+            </a:endParaRPr>
+          </a:p>
+        </p:txBody>
+      </p:sp>
+      <p:sp>
+        <p:nvSpPr>
+          <p:cNvPr id="26" name="TextBox 25"/>
+          <p:cNvSpPr txBox="1"/>
+          <p:nvPr/>
+        </p:nvSpPr>
+        <p:spPr>
+          <a:xfrm>
+            <a:off x="8951976" y="4791456"/>
+            <a:ext cx="2487168" cy="512064"/>
+          </a:xfrm>
+          <a:prstGeom prst="rect">
+            <a:avLst/>
+          </a:prstGeom>
+          <a:noFill/>
+        </p:spPr>
+        <p:txBody>
+          <a:bodyPr wrap="square" lIns="18288" rIns="18288" tIns="18288" bIns="18288" anchor="ctr">
+            <a:noAutofit/>
+          </a:bodyPr>
+          <a:lstStyle/>
+          <a:p>
+            <a:pPr algn="l">
+              <a:lnSpc>
+                <a:spcPct val="105000"/>
+              </a:lnSpc>
+            </a:pPr>
+            <a:r>
+              <a:rPr sz="1100" b="0" i="0">
+                <a:solidFill>
+                  <a:srgbClr val="15243A"/>
+                </a:solidFill>
+                <a:latin typeface="Montserrat"/>
+              </a:rPr>
+              <a:t>Повтор обновляет заказ без дубля</a:t>
             </a:r>
             <a:endParaRPr sz="1100" b="0" i="0">
               <a:latin typeface="Montserrat"/>
@@ -6460,7 +6884,7 @@
       </p:sp>
       <p:sp>
         <p:nvSpPr>
-          <p:cNvPr id="16" name="TextBox 15"/>
+          <p:cNvPr id="27" name="TextBox 26"/>
           <p:cNvSpPr txBox="1"/>
           <p:nvPr/>
         </p:nvSpPr>
@@ -6602,7 +7026,7 @@
                 </a:solidFill>
                 <a:latin typeface="Montserrat"/>
               </a:rPr>
-              <a:t>Временная ошибка не превращается в дубль</a:t>
+              <a:t>Временный сбой не создаёт дубль</a:t>
             </a:r>
             <a:endParaRPr sz="2600" b="0" i="0">
               <a:latin typeface="Montserrat"/>
@@ -6654,14 +7078,146 @@
       </p:sp>
       <p:sp>
         <p:nvSpPr>
-          <p:cNvPr id="5" name="Rounded Rectangle 4"/>
+          <p:cNvPr id="5" name="Rectangle 4"/>
           <p:cNvSpPr/>
           <p:nvPr/>
         </p:nvSpPr>
         <p:spPr>
           <a:xfrm>
-            <a:off x="640080" y="1874519"/>
-            <a:ext cx="2468880" cy="2194560"/>
+            <a:off x="1234440" y="2240280"/>
+            <a:ext cx="9646920" cy="54864"/>
+          </a:xfrm>
+          <a:prstGeom prst="rect">
+            <a:avLst/>
+          </a:prstGeom>
+          <a:solidFill>
+            <a:srgbClr val="1769AA"/>
+          </a:solidFill>
+          <a:ln w="10160">
+            <a:solidFill>
+              <a:srgbClr val="1769AA"/>
+            </a:solidFill>
+          </a:ln>
+        </p:spPr>
+        <p:style>
+          <a:lnRef idx="1">
+            <a:schemeClr val="accent1"/>
+          </a:lnRef>
+          <a:fillRef idx="3">
+            <a:schemeClr val="accent1"/>
+          </a:fillRef>
+          <a:effectRef idx="2">
+            <a:schemeClr val="accent1"/>
+          </a:effectRef>
+          <a:fontRef idx="minor">
+            <a:schemeClr val="lt1"/>
+          </a:fontRef>
+        </p:style>
+        <p:txBody>
+          <a:bodyPr rtlCol="0" anchor="ctr"/>
+          <a:lstStyle/>
+          <a:p>
+            <a:pPr algn="ctr"/>
+          </a:p>
+        </p:txBody>
+      </p:sp>
+      <p:sp>
+        <p:nvSpPr>
+          <p:cNvPr id="6" name="Rounded Rectangle 5"/>
+          <p:cNvSpPr/>
+          <p:nvPr/>
+        </p:nvSpPr>
+        <p:spPr>
+          <a:xfrm>
+            <a:off x="1536192" y="1901952"/>
+            <a:ext cx="676656" cy="676656"/>
+          </a:xfrm>
+          <a:prstGeom prst="roundRect">
+            <a:avLst/>
+          </a:prstGeom>
+          <a:solidFill>
+            <a:srgbClr val="1769AA"/>
+          </a:solidFill>
+          <a:ln w="10160">
+            <a:solidFill>
+              <a:srgbClr val="1769AA"/>
+            </a:solidFill>
+          </a:ln>
+        </p:spPr>
+        <p:style>
+          <a:lnRef idx="1">
+            <a:schemeClr val="accent1"/>
+          </a:lnRef>
+          <a:fillRef idx="3">
+            <a:schemeClr val="accent1"/>
+          </a:fillRef>
+          <a:effectRef idx="2">
+            <a:schemeClr val="accent1"/>
+          </a:effectRef>
+          <a:fontRef idx="minor">
+            <a:schemeClr val="lt1"/>
+          </a:fontRef>
+        </p:style>
+        <p:txBody>
+          <a:bodyPr rtlCol="0" anchor="ctr"/>
+          <a:lstStyle/>
+          <a:p>
+            <a:pPr algn="ctr"/>
+          </a:p>
+        </p:txBody>
+      </p:sp>
+      <p:sp>
+        <p:nvSpPr>
+          <p:cNvPr id="7" name="TextBox 6"/>
+          <p:cNvSpPr txBox="1"/>
+          <p:nvPr/>
+        </p:nvSpPr>
+        <p:spPr>
+          <a:xfrm>
+            <a:off x="1600200" y="2093976"/>
+            <a:ext cx="548640" cy="201168"/>
+          </a:xfrm>
+          <a:prstGeom prst="rect">
+            <a:avLst/>
+          </a:prstGeom>
+          <a:noFill/>
+        </p:spPr>
+        <p:txBody>
+          <a:bodyPr wrap="square" lIns="18288" rIns="18288" tIns="18288" bIns="18288" anchor="t">
+            <a:noAutofit/>
+          </a:bodyPr>
+          <a:lstStyle/>
+          <a:p>
+            <a:pPr algn="ctr">
+              <a:lnSpc>
+                <a:spcPct val="105000"/>
+              </a:lnSpc>
+            </a:pPr>
+            <a:r>
+              <a:rPr sz="1100" b="0" i="0">
+                <a:solidFill>
+                  <a:srgbClr val="FFFFFF"/>
+                </a:solidFill>
+                <a:latin typeface="Montserrat"/>
+              </a:rPr>
+              <a:t>01</a:t>
+            </a:r>
+            <a:endParaRPr sz="1100" b="0" i="0">
+              <a:latin typeface="Montserrat"/>
+            </a:endParaRPr>
+          </a:p>
+        </p:txBody>
+      </p:sp>
+      <p:sp>
+        <p:nvSpPr>
+          <p:cNvPr id="8" name="Rounded Rectangle 7"/>
+          <p:cNvSpPr/>
+          <p:nvPr/>
+        </p:nvSpPr>
+        <p:spPr>
+          <a:xfrm>
+            <a:off x="640080" y="2761488"/>
+            <a:ext cx="2468880" cy="1261872"/>
           </a:xfrm>
           <a:prstGeom prst="roundRect">
             <a:avLst/>
@@ -6699,14 +7255,14 @@
       </p:sp>
       <p:sp>
         <p:nvSpPr>
-          <p:cNvPr id="6" name="TextBox 5"/>
+          <p:cNvPr id="9" name="TextBox 8"/>
           <p:cNvSpPr txBox="1"/>
           <p:nvPr/>
         </p:nvSpPr>
         <p:spPr>
           <a:xfrm>
-            <a:off x="841247" y="2112264"/>
-            <a:ext cx="2066543" cy="329184"/>
+            <a:off x="859536" y="2990088"/>
+            <a:ext cx="2029968" cy="365760"/>
           </a:xfrm>
           <a:prstGeom prst="rect">
             <a:avLst/>
@@ -6725,15 +7281,15 @@
               </a:lnSpc>
             </a:pPr>
             <a:r>
-              <a:rPr sz="1600" b="0" i="0">
-                <a:solidFill>
-                  <a:srgbClr val="1769AA"/>
+              <a:rPr sz="1300" b="0" i="0">
+                <a:solidFill>
+                  <a:srgbClr val="15243A"/>
                 </a:solidFill>
                 <a:latin typeface="Montserrat"/>
               </a:rPr>
-              <a:t>01</a:t>
-            </a:r>
-            <a:endParaRPr sz="1600" b="0" i="0">
+              <a:t>Команда не теряется</a:t>
+            </a:r>
+            <a:endParaRPr sz="1300" b="0" i="0">
               <a:latin typeface="Montserrat"/>
             </a:endParaRPr>
           </a:p>
@@ -6741,14 +7297,14 @@
       </p:sp>
       <p:sp>
         <p:nvSpPr>
-          <p:cNvPr id="7" name="TextBox 6"/>
+          <p:cNvPr id="10" name="TextBox 9"/>
           <p:cNvSpPr txBox="1"/>
           <p:nvPr/>
         </p:nvSpPr>
         <p:spPr>
           <a:xfrm>
-            <a:off x="960119" y="2743200"/>
-            <a:ext cx="1828800" cy="822960"/>
+            <a:off x="896112" y="3456432"/>
+            <a:ext cx="1956816" cy="256032"/>
           </a:xfrm>
           <a:prstGeom prst="rect">
             <a:avLst/>
@@ -6756,7 +7312,7 @@
           <a:noFill/>
         </p:spPr>
         <p:txBody>
-          <a:bodyPr wrap="square" lIns="18288" rIns="18288" tIns="18288" bIns="18288" anchor="ctr">
+          <a:bodyPr wrap="square" lIns="18288" rIns="18288" tIns="18288" bIns="18288" anchor="t">
             <a:noAutofit/>
           </a:bodyPr>
           <a:lstStyle/>
@@ -6767,15 +7323,15 @@
               </a:lnSpc>
             </a:pPr>
             <a:r>
-              <a:rPr sz="1400" b="0" i="0">
-                <a:solidFill>
-                  <a:srgbClr val="15243A"/>
+              <a:rPr sz="1000" b="0" i="0">
+                <a:solidFill>
+                  <a:srgbClr val="667085"/>
                 </a:solidFill>
                 <a:latin typeface="Montserrat"/>
               </a:rPr>
-              <a:t>Команда остаётся в очереди</a:t>
-            </a:r>
-            <a:endParaRPr sz="1400" b="0" i="0">
+              <a:t>остаётся в очереди</a:t>
+            </a:r>
+            <a:endParaRPr sz="1000" b="0" i="0">
               <a:latin typeface="Montserrat"/>
             </a:endParaRPr>
           </a:p>
@@ -6783,16 +7339,232 @@
       </p:sp>
       <p:sp>
         <p:nvSpPr>
-          <p:cNvPr id="8" name="Rectangle 7"/>
+          <p:cNvPr id="11" name="Rounded Rectangle 10"/>
           <p:cNvSpPr/>
           <p:nvPr/>
         </p:nvSpPr>
         <p:spPr>
           <a:xfrm>
-            <a:off x="3108960" y="2926080"/>
-            <a:ext cx="274320" cy="91440"/>
-          </a:xfrm>
-          <a:prstGeom prst="rect">
+            <a:off x="4279392" y="1901952"/>
+            <a:ext cx="676656" cy="676656"/>
+          </a:xfrm>
+          <a:prstGeom prst="roundRect">
+            <a:avLst/>
+          </a:prstGeom>
+          <a:solidFill>
+            <a:srgbClr val="008C8C"/>
+          </a:solidFill>
+          <a:ln w="10160">
+            <a:solidFill>
+              <a:srgbClr val="008C8C"/>
+            </a:solidFill>
+          </a:ln>
+        </p:spPr>
+        <p:style>
+          <a:lnRef idx="1">
+            <a:schemeClr val="accent1"/>
+          </a:lnRef>
+          <a:fillRef idx="3">
+            <a:schemeClr val="accent1"/>
+          </a:fillRef>
+          <a:effectRef idx="2">
+            <a:schemeClr val="accent1"/>
+          </a:effectRef>
+          <a:fontRef idx="minor">
+            <a:schemeClr val="lt1"/>
+          </a:fontRef>
+        </p:style>
+        <p:txBody>
+          <a:bodyPr rtlCol="0" anchor="ctr"/>
+          <a:lstStyle/>
+          <a:p>
+            <a:pPr algn="ctr"/>
+          </a:p>
+        </p:txBody>
+      </p:sp>
+      <p:sp>
+        <p:nvSpPr>
+          <p:cNvPr id="12" name="TextBox 11"/>
+          <p:cNvSpPr txBox="1"/>
+          <p:nvPr/>
+        </p:nvSpPr>
+        <p:spPr>
+          <a:xfrm>
+            <a:off x="4343400" y="2093976"/>
+            <a:ext cx="548640" cy="201168"/>
+          </a:xfrm>
+          <a:prstGeom prst="rect">
+            <a:avLst/>
+          </a:prstGeom>
+          <a:noFill/>
+        </p:spPr>
+        <p:txBody>
+          <a:bodyPr wrap="square" lIns="18288" rIns="18288" tIns="18288" bIns="18288" anchor="t">
+            <a:noAutofit/>
+          </a:bodyPr>
+          <a:lstStyle/>
+          <a:p>
+            <a:pPr algn="ctr">
+              <a:lnSpc>
+                <a:spcPct val="105000"/>
+              </a:lnSpc>
+            </a:pPr>
+            <a:r>
+              <a:rPr sz="1100" b="0" i="0">
+                <a:solidFill>
+                  <a:srgbClr val="FFFFFF"/>
+                </a:solidFill>
+                <a:latin typeface="Montserrat"/>
+              </a:rPr>
+              <a:t>02</a:t>
+            </a:r>
+            <a:endParaRPr sz="1100" b="0" i="0">
+              <a:latin typeface="Montserrat"/>
+            </a:endParaRPr>
+          </a:p>
+        </p:txBody>
+      </p:sp>
+      <p:sp>
+        <p:nvSpPr>
+          <p:cNvPr id="13" name="Rounded Rectangle 12"/>
+          <p:cNvSpPr/>
+          <p:nvPr/>
+        </p:nvSpPr>
+        <p:spPr>
+          <a:xfrm>
+            <a:off x="3383280" y="2761488"/>
+            <a:ext cx="2468880" cy="1261872"/>
+          </a:xfrm>
+          <a:prstGeom prst="roundRect">
+            <a:avLst/>
+          </a:prstGeom>
+          <a:solidFill>
+            <a:srgbClr val="E8F2FB"/>
+          </a:solidFill>
+          <a:ln w="10160">
+            <a:solidFill>
+              <a:srgbClr val="C9DFF0"/>
+            </a:solidFill>
+          </a:ln>
+        </p:spPr>
+        <p:style>
+          <a:lnRef idx="1">
+            <a:schemeClr val="accent1"/>
+          </a:lnRef>
+          <a:fillRef idx="3">
+            <a:schemeClr val="accent1"/>
+          </a:fillRef>
+          <a:effectRef idx="2">
+            <a:schemeClr val="accent1"/>
+          </a:effectRef>
+          <a:fontRef idx="minor">
+            <a:schemeClr val="lt1"/>
+          </a:fontRef>
+        </p:style>
+        <p:txBody>
+          <a:bodyPr rtlCol="0" anchor="ctr"/>
+          <a:lstStyle/>
+          <a:p>
+            <a:pPr algn="ctr"/>
+          </a:p>
+        </p:txBody>
+      </p:sp>
+      <p:sp>
+        <p:nvSpPr>
+          <p:cNvPr id="14" name="TextBox 13"/>
+          <p:cNvSpPr txBox="1"/>
+          <p:nvPr/>
+        </p:nvSpPr>
+        <p:spPr>
+          <a:xfrm>
+            <a:off x="3602736" y="2990088"/>
+            <a:ext cx="2029968" cy="365760"/>
+          </a:xfrm>
+          <a:prstGeom prst="rect">
+            <a:avLst/>
+          </a:prstGeom>
+          <a:noFill/>
+        </p:spPr>
+        <p:txBody>
+          <a:bodyPr wrap="square" lIns="18288" rIns="18288" tIns="18288" bIns="18288" anchor="t">
+            <a:noAutofit/>
+          </a:bodyPr>
+          <a:lstStyle/>
+          <a:p>
+            <a:pPr algn="ctr">
+              <a:lnSpc>
+                <a:spcPct val="105000"/>
+              </a:lnSpc>
+            </a:pPr>
+            <a:r>
+              <a:rPr sz="1300" b="0" i="0">
+                <a:solidFill>
+                  <a:srgbClr val="15243A"/>
+                </a:solidFill>
+                <a:latin typeface="Montserrat"/>
+              </a:rPr>
+              <a:t>Система пробует снова</a:t>
+            </a:r>
+            <a:endParaRPr sz="1300" b="0" i="0">
+              <a:latin typeface="Montserrat"/>
+            </a:endParaRPr>
+          </a:p>
+        </p:txBody>
+      </p:sp>
+      <p:sp>
+        <p:nvSpPr>
+          <p:cNvPr id="15" name="TextBox 14"/>
+          <p:cNvSpPr txBox="1"/>
+          <p:nvPr/>
+        </p:nvSpPr>
+        <p:spPr>
+          <a:xfrm>
+            <a:off x="3639312" y="3456432"/>
+            <a:ext cx="1956816" cy="256032"/>
+          </a:xfrm>
+          <a:prstGeom prst="rect">
+            <a:avLst/>
+          </a:prstGeom>
+          <a:noFill/>
+        </p:spPr>
+        <p:txBody>
+          <a:bodyPr wrap="square" lIns="18288" rIns="18288" tIns="18288" bIns="18288" anchor="t">
+            <a:noAutofit/>
+          </a:bodyPr>
+          <a:lstStyle/>
+          <a:p>
+            <a:pPr algn="ctr">
+              <a:lnSpc>
+                <a:spcPct val="105000"/>
+              </a:lnSpc>
+            </a:pPr>
+            <a:r>
+              <a:rPr sz="1000" b="0" i="0">
+                <a:solidFill>
+                  <a:srgbClr val="667085"/>
+                </a:solidFill>
+                <a:latin typeface="Montserrat"/>
+              </a:rPr>
+              <a:t>автоматически</a:t>
+            </a:r>
+            <a:endParaRPr sz="1000" b="0" i="0">
+              <a:latin typeface="Montserrat"/>
+            </a:endParaRPr>
+          </a:p>
+        </p:txBody>
+      </p:sp>
+      <p:sp>
+        <p:nvSpPr>
+          <p:cNvPr id="16" name="Rounded Rectangle 15"/>
+          <p:cNvSpPr/>
+          <p:nvPr/>
+        </p:nvSpPr>
+        <p:spPr>
+          <a:xfrm>
+            <a:off x="7022592" y="1901952"/>
+            <a:ext cx="676656" cy="676656"/>
+          </a:xfrm>
+          <a:prstGeom prst="roundRect">
             <a:avLst/>
           </a:prstGeom>
           <a:solidFill>
@@ -6828,14 +7600,56 @@
       </p:sp>
       <p:sp>
         <p:nvSpPr>
-          <p:cNvPr id="9" name="Rounded Rectangle 8"/>
+          <p:cNvPr id="17" name="TextBox 16"/>
+          <p:cNvSpPr txBox="1"/>
+          <p:nvPr/>
+        </p:nvSpPr>
+        <p:spPr>
+          <a:xfrm>
+            <a:off x="7086600" y="2093976"/>
+            <a:ext cx="548640" cy="201168"/>
+          </a:xfrm>
+          <a:prstGeom prst="rect">
+            <a:avLst/>
+          </a:prstGeom>
+          <a:noFill/>
+        </p:spPr>
+        <p:txBody>
+          <a:bodyPr wrap="square" lIns="18288" rIns="18288" tIns="18288" bIns="18288" anchor="t">
+            <a:noAutofit/>
+          </a:bodyPr>
+          <a:lstStyle/>
+          <a:p>
+            <a:pPr algn="ctr">
+              <a:lnSpc>
+                <a:spcPct val="105000"/>
+              </a:lnSpc>
+            </a:pPr>
+            <a:r>
+              <a:rPr sz="1100" b="0" i="0">
+                <a:solidFill>
+                  <a:srgbClr val="FFFFFF"/>
+                </a:solidFill>
+                <a:latin typeface="Montserrat"/>
+              </a:rPr>
+              <a:t>03</a:t>
+            </a:r>
+            <a:endParaRPr sz="1100" b="0" i="0">
+              <a:latin typeface="Montserrat"/>
+            </a:endParaRPr>
+          </a:p>
+        </p:txBody>
+      </p:sp>
+      <p:sp>
+        <p:nvSpPr>
+          <p:cNvPr id="18" name="Rounded Rectangle 17"/>
           <p:cNvSpPr/>
           <p:nvPr/>
         </p:nvSpPr>
         <p:spPr>
           <a:xfrm>
-            <a:off x="3383280" y="1874519"/>
-            <a:ext cx="2468880" cy="2194560"/>
+            <a:off x="6126480" y="2761488"/>
+            <a:ext cx="2468880" cy="1261872"/>
           </a:xfrm>
           <a:prstGeom prst="roundRect">
             <a:avLst/>
@@ -6873,14 +7687,14 @@
       </p:sp>
       <p:sp>
         <p:nvSpPr>
-          <p:cNvPr id="10" name="TextBox 9"/>
+          <p:cNvPr id="19" name="TextBox 18"/>
           <p:cNvSpPr txBox="1"/>
           <p:nvPr/>
         </p:nvSpPr>
         <p:spPr>
           <a:xfrm>
-            <a:off x="3584448" y="2112264"/>
-            <a:ext cx="2066543" cy="329184"/>
+            <a:off x="6345936" y="2990088"/>
+            <a:ext cx="2029968" cy="365760"/>
           </a:xfrm>
           <a:prstGeom prst="rect">
             <a:avLst/>
@@ -6899,15 +7713,15 @@
               </a:lnSpc>
             </a:pPr>
             <a:r>
-              <a:rPr sz="1600" b="0" i="0">
-                <a:solidFill>
-                  <a:srgbClr val="1769AA"/>
+              <a:rPr sz="1300" b="0" i="0">
+                <a:solidFill>
+                  <a:srgbClr val="15243A"/>
                 </a:solidFill>
                 <a:latin typeface="Montserrat"/>
               </a:rPr>
-              <a:t>02</a:t>
-            </a:r>
-            <a:endParaRPr sz="1600" b="0" i="0">
+              <a:t>Связь проверяется</a:t>
+            </a:r>
+            <a:endParaRPr sz="1300" b="0" i="0">
               <a:latin typeface="Montserrat"/>
             </a:endParaRPr>
           </a:p>
@@ -6915,14 +7729,14 @@
       </p:sp>
       <p:sp>
         <p:nvSpPr>
-          <p:cNvPr id="11" name="TextBox 10"/>
+          <p:cNvPr id="20" name="TextBox 19"/>
           <p:cNvSpPr txBox="1"/>
           <p:nvPr/>
         </p:nvSpPr>
         <p:spPr>
           <a:xfrm>
-            <a:off x="3703320" y="2743200"/>
-            <a:ext cx="1828800" cy="822960"/>
+            <a:off x="6382512" y="3456432"/>
+            <a:ext cx="1956816" cy="256032"/>
           </a:xfrm>
           <a:prstGeom prst="rect">
             <a:avLst/>
@@ -6930,7 +7744,7 @@
           <a:noFill/>
         </p:spPr>
         <p:txBody>
-          <a:bodyPr wrap="square" lIns="18288" rIns="18288" tIns="18288" bIns="18288" anchor="ctr">
+          <a:bodyPr wrap="square" lIns="18288" rIns="18288" tIns="18288" bIns="18288" anchor="t">
             <a:noAutofit/>
           </a:bodyPr>
           <a:lstStyle/>
@@ -6941,15 +7755,15 @@
               </a:lnSpc>
             </a:pPr>
             <a:r>
-              <a:rPr sz="1400" b="0" i="0">
-                <a:solidFill>
-                  <a:srgbClr val="15243A"/>
+              <a:rPr sz="1000" b="0" i="0">
+                <a:solidFill>
+                  <a:srgbClr val="667085"/>
                 </a:solidFill>
                 <a:latin typeface="Montserrat"/>
               </a:rPr>
-              <a:t>Обмен повторяется автоматически</a:t>
-            </a:r>
-            <a:endParaRPr sz="1400" b="0" i="0">
+              <a:t>перед записью</a:t>
+            </a:r>
+            <a:endParaRPr sz="1000" b="0" i="0">
               <a:latin typeface="Montserrat"/>
             </a:endParaRPr>
           </a:p>
@@ -6957,24 +7771,24 @@
       </p:sp>
       <p:sp>
         <p:nvSpPr>
-          <p:cNvPr id="12" name="Rectangle 11"/>
+          <p:cNvPr id="21" name="Rounded Rectangle 20"/>
           <p:cNvSpPr/>
           <p:nvPr/>
         </p:nvSpPr>
         <p:spPr>
           <a:xfrm>
-            <a:off x="5852160" y="2926080"/>
-            <a:ext cx="274320" cy="91440"/>
-          </a:xfrm>
-          <a:prstGeom prst="rect">
+            <a:off x="9765792" y="1901952"/>
+            <a:ext cx="676656" cy="676656"/>
+          </a:xfrm>
+          <a:prstGeom prst="roundRect">
             <a:avLst/>
           </a:prstGeom>
           <a:solidFill>
-            <a:srgbClr val="1769AA"/>
+            <a:srgbClr val="008C8C"/>
           </a:solidFill>
           <a:ln w="10160">
             <a:solidFill>
-              <a:srgbClr val="1769AA"/>
+              <a:srgbClr val="008C8C"/>
             </a:solidFill>
           </a:ln>
         </p:spPr>
@@ -7002,14 +7816,56 @@
       </p:sp>
       <p:sp>
         <p:nvSpPr>
-          <p:cNvPr id="13" name="Rounded Rectangle 12"/>
+          <p:cNvPr id="22" name="TextBox 21"/>
+          <p:cNvSpPr txBox="1"/>
+          <p:nvPr/>
+        </p:nvSpPr>
+        <p:spPr>
+          <a:xfrm>
+            <a:off x="9829800" y="2093976"/>
+            <a:ext cx="548640" cy="201168"/>
+          </a:xfrm>
+          <a:prstGeom prst="rect">
+            <a:avLst/>
+          </a:prstGeom>
+          <a:noFill/>
+        </p:spPr>
+        <p:txBody>
+          <a:bodyPr wrap="square" lIns="18288" rIns="18288" tIns="18288" bIns="18288" anchor="t">
+            <a:noAutofit/>
+          </a:bodyPr>
+          <a:lstStyle/>
+          <a:p>
+            <a:pPr algn="ctr">
+              <a:lnSpc>
+                <a:spcPct val="105000"/>
+              </a:lnSpc>
+            </a:pPr>
+            <a:r>
+              <a:rPr sz="1100" b="0" i="0">
+                <a:solidFill>
+                  <a:srgbClr val="FFFFFF"/>
+                </a:solidFill>
+                <a:latin typeface="Montserrat"/>
+              </a:rPr>
+              <a:t>04</a:t>
+            </a:r>
+            <a:endParaRPr sz="1100" b="0" i="0">
+              <a:latin typeface="Montserrat"/>
+            </a:endParaRPr>
+          </a:p>
+        </p:txBody>
+      </p:sp>
+      <p:sp>
+        <p:nvSpPr>
+          <p:cNvPr id="23" name="Rounded Rectangle 22"/>
           <p:cNvSpPr/>
           <p:nvPr/>
         </p:nvSpPr>
         <p:spPr>
           <a:xfrm>
-            <a:off x="6126480" y="1874519"/>
-            <a:ext cx="2468880" cy="2194560"/>
+            <a:off x="8869680" y="2761488"/>
+            <a:ext cx="2468880" cy="1261872"/>
           </a:xfrm>
           <a:prstGeom prst="roundRect">
             <a:avLst/>
@@ -7047,14 +7903,14 @@
       </p:sp>
       <p:sp>
         <p:nvSpPr>
-          <p:cNvPr id="14" name="TextBox 13"/>
+          <p:cNvPr id="24" name="TextBox 23"/>
           <p:cNvSpPr txBox="1"/>
           <p:nvPr/>
         </p:nvSpPr>
         <p:spPr>
           <a:xfrm>
-            <a:off x="6327648" y="2112264"/>
-            <a:ext cx="2066543" cy="329184"/>
+            <a:off x="9089136" y="2990088"/>
+            <a:ext cx="2029968" cy="365760"/>
           </a:xfrm>
           <a:prstGeom prst="rect">
             <a:avLst/>
@@ -7073,15 +7929,15 @@
               </a:lnSpc>
             </a:pPr>
             <a:r>
-              <a:rPr sz="1600" b="0" i="0">
-                <a:solidFill>
-                  <a:srgbClr val="1769AA"/>
+              <a:rPr sz="1300" b="0" i="0">
+                <a:solidFill>
+                  <a:srgbClr val="15243A"/>
                 </a:solidFill>
                 <a:latin typeface="Montserrat"/>
               </a:rPr>
-              <a:t>03</a:t>
-            </a:r>
-            <a:endParaRPr sz="1600" b="0" i="0">
+              <a:t>Заказ обновляется</a:t>
+            </a:r>
+            <a:endParaRPr sz="1300" b="0" i="0">
               <a:latin typeface="Montserrat"/>
             </a:endParaRPr>
           </a:p>
@@ -7089,14 +7945,14 @@
       </p:sp>
       <p:sp>
         <p:nvSpPr>
-          <p:cNvPr id="15" name="TextBox 14"/>
+          <p:cNvPr id="25" name="TextBox 24"/>
           <p:cNvSpPr txBox="1"/>
           <p:nvPr/>
         </p:nvSpPr>
         <p:spPr>
           <a:xfrm>
-            <a:off x="6446520" y="2743200"/>
-            <a:ext cx="1828800" cy="822960"/>
+            <a:off x="9125711" y="3456432"/>
+            <a:ext cx="1956816" cy="256032"/>
           </a:xfrm>
           <a:prstGeom prst="rect">
             <a:avLst/>
@@ -7104,7 +7960,7 @@
           <a:noFill/>
         </p:spPr>
         <p:txBody>
-          <a:bodyPr wrap="square" lIns="18288" rIns="18288" tIns="18288" bIns="18288" anchor="ctr">
+          <a:bodyPr wrap="square" lIns="18288" rIns="18288" tIns="18288" bIns="18288" anchor="t">
             <a:noAutofit/>
           </a:bodyPr>
           <a:lstStyle/>
@@ -7115,15 +7971,15 @@
               </a:lnSpc>
             </a:pPr>
             <a:r>
-              <a:rPr sz="1400" b="0" i="0">
-                <a:solidFill>
-                  <a:srgbClr val="15243A"/>
+              <a:rPr sz="1000" b="0" i="0">
+                <a:solidFill>
+                  <a:srgbClr val="667085"/>
                 </a:solidFill>
                 <a:latin typeface="Montserrat"/>
               </a:rPr>
-              <a:t>Связь проверяется перед записью</a:t>
-            </a:r>
-            <a:endParaRPr sz="1400" b="0" i="0">
+              <a:t>вместо создания нового</a:t>
+            </a:r>
+            <a:endParaRPr sz="1000" b="0" i="0">
               <a:latin typeface="Montserrat"/>
             </a:endParaRPr>
           </a:p>
@@ -7131,181 +7987,7 @@
       </p:sp>
       <p:sp>
         <p:nvSpPr>
-          <p:cNvPr id="16" name="Rectangle 15"/>
-          <p:cNvSpPr/>
-          <p:nvPr/>
-        </p:nvSpPr>
-        <p:spPr>
-          <a:xfrm>
-            <a:off x="8595360" y="2926080"/>
-            <a:ext cx="274320" cy="91440"/>
-          </a:xfrm>
-          <a:prstGeom prst="rect">
-            <a:avLst/>
-          </a:prstGeom>
-          <a:solidFill>
-            <a:srgbClr val="1769AA"/>
-          </a:solidFill>
-          <a:ln w="10160">
-            <a:solidFill>
-              <a:srgbClr val="1769AA"/>
-            </a:solidFill>
-          </a:ln>
-        </p:spPr>
-        <p:style>
-          <a:lnRef idx="1">
-            <a:schemeClr val="accent1"/>
-          </a:lnRef>
-          <a:fillRef idx="3">
-            <a:schemeClr val="accent1"/>
-          </a:fillRef>
-          <a:effectRef idx="2">
-            <a:schemeClr val="accent1"/>
-          </a:effectRef>
-          <a:fontRef idx="minor">
-            <a:schemeClr val="lt1"/>
-          </a:fontRef>
-        </p:style>
-        <p:txBody>
-          <a:bodyPr rtlCol="0" anchor="ctr"/>
-          <a:lstStyle/>
-          <a:p>
-            <a:pPr algn="ctr"/>
-          </a:p>
-        </p:txBody>
-      </p:sp>
-      <p:sp>
-        <p:nvSpPr>
-          <p:cNvPr id="17" name="Rounded Rectangle 16"/>
-          <p:cNvSpPr/>
-          <p:nvPr/>
-        </p:nvSpPr>
-        <p:spPr>
-          <a:xfrm>
-            <a:off x="8869680" y="1874519"/>
-            <a:ext cx="2468880" cy="2194560"/>
-          </a:xfrm>
-          <a:prstGeom prst="roundRect">
-            <a:avLst/>
-          </a:prstGeom>
-          <a:solidFill>
-            <a:srgbClr val="E8F2FB"/>
-          </a:solidFill>
-          <a:ln w="10160">
-            <a:solidFill>
-              <a:srgbClr val="C9DFF0"/>
-            </a:solidFill>
-          </a:ln>
-        </p:spPr>
-        <p:style>
-          <a:lnRef idx="1">
-            <a:schemeClr val="accent1"/>
-          </a:lnRef>
-          <a:fillRef idx="3">
-            <a:schemeClr val="accent1"/>
-          </a:fillRef>
-          <a:effectRef idx="2">
-            <a:schemeClr val="accent1"/>
-          </a:effectRef>
-          <a:fontRef idx="minor">
-            <a:schemeClr val="lt1"/>
-          </a:fontRef>
-        </p:style>
-        <p:txBody>
-          <a:bodyPr rtlCol="0" anchor="ctr"/>
-          <a:lstStyle/>
-          <a:p>
-            <a:pPr algn="ctr"/>
-          </a:p>
-        </p:txBody>
-      </p:sp>
-      <p:sp>
-        <p:nvSpPr>
-          <p:cNvPr id="18" name="TextBox 17"/>
-          <p:cNvSpPr txBox="1"/>
-          <p:nvPr/>
-        </p:nvSpPr>
-        <p:spPr>
-          <a:xfrm>
-            <a:off x="9070848" y="2112264"/>
-            <a:ext cx="2066543" cy="329184"/>
-          </a:xfrm>
-          <a:prstGeom prst="rect">
-            <a:avLst/>
-          </a:prstGeom>
-          <a:noFill/>
-        </p:spPr>
-        <p:txBody>
-          <a:bodyPr wrap="square" lIns="18288" rIns="18288" tIns="18288" bIns="18288" anchor="t">
-            <a:noAutofit/>
-          </a:bodyPr>
-          <a:lstStyle/>
-          <a:p>
-            <a:pPr algn="ctr">
-              <a:lnSpc>
-                <a:spcPct val="105000"/>
-              </a:lnSpc>
-            </a:pPr>
-            <a:r>
-              <a:rPr sz="1600" b="0" i="0">
-                <a:solidFill>
-                  <a:srgbClr val="1769AA"/>
-                </a:solidFill>
-                <a:latin typeface="Montserrat"/>
-              </a:rPr>
-              <a:t>04</a:t>
-            </a:r>
-            <a:endParaRPr sz="1600" b="0" i="0">
-              <a:latin typeface="Montserrat"/>
-            </a:endParaRPr>
-          </a:p>
-        </p:txBody>
-      </p:sp>
-      <p:sp>
-        <p:nvSpPr>
-          <p:cNvPr id="19" name="TextBox 18"/>
-          <p:cNvSpPr txBox="1"/>
-          <p:nvPr/>
-        </p:nvSpPr>
-        <p:spPr>
-          <a:xfrm>
-            <a:off x="9189719" y="2743200"/>
-            <a:ext cx="1828800" cy="822960"/>
-          </a:xfrm>
-          <a:prstGeom prst="rect">
-            <a:avLst/>
-          </a:prstGeom>
-          <a:noFill/>
-        </p:spPr>
-        <p:txBody>
-          <a:bodyPr wrap="square" lIns="18288" rIns="18288" tIns="18288" bIns="18288" anchor="ctr">
-            <a:noAutofit/>
-          </a:bodyPr>
-          <a:lstStyle/>
-          <a:p>
-            <a:pPr algn="ctr">
-              <a:lnSpc>
-                <a:spcPct val="105000"/>
-              </a:lnSpc>
-            </a:pPr>
-            <a:r>
-              <a:rPr sz="1400" b="0" i="0">
-                <a:solidFill>
-                  <a:srgbClr val="15243A"/>
-                </a:solidFill>
-                <a:latin typeface="Montserrat"/>
-              </a:rPr>
-              <a:t>Обновляется существующий заказ</a:t>
-            </a:r>
-            <a:endParaRPr sz="1400" b="0" i="0">
-              <a:latin typeface="Montserrat"/>
-            </a:endParaRPr>
-          </a:p>
-        </p:txBody>
-      </p:sp>
-      <p:sp>
-        <p:nvSpPr>
-          <p:cNvPr id="20" name="Rounded Rectangle 19"/>
+          <p:cNvPr id="26" name="Rounded Rectangle 25"/>
           <p:cNvSpPr/>
           <p:nvPr/>
         </p:nvSpPr>
@@ -7350,7 +8032,7 @@
       </p:sp>
       <p:sp>
         <p:nvSpPr>
-          <p:cNvPr id="21" name="TextBox 20"/>
+          <p:cNvPr id="27" name="TextBox 26"/>
           <p:cNvSpPr txBox="1"/>
           <p:nvPr/>
         </p:nvSpPr>
@@ -7392,7 +8074,7 @@
       </p:sp>
       <p:sp>
         <p:nvSpPr>
-          <p:cNvPr id="22" name="TextBox 21"/>
+          <p:cNvPr id="28" name="TextBox 27"/>
           <p:cNvSpPr txBox="1"/>
           <p:nvPr/>
         </p:nvSpPr>
@@ -7706,8 +8388,50 @@
         </p:nvSpPr>
         <p:spPr>
           <a:xfrm>
-            <a:off x="9582912" y="1737360"/>
-            <a:ext cx="1691640" cy="402336"/>
+            <a:off x="9025128" y="1856231"/>
+            <a:ext cx="329184" cy="146304"/>
+          </a:xfrm>
+          <a:prstGeom prst="rect">
+            <a:avLst/>
+          </a:prstGeom>
+          <a:noFill/>
+        </p:spPr>
+        <p:txBody>
+          <a:bodyPr wrap="square" lIns="18288" rIns="18288" tIns="18288" bIns="18288" anchor="t">
+            <a:noAutofit/>
+          </a:bodyPr>
+          <a:lstStyle/>
+          <a:p>
+            <a:pPr algn="ctr">
+              <a:lnSpc>
+                <a:spcPct val="105000"/>
+              </a:lnSpc>
+            </a:pPr>
+            <a:r>
+              <a:rPr sz="800" b="0" i="0">
+                <a:solidFill>
+                  <a:srgbClr val="FFFFFF"/>
+                </a:solidFill>
+                <a:latin typeface="Montserrat"/>
+              </a:rPr>
+              <a:t>01</a:t>
+            </a:r>
+            <a:endParaRPr sz="800" b="0" i="0">
+              <a:latin typeface="Montserrat"/>
+            </a:endParaRPr>
+          </a:p>
+        </p:txBody>
+      </p:sp>
+      <p:sp>
+        <p:nvSpPr>
+          <p:cNvPr id="9" name="TextBox 8"/>
+          <p:cNvSpPr txBox="1"/>
+          <p:nvPr/>
+        </p:nvSpPr>
+        <p:spPr>
+          <a:xfrm>
+            <a:off x="9528048" y="1719072"/>
+            <a:ext cx="1810512" cy="438912"/>
           </a:xfrm>
           <a:prstGeom prst="rect">
             <a:avLst/>
@@ -7726,7 +8450,7 @@
               </a:lnSpc>
             </a:pPr>
             <a:r>
-              <a:rPr sz="1000" b="0" i="0">
+              <a:rPr sz="1100" b="0" i="0">
                 <a:solidFill>
                   <a:srgbClr val="15243A"/>
                 </a:solidFill>
@@ -7734,7 +8458,7 @@
               </a:rPr>
               <a:t>Заказ создаётся из сделки</a:t>
             </a:r>
-            <a:endParaRPr sz="1000" b="0" i="0">
+            <a:endParaRPr sz="1100" b="0" i="0">
               <a:latin typeface="Montserrat"/>
             </a:endParaRPr>
           </a:p>
@@ -7742,7 +8466,7 @@
       </p:sp>
       <p:sp>
         <p:nvSpPr>
-          <p:cNvPr id="9" name="Rounded Rectangle 8"/>
+          <p:cNvPr id="10" name="Rounded Rectangle 9"/>
           <p:cNvSpPr/>
           <p:nvPr/>
         </p:nvSpPr>
@@ -7787,7 +8511,7 @@
       </p:sp>
       <p:sp>
         <p:nvSpPr>
-          <p:cNvPr id="10" name="Rounded Rectangle 9"/>
+          <p:cNvPr id="11" name="Rounded Rectangle 10"/>
           <p:cNvSpPr/>
           <p:nvPr/>
         </p:nvSpPr>
@@ -7832,14 +8556,56 @@
       </p:sp>
       <p:sp>
         <p:nvSpPr>
-          <p:cNvPr id="11" name="TextBox 10"/>
+          <p:cNvPr id="12" name="TextBox 11"/>
           <p:cNvSpPr txBox="1"/>
           <p:nvPr/>
         </p:nvSpPr>
         <p:spPr>
           <a:xfrm>
-            <a:off x="9582912" y="2724912"/>
-            <a:ext cx="1691640" cy="402336"/>
+            <a:off x="9025128" y="2843784"/>
+            <a:ext cx="329184" cy="146304"/>
+          </a:xfrm>
+          <a:prstGeom prst="rect">
+            <a:avLst/>
+          </a:prstGeom>
+          <a:noFill/>
+        </p:spPr>
+        <p:txBody>
+          <a:bodyPr wrap="square" lIns="18288" rIns="18288" tIns="18288" bIns="18288" anchor="t">
+            <a:noAutofit/>
+          </a:bodyPr>
+          <a:lstStyle/>
+          <a:p>
+            <a:pPr algn="ctr">
+              <a:lnSpc>
+                <a:spcPct val="105000"/>
+              </a:lnSpc>
+            </a:pPr>
+            <a:r>
+              <a:rPr sz="800" b="0" i="0">
+                <a:solidFill>
+                  <a:srgbClr val="FFFFFF"/>
+                </a:solidFill>
+                <a:latin typeface="Montserrat"/>
+              </a:rPr>
+              <a:t>02</a:t>
+            </a:r>
+            <a:endParaRPr sz="800" b="0" i="0">
+              <a:latin typeface="Montserrat"/>
+            </a:endParaRPr>
+          </a:p>
+        </p:txBody>
+      </p:sp>
+      <p:sp>
+        <p:nvSpPr>
+          <p:cNvPr id="13" name="TextBox 12"/>
+          <p:cNvSpPr txBox="1"/>
+          <p:nvPr/>
+        </p:nvSpPr>
+        <p:spPr>
+          <a:xfrm>
+            <a:off x="9528048" y="2706624"/>
+            <a:ext cx="1810512" cy="438912"/>
           </a:xfrm>
           <a:prstGeom prst="rect">
             <a:avLst/>
@@ -7858,15 +8624,15 @@
               </a:lnSpc>
             </a:pPr>
             <a:r>
-              <a:rPr sz="1000" b="0" i="0">
+              <a:rPr sz="1100" b="0" i="0">
                 <a:solidFill>
                   <a:srgbClr val="15243A"/>
                 </a:solidFill>
                 <a:latin typeface="Montserrat"/>
               </a:rPr>
-              <a:t>Повтор обновляет связь без дубля</a:t>
-            </a:r>
-            <a:endParaRPr sz="1000" b="0" i="0">
+              <a:t>Повтор обновляет заказ без дубля</a:t>
+            </a:r>
+            <a:endParaRPr sz="1100" b="0" i="0">
               <a:latin typeface="Montserrat"/>
             </a:endParaRPr>
           </a:p>
@@ -7874,7 +8640,7 @@
       </p:sp>
       <p:sp>
         <p:nvSpPr>
-          <p:cNvPr id="12" name="Rounded Rectangle 11"/>
+          <p:cNvPr id="14" name="Rounded Rectangle 13"/>
           <p:cNvSpPr/>
           <p:nvPr/>
         </p:nvSpPr>
@@ -7919,7 +8685,7 @@
       </p:sp>
       <p:sp>
         <p:nvSpPr>
-          <p:cNvPr id="13" name="Rounded Rectangle 12"/>
+          <p:cNvPr id="15" name="Rounded Rectangle 14"/>
           <p:cNvSpPr/>
           <p:nvPr/>
         </p:nvSpPr>
@@ -7964,14 +8730,56 @@
       </p:sp>
       <p:sp>
         <p:nvSpPr>
-          <p:cNvPr id="14" name="TextBox 13"/>
+          <p:cNvPr id="16" name="TextBox 15"/>
           <p:cNvSpPr txBox="1"/>
           <p:nvPr/>
         </p:nvSpPr>
         <p:spPr>
           <a:xfrm>
-            <a:off x="9582912" y="3712463"/>
-            <a:ext cx="1691640" cy="402336"/>
+            <a:off x="9025128" y="3831335"/>
+            <a:ext cx="329184" cy="146304"/>
+          </a:xfrm>
+          <a:prstGeom prst="rect">
+            <a:avLst/>
+          </a:prstGeom>
+          <a:noFill/>
+        </p:spPr>
+        <p:txBody>
+          <a:bodyPr wrap="square" lIns="18288" rIns="18288" tIns="18288" bIns="18288" anchor="t">
+            <a:noAutofit/>
+          </a:bodyPr>
+          <a:lstStyle/>
+          <a:p>
+            <a:pPr algn="ctr">
+              <a:lnSpc>
+                <a:spcPct val="105000"/>
+              </a:lnSpc>
+            </a:pPr>
+            <a:r>
+              <a:rPr sz="800" b="0" i="0">
+                <a:solidFill>
+                  <a:srgbClr val="FFFFFF"/>
+                </a:solidFill>
+                <a:latin typeface="Montserrat"/>
+              </a:rPr>
+              <a:t>03</a:t>
+            </a:r>
+            <a:endParaRPr sz="800" b="0" i="0">
+              <a:latin typeface="Montserrat"/>
+            </a:endParaRPr>
+          </a:p>
+        </p:txBody>
+      </p:sp>
+      <p:sp>
+        <p:nvSpPr>
+          <p:cNvPr id="17" name="TextBox 16"/>
+          <p:cNvSpPr txBox="1"/>
+          <p:nvPr/>
+        </p:nvSpPr>
+        <p:spPr>
+          <a:xfrm>
+            <a:off x="9528048" y="3694176"/>
+            <a:ext cx="1810512" cy="438912"/>
           </a:xfrm>
           <a:prstGeom prst="rect">
             <a:avLst/>
@@ -7990,7 +8798,7 @@
               </a:lnSpc>
             </a:pPr>
             <a:r>
-              <a:rPr sz="1000" b="0" i="0">
+              <a:rPr sz="1100" b="0" i="0">
                 <a:solidFill>
                   <a:srgbClr val="15243A"/>
                 </a:solidFill>
@@ -7998,7 +8806,7 @@
               </a:rPr>
               <a:t>Статус возвращается в Bitrix24</a:t>
             </a:r>
-            <a:endParaRPr sz="1000" b="0" i="0">
+            <a:endParaRPr sz="1100" b="0" i="0">
               <a:latin typeface="Montserrat"/>
             </a:endParaRPr>
           </a:p>
@@ -8006,7 +8814,7 @@
       </p:sp>
       <p:sp>
         <p:nvSpPr>
-          <p:cNvPr id="15" name="Rounded Rectangle 14"/>
+          <p:cNvPr id="18" name="Rounded Rectangle 17"/>
           <p:cNvSpPr/>
           <p:nvPr/>
         </p:nvSpPr>
@@ -8051,7 +8859,7 @@
       </p:sp>
       <p:sp>
         <p:nvSpPr>
-          <p:cNvPr id="16" name="Rounded Rectangle 15"/>
+          <p:cNvPr id="19" name="Rounded Rectangle 18"/>
           <p:cNvSpPr/>
           <p:nvPr/>
         </p:nvSpPr>
@@ -8096,14 +8904,56 @@
       </p:sp>
       <p:sp>
         <p:nvSpPr>
-          <p:cNvPr id="17" name="TextBox 16"/>
+          <p:cNvPr id="20" name="TextBox 19"/>
           <p:cNvSpPr txBox="1"/>
           <p:nvPr/>
         </p:nvSpPr>
         <p:spPr>
           <a:xfrm>
-            <a:off x="9582912" y="4700016"/>
-            <a:ext cx="1691640" cy="402336"/>
+            <a:off x="9025128" y="4818888"/>
+            <a:ext cx="329184" cy="146304"/>
+          </a:xfrm>
+          <a:prstGeom prst="rect">
+            <a:avLst/>
+          </a:prstGeom>
+          <a:noFill/>
+        </p:spPr>
+        <p:txBody>
+          <a:bodyPr wrap="square" lIns="18288" rIns="18288" tIns="18288" bIns="18288" anchor="t">
+            <a:noAutofit/>
+          </a:bodyPr>
+          <a:lstStyle/>
+          <a:p>
+            <a:pPr algn="ctr">
+              <a:lnSpc>
+                <a:spcPct val="105000"/>
+              </a:lnSpc>
+            </a:pPr>
+            <a:r>
+              <a:rPr sz="800" b="0" i="0">
+                <a:solidFill>
+                  <a:srgbClr val="FFFFFF"/>
+                </a:solidFill>
+                <a:latin typeface="Montserrat"/>
+              </a:rPr>
+              <a:t>04</a:t>
+            </a:r>
+            <a:endParaRPr sz="800" b="0" i="0">
+              <a:latin typeface="Montserrat"/>
+            </a:endParaRPr>
+          </a:p>
+        </p:txBody>
+      </p:sp>
+      <p:sp>
+        <p:nvSpPr>
+          <p:cNvPr id="21" name="TextBox 20"/>
+          <p:cNvSpPr txBox="1"/>
+          <p:nvPr/>
+        </p:nvSpPr>
+        <p:spPr>
+          <a:xfrm>
+            <a:off x="9528048" y="4681728"/>
+            <a:ext cx="1810512" cy="438912"/>
           </a:xfrm>
           <a:prstGeom prst="rect">
             <a:avLst/>
@@ -8122,7 +8972,7 @@
               </a:lnSpc>
             </a:pPr>
             <a:r>
-              <a:rPr sz="900" b="0" i="0">
+              <a:rPr sz="1100" b="0" i="0">
                 <a:solidFill>
                   <a:srgbClr val="15243A"/>
                 </a:solidFill>
@@ -8130,7 +8980,7 @@
               </a:rPr>
               <a:t>Производство продолжает работать в 1С</a:t>
             </a:r>
-            <a:endParaRPr sz="900" b="0" i="0">
+            <a:endParaRPr sz="1100" b="0" i="0">
               <a:latin typeface="Montserrat"/>
             </a:endParaRPr>
           </a:p>
@@ -8138,7 +8988,7 @@
       </p:sp>
       <p:sp>
         <p:nvSpPr>
-          <p:cNvPr id="18" name="TextBox 17"/>
+          <p:cNvPr id="22" name="TextBox 21"/>
           <p:cNvSpPr txBox="1"/>
           <p:nvPr/>
         </p:nvSpPr>
@@ -8180,7 +9030,7 @@
       </p:sp>
       <p:sp>
         <p:nvSpPr>
-          <p:cNvPr id="19" name="TextBox 18"/>
+          <p:cNvPr id="23" name="TextBox 22"/>
           <p:cNvSpPr txBox="1"/>
           <p:nvPr/>
         </p:nvSpPr>
@@ -8399,48 +9249,6 @@
       <p:sp>
         <p:nvSpPr>
           <p:cNvPr id="6" name="TextBox 5"/>
-          <p:cNvSpPr txBox="1"/>
-          <p:nvPr/>
-        </p:nvSpPr>
-        <p:spPr>
-          <a:xfrm>
-            <a:off x="685800" y="5916168"/>
-            <a:ext cx="10789920" cy="228600"/>
-          </a:xfrm>
-          <a:prstGeom prst="rect">
-            <a:avLst/>
-          </a:prstGeom>
-          <a:noFill/>
-        </p:spPr>
-        <p:txBody>
-          <a:bodyPr wrap="square" lIns="18288" rIns="18288" tIns="18288" bIns="18288" anchor="t">
-            <a:noAutofit/>
-          </a:bodyPr>
-          <a:lstStyle/>
-          <a:p>
-            <a:pPr algn="ctr">
-              <a:lnSpc>
-                <a:spcPct val="105000"/>
-              </a:lnSpc>
-            </a:pPr>
-            <a:r>
-              <a:rPr sz="900" b="0" i="0">
-                <a:solidFill>
-                  <a:srgbClr val="667085"/>
-                </a:solidFill>
-                <a:latin typeface="Montserrat"/>
-              </a:rPr>
-              <a:t>Расчёт: 15–25 заказов в день, 22 рабочих дня, 17 минут экономии на заказ.</a:t>
-            </a:r>
-            <a:endParaRPr sz="900" b="0" i="0">
-              <a:latin typeface="Montserrat"/>
-            </a:endParaRPr>
-          </a:p>
-        </p:txBody>
-      </p:sp>
-      <p:sp>
-        <p:nvSpPr>
-          <p:cNvPr id="7" name="TextBox 6"/>
           <p:cNvSpPr txBox="1"/>
           <p:nvPr/>
         </p:nvSpPr>

</xml_diff>

<commit_message>
Visualize final PTZ case outcome
</commit_message>
<xml_diff>
--- a/downloads/ptz-steklo-weboptimize-case.pptx
+++ b/downloads/ptz-steklo-weboptimize-case.pptx
@@ -3164,8 +3164,8 @@
         </p:blipFill>
         <p:spPr>
           <a:xfrm>
-            <a:off x="7543800" y="0"/>
-            <a:ext cx="4645152" cy="6858000"/>
+            <a:off x="8339327" y="0"/>
+            <a:ext cx="3849624" cy="6858000"/>
           </a:xfrm>
           <a:prstGeom prst="rect">
             <a:avLst/>
@@ -3180,8 +3180,8 @@
         </p:nvSpPr>
         <p:spPr>
           <a:xfrm>
-            <a:off x="7269480" y="0"/>
-            <a:ext cx="384048" cy="6858000"/>
+            <a:off x="8119872" y="0"/>
+            <a:ext cx="310896" cy="6858000"/>
           </a:xfrm>
           <a:prstGeom prst="rect">
             <a:avLst/>
@@ -3268,7 +3268,7 @@
         <p:spPr>
           <a:xfrm>
             <a:off x="685800" y="1143000"/>
-            <a:ext cx="6309360" cy="1325880"/>
+            <a:ext cx="7040880" cy="658368"/>
           </a:xfrm>
           <a:prstGeom prst="rect">
             <a:avLst/>
@@ -3287,16 +3287,15 @@
               </a:lnSpc>
             </a:pPr>
             <a:r>
-              <a:rPr sz="3600" b="0" i="0">
+              <a:rPr sz="3200" b="0" i="0">
                 <a:solidFill>
                   <a:srgbClr val="FFFFFF"/>
                 </a:solidFill>
                 <a:latin typeface="Montserrat"/>
               </a:rPr>
-              <a:t>Одна сделка соответствует
-одному заказу</a:t>
-            </a:r>
-            <a:endParaRPr sz="3600" b="0" i="0">
+              <a:t>Одна сделка — один заказ</a:t>
+            </a:r>
+            <a:endParaRPr sz="3200" b="0" i="0">
               <a:latin typeface="Montserrat"/>
             </a:endParaRPr>
           </a:p>
@@ -3310,8 +3309,8 @@
         </p:nvSpPr>
         <p:spPr>
           <a:xfrm>
-            <a:off x="685800" y="2697480"/>
-            <a:ext cx="6309360" cy="731520"/>
+            <a:off x="685800" y="1847088"/>
+            <a:ext cx="7132320" cy="384048"/>
           </a:xfrm>
           <a:prstGeom prst="rect">
             <a:avLst/>
@@ -3330,16 +3329,15 @@
               </a:lnSpc>
             </a:pPr>
             <a:r>
-              <a:rPr sz="1700" b="0" i="0">
+              <a:rPr sz="1300" b="0" i="0">
                 <a:solidFill>
                   <a:srgbClr val="D6E4EC"/>
                 </a:solidFill>
                 <a:latin typeface="Montserrat"/>
               </a:rPr>
-              <a:t>Компания сохранила текущий штат, ускорила работу сотрудников
-и устранила повторный ввод между системами.</a:t>
-            </a:r>
-            <a:endParaRPr sz="1700" b="0" i="0">
+              <a:t>Сокращение ручной операции высвободило время и создало запас мощности.</a:t>
+            </a:r>
+            <a:endParaRPr sz="1300" b="0" i="0">
               <a:latin typeface="Montserrat"/>
             </a:endParaRPr>
           </a:p>
@@ -3347,14 +3345,272 @@
       </p:sp>
       <p:sp>
         <p:nvSpPr>
-          <p:cNvPr id="7" name="Rounded Rectangle 6"/>
+          <p:cNvPr id="7" name="TextBox 6"/>
+          <p:cNvSpPr txBox="1"/>
+          <p:nvPr/>
+        </p:nvSpPr>
+        <p:spPr>
+          <a:xfrm>
+            <a:off x="685800" y="2496312"/>
+            <a:ext cx="658368" cy="228600"/>
+          </a:xfrm>
+          <a:prstGeom prst="rect">
+            <a:avLst/>
+          </a:prstGeom>
+          <a:noFill/>
+        </p:spPr>
+        <p:txBody>
+          <a:bodyPr wrap="square" lIns="18288" rIns="18288" tIns="18288" bIns="18288" anchor="t">
+            <a:noAutofit/>
+          </a:bodyPr>
+          <a:lstStyle/>
+          <a:p>
+            <a:pPr algn="l">
+              <a:lnSpc>
+                <a:spcPct val="105000"/>
+              </a:lnSpc>
+            </a:pPr>
+            <a:r>
+              <a:rPr sz="1100" b="0" i="0">
+                <a:solidFill>
+                  <a:srgbClr val="E78A8E"/>
+                </a:solidFill>
+                <a:latin typeface="Montserrat"/>
+              </a:rPr>
+              <a:t>ДО</a:t>
+            </a:r>
+            <a:endParaRPr sz="1100" b="0" i="0">
+              <a:latin typeface="Montserrat"/>
+            </a:endParaRPr>
+          </a:p>
+        </p:txBody>
+      </p:sp>
+      <p:sp>
+        <p:nvSpPr>
+          <p:cNvPr id="8" name="Rounded Rectangle 7"/>
           <p:cNvSpPr/>
           <p:nvPr/>
         </p:nvSpPr>
         <p:spPr>
           <a:xfrm>
-            <a:off x="685800" y="3977639"/>
-            <a:ext cx="2834640" cy="1005840"/>
+            <a:off x="1463040" y="2450592"/>
+            <a:ext cx="4709160" cy="420624"/>
+          </a:xfrm>
+          <a:prstGeom prst="roundRect">
+            <a:avLst/>
+          </a:prstGeom>
+          <a:solidFill>
+            <a:srgbClr val="C74B50"/>
+          </a:solidFill>
+          <a:ln w="10160">
+            <a:solidFill>
+              <a:srgbClr val="C74B50"/>
+            </a:solidFill>
+          </a:ln>
+        </p:spPr>
+        <p:style>
+          <a:lnRef idx="1">
+            <a:schemeClr val="accent1"/>
+          </a:lnRef>
+          <a:fillRef idx="3">
+            <a:schemeClr val="accent1"/>
+          </a:fillRef>
+          <a:effectRef idx="2">
+            <a:schemeClr val="accent1"/>
+          </a:effectRef>
+          <a:fontRef idx="minor">
+            <a:schemeClr val="lt1"/>
+          </a:fontRef>
+        </p:style>
+        <p:txBody>
+          <a:bodyPr rtlCol="0" anchor="ctr"/>
+          <a:lstStyle/>
+          <a:p>
+            <a:pPr algn="ctr"/>
+          </a:p>
+        </p:txBody>
+      </p:sp>
+      <p:sp>
+        <p:nvSpPr>
+          <p:cNvPr id="9" name="TextBox 8"/>
+          <p:cNvSpPr txBox="1"/>
+          <p:nvPr/>
+        </p:nvSpPr>
+        <p:spPr>
+          <a:xfrm>
+            <a:off x="5074920" y="2560320"/>
+            <a:ext cx="914400" cy="164592"/>
+          </a:xfrm>
+          <a:prstGeom prst="rect">
+            <a:avLst/>
+          </a:prstGeom>
+          <a:noFill/>
+        </p:spPr>
+        <p:txBody>
+          <a:bodyPr wrap="square" lIns="18288" rIns="18288" tIns="18288" bIns="18288" anchor="t">
+            <a:noAutofit/>
+          </a:bodyPr>
+          <a:lstStyle/>
+          <a:p>
+            <a:pPr algn="r">
+              <a:lnSpc>
+                <a:spcPct val="105000"/>
+              </a:lnSpc>
+            </a:pPr>
+            <a:r>
+              <a:rPr sz="1000" b="0" i="0">
+                <a:solidFill>
+                  <a:srgbClr val="FFFFFF"/>
+                </a:solidFill>
+                <a:latin typeface="Montserrat"/>
+              </a:rPr>
+              <a:t>15–25 мин</a:t>
+            </a:r>
+            <a:endParaRPr sz="1000" b="0" i="0">
+              <a:latin typeface="Montserrat"/>
+            </a:endParaRPr>
+          </a:p>
+        </p:txBody>
+      </p:sp>
+      <p:sp>
+        <p:nvSpPr>
+          <p:cNvPr id="10" name="TextBox 9"/>
+          <p:cNvSpPr txBox="1"/>
+          <p:nvPr/>
+        </p:nvSpPr>
+        <p:spPr>
+          <a:xfrm>
+            <a:off x="685800" y="3090672"/>
+            <a:ext cx="713232" cy="228600"/>
+          </a:xfrm>
+          <a:prstGeom prst="rect">
+            <a:avLst/>
+          </a:prstGeom>
+          <a:noFill/>
+        </p:spPr>
+        <p:txBody>
+          <a:bodyPr wrap="square" lIns="18288" rIns="18288" tIns="18288" bIns="18288" anchor="t">
+            <a:noAutofit/>
+          </a:bodyPr>
+          <a:lstStyle/>
+          <a:p>
+            <a:pPr algn="l">
+              <a:lnSpc>
+                <a:spcPct val="105000"/>
+              </a:lnSpc>
+            </a:pPr>
+            <a:r>
+              <a:rPr sz="1100" b="0" i="0">
+                <a:solidFill>
+                  <a:srgbClr val="1AC1C1"/>
+                </a:solidFill>
+                <a:latin typeface="Montserrat"/>
+              </a:rPr>
+              <a:t>ПОСЛЕ</a:t>
+            </a:r>
+            <a:endParaRPr sz="1100" b="0" i="0">
+              <a:latin typeface="Montserrat"/>
+            </a:endParaRPr>
+          </a:p>
+        </p:txBody>
+      </p:sp>
+      <p:sp>
+        <p:nvSpPr>
+          <p:cNvPr id="11" name="Rounded Rectangle 10"/>
+          <p:cNvSpPr/>
+          <p:nvPr/>
+        </p:nvSpPr>
+        <p:spPr>
+          <a:xfrm>
+            <a:off x="1463040" y="3044952"/>
+            <a:ext cx="749808" cy="420624"/>
+          </a:xfrm>
+          <a:prstGeom prst="roundRect">
+            <a:avLst/>
+          </a:prstGeom>
+          <a:solidFill>
+            <a:srgbClr val="008C8C"/>
+          </a:solidFill>
+          <a:ln w="10160">
+            <a:solidFill>
+              <a:srgbClr val="008C8C"/>
+            </a:solidFill>
+          </a:ln>
+        </p:spPr>
+        <p:style>
+          <a:lnRef idx="1">
+            <a:schemeClr val="accent1"/>
+          </a:lnRef>
+          <a:fillRef idx="3">
+            <a:schemeClr val="accent1"/>
+          </a:fillRef>
+          <a:effectRef idx="2">
+            <a:schemeClr val="accent1"/>
+          </a:effectRef>
+          <a:fontRef idx="minor">
+            <a:schemeClr val="lt1"/>
+          </a:fontRef>
+        </p:style>
+        <p:txBody>
+          <a:bodyPr rtlCol="0" anchor="ctr"/>
+          <a:lstStyle/>
+          <a:p>
+            <a:pPr algn="ctr"/>
+          </a:p>
+        </p:txBody>
+      </p:sp>
+      <p:sp>
+        <p:nvSpPr>
+          <p:cNvPr id="12" name="TextBox 11"/>
+          <p:cNvSpPr txBox="1"/>
+          <p:nvPr/>
+        </p:nvSpPr>
+        <p:spPr>
+          <a:xfrm>
+            <a:off x="2350008" y="3154680"/>
+            <a:ext cx="777240" cy="164592"/>
+          </a:xfrm>
+          <a:prstGeom prst="rect">
+            <a:avLst/>
+          </a:prstGeom>
+          <a:noFill/>
+        </p:spPr>
+        <p:txBody>
+          <a:bodyPr wrap="square" lIns="18288" rIns="18288" tIns="18288" bIns="18288" anchor="t">
+            <a:noAutofit/>
+          </a:bodyPr>
+          <a:lstStyle/>
+          <a:p>
+            <a:pPr algn="l">
+              <a:lnSpc>
+                <a:spcPct val="105000"/>
+              </a:lnSpc>
+            </a:pPr>
+            <a:r>
+              <a:rPr sz="1000" b="0" i="0">
+                <a:solidFill>
+                  <a:srgbClr val="1AC1C1"/>
+                </a:solidFill>
+                <a:latin typeface="Montserrat"/>
+              </a:rPr>
+              <a:t>2–3 мин</a:t>
+            </a:r>
+            <a:endParaRPr sz="1000" b="0" i="0">
+              <a:latin typeface="Montserrat"/>
+            </a:endParaRPr>
+          </a:p>
+        </p:txBody>
+      </p:sp>
+      <p:sp>
+        <p:nvSpPr>
+          <p:cNvPr id="13" name="Rounded Rectangle 12"/>
+          <p:cNvSpPr/>
+          <p:nvPr/>
+        </p:nvSpPr>
+        <p:spPr>
+          <a:xfrm>
+            <a:off x="5715000" y="2953512"/>
+            <a:ext cx="2057400" cy="603504"/>
           </a:xfrm>
           <a:prstGeom prst="roundRect">
             <a:avLst/>
@@ -3364,7 +3620,7 @@
           </a:solidFill>
           <a:ln w="10160">
             <a:solidFill>
-              <a:srgbClr val="3B536C"/>
+              <a:srgbClr val="008C8C"/>
             </a:solidFill>
           </a:ln>
         </p:spPr>
@@ -3392,14 +3648,14 @@
       </p:sp>
       <p:sp>
         <p:nvSpPr>
-          <p:cNvPr id="8" name="TextBox 7"/>
+          <p:cNvPr id="14" name="TextBox 13"/>
           <p:cNvSpPr txBox="1"/>
           <p:nvPr/>
         </p:nvSpPr>
         <p:spPr>
           <a:xfrm>
-            <a:off x="868680" y="4142231"/>
-            <a:ext cx="2423160" cy="310896"/>
+            <a:off x="5925312" y="3136392"/>
+            <a:ext cx="1645920" cy="201168"/>
           </a:xfrm>
           <a:prstGeom prst="rect">
             <a:avLst/>
@@ -3412,21 +3668,21 @@
           </a:bodyPr>
           <a:lstStyle/>
           <a:p>
-            <a:pPr algn="l">
+            <a:pPr algn="ctr">
               <a:lnSpc>
                 <a:spcPct val="105000"/>
               </a:lnSpc>
             </a:pPr>
             <a:r>
-              <a:rPr sz="1700" b="0" i="0">
+              <a:rPr sz="1200" b="0" i="0">
                 <a:solidFill>
                   <a:srgbClr val="1AC1C1"/>
                 </a:solidFill>
                 <a:latin typeface="Montserrat"/>
               </a:rPr>
-              <a:t>до 1 млн руб.</a:t>
-            </a:r>
-            <a:endParaRPr sz="1700" b="0" i="0">
+              <a:t>−80–90% времени</a:t>
+            </a:r>
+            <a:endParaRPr sz="1200" b="0" i="0">
               <a:latin typeface="Montserrat"/>
             </a:endParaRPr>
           </a:p>
@@ -3434,56 +3690,14 @@
       </p:sp>
       <p:sp>
         <p:nvSpPr>
-          <p:cNvPr id="9" name="TextBox 8"/>
-          <p:cNvSpPr txBox="1"/>
-          <p:nvPr/>
-        </p:nvSpPr>
-        <p:spPr>
-          <a:xfrm>
-            <a:off x="868680" y="4562855"/>
-            <a:ext cx="2377440" cy="228600"/>
-          </a:xfrm>
-          <a:prstGeom prst="rect">
-            <a:avLst/>
-          </a:prstGeom>
-          <a:noFill/>
-        </p:spPr>
-        <p:txBody>
-          <a:bodyPr wrap="square" lIns="18288" rIns="18288" tIns="18288" bIns="18288" anchor="t">
-            <a:noAutofit/>
-          </a:bodyPr>
-          <a:lstStyle/>
-          <a:p>
-            <a:pPr algn="l">
-              <a:lnSpc>
-                <a:spcPct val="105000"/>
-              </a:lnSpc>
-            </a:pPr>
-            <a:r>
-              <a:rPr sz="900" b="0" i="0">
-                <a:solidFill>
-                  <a:srgbClr val="C5D4DE"/>
-                </a:solidFill>
-                <a:latin typeface="Montserrat"/>
-              </a:rPr>
-              <a:t>экономии в год</a:t>
-            </a:r>
-            <a:endParaRPr sz="900" b="0" i="0">
-              <a:latin typeface="Montserrat"/>
-            </a:endParaRPr>
-          </a:p>
-        </p:txBody>
-      </p:sp>
-      <p:sp>
-        <p:nvSpPr>
-          <p:cNvPr id="10" name="Rounded Rectangle 9"/>
+          <p:cNvPr id="15" name="Rounded Rectangle 14"/>
           <p:cNvSpPr/>
           <p:nvPr/>
         </p:nvSpPr>
         <p:spPr>
           <a:xfrm>
-            <a:off x="3886200" y="3977639"/>
-            <a:ext cx="2834640" cy="1005840"/>
+            <a:off x="685800" y="3977639"/>
+            <a:ext cx="2148840" cy="1115568"/>
           </a:xfrm>
           <a:prstGeom prst="roundRect">
             <a:avLst/>
@@ -3493,7 +3707,7 @@
           </a:solidFill>
           <a:ln w="10160">
             <a:solidFill>
-              <a:srgbClr val="3B536C"/>
+              <a:srgbClr val="1769AA"/>
             </a:solidFill>
           </a:ln>
         </p:spPr>
@@ -3521,14 +3735,14 @@
       </p:sp>
       <p:sp>
         <p:nvSpPr>
-          <p:cNvPr id="11" name="TextBox 10"/>
+          <p:cNvPr id="16" name="TextBox 15"/>
           <p:cNvSpPr txBox="1"/>
           <p:nvPr/>
         </p:nvSpPr>
         <p:spPr>
           <a:xfrm>
-            <a:off x="4069080" y="4142231"/>
-            <a:ext cx="2423160" cy="310896"/>
+            <a:off x="832104" y="4151376"/>
+            <a:ext cx="1847088" cy="310896"/>
           </a:xfrm>
           <a:prstGeom prst="rect">
             <a:avLst/>
@@ -3541,21 +3755,21 @@
           </a:bodyPr>
           <a:lstStyle/>
           <a:p>
-            <a:pPr algn="l">
+            <a:pPr algn="ctr">
               <a:lnSpc>
                 <a:spcPct val="105000"/>
               </a:lnSpc>
             </a:pPr>
             <a:r>
-              <a:rPr sz="1700" b="0" i="0">
+              <a:rPr sz="1800" b="0" i="0">
                 <a:solidFill>
                   <a:srgbClr val="1AC1C1"/>
                 </a:solidFill>
                 <a:latin typeface="Montserrat"/>
               </a:rPr>
-              <a:t>3–5 мес</a:t>
-            </a:r>
-            <a:endParaRPr sz="1700" b="0" i="0">
+              <a:t>94–156</a:t>
+            </a:r>
+            <a:endParaRPr sz="1800" b="0" i="0">
               <a:latin typeface="Montserrat"/>
             </a:endParaRPr>
           </a:p>
@@ -3563,14 +3777,14 @@
       </p:sp>
       <p:sp>
         <p:nvSpPr>
-          <p:cNvPr id="12" name="TextBox 11"/>
+          <p:cNvPr id="17" name="TextBox 16"/>
           <p:cNvSpPr txBox="1"/>
           <p:nvPr/>
         </p:nvSpPr>
         <p:spPr>
           <a:xfrm>
-            <a:off x="4069080" y="4562855"/>
-            <a:ext cx="2377440" cy="228600"/>
+            <a:off x="832104" y="4517136"/>
+            <a:ext cx="1847088" cy="201168"/>
           </a:xfrm>
           <a:prstGeom prst="rect">
             <a:avLst/>
@@ -3583,7 +3797,7 @@
           </a:bodyPr>
           <a:lstStyle/>
           <a:p>
-            <a:pPr algn="l">
+            <a:pPr algn="ctr">
               <a:lnSpc>
                 <a:spcPct val="105000"/>
               </a:lnSpc>
@@ -3591,11 +3805,11 @@
             <a:r>
               <a:rPr sz="900" b="0" i="0">
                 <a:solidFill>
-                  <a:srgbClr val="C5D4DE"/>
+                  <a:srgbClr val="FFFFFF"/>
                 </a:solidFill>
                 <a:latin typeface="Montserrat"/>
               </a:rPr>
-              <a:t>окупаемость проекта</a:t>
+              <a:t>часов в месяц</a:t>
             </a:r>
             <a:endParaRPr sz="900" b="0" i="0">
               <a:latin typeface="Montserrat"/>
@@ -3605,14 +3819,98 @@
       </p:sp>
       <p:sp>
         <p:nvSpPr>
-          <p:cNvPr id="13" name="Rounded Rectangle 12"/>
+          <p:cNvPr id="18" name="TextBox 17"/>
+          <p:cNvSpPr txBox="1"/>
+          <p:nvPr/>
+        </p:nvSpPr>
+        <p:spPr>
+          <a:xfrm>
+            <a:off x="832104" y="4818888"/>
+            <a:ext cx="1847088" cy="164592"/>
+          </a:xfrm>
+          <a:prstGeom prst="rect">
+            <a:avLst/>
+          </a:prstGeom>
+          <a:noFill/>
+        </p:spPr>
+        <p:txBody>
+          <a:bodyPr wrap="square" lIns="18288" rIns="18288" tIns="18288" bIns="18288" anchor="t">
+            <a:noAutofit/>
+          </a:bodyPr>
+          <a:lstStyle/>
+          <a:p>
+            <a:pPr algn="ctr">
+              <a:lnSpc>
+                <a:spcPct val="105000"/>
+              </a:lnSpc>
+            </a:pPr>
+            <a:r>
+              <a:rPr sz="800" b="0" i="0">
+                <a:solidFill>
+                  <a:srgbClr val="B8C8D4"/>
+                </a:solidFill>
+                <a:latin typeface="Montserrat"/>
+              </a:rPr>
+              <a:t>высвобождено</a:t>
+            </a:r>
+            <a:endParaRPr sz="800" b="0" i="0">
+              <a:latin typeface="Montserrat"/>
+            </a:endParaRPr>
+          </a:p>
+        </p:txBody>
+      </p:sp>
+      <p:sp>
+        <p:nvSpPr>
+          <p:cNvPr id="19" name="TextBox 18"/>
+          <p:cNvSpPr txBox="1"/>
+          <p:nvPr/>
+        </p:nvSpPr>
+        <p:spPr>
+          <a:xfrm>
+            <a:off x="2907792" y="4279392"/>
+            <a:ext cx="292608" cy="384048"/>
+          </a:xfrm>
+          <a:prstGeom prst="rect">
+            <a:avLst/>
+          </a:prstGeom>
+          <a:noFill/>
+        </p:spPr>
+        <p:txBody>
+          <a:bodyPr wrap="square" lIns="18288" rIns="18288" tIns="18288" bIns="18288" anchor="t">
+            <a:noAutofit/>
+          </a:bodyPr>
+          <a:lstStyle/>
+          <a:p>
+            <a:pPr algn="ctr">
+              <a:lnSpc>
+                <a:spcPct val="105000"/>
+              </a:lnSpc>
+            </a:pPr>
+            <a:r>
+              <a:rPr sz="2200" b="0" i="0">
+                <a:solidFill>
+                  <a:srgbClr val="1AC1C1"/>
+                </a:solidFill>
+                <a:latin typeface="Montserrat"/>
+              </a:rPr>
+              <a:t>&gt;</a:t>
+            </a:r>
+            <a:endParaRPr sz="2200" b="0" i="0">
+              <a:latin typeface="Montserrat"/>
+            </a:endParaRPr>
+          </a:p>
+        </p:txBody>
+      </p:sp>
+      <p:sp>
+        <p:nvSpPr>
+          <p:cNvPr id="20" name="Rounded Rectangle 19"/>
           <p:cNvSpPr/>
           <p:nvPr/>
         </p:nvSpPr>
         <p:spPr>
           <a:xfrm>
-            <a:off x="685800" y="5257800"/>
-            <a:ext cx="2834640" cy="1005840"/>
+            <a:off x="3264408" y="3977639"/>
+            <a:ext cx="2148840" cy="1115568"/>
           </a:xfrm>
           <a:prstGeom prst="roundRect">
             <a:avLst/>
@@ -3622,7 +3920,7 @@
           </a:solidFill>
           <a:ln w="10160">
             <a:solidFill>
-              <a:srgbClr val="3B536C"/>
+              <a:srgbClr val="17805E"/>
             </a:solidFill>
           </a:ln>
         </p:spPr>
@@ -3650,14 +3948,14 @@
       </p:sp>
       <p:sp>
         <p:nvSpPr>
-          <p:cNvPr id="14" name="TextBox 13"/>
+          <p:cNvPr id="21" name="TextBox 20"/>
           <p:cNvSpPr txBox="1"/>
           <p:nvPr/>
         </p:nvSpPr>
         <p:spPr>
           <a:xfrm>
-            <a:off x="868680" y="5422392"/>
-            <a:ext cx="2423160" cy="310896"/>
+            <a:off x="3410712" y="4151376"/>
+            <a:ext cx="1847088" cy="310896"/>
           </a:xfrm>
           <a:prstGeom prst="rect">
             <a:avLst/>
@@ -3670,21 +3968,21 @@
           </a:bodyPr>
           <a:lstStyle/>
           <a:p>
-            <a:pPr algn="l">
+            <a:pPr algn="ctr">
               <a:lnSpc>
                 <a:spcPct val="105000"/>
               </a:lnSpc>
             </a:pPr>
             <a:r>
-              <a:rPr sz="1700" b="0" i="0">
-                <a:solidFill>
-                  <a:srgbClr val="1AC1C1"/>
+              <a:rPr sz="1800" b="0" i="0">
+                <a:solidFill>
+                  <a:srgbClr val="17805E"/>
                 </a:solidFill>
                 <a:latin typeface="Montserrat"/>
               </a:rPr>
-              <a:t>без найма</a:t>
-            </a:r>
-            <a:endParaRPr sz="1700" b="0" i="0">
+              <a:t>0,6–1</a:t>
+            </a:r>
+            <a:endParaRPr sz="1800" b="0" i="0">
               <a:latin typeface="Montserrat"/>
             </a:endParaRPr>
           </a:p>
@@ -3692,14 +3990,14 @@
       </p:sp>
       <p:sp>
         <p:nvSpPr>
-          <p:cNvPr id="15" name="TextBox 14"/>
+          <p:cNvPr id="22" name="TextBox 21"/>
           <p:cNvSpPr txBox="1"/>
           <p:nvPr/>
         </p:nvSpPr>
         <p:spPr>
           <a:xfrm>
-            <a:off x="868680" y="5843016"/>
-            <a:ext cx="2377440" cy="228600"/>
+            <a:off x="3410712" y="4517136"/>
+            <a:ext cx="1847088" cy="201168"/>
           </a:xfrm>
           <a:prstGeom prst="rect">
             <a:avLst/>
@@ -3712,7 +4010,7 @@
           </a:bodyPr>
           <a:lstStyle/>
           <a:p>
-            <a:pPr algn="l">
+            <a:pPr algn="ctr">
               <a:lnSpc>
                 <a:spcPct val="105000"/>
               </a:lnSpc>
@@ -3720,11 +4018,11 @@
             <a:r>
               <a:rPr sz="900" b="0" i="0">
                 <a:solidFill>
-                  <a:srgbClr val="C5D4DE"/>
+                  <a:srgbClr val="FFFFFF"/>
                 </a:solidFill>
                 <a:latin typeface="Montserrat"/>
               </a:rPr>
-              <a:t>при росте нагрузки</a:t>
+              <a:t>рабочей ставки</a:t>
             </a:r>
             <a:endParaRPr sz="900" b="0" i="0">
               <a:latin typeface="Montserrat"/>
@@ -3734,14 +4032,98 @@
       </p:sp>
       <p:sp>
         <p:nvSpPr>
-          <p:cNvPr id="16" name="Rounded Rectangle 15"/>
+          <p:cNvPr id="23" name="TextBox 22"/>
+          <p:cNvSpPr txBox="1"/>
+          <p:nvPr/>
+        </p:nvSpPr>
+        <p:spPr>
+          <a:xfrm>
+            <a:off x="3410712" y="4818888"/>
+            <a:ext cx="1847088" cy="164592"/>
+          </a:xfrm>
+          <a:prstGeom prst="rect">
+            <a:avLst/>
+          </a:prstGeom>
+          <a:noFill/>
+        </p:spPr>
+        <p:txBody>
+          <a:bodyPr wrap="square" lIns="18288" rIns="18288" tIns="18288" bIns="18288" anchor="t">
+            <a:noAutofit/>
+          </a:bodyPr>
+          <a:lstStyle/>
+          <a:p>
+            <a:pPr algn="ctr">
+              <a:lnSpc>
+                <a:spcPct val="105000"/>
+              </a:lnSpc>
+            </a:pPr>
+            <a:r>
+              <a:rPr sz="800" b="0" i="0">
+                <a:solidFill>
+                  <a:srgbClr val="B8C8D4"/>
+                </a:solidFill>
+                <a:latin typeface="Montserrat"/>
+              </a:rPr>
+              <a:t>запас мощности</a:t>
+            </a:r>
+            <a:endParaRPr sz="800" b="0" i="0">
+              <a:latin typeface="Montserrat"/>
+            </a:endParaRPr>
+          </a:p>
+        </p:txBody>
+      </p:sp>
+      <p:sp>
+        <p:nvSpPr>
+          <p:cNvPr id="24" name="TextBox 23"/>
+          <p:cNvSpPr txBox="1"/>
+          <p:nvPr/>
+        </p:nvSpPr>
+        <p:spPr>
+          <a:xfrm>
+            <a:off x="5486400" y="4279392"/>
+            <a:ext cx="292608" cy="384048"/>
+          </a:xfrm>
+          <a:prstGeom prst="rect">
+            <a:avLst/>
+          </a:prstGeom>
+          <a:noFill/>
+        </p:spPr>
+        <p:txBody>
+          <a:bodyPr wrap="square" lIns="18288" rIns="18288" tIns="18288" bIns="18288" anchor="t">
+            <a:noAutofit/>
+          </a:bodyPr>
+          <a:lstStyle/>
+          <a:p>
+            <a:pPr algn="ctr">
+              <a:lnSpc>
+                <a:spcPct val="105000"/>
+              </a:lnSpc>
+            </a:pPr>
+            <a:r>
+              <a:rPr sz="2200" b="0" i="0">
+                <a:solidFill>
+                  <a:srgbClr val="1AC1C1"/>
+                </a:solidFill>
+                <a:latin typeface="Montserrat"/>
+              </a:rPr>
+              <a:t>&gt;</a:t>
+            </a:r>
+            <a:endParaRPr sz="2200" b="0" i="0">
+              <a:latin typeface="Montserrat"/>
+            </a:endParaRPr>
+          </a:p>
+        </p:txBody>
+      </p:sp>
+      <p:sp>
+        <p:nvSpPr>
+          <p:cNvPr id="25" name="Rounded Rectangle 24"/>
           <p:cNvSpPr/>
           <p:nvPr/>
         </p:nvSpPr>
         <p:spPr>
           <a:xfrm>
-            <a:off x="3886200" y="5257800"/>
-            <a:ext cx="2834640" cy="1005840"/>
+            <a:off x="5843016" y="3977639"/>
+            <a:ext cx="2148840" cy="1115568"/>
           </a:xfrm>
           <a:prstGeom prst="roundRect">
             <a:avLst/>
@@ -3751,7 +4133,7 @@
           </a:solidFill>
           <a:ln w="10160">
             <a:solidFill>
-              <a:srgbClr val="3B536C"/>
+              <a:srgbClr val="D99400"/>
             </a:solidFill>
           </a:ln>
         </p:spPr>
@@ -3779,14 +4161,14 @@
       </p:sp>
       <p:sp>
         <p:nvSpPr>
-          <p:cNvPr id="17" name="TextBox 16"/>
+          <p:cNvPr id="26" name="TextBox 25"/>
           <p:cNvSpPr txBox="1"/>
           <p:nvPr/>
         </p:nvSpPr>
         <p:spPr>
           <a:xfrm>
-            <a:off x="4069080" y="5422392"/>
-            <a:ext cx="2423160" cy="310896"/>
+            <a:off x="5989320" y="4151376"/>
+            <a:ext cx="1847088" cy="310896"/>
           </a:xfrm>
           <a:prstGeom prst="rect">
             <a:avLst/>
@@ -3799,21 +4181,21 @@
           </a:bodyPr>
           <a:lstStyle/>
           <a:p>
-            <a:pPr algn="l">
+            <a:pPr algn="ctr">
               <a:lnSpc>
                 <a:spcPct val="105000"/>
               </a:lnSpc>
             </a:pPr>
             <a:r>
-              <a:rPr sz="1700" b="0" i="0">
-                <a:solidFill>
-                  <a:srgbClr val="1AC1C1"/>
+              <a:rPr sz="1800" b="0" i="0">
+                <a:solidFill>
+                  <a:srgbClr val="D99400"/>
                 </a:solidFill>
                 <a:latin typeface="Montserrat"/>
               </a:rPr>
-              <a:t>0 дублей</a:t>
-            </a:r>
-            <a:endParaRPr sz="1700" b="0" i="0">
+              <a:t>0,5–1 млн</a:t>
+            </a:r>
+            <a:endParaRPr sz="1800" b="0" i="0">
               <a:latin typeface="Montserrat"/>
             </a:endParaRPr>
           </a:p>
@@ -3821,14 +4203,14 @@
       </p:sp>
       <p:sp>
         <p:nvSpPr>
-          <p:cNvPr id="18" name="TextBox 17"/>
+          <p:cNvPr id="27" name="TextBox 26"/>
           <p:cNvSpPr txBox="1"/>
           <p:nvPr/>
         </p:nvSpPr>
         <p:spPr>
           <a:xfrm>
-            <a:off x="4069080" y="5843016"/>
-            <a:ext cx="2377440" cy="228600"/>
+            <a:off x="5989320" y="4517136"/>
+            <a:ext cx="1847088" cy="201168"/>
           </a:xfrm>
           <a:prstGeom prst="rect">
             <a:avLst/>
@@ -3841,7 +4223,7 @@
           </a:bodyPr>
           <a:lstStyle/>
           <a:p>
-            <a:pPr algn="l">
+            <a:pPr algn="ctr">
               <a:lnSpc>
                 <a:spcPct val="105000"/>
               </a:lnSpc>
@@ -3849,11 +4231,11 @@
             <a:r>
               <a:rPr sz="900" b="0" i="0">
                 <a:solidFill>
-                  <a:srgbClr val="C5D4DE"/>
+                  <a:srgbClr val="FFFFFF"/>
                 </a:solidFill>
                 <a:latin typeface="Montserrat"/>
               </a:rPr>
-              <a:t>при повторной отправке</a:t>
+              <a:t>рублей в год</a:t>
             </a:r>
             <a:endParaRPr sz="900" b="0" i="0">
               <a:latin typeface="Montserrat"/>
@@ -3863,7 +4245,224 @@
       </p:sp>
       <p:sp>
         <p:nvSpPr>
-          <p:cNvPr id="19" name="TextBox 18"/>
+          <p:cNvPr id="28" name="TextBox 27"/>
+          <p:cNvSpPr txBox="1"/>
+          <p:nvPr/>
+        </p:nvSpPr>
+        <p:spPr>
+          <a:xfrm>
+            <a:off x="5989320" y="4818888"/>
+            <a:ext cx="1847088" cy="164592"/>
+          </a:xfrm>
+          <a:prstGeom prst="rect">
+            <a:avLst/>
+          </a:prstGeom>
+          <a:noFill/>
+        </p:spPr>
+        <p:txBody>
+          <a:bodyPr wrap="square" lIns="18288" rIns="18288" tIns="18288" bIns="18288" anchor="t">
+            <a:noAutofit/>
+          </a:bodyPr>
+          <a:lstStyle/>
+          <a:p>
+            <a:pPr algn="ctr">
+              <a:lnSpc>
+                <a:spcPct val="105000"/>
+              </a:lnSpc>
+            </a:pPr>
+            <a:r>
+              <a:rPr sz="800" b="0" i="0">
+                <a:solidFill>
+                  <a:srgbClr val="B8C8D4"/>
+                </a:solidFill>
+                <a:latin typeface="Montserrat"/>
+              </a:rPr>
+              <a:t>полученная экономия</a:t>
+            </a:r>
+            <a:endParaRPr sz="800" b="0" i="0">
+              <a:latin typeface="Montserrat"/>
+            </a:endParaRPr>
+          </a:p>
+        </p:txBody>
+      </p:sp>
+      <p:sp>
+        <p:nvSpPr>
+          <p:cNvPr id="29" name="Rounded Rectangle 28"/>
+          <p:cNvSpPr/>
+          <p:nvPr/>
+        </p:nvSpPr>
+        <p:spPr>
+          <a:xfrm>
+            <a:off x="685800" y="5504688"/>
+            <a:ext cx="7306056" cy="548640"/>
+          </a:xfrm>
+          <a:prstGeom prst="roundRect">
+            <a:avLst/>
+          </a:prstGeom>
+          <a:solidFill>
+            <a:srgbClr val="183A48"/>
+          </a:solidFill>
+          <a:ln w="10160">
+            <a:solidFill>
+              <a:srgbClr val="008C8C"/>
+            </a:solidFill>
+          </a:ln>
+        </p:spPr>
+        <p:style>
+          <a:lnRef idx="1">
+            <a:schemeClr val="accent1"/>
+          </a:lnRef>
+          <a:fillRef idx="3">
+            <a:schemeClr val="accent1"/>
+          </a:fillRef>
+          <a:effectRef idx="2">
+            <a:schemeClr val="accent1"/>
+          </a:effectRef>
+          <a:fontRef idx="minor">
+            <a:schemeClr val="lt1"/>
+          </a:fontRef>
+        </p:style>
+        <p:txBody>
+          <a:bodyPr rtlCol="0" anchor="ctr"/>
+          <a:lstStyle/>
+          <a:p>
+            <a:pPr algn="ctr"/>
+          </a:p>
+        </p:txBody>
+      </p:sp>
+      <p:sp>
+        <p:nvSpPr>
+          <p:cNvPr id="30" name="TextBox 29"/>
+          <p:cNvSpPr txBox="1"/>
+          <p:nvPr/>
+        </p:nvSpPr>
+        <p:spPr>
+          <a:xfrm>
+            <a:off x="896112" y="5687568"/>
+            <a:ext cx="6885432" cy="182880"/>
+          </a:xfrm>
+          <a:prstGeom prst="rect">
+            <a:avLst/>
+          </a:prstGeom>
+          <a:noFill/>
+        </p:spPr>
+        <p:txBody>
+          <a:bodyPr wrap="square" lIns="18288" rIns="18288" tIns="18288" bIns="18288" anchor="t">
+            <a:noAutofit/>
+          </a:bodyPr>
+          <a:lstStyle/>
+          <a:p>
+            <a:pPr algn="ctr">
+              <a:lnSpc>
+                <a:spcPct val="105000"/>
+              </a:lnSpc>
+            </a:pPr>
+            <a:r>
+              <a:rPr sz="1000" b="0" i="0">
+                <a:solidFill>
+                  <a:srgbClr val="1AC1C1"/>
+                </a:solidFill>
+                <a:latin typeface="Montserrat"/>
+              </a:rPr>
+              <a:t>ТЕКУЩИЙ ШТАТ СОХРАНЁН  •  ОКУПАЕМОСТЬ 3–5 МЕСЯЦЕВ  •  ПОВТОР БЕЗ ДУБЛЯ</a:t>
+            </a:r>
+            <a:endParaRPr sz="1000" b="0" i="0">
+              <a:latin typeface="Montserrat"/>
+            </a:endParaRPr>
+          </a:p>
+        </p:txBody>
+      </p:sp>
+      <p:sp>
+        <p:nvSpPr>
+          <p:cNvPr id="31" name="Rectangle 30"/>
+          <p:cNvSpPr/>
+          <p:nvPr/>
+        </p:nvSpPr>
+        <p:spPr>
+          <a:xfrm>
+            <a:off x="8339327" y="6089904"/>
+            <a:ext cx="3849624" cy="768096"/>
+          </a:xfrm>
+          <a:prstGeom prst="rect">
+            <a:avLst/>
+          </a:prstGeom>
+          <a:solidFill>
+            <a:srgbClr val="15243A"/>
+          </a:solidFill>
+          <a:ln w="10160">
+            <a:solidFill>
+              <a:srgbClr val="15243A"/>
+            </a:solidFill>
+          </a:ln>
+        </p:spPr>
+        <p:style>
+          <a:lnRef idx="1">
+            <a:schemeClr val="accent1"/>
+          </a:lnRef>
+          <a:fillRef idx="3">
+            <a:schemeClr val="accent1"/>
+          </a:fillRef>
+          <a:effectRef idx="2">
+            <a:schemeClr val="accent1"/>
+          </a:effectRef>
+          <a:fontRef idx="minor">
+            <a:schemeClr val="lt1"/>
+          </a:fontRef>
+        </p:style>
+        <p:txBody>
+          <a:bodyPr rtlCol="0" anchor="ctr"/>
+          <a:lstStyle/>
+          <a:p>
+            <a:pPr algn="ctr"/>
+          </a:p>
+        </p:txBody>
+      </p:sp>
+      <p:sp>
+        <p:nvSpPr>
+          <p:cNvPr id="32" name="TextBox 31"/>
+          <p:cNvSpPr txBox="1"/>
+          <p:nvPr/>
+        </p:nvSpPr>
+        <p:spPr>
+          <a:xfrm>
+            <a:off x="8577072" y="6291072"/>
+            <a:ext cx="3374136" cy="384048"/>
+          </a:xfrm>
+          <a:prstGeom prst="rect">
+            <a:avLst/>
+          </a:prstGeom>
+          <a:noFill/>
+        </p:spPr>
+        <p:txBody>
+          <a:bodyPr wrap="square" lIns="18288" rIns="18288" tIns="18288" bIns="18288" anchor="t">
+            <a:noAutofit/>
+          </a:bodyPr>
+          <a:lstStyle/>
+          <a:p>
+            <a:pPr algn="ctr">
+              <a:lnSpc>
+                <a:spcPct val="105000"/>
+              </a:lnSpc>
+            </a:pPr>
+            <a:r>
+              <a:rPr sz="1000" b="0" i="0">
+                <a:solidFill>
+                  <a:srgbClr val="FFFFFF"/>
+                </a:solidFill>
+                <a:latin typeface="Montserrat"/>
+              </a:rPr>
+              <a:t>РЕАЛЬНЫЕ РАБОТЫ
+СТЕКЛОЦЕНТР.ПТЗ</a:t>
+            </a:r>
+            <a:endParaRPr sz="1000" b="0" i="0">
+              <a:latin typeface="Montserrat"/>
+            </a:endParaRPr>
+          </a:p>
+        </p:txBody>
+      </p:sp>
+      <p:sp>
+        <p:nvSpPr>
+          <p:cNvPr id="33" name="TextBox 32"/>
           <p:cNvSpPr txBox="1"/>
           <p:nvPr/>
         </p:nvSpPr>

</xml_diff>